<commit_message>
Verify all datasets live, correct GRW/TZ-SAM field names, add first China results
</commit_message>
<xml_diff>
--- a/RS_Renewables_Biodiversity_Workflow.pptx
+++ b/RS_Renewables_Biodiversity_Workflow.pptx
@@ -22,9 +22,10 @@
     <p:sldId id="270" r:id="rId16"/>
     <p:sldId id="271" r:id="rId17"/>
     <p:sldId id="272" r:id="rId18"/>
+    <p:sldId id="273" r:id="rId19"/>
   </p:sldIdLst>
   <p:notesMasterIdLst>
-    <p:notesMasterId r:id="rId19"/>
+    <p:notesMasterId r:id="rId20"/>
   </p:notesMasterIdLst>
   <p:sldSz cx="12192000" cy="6858000"/>
   <p:notesSz cx="6858000" cy="12192000"/>
@@ -121,6 +122,412 @@
     </a:lvl9pPr>
   </p:defaultTextStyle>
 </p:presentation>
+</file>
+
+<file path=ppt/charts/chart1.xml><?xml version="1.0" encoding="utf-8"?>
+<c:chartSpace xmlns:c="http://schemas.openxmlformats.org/drawingml/2006/chart" xmlns:a="http://schemas.openxmlformats.org/drawingml/2006/main" xmlns:r="http://schemas.openxmlformats.org/officeDocument/2006/relationships">
+  <c:date1904 val="0"/>
+  <c:roundedCorners val="1"/>
+  <c:chart>
+    <c:title>
+      <c:tx>
+        <c:rich>
+          <a:bodyPr/>
+          <a:lstStyle/>
+          <a:p>
+            <a:pPr>
+              <a:defRPr sz="1400" b="0" i="0" u="none" strike="noStrike">
+                <a:solidFill>
+                  <a:srgbClr val="0E2F3C"/>
+                </a:solidFill>
+                <a:latin typeface="PingFang SC"/>
+              </a:defRPr>
+            </a:pPr>
+            <a:r>
+              <a:rPr sz="1400" b="0" i="0" u="none" strike="noStrike">
+                <a:solidFill>
+                  <a:srgbClr val="0E2F3C"/>
+                </a:solidFill>
+                <a:latin typeface="PingFang SC"/>
+              </a:rPr>
+              <a:t>建设前土地覆盖(ESA CCI 2018,300 m)</a:t>
+            </a:r>
+          </a:p>
+        </c:rich>
+      </c:tx>
+      <c:layout/>
+      <c:overlay val="0"/>
+    </c:title>
+    <c:autoTitleDeleted val="0"/>
+    <c:plotArea>
+      <c:layout/>
+      <c:barChart>
+        <c:barDir val="col"/>
+        <c:grouping val="clustered"/>
+        <c:varyColors val="0"/>
+        <c:ser>
+          <c:idx val="0"/>
+          <c:order val="0"/>
+          <c:tx>
+            <c:strRef>
+              <c:f>Sheet1!$B$1</c:f>
+              <c:strCache>
+                <c:ptCount val="1"/>
+                <c:pt idx="0">
+                  <c:v>光伏(面积 %)</c:v>
+                </c:pt>
+              </c:strCache>
+            </c:strRef>
+          </c:tx>
+          <c:spPr>
+            <a:solidFill>
+              <a:srgbClr val="E9A23B"/>
+            </a:solidFill>
+            <a:effectLst/>
+          </c:spPr>
+          <c:invertIfNegative val="0"/>
+          <c:dLbls>
+            <c:numFmt formatCode="0.0" sourceLinked="0"/>
+            <c:txPr>
+              <a:bodyPr/>
+              <a:lstStyle/>
+              <a:p>
+                <a:pPr>
+                  <a:defRPr b="0" i="0" strike="noStrike" sz="1000" u="none">
+                    <a:solidFill>
+                      <a:srgbClr val="000000"/>
+                    </a:solidFill>
+                    <a:latin typeface="Arial"/>
+                  </a:defRPr>
+                </a:pPr>
+              </a:p>
+            </c:txPr>
+            <c:showLegendKey val="0"/>
+            <c:showVal val="1"/>
+            <c:showCatName val="0"/>
+            <c:showSerName val="0"/>
+            <c:showPercent val="0"/>
+            <c:showBubbleSize val="0"/>
+            <c:showLeaderLines val="0"/>
+          </c:dLbls>
+          <c:cat>
+            <c:multiLvlStrRef>
+              <c:f>Sheet1!$A$2:$A$7</c:f>
+              <c:multiLvlStrCache>
+                <c:ptCount val="6"/>
+                <c:lvl>
+                  <c:pt idx="0">
+                    <c:v>裸地</c:v>
+                  </c:pt>
+                  <c:pt idx="1">
+                    <c:v>草地</c:v>
+                  </c:pt>
+                  <c:pt idx="2">
+                    <c:v>耕地</c:v>
+                  </c:pt>
+                  <c:pt idx="3">
+                    <c:v>森林</c:v>
+                  </c:pt>
+                  <c:pt idx="4">
+                    <c:v>水体</c:v>
+                  </c:pt>
+                  <c:pt idx="5">
+                    <c:v>其他</c:v>
+                  </c:pt>
+                </c:lvl>
+              </c:multiLvlStrCache>
+            </c:multiLvlStrRef>
+          </c:cat>
+          <c:val>
+            <c:numRef>
+              <c:f>Sheet1!$B$2:$B$7</c:f>
+              <c:numCache>
+                <c:formatCode>General</c:formatCode>
+                <c:ptCount val="6"/>
+                <c:pt idx="0">
+                  <c:v>33.2</c:v>
+                </c:pt>
+                <c:pt idx="1">
+                  <c:v>31.2</c:v>
+                </c:pt>
+                <c:pt idx="2">
+                  <c:v>26.5</c:v>
+                </c:pt>
+                <c:pt idx="3">
+                  <c:v>0.7</c:v>
+                </c:pt>
+                <c:pt idx="4">
+                  <c:v>4.1</c:v>
+                </c:pt>
+                <c:pt idx="5">
+                  <c:v>4.3</c:v>
+                </c:pt>
+              </c:numCache>
+            </c:numRef>
+          </c:val>
+        </c:ser>
+        <c:ser>
+          <c:idx val="1"/>
+          <c:order val="1"/>
+          <c:tx>
+            <c:strRef>
+              <c:f>Sheet1!$C$1</c:f>
+              <c:strCache>
+                <c:ptCount val="1"/>
+                <c:pt idx="0">
+                  <c:v>风机(数量 %)</c:v>
+                </c:pt>
+              </c:strCache>
+            </c:strRef>
+          </c:tx>
+          <c:spPr>
+            <a:solidFill>
+              <a:srgbClr val="1F6F78"/>
+            </a:solidFill>
+            <a:effectLst/>
+          </c:spPr>
+          <c:invertIfNegative val="0"/>
+          <c:dLbls>
+            <c:numFmt formatCode="0.0" sourceLinked="0"/>
+            <c:txPr>
+              <a:bodyPr/>
+              <a:lstStyle/>
+              <a:p>
+                <a:pPr>
+                  <a:defRPr b="0" i="0" strike="noStrike" sz="1000" u="none">
+                    <a:solidFill>
+                      <a:srgbClr val="000000"/>
+                    </a:solidFill>
+                    <a:latin typeface="Arial"/>
+                  </a:defRPr>
+                </a:pPr>
+              </a:p>
+            </c:txPr>
+            <c:showLegendKey val="0"/>
+            <c:showVal val="1"/>
+            <c:showCatName val="0"/>
+            <c:showSerName val="0"/>
+            <c:showPercent val="0"/>
+            <c:showBubbleSize val="0"/>
+            <c:showLeaderLines val="0"/>
+          </c:dLbls>
+          <c:cat>
+            <c:multiLvlStrRef>
+              <c:f>Sheet1!$A$2:$A$7</c:f>
+              <c:multiLvlStrCache>
+                <c:ptCount val="6"/>
+                <c:lvl>
+                  <c:pt idx="0">
+                    <c:v>裸地</c:v>
+                  </c:pt>
+                  <c:pt idx="1">
+                    <c:v>草地</c:v>
+                  </c:pt>
+                  <c:pt idx="2">
+                    <c:v>耕地</c:v>
+                  </c:pt>
+                  <c:pt idx="3">
+                    <c:v>森林</c:v>
+                  </c:pt>
+                  <c:pt idx="4">
+                    <c:v>水体</c:v>
+                  </c:pt>
+                  <c:pt idx="5">
+                    <c:v>其他</c:v>
+                  </c:pt>
+                </c:lvl>
+              </c:multiLvlStrCache>
+            </c:multiLvlStrRef>
+          </c:cat>
+          <c:val>
+            <c:numRef>
+              <c:f>Sheet1!$C$2:$C$7</c:f>
+              <c:numCache>
+                <c:formatCode>General</c:formatCode>
+                <c:ptCount val="6"/>
+                <c:pt idx="0">
+                  <c:v>21.8</c:v>
+                </c:pt>
+                <c:pt idx="1">
+                  <c:v>34.9</c:v>
+                </c:pt>
+                <c:pt idx="2">
+                  <c:v>19.4</c:v>
+                </c:pt>
+                <c:pt idx="3">
+                  <c:v>12.2</c:v>
+                </c:pt>
+                <c:pt idx="4">
+                  <c:v>0.8</c:v>
+                </c:pt>
+                <c:pt idx="5">
+                  <c:v>10.9</c:v>
+                </c:pt>
+              </c:numCache>
+            </c:numRef>
+          </c:val>
+        </c:ser>
+        <c:dLbls>
+          <c:numFmt formatCode="0.0" sourceLinked="0"/>
+          <c:txPr>
+            <a:bodyPr/>
+            <a:lstStyle/>
+            <a:p>
+              <a:pPr>
+                <a:defRPr b="0" i="0" strike="noStrike" sz="1000" u="none">
+                  <a:solidFill>
+                    <a:srgbClr val="000000"/>
+                  </a:solidFill>
+                  <a:latin typeface="Arial"/>
+                </a:defRPr>
+              </a:pPr>
+            </a:p>
+          </c:txPr>
+          <c:showLegendKey val="0"/>
+          <c:showVal val="1"/>
+          <c:showCatName val="0"/>
+          <c:showSerName val="0"/>
+          <c:showPercent val="0"/>
+          <c:showBubbleSize val="0"/>
+          <c:showLeaderLines val="0"/>
+        </c:dLbls>
+        <c:gapWidth val="150"/>
+        <c:overlap val="0"/>
+        <c:axId val="2094734554"/>
+        <c:axId val="2094734552"/>
+        <c:axId val="2094734556"/>
+      </c:barChart>
+      <c:catAx>
+        <c:axId val="2094734554"/>
+        <c:scaling>
+          <c:orientation val="minMax"/>
+        </c:scaling>
+        <c:delete val="0"/>
+        <c:axPos val="b"/>
+        <c:numFmt formatCode="General" sourceLinked="1"/>
+        <c:majorTickMark val="out"/>
+        <c:minorTickMark val="none"/>
+        <c:tickLblPos val="low"/>
+        <c:spPr>
+          <a:ln w="12700" cap="flat">
+            <a:solidFill>
+              <a:srgbClr val="888888"/>
+            </a:solidFill>
+            <a:prstDash val="solid"/>
+            <a:round/>
+          </a:ln>
+        </c:spPr>
+        <c:txPr>
+          <a:bodyPr/>
+          <a:lstStyle/>
+          <a:p>
+            <a:pPr>
+              <a:defRPr sz="1200" b="0" i="0" u="none" strike="noStrike">
+                <a:solidFill>
+                  <a:srgbClr val="1D2A33"/>
+                </a:solidFill>
+                <a:latin typeface="PingFang SC"/>
+              </a:defRPr>
+            </a:pPr>
+            <a:endParaRPr lang="en-US"/>
+          </a:p>
+        </c:txPr>
+        <c:crossAx val="2094734552"/>
+        <c:crosses val="autoZero"/>
+        <c:auto val="1"/>
+        <c:lblAlgn val="ctr"/>
+        <c:noMultiLvlLbl val="1"/>
+      </c:catAx>
+      <c:valAx>
+        <c:axId val="2094734552"/>
+        <c:scaling>
+          <c:orientation val="minMax"/>
+          <c:max val="40"/>
+        </c:scaling>
+        <c:delete val="0"/>
+        <c:axPos val="l"/>
+        <c:majorGridlines>
+          <c:spPr>
+            <a:ln w="6350" cap="flat">
+              <a:solidFill>
+                <a:srgbClr val="E3E9EC"/>
+              </a:solidFill>
+              <a:prstDash val="solid"/>
+              <a:round/>
+            </a:ln>
+          </c:spPr>
+        </c:majorGridlines>
+        <c:numFmt formatCode="General" sourceLinked="0"/>
+        <c:majorTickMark val="out"/>
+        <c:minorTickMark val="none"/>
+        <c:tickLblPos val="nextTo"/>
+        <c:spPr>
+          <a:ln w="12700" cap="flat">
+            <a:solidFill>
+              <a:srgbClr val="888888"/>
+            </a:solidFill>
+            <a:prstDash val="solid"/>
+            <a:round/>
+          </a:ln>
+        </c:spPr>
+        <c:txPr>
+          <a:bodyPr/>
+          <a:lstStyle/>
+          <a:p>
+            <a:pPr>
+              <a:defRPr sz="1200" b="0" i="0" u="none" strike="noStrike">
+                <a:solidFill>
+                  <a:srgbClr val="5E6B75"/>
+                </a:solidFill>
+                <a:latin typeface="Arial"/>
+              </a:defRPr>
+            </a:pPr>
+            <a:endParaRPr lang="en-US"/>
+          </a:p>
+        </c:txPr>
+        <c:crossAx val="2094734554"/>
+        <c:crosses val="autoZero"/>
+        <c:crossBetween val="between"/>
+      </c:valAx>
+      <c:spPr>
+        <a:noFill/>
+        <a:ln>
+          <a:noFill/>
+        </a:ln>
+        <a:effectLst/>
+      </c:spPr>
+    </c:plotArea>
+    <c:legend>
+      <c:legendPos val="t"/>
+      <c:overlay val="0"/>
+      <c:txPr>
+        <a:bodyPr/>
+        <a:lstStyle/>
+        <a:p>
+          <a:pPr>
+            <a:defRPr sz="1200">
+              <a:latin typeface="PingFang SC"/>
+              <a:cs typeface="PingFang SC"/>
+            </a:defRPr>
+          </a:pPr>
+          <a:endParaRPr lang="en-US"/>
+        </a:p>
+      </c:txPr>
+    </c:legend>
+    <c:plotVisOnly val="1"/>
+    <c:dispBlanksAs val="span"/>
+  </c:chart>
+  <c:spPr>
+    <a:noFill/>
+    <a:ln>
+      <a:noFill/>
+    </a:ln>
+    <a:effectLst/>
+  </c:spPr>
+  <c:externalData r:id="rId1">
+    <c:autoUpdate val="0"/>
+  </c:externalData>
+</c:chartSpace>
 </file>
 
 <file path=ppt/notesMasters/notesMaster1.xml><?xml version="1.0" encoding="utf-8"?>
@@ -1246,6 +1653,94 @@
             <a:fld id="{F7021451-1387-4CA6-816F-3879F97B5CBC}" type="slidenum">
               <a:rPr lang="en-US"/>
               <a:t>17</a:t>
+            </a:fld>
+            <a:endParaRPr lang="en-US"/>
+          </a:p>
+        </p:txBody>
+      </p:sp>
+    </p:spTree>
+    <p:extLst>
+      <p:ext uri="{BB962C8B-B14F-4D97-AF65-F5344CB8AC3E}">
+        <p14:creationId xmlns:p14="http://schemas.microsoft.com/office/powerpoint/2010/main" val="1024086991"/>
+      </p:ext>
+    </p:extLst>
+  </p:cSld>
+  <p:clrMapOvr>
+    <a:masterClrMapping/>
+  </p:clrMapOvr>
+</p:notes>
+</file>
+
+<file path=ppt/notesSlides/notesSlide18.xml><?xml version="1.0" encoding="utf-8"?>
+<p:notes xmlns:a="http://schemas.openxmlformats.org/drawingml/2006/main" xmlns:r="http://schemas.openxmlformats.org/officeDocument/2006/relationships" xmlns:p="http://schemas.openxmlformats.org/presentationml/2006/main">
+  <p:cSld>
+    <p:spTree>
+      <p:nvGrpSpPr>
+        <p:cNvPr id="1" name=""/>
+        <p:cNvGrpSpPr/>
+        <p:nvPr/>
+      </p:nvGrpSpPr>
+      <p:grpSpPr>
+        <a:xfrm>
+          <a:off x="0" y="0"/>
+          <a:ext cx="0" cy="0"/>
+          <a:chOff x="0" y="0"/>
+          <a:chExt cx="0" cy="0"/>
+        </a:xfrm>
+      </p:grpSpPr>
+      <p:sp>
+        <p:nvSpPr>
+          <p:cNvPr id="2" name="Slide Image Placeholder 1"/>
+          <p:cNvSpPr>
+            <a:spLocks noGrp="1" noRot="1" noChangeAspect="1"/>
+          </p:cNvSpPr>
+          <p:nvPr>
+            <p:ph type="sldImg"/>
+          </p:nvPr>
+        </p:nvSpPr>
+        <p:spPr/>
+      </p:sp>
+      <p:sp>
+        <p:nvSpPr>
+          <p:cNvPr id="3" name="Notes Placeholder 2"/>
+          <p:cNvSpPr>
+            <a:spLocks noGrp="1"/>
+          </p:cNvSpPr>
+          <p:nvPr>
+            <p:ph type="body" idx="1"/>
+          </p:nvPr>
+        </p:nvSpPr>
+        <p:spPr/>
+        <p:txBody>
+          <a:bodyPr/>
+          <a:lstStyle/>
+          <a:p>
+            <a:r>
+              <a:rPr lang="en-US" dirty="0"/>
+              <a:t/>
+            </a:r>
+            <a:endParaRPr lang="en-US" dirty="0"/>
+          </a:p>
+        </p:txBody>
+      </p:sp>
+      <p:sp>
+        <p:nvSpPr>
+          <p:cNvPr id="4" name="Slide Number Placeholder 3"/>
+          <p:cNvSpPr>
+            <a:spLocks noGrp="1"/>
+          </p:cNvSpPr>
+          <p:nvPr>
+            <p:ph type="sldNum" sz="quarter" idx="10"/>
+          </p:nvPr>
+        </p:nvSpPr>
+        <p:spPr/>
+        <p:txBody>
+          <a:bodyPr/>
+          <a:lstStyle/>
+          <a:p>
+            <a:fld id="{F7021451-1387-4CA6-816F-3879F97B5CBC}" type="slidenum">
+              <a:rPr lang="en-US"/>
+              <a:t>18</a:t>
             </a:fld>
             <a:endParaRPr lang="en-US"/>
           </a:p>
@@ -3255,7 +3750,7 @@
                 <a:ea typeface="PingFang SC" pitchFamily="34" charset="-122"/>
                 <a:cs typeface="PingFang SC" pitchFamily="34" charset="-120"/>
               </a:rPr>
-              <a:t>目录中已核实存在;注册 GEE 项目后需在线复核</a:t>
+              <a:t>全部数据集已于 2026-10-20 在线实测可访问</a:t>
             </a:r>
             <a:endParaRPr lang="en-US" sz="1400" dirty="0"/>
           </a:p>
@@ -5501,7 +5996,7 @@
                 <a:ea typeface="PingFang SC" pitchFamily="34" charset="-122"/>
                 <a:cs typeface="PingFang SC" pitchFamily="34" charset="-120"/>
               </a:rPr>
-              <a:t>MODIS GPP 与蒸散产品、ERA5-Land 月聚合版本本次未核验,使用前确认。</a:t>
+              <a:t>另已实测可用:MODIS GPP(MOD17A2HGF)、蒸散(MOD16A2GF)、ERA5-Land 月聚合(MONTHLY_AGGR)。</a:t>
             </a:r>
             <a:endParaRPr lang="en-US" sz="1100" dirty="0"/>
           </a:p>
@@ -9454,15 +9949,632 @@
                 <a:ea typeface="PingFang SC" pitchFamily="34" charset="-122"/>
                 <a:cs typeface="PingFang SC" pitchFamily="34" charset="-120"/>
               </a:rPr>
-              <a:t>主要风险与对策</a:t>
+              <a:t>首批实测:中国站点规模与建设前生境</a:t>
             </a:r>
             <a:endParaRPr lang="en-US" sz="3000" dirty="0"/>
+          </a:p>
+        </p:txBody>
+      </p:sp>
+      <p:sp>
+        <p:nvSpPr>
+          <p:cNvPr id="3" name="Text 1"/>
+          <p:cNvSpPr/>
+          <p:nvPr/>
+        </p:nvSpPr>
+        <p:spPr>
+          <a:xfrm>
+            <a:off x="548640" y="960120"/>
+            <a:ext cx="11094415" cy="365760"/>
+          </a:xfrm>
+          <a:prstGeom prst="rect">
+            <a:avLst/>
+          </a:prstGeom>
+          <a:noFill/>
+          <a:ln/>
+        </p:spPr>
+        <p:txBody>
+          <a:bodyPr wrap="square" lIns="0" tIns="0" rIns="0" bIns="0" rtlCol="0" anchor="ctr"/>
+          <a:lstStyle/>
+          <a:p>
+            <a:pPr indent="0" marL="0">
+              <a:buNone/>
+            </a:pPr>
+            <a:r>
+              <a:rPr lang="en-US" sz="1400" dirty="0">
+                <a:solidFill>
+                  <a:srgbClr val="5E6B75"/>
+                </a:solidFill>
+                <a:latin typeface="PingFang SC" pitchFamily="34" charset="0"/>
+                <a:ea typeface="PingFang SC" pitchFamily="34" charset="-122"/>
+                <a:cs typeface="PingFang SC" pitchFamily="34" charset="-120"/>
+              </a:rPr>
+              <a:t>GRW,项目 renewable-conservation,2026-10-20;只计 2018 年后新建站点(2017 为左删失)</a:t>
+            </a:r>
+            <a:endParaRPr lang="en-US" sz="1400" dirty="0"/>
+          </a:p>
+        </p:txBody>
+      </p:sp>
+      <p:sp>
+        <p:nvSpPr>
+          <p:cNvPr id="4" name="Shape 2"/>
+          <p:cNvSpPr/>
+          <p:nvPr/>
+        </p:nvSpPr>
+        <p:spPr>
+          <a:xfrm>
+            <a:off x="548640" y="1600200"/>
+            <a:ext cx="3291840" cy="960120"/>
+          </a:xfrm>
+          <a:prstGeom prst="roundRect">
+            <a:avLst>
+              <a:gd name="adj" fmla="val 5714"/>
+            </a:avLst>
+          </a:prstGeom>
+          <a:solidFill>
+            <a:srgbClr val="FBF1DF"/>
+          </a:solidFill>
+          <a:ln w="12700">
+            <a:solidFill>
+              <a:srgbClr val="FBF1DF"/>
+            </a:solidFill>
+            <a:prstDash val="solid"/>
+          </a:ln>
+        </p:spPr>
+      </p:sp>
+      <p:sp>
+        <p:nvSpPr>
+          <p:cNvPr id="5" name="Text 3"/>
+          <p:cNvSpPr/>
+          <p:nvPr/>
+        </p:nvSpPr>
+        <p:spPr>
+          <a:xfrm>
+            <a:off x="731520" y="1673352"/>
+            <a:ext cx="3017520" cy="502920"/>
+          </a:xfrm>
+          <a:prstGeom prst="rect">
+            <a:avLst/>
+          </a:prstGeom>
+          <a:noFill/>
+          <a:ln/>
+        </p:spPr>
+        <p:txBody>
+          <a:bodyPr wrap="square" lIns="0" tIns="0" rIns="0" bIns="0" rtlCol="0" anchor="ctr"/>
+          <a:lstStyle/>
+          <a:p>
+            <a:pPr indent="0" marL="0">
+              <a:buNone/>
+            </a:pPr>
+            <a:r>
+              <a:rPr lang="en-US" sz="2200" b="1" dirty="0">
+                <a:solidFill>
+                  <a:srgbClr val="0E2F3C"/>
+                </a:solidFill>
+                <a:latin typeface="Arial" pitchFamily="34" charset="0"/>
+                <a:ea typeface="Arial" pitchFamily="34" charset="-122"/>
+                <a:cs typeface="Arial" pitchFamily="34" charset="-120"/>
+              </a:rPr>
+              <a:t>20,231</a:t>
+            </a:r>
+            <a:endParaRPr lang="en-US" sz="2200" dirty="0"/>
+          </a:p>
+        </p:txBody>
+      </p:sp>
+      <p:sp>
+        <p:nvSpPr>
+          <p:cNvPr id="6" name="Text 4"/>
+          <p:cNvSpPr/>
+          <p:nvPr/>
+        </p:nvSpPr>
+        <p:spPr>
+          <a:xfrm>
+            <a:off x="731520" y="2148840"/>
+            <a:ext cx="3017520" cy="320040"/>
+          </a:xfrm>
+          <a:prstGeom prst="rect">
+            <a:avLst/>
+          </a:prstGeom>
+          <a:noFill/>
+          <a:ln/>
+        </p:spPr>
+        <p:txBody>
+          <a:bodyPr wrap="square" lIns="0" tIns="0" rIns="0" bIns="0" rtlCol="0" anchor="ctr"/>
+          <a:lstStyle/>
+          <a:p>
+            <a:pPr indent="0" marL="0">
+              <a:buNone/>
+            </a:pPr>
+            <a:r>
+              <a:rPr lang="en-US" sz="1200" dirty="0">
+                <a:solidFill>
+                  <a:srgbClr val="5E6B75"/>
+                </a:solidFill>
+                <a:latin typeface="PingFang SC" pitchFamily="34" charset="0"/>
+                <a:ea typeface="PingFang SC" pitchFamily="34" charset="-122"/>
+                <a:cs typeface="PingFang SC" pitchFamily="34" charset="-120"/>
+              </a:rPr>
+              <a:t>光伏地块(全部)</a:t>
+            </a:r>
+            <a:endParaRPr lang="en-US" sz="1200" dirty="0"/>
+          </a:p>
+        </p:txBody>
+      </p:sp>
+      <p:sp>
+        <p:nvSpPr>
+          <p:cNvPr id="7" name="Shape 5"/>
+          <p:cNvSpPr/>
+          <p:nvPr/>
+        </p:nvSpPr>
+        <p:spPr>
+          <a:xfrm>
+            <a:off x="548640" y="2715768"/>
+            <a:ext cx="3291840" cy="960120"/>
+          </a:xfrm>
+          <a:prstGeom prst="roundRect">
+            <a:avLst>
+              <a:gd name="adj" fmla="val 5714"/>
+            </a:avLst>
+          </a:prstGeom>
+          <a:solidFill>
+            <a:srgbClr val="EEF4F4"/>
+          </a:solidFill>
+          <a:ln w="12700">
+            <a:solidFill>
+              <a:srgbClr val="EEF4F4"/>
+            </a:solidFill>
+            <a:prstDash val="solid"/>
+          </a:ln>
+        </p:spPr>
+      </p:sp>
+      <p:sp>
+        <p:nvSpPr>
+          <p:cNvPr id="8" name="Text 6"/>
+          <p:cNvSpPr/>
+          <p:nvPr/>
+        </p:nvSpPr>
+        <p:spPr>
+          <a:xfrm>
+            <a:off x="731520" y="2788920"/>
+            <a:ext cx="3017520" cy="502920"/>
+          </a:xfrm>
+          <a:prstGeom prst="rect">
+            <a:avLst/>
+          </a:prstGeom>
+          <a:noFill/>
+          <a:ln/>
+        </p:spPr>
+        <p:txBody>
+          <a:bodyPr wrap="square" lIns="0" tIns="0" rIns="0" bIns="0" rtlCol="0" anchor="ctr"/>
+          <a:lstStyle/>
+          <a:p>
+            <a:pPr indent="0" marL="0">
+              <a:buNone/>
+            </a:pPr>
+            <a:r>
+              <a:rPr lang="en-US" sz="2200" b="1" dirty="0">
+                <a:solidFill>
+                  <a:srgbClr val="0E2F3C"/>
+                </a:solidFill>
+                <a:latin typeface="Arial" pitchFamily="34" charset="0"/>
+                <a:ea typeface="Arial" pitchFamily="34" charset="-122"/>
+                <a:cs typeface="Arial" pitchFamily="34" charset="-120"/>
+              </a:rPr>
+              <a:t>6,312 km²</a:t>
+            </a:r>
+            <a:endParaRPr lang="en-US" sz="2200" dirty="0"/>
+          </a:p>
+        </p:txBody>
+      </p:sp>
+      <p:sp>
+        <p:nvSpPr>
+          <p:cNvPr id="9" name="Text 7"/>
+          <p:cNvSpPr/>
+          <p:nvPr/>
+        </p:nvSpPr>
+        <p:spPr>
+          <a:xfrm>
+            <a:off x="731520" y="3264408"/>
+            <a:ext cx="3017520" cy="320040"/>
+          </a:xfrm>
+          <a:prstGeom prst="rect">
+            <a:avLst/>
+          </a:prstGeom>
+          <a:noFill/>
+          <a:ln/>
+        </p:spPr>
+        <p:txBody>
+          <a:bodyPr wrap="square" lIns="0" tIns="0" rIns="0" bIns="0" rtlCol="0" anchor="ctr"/>
+          <a:lstStyle/>
+          <a:p>
+            <a:pPr indent="0" marL="0">
+              <a:buNone/>
+            </a:pPr>
+            <a:r>
+              <a:rPr lang="en-US" sz="1200" dirty="0">
+                <a:solidFill>
+                  <a:srgbClr val="5E6B75"/>
+                </a:solidFill>
+                <a:latin typeface="PingFang SC" pitchFamily="34" charset="0"/>
+                <a:ea typeface="PingFang SC" pitchFamily="34" charset="-122"/>
+                <a:cs typeface="PingFang SC" pitchFamily="34" charset="-120"/>
+              </a:rPr>
+              <a:t>光伏总面积</a:t>
+            </a:r>
+            <a:endParaRPr lang="en-US" sz="1200" dirty="0"/>
+          </a:p>
+        </p:txBody>
+      </p:sp>
+      <p:sp>
+        <p:nvSpPr>
+          <p:cNvPr id="10" name="Shape 8"/>
+          <p:cNvSpPr/>
+          <p:nvPr/>
+        </p:nvSpPr>
+        <p:spPr>
+          <a:xfrm>
+            <a:off x="548640" y="3831336"/>
+            <a:ext cx="3291840" cy="960120"/>
+          </a:xfrm>
+          <a:prstGeom prst="roundRect">
+            <a:avLst>
+              <a:gd name="adj" fmla="val 5714"/>
+            </a:avLst>
+          </a:prstGeom>
+          <a:solidFill>
+            <a:srgbClr val="FBF1DF"/>
+          </a:solidFill>
+          <a:ln w="12700">
+            <a:solidFill>
+              <a:srgbClr val="FBF1DF"/>
+            </a:solidFill>
+            <a:prstDash val="solid"/>
+          </a:ln>
+        </p:spPr>
+      </p:sp>
+      <p:sp>
+        <p:nvSpPr>
+          <p:cNvPr id="11" name="Text 9"/>
+          <p:cNvSpPr/>
+          <p:nvPr/>
+        </p:nvSpPr>
+        <p:spPr>
+          <a:xfrm>
+            <a:off x="731520" y="3904488"/>
+            <a:ext cx="3017520" cy="502920"/>
+          </a:xfrm>
+          <a:prstGeom prst="rect">
+            <a:avLst/>
+          </a:prstGeom>
+          <a:noFill/>
+          <a:ln/>
+        </p:spPr>
+        <p:txBody>
+          <a:bodyPr wrap="square" lIns="0" tIns="0" rIns="0" bIns="0" rtlCol="0" anchor="ctr"/>
+          <a:lstStyle/>
+          <a:p>
+            <a:pPr indent="0" marL="0">
+              <a:buNone/>
+            </a:pPr>
+            <a:r>
+              <a:rPr lang="en-US" sz="2200" b="1" dirty="0">
+                <a:solidFill>
+                  <a:srgbClr val="0E2F3C"/>
+                </a:solidFill>
+                <a:latin typeface="Arial" pitchFamily="34" charset="0"/>
+                <a:ea typeface="Arial" pitchFamily="34" charset="-122"/>
+                <a:cs typeface="Arial" pitchFamily="34" charset="-120"/>
+              </a:rPr>
+              <a:t>119,974</a:t>
+            </a:r>
+            <a:endParaRPr lang="en-US" sz="2200" dirty="0"/>
+          </a:p>
+        </p:txBody>
+      </p:sp>
+      <p:sp>
+        <p:nvSpPr>
+          <p:cNvPr id="12" name="Text 10"/>
+          <p:cNvSpPr/>
+          <p:nvPr/>
+        </p:nvSpPr>
+        <p:spPr>
+          <a:xfrm>
+            <a:off x="731520" y="4379976"/>
+            <a:ext cx="3017520" cy="320040"/>
+          </a:xfrm>
+          <a:prstGeom prst="rect">
+            <a:avLst/>
+          </a:prstGeom>
+          <a:noFill/>
+          <a:ln/>
+        </p:spPr>
+        <p:txBody>
+          <a:bodyPr wrap="square" lIns="0" tIns="0" rIns="0" bIns="0" rtlCol="0" anchor="ctr"/>
+          <a:lstStyle/>
+          <a:p>
+            <a:pPr indent="0" marL="0">
+              <a:buNone/>
+            </a:pPr>
+            <a:r>
+              <a:rPr lang="en-US" sz="1200" dirty="0">
+                <a:solidFill>
+                  <a:srgbClr val="5E6B75"/>
+                </a:solidFill>
+                <a:latin typeface="PingFang SC" pitchFamily="34" charset="0"/>
+                <a:ea typeface="PingFang SC" pitchFamily="34" charset="-122"/>
+                <a:cs typeface="PingFang SC" pitchFamily="34" charset="-120"/>
+              </a:rPr>
+              <a:t>风机(全部)</a:t>
+            </a:r>
+            <a:endParaRPr lang="en-US" sz="1200" dirty="0"/>
+          </a:p>
+        </p:txBody>
+      </p:sp>
+      <p:sp>
+        <p:nvSpPr>
+          <p:cNvPr id="13" name="Shape 11"/>
+          <p:cNvSpPr/>
+          <p:nvPr/>
+        </p:nvSpPr>
+        <p:spPr>
+          <a:xfrm>
+            <a:off x="548640" y="4946904"/>
+            <a:ext cx="3291840" cy="960120"/>
+          </a:xfrm>
+          <a:prstGeom prst="roundRect">
+            <a:avLst>
+              <a:gd name="adj" fmla="val 5714"/>
+            </a:avLst>
+          </a:prstGeom>
+          <a:solidFill>
+            <a:srgbClr val="EEF4F4"/>
+          </a:solidFill>
+          <a:ln w="12700">
+            <a:solidFill>
+              <a:srgbClr val="EEF4F4"/>
+            </a:solidFill>
+            <a:prstDash val="solid"/>
+          </a:ln>
+        </p:spPr>
+      </p:sp>
+      <p:sp>
+        <p:nvSpPr>
+          <p:cNvPr id="14" name="Text 12"/>
+          <p:cNvSpPr/>
+          <p:nvPr/>
+        </p:nvSpPr>
+        <p:spPr>
+          <a:xfrm>
+            <a:off x="731520" y="5020056"/>
+            <a:ext cx="3017520" cy="502920"/>
+          </a:xfrm>
+          <a:prstGeom prst="rect">
+            <a:avLst/>
+          </a:prstGeom>
+          <a:noFill/>
+          <a:ln/>
+        </p:spPr>
+        <p:txBody>
+          <a:bodyPr wrap="square" lIns="0" tIns="0" rIns="0" bIns="0" rtlCol="0" anchor="ctr"/>
+          <a:lstStyle/>
+          <a:p>
+            <a:pPr indent="0" marL="0">
+              <a:buNone/>
+            </a:pPr>
+            <a:r>
+              <a:rPr lang="en-US" sz="2200" b="1" dirty="0">
+                <a:solidFill>
+                  <a:srgbClr val="0E2F3C"/>
+                </a:solidFill>
+                <a:latin typeface="Arial" pitchFamily="34" charset="0"/>
+                <a:ea typeface="Arial" pitchFamily="34" charset="-122"/>
+                <a:cs typeface="Arial" pitchFamily="34" charset="-120"/>
+              </a:rPr>
+              <a:t>14,421 · 72,838</a:t>
+            </a:r>
+            <a:endParaRPr lang="en-US" sz="2200" dirty="0"/>
+          </a:p>
+        </p:txBody>
+      </p:sp>
+      <p:sp>
+        <p:nvSpPr>
+          <p:cNvPr id="15" name="Text 13"/>
+          <p:cNvSpPr/>
+          <p:nvPr/>
+        </p:nvSpPr>
+        <p:spPr>
+          <a:xfrm>
+            <a:off x="731520" y="5495544"/>
+            <a:ext cx="3017520" cy="320040"/>
+          </a:xfrm>
+          <a:prstGeom prst="rect">
+            <a:avLst/>
+          </a:prstGeom>
+          <a:noFill/>
+          <a:ln/>
+        </p:spPr>
+        <p:txBody>
+          <a:bodyPr wrap="square" lIns="0" tIns="0" rIns="0" bIns="0" rtlCol="0" anchor="ctr"/>
+          <a:lstStyle/>
+          <a:p>
+            <a:pPr indent="0" marL="0">
+              <a:buNone/>
+            </a:pPr>
+            <a:r>
+              <a:rPr lang="en-US" sz="1200" dirty="0">
+                <a:solidFill>
+                  <a:srgbClr val="5E6B75"/>
+                </a:solidFill>
+                <a:latin typeface="PingFang SC" pitchFamily="34" charset="0"/>
+                <a:ea typeface="PingFang SC" pitchFamily="34" charset="-122"/>
+                <a:cs typeface="PingFang SC" pitchFamily="34" charset="-120"/>
+              </a:rPr>
+              <a:t>2018 年后新建光伏 · 风机</a:t>
+            </a:r>
+            <a:endParaRPr lang="en-US" sz="1200" dirty="0"/>
           </a:p>
         </p:txBody>
       </p:sp>
       <p:graphicFrame>
         <p:nvGraphicFramePr>
-          <p:cNvPr id="16" name="Table 0"/>
+          <p:cNvPr id="16" name="Chart 0" descr=""/>
+          <p:cNvGraphicFramePr/>
+          <p:nvPr/>
+        </p:nvGraphicFramePr>
+        <p:xfrm>
+          <a:off x="4114800" y="1463040"/>
+          <a:ext cx="7498080" cy="4206240"/>
+        </p:xfrm>
+        <a:graphic xmlns:a="http://schemas.openxmlformats.org/drawingml/2006/main">
+          <a:graphicData uri="http://schemas.openxmlformats.org/drawingml/2006/chart">
+            <c:chart xmlns:c="http://schemas.openxmlformats.org/drawingml/2006/chart" r:id="rId1"/>
+          </a:graphicData>
+        </a:graphic>
+      </p:graphicFrame>
+      <p:sp>
+        <p:nvSpPr>
+          <p:cNvPr id="17" name="Text 14"/>
+          <p:cNvSpPr/>
+          <p:nvPr/>
+        </p:nvSpPr>
+        <p:spPr>
+          <a:xfrm>
+            <a:off x="4114800" y="5806440"/>
+            <a:ext cx="7498080" cy="548640"/>
+          </a:xfrm>
+          <a:prstGeom prst="rect">
+            <a:avLst/>
+          </a:prstGeom>
+          <a:noFill/>
+          <a:ln/>
+        </p:spPr>
+        <p:txBody>
+          <a:bodyPr wrap="square" lIns="0" tIns="0" rIns="0" bIns="0" rtlCol="0" anchor="ctr"/>
+          <a:lstStyle/>
+          <a:p>
+            <a:pPr indent="0" marL="0">
+              <a:buNone/>
+            </a:pPr>
+            <a:r>
+              <a:rPr lang="en-US" sz="1150" dirty="0">
+                <a:solidFill>
+                  <a:srgbClr val="5E6B75"/>
+                </a:solidFill>
+                <a:latin typeface="PingFang SC" pitchFamily="34" charset="0"/>
+                <a:ea typeface="PingFang SC" pitchFamily="34" charset="-122"/>
+                <a:cs typeface="PingFang SC" pitchFamily="34" charset="-120"/>
+              </a:rPr>
+              <a:t>提示:ESA CCI 为 300 m 粗分辨率;2018 年建成站点的"2018 年覆盖"可能已是建成后状态,正式分析改用建设前一年的 30 m 年度土地覆盖。</a:t>
+            </a:r>
+            <a:endParaRPr lang="en-US" sz="1150" dirty="0"/>
+          </a:p>
+        </p:txBody>
+      </p:sp>
+      <p:sp>
+        <p:nvSpPr>
+          <p:cNvPr id="18" name="Text 15"/>
+          <p:cNvSpPr/>
+          <p:nvPr/>
+        </p:nvSpPr>
+        <p:spPr>
+          <a:xfrm>
+            <a:off x="11277295" y="6400800"/>
+            <a:ext cx="457200" cy="274320"/>
+          </a:xfrm>
+          <a:prstGeom prst="rect">
+            <a:avLst/>
+          </a:prstGeom>
+          <a:noFill/>
+          <a:ln/>
+        </p:spPr>
+        <p:txBody>
+          <a:bodyPr wrap="square" lIns="0" tIns="0" rIns="0" bIns="0" rtlCol="0" anchor="ctr"/>
+          <a:lstStyle/>
+          <a:p>
+            <a:pPr algn="r" indent="0" marL="0">
+              <a:buNone/>
+            </a:pPr>
+            <a:r>
+              <a:rPr lang="en-US" sz="1000" dirty="0">
+                <a:solidFill>
+                  <a:srgbClr val="5E6B75"/>
+                </a:solidFill>
+                <a:latin typeface="Arial" pitchFamily="34" charset="0"/>
+                <a:ea typeface="Arial" pitchFamily="34" charset="-122"/>
+                <a:cs typeface="Arial" pitchFamily="34" charset="-120"/>
+              </a:rPr>
+              <a:t>15</a:t>
+            </a:r>
+            <a:endParaRPr lang="en-US" sz="1000" dirty="0"/>
+          </a:p>
+        </p:txBody>
+      </p:sp>
+    </p:spTree>
+  </p:cSld>
+  <p:clrMapOvr>
+    <a:masterClrMapping/>
+  </p:clrMapOvr>
+</p:sld>
+</file>
+
+<file path=ppt/slides/slide16.xml><?xml version="1.0" encoding="utf-8"?>
+<p:sld xmlns:a="http://schemas.openxmlformats.org/drawingml/2006/main" xmlns:r="http://schemas.openxmlformats.org/officeDocument/2006/relationships" xmlns:p="http://schemas.openxmlformats.org/presentationml/2006/main">
+  <p:cSld name="Slide 16">
+    <p:spTree>
+      <p:nvGrpSpPr>
+        <p:cNvPr id="1" name=""/>
+        <p:cNvGrpSpPr/>
+        <p:nvPr/>
+      </p:nvGrpSpPr>
+      <p:grpSpPr>
+        <a:xfrm>
+          <a:off x="0" y="0"/>
+          <a:ext cx="0" cy="0"/>
+          <a:chOff x="0" y="0"/>
+          <a:chExt cx="0" cy="0"/>
+        </a:xfrm>
+      </p:grpSpPr>
+      <p:sp>
+        <p:nvSpPr>
+          <p:cNvPr id="2" name="Text 0"/>
+          <p:cNvSpPr/>
+          <p:nvPr/>
+        </p:nvSpPr>
+        <p:spPr>
+          <a:xfrm>
+            <a:off x="548640" y="320040"/>
+            <a:ext cx="11094415" cy="685800"/>
+          </a:xfrm>
+          <a:prstGeom prst="rect">
+            <a:avLst/>
+          </a:prstGeom>
+          <a:noFill/>
+          <a:ln/>
+        </p:spPr>
+        <p:txBody>
+          <a:bodyPr wrap="square" lIns="0" tIns="0" rIns="0" bIns="0" rtlCol="0" anchor="ctr"/>
+          <a:lstStyle/>
+          <a:p>
+            <a:pPr indent="0" marL="0">
+              <a:buNone/>
+            </a:pPr>
+            <a:r>
+              <a:rPr lang="en-US" sz="3000" b="1" dirty="0">
+                <a:solidFill>
+                  <a:srgbClr val="0E2F3C"/>
+                </a:solidFill>
+                <a:latin typeface="PingFang SC" pitchFamily="34" charset="0"/>
+                <a:ea typeface="PingFang SC" pitchFamily="34" charset="-122"/>
+                <a:cs typeface="PingFang SC" pitchFamily="34" charset="-120"/>
+              </a:rPr>
+              <a:t>主要风险与对策</a:t>
+            </a:r>
+            <a:endParaRPr lang="en-US" sz="3000" dirty="0"/>
+          </a:p>
+        </p:txBody>
+      </p:sp>
+      <p:graphicFrame>
+        <p:nvGraphicFramePr>
+          <p:cNvPr id="17" name="Table 0"/>
           <p:cNvGraphicFramePr>
             <a:graphicFrameLocks noGrp="1"/>
           </p:cNvGraphicFramePr>
@@ -10453,7 +11565,7 @@
                 <a:ea typeface="Arial" pitchFamily="34" charset="-122"/>
                 <a:cs typeface="Arial" pitchFamily="34" charset="-120"/>
               </a:rPr>
-              <a:t>15</a:t>
+              <a:t>16</a:t>
             </a:r>
             <a:endParaRPr lang="en-US" sz="1000" dirty="0"/>
           </a:p>
@@ -10467,9 +11579,9 @@
 </p:sld>
 </file>
 
-<file path=ppt/slides/slide16.xml><?xml version="1.0" encoding="utf-8"?>
+<file path=ppt/slides/slide17.xml><?xml version="1.0" encoding="utf-8"?>
 <p:sld xmlns:a="http://schemas.openxmlformats.org/drawingml/2006/main" xmlns:r="http://schemas.openxmlformats.org/officeDocument/2006/relationships" xmlns:p="http://schemas.openxmlformats.org/presentationml/2006/main">
-  <p:cSld name="Slide 16">
+  <p:cSld name="Slide 17">
     <p:spTree>
       <p:nvGrpSpPr>
         <p:cNvPr id="1" name=""/>
@@ -10798,7 +11910,7 @@
                 <a:ea typeface="Arial" pitchFamily="34" charset="-122"/>
                 <a:cs typeface="Arial" pitchFamily="34" charset="-120"/>
               </a:rPr>
-              <a:t>16</a:t>
+              <a:t>17</a:t>
             </a:r>
             <a:endParaRPr lang="en-US" sz="1000" dirty="0"/>
           </a:p>
@@ -10812,9 +11924,9 @@
 </p:sld>
 </file>
 
-<file path=ppt/slides/slide17.xml><?xml version="1.0" encoding="utf-8"?>
+<file path=ppt/slides/slide18.xml><?xml version="1.0" encoding="utf-8"?>
 <p:sld xmlns:a="http://schemas.openxmlformats.org/drawingml/2006/main" xmlns:r="http://schemas.openxmlformats.org/officeDocument/2006/relationships" xmlns:p="http://schemas.openxmlformats.org/presentationml/2006/main">
-  <p:cSld name="Slide 17">
+  <p:cSld name="Slide 18">
     <p:bg>
       <p:bgPr>
         <a:solidFill>
@@ -10972,7 +12084,7 @@
                 <a:ea typeface="PingFang SC" pitchFamily="34" charset="-122"/>
                 <a:cs typeface="PingFang SC" pitchFamily="34" charset="-120"/>
               </a:rPr>
-              <a:t>注册 GEE 非商业项目,跑通起步脚本,统计中国站点的季度分布</a:t>
+              <a:t>GEE 项目已注册;按实测字段跑通起步脚本,导出中国站点</a:t>
             </a:r>
             <a:endParaRPr lang="en-US" sz="1800" dirty="0"/>
           </a:p>
@@ -18562,7 +19674,7 @@
                 <a:ea typeface="PingFang SC" pitchFamily="34" charset="-122"/>
                 <a:cs typeface="PingFang SC" pitchFamily="34" charset="-120"/>
               </a:rPr>
-              <a:t>主数据:GRW 光伏与风电,筛选 country_code = CHN,保留 construction_date</a:t>
+              <a:t>主数据:GRW 光伏与风电,筛选 COUNTRY = China,保留 construction_year 与 construction_quarter;2017 年为左删失</a:t>
             </a:r>
             <a:endParaRPr lang="en-US" sz="1300" dirty="0"/>
           </a:p>

</xml_diff>

<commit_message>
Add CLCD v1.0.5 (1985-2025) as primary pre-construction land cover source
</commit_message>
<xml_diff>
--- a/RS_Renewables_Biodiversity_Workflow.pptx
+++ b/RS_Renewables_Biodiversity_Workflow.pptx
@@ -7975,7 +7975,7 @@
                           <a:ea typeface="PingFang SC" pitchFamily="34" charset="-122"/>
                           <a:cs typeface="PingFang SC" pitchFamily="34" charset="-120"/>
                         </a:rPr>
-                        <a:t>CLCD</a:t>
+                        <a:t>CLCD v1.0.5</a:t>
                       </a:r>
                       <a:endParaRPr lang="en-US" sz="1100" dirty="0">
                         <a:latin typeface="PingFang SC" charset="0"/>
@@ -8040,7 +8040,7 @@
                           <a:ea typeface="PingFang SC" pitchFamily="34" charset="-122"/>
                           <a:cs typeface="PingFang SC" pitchFamily="34" charset="-120"/>
                         </a:rPr>
-                        <a:t>中国逐年 30 m 土地覆盖(Yang &amp; Huang 2021)</a:t>
+                        <a:t>中国逐年 30 m 土地覆盖 1985–2025(Yang &amp; Huang 2026,Zenodo,CC BY 4.0)</a:t>
                       </a:r>
                       <a:endParaRPr lang="en-US" sz="1100" dirty="0">
                         <a:latin typeface="PingFang SC" charset="0"/>
@@ -8105,7 +8105,7 @@
                           <a:ea typeface="PingFang SC" pitchFamily="34" charset="-122"/>
                           <a:cs typeface="PingFang SC" pitchFamily="34" charset="-120"/>
                         </a:rPr>
-                        <a:t>Zenodo 下载后上传为 GEE 资产;先核对最新版本</a:t>
+                        <a:t>doi:10.5281/zenodo.18180184;需 2017–2023 年 7 幅,约 5.7 GB</a:t>
                       </a:r>
                       <a:endParaRPr lang="en-US" sz="1100" dirty="0">
                         <a:latin typeface="PingFang SC" charset="0"/>
@@ -23538,7 +23538,7 @@
                 <a:ea typeface="PingFang SC" pitchFamily="34" charset="-122"/>
                 <a:cs typeface="PingFang SC" pitchFamily="34" charset="-120"/>
               </a:rPr>
-              <a:t>建设前生境:建设前一年年度土地覆盖(GLC_FCS30D;中国专题用 CLCD)</a:t>
+              <a:t>建设前生境:建设前一年年度土地覆盖(CLCD 1985–2025 为主,GLC_FCS30D 交叉核对)</a:t>
             </a:r>
             <a:endParaRPr lang="en-US" sz="1300" dirty="0"/>
           </a:p>

</xml_diff>

<commit_message>
G1 triple check (visual + TZ-SAM), wind 30 m pre-construction cover, CLCD script
- gee/05: Sentinel-2 quarterly strips for the 23 sites where the automatic
  break disagreed with GRW; visual calls in results/g1_visual_calls.csv
- gee/06-07: GRW vs TZ-SAM max-overlap join; 79.6% consistent, 14.8% GRW
  late (median 4.1 quarters), 5.6% early (n = 7,987)
- gee/08: prior-year GLC_FCS30D cover for 72,837 post-2018 turbines
- gee/04: CLCD v1.0.5 extraction with local-file mode (remote range reads
  are rate-limited by Zenodo)
- Page and deck: revised G1 rule, wind results
</commit_message>
<xml_diff>
--- a/RS_Renewables_Biodiversity_Workflow.pptx
+++ b/RS_Renewables_Biodiversity_Workflow.pptx
@@ -11846,7 +11846,7 @@
                 <a:ea typeface="PingFang SC" pitchFamily="34" charset="-122"/>
                 <a:cs typeface="PingFang SC" pitchFamily="34" charset="-120"/>
               </a:rPr>
-              <a:t>按站点数,近一半建在耕地上。对照 GRW 自带 ESA CCI 2018(300 m):裸地 33.2%、草地 31.2%、耕地 26.5%。风机(ESA CCI,按数量):草地 34.9%、裸地 21.8%、耕地 19.4%、森林 12.2%。</a:t>
+              <a:t>按站点数,近一半建在耕地上。对照 GRW 自带 ESA CCI 2018(300 m):裸地 33.2%、草地 31.2%、耕地 26.5%。风机(GLC_FCS30D 前一年 30 m,72,837 台):裸地 32.9%、耕地 23.3%、草地 21.2%、森林 6.3%(ESA CCI 300 m 给出森林 12.2%,高估约一倍)。</a:t>
             </a:r>
             <a:endParaRPr lang="en-US" sz="1150" dirty="0"/>
           </a:p>
@@ -11949,7 +11949,7 @@
                 <a:ea typeface="PingFang SC" pitchFamily="34" charset="-122"/>
                 <a:cs typeface="PingFang SC" pitchFamily="34" charset="-120"/>
               </a:rPr>
-              <a:t>选址急转向裸地 · G1 日期校验</a:t>
+              <a:t>选址急转向裸地 · G1 日期三重核对</a:t>
             </a:r>
             <a:endParaRPr lang="en-US" sz="3000" dirty="0"/>
           </a:p>
@@ -11988,7 +11988,7 @@
                 <a:ea typeface="PingFang SC" pitchFamily="34" charset="-122"/>
                 <a:cs typeface="PingFang SC" pitchFamily="34" charset="-120"/>
               </a:rPr>
-              <a:t>建设前一年 30 m 覆盖按建设年份;哨兵-2 季节 + 阶跃模型,100 站</a:t>
+              <a:t>左:建设前一年 30 m 覆盖按建设年份;右:哨兵-2 自动断点、目视复核、TZ-SAM 独立日期</a:t>
             </a:r>
             <a:endParaRPr lang="en-US" sz="1400" dirty="0"/>
           </a:p>
@@ -12066,6 +12066,111 @@
             </a:avLst>
           </a:prstGeom>
           <a:solidFill>
+            <a:srgbClr val="F3E7E4"/>
+          </a:solidFill>
+          <a:ln w="12700">
+            <a:solidFill>
+              <a:srgbClr val="F3E7E4"/>
+            </a:solidFill>
+            <a:prstDash val="solid"/>
+          </a:ln>
+        </p:spPr>
+      </p:sp>
+      <p:sp>
+        <p:nvSpPr>
+          <p:cNvPr id="7" name="Text 4"/>
+          <p:cNvSpPr/>
+          <p:nvPr/>
+        </p:nvSpPr>
+        <p:spPr>
+          <a:xfrm>
+            <a:off x="7772400" y="1536192"/>
+            <a:ext cx="3749040" cy="457200"/>
+          </a:xfrm>
+          <a:prstGeom prst="rect">
+            <a:avLst/>
+          </a:prstGeom>
+          <a:noFill/>
+          <a:ln/>
+        </p:spPr>
+        <p:txBody>
+          <a:bodyPr wrap="square" lIns="0" tIns="0" rIns="0" bIns="0" rtlCol="0" anchor="ctr"/>
+          <a:lstStyle/>
+          <a:p>
+            <a:pPr indent="0" marL="0">
+              <a:buNone/>
+            </a:pPr>
+            <a:r>
+              <a:rPr lang="en-US" sz="2200" b="1" dirty="0">
+                <a:solidFill>
+                  <a:srgbClr val="0E2F3C"/>
+                </a:solidFill>
+                <a:latin typeface="Arial" pitchFamily="34" charset="0"/>
+                <a:ea typeface="Arial" pitchFamily="34" charset="-122"/>
+                <a:cs typeface="Arial" pitchFamily="34" charset="-120"/>
+              </a:rPr>
+              <a:t>77%</a:t>
+            </a:r>
+            <a:endParaRPr lang="en-US" sz="2200" dirty="0"/>
+          </a:p>
+        </p:txBody>
+      </p:sp>
+      <p:sp>
+        <p:nvSpPr>
+          <p:cNvPr id="8" name="Text 5"/>
+          <p:cNvSpPr/>
+          <p:nvPr/>
+        </p:nvSpPr>
+        <p:spPr>
+          <a:xfrm>
+            <a:off x="7772400" y="2011680"/>
+            <a:ext cx="3749040" cy="457200"/>
+          </a:xfrm>
+          <a:prstGeom prst="rect">
+            <a:avLst/>
+          </a:prstGeom>
+          <a:noFill/>
+          <a:ln/>
+        </p:spPr>
+        <p:txBody>
+          <a:bodyPr wrap="square" lIns="0" tIns="0" rIns="0" bIns="0" rtlCol="0" anchor="ctr"/>
+          <a:lstStyle/>
+          <a:p>
+            <a:pPr indent="0" marL="0">
+              <a:buNone/>
+            </a:pPr>
+            <a:r>
+              <a:rPr lang="en-US" sz="1150" dirty="0">
+                <a:solidFill>
+                  <a:srgbClr val="1D2A33"/>
+                </a:solidFill>
+                <a:latin typeface="PingFang SC" pitchFamily="34" charset="0"/>
+                <a:ea typeface="PingFang SC" pitchFamily="34" charset="-122"/>
+                <a:cs typeface="PingFang SC" pitchFamily="34" charset="-120"/>
+              </a:rPr>
+              <a:t>哨兵-2 自动断点在 GRW 季度 ±2 内(100 站;预设 85%)</a:t>
+            </a:r>
+            <a:endParaRPr lang="en-US" sz="1150" dirty="0"/>
+          </a:p>
+        </p:txBody>
+      </p:sp>
+      <p:sp>
+        <p:nvSpPr>
+          <p:cNvPr id="9" name="Shape 6"/>
+          <p:cNvSpPr/>
+          <p:nvPr/>
+        </p:nvSpPr>
+        <p:spPr>
+          <a:xfrm>
+            <a:off x="7589520" y="2670048"/>
+            <a:ext cx="4069080" cy="1051560"/>
+          </a:xfrm>
+          <a:prstGeom prst="roundRect">
+            <a:avLst>
+              <a:gd name="adj" fmla="val 5217"/>
+            </a:avLst>
+          </a:prstGeom>
+          <a:solidFill>
             <a:srgbClr val="EEF4F4"/>
           </a:solidFill>
           <a:ln w="12700">
@@ -12078,13 +12183,13 @@
       </p:sp>
       <p:sp>
         <p:nvSpPr>
-          <p:cNvPr id="7" name="Text 4"/>
-          <p:cNvSpPr/>
-          <p:nvPr/>
-        </p:nvSpPr>
-        <p:spPr>
-          <a:xfrm>
-            <a:off x="7772400" y="1536192"/>
+          <p:cNvPr id="10" name="Text 7"/>
+          <p:cNvSpPr/>
+          <p:nvPr/>
+        </p:nvSpPr>
+        <p:spPr>
+          <a:xfrm>
+            <a:off x="7772400" y="2743200"/>
             <a:ext cx="3749040" cy="457200"/>
           </a:xfrm>
           <a:prstGeom prst="rect">
@@ -12109,7 +12214,7 @@
                 <a:ea typeface="Arial" pitchFamily="34" charset="-122"/>
                 <a:cs typeface="Arial" pitchFamily="34" charset="-120"/>
               </a:rPr>
-              <a:t>0 与 −1</a:t>
+              <a:t>79.6%</a:t>
             </a:r>
             <a:endParaRPr lang="en-US" sz="2200" dirty="0"/>
           </a:p>
@@ -12117,13 +12222,13 @@
       </p:sp>
       <p:sp>
         <p:nvSpPr>
-          <p:cNvPr id="8" name="Text 5"/>
-          <p:cNvSpPr/>
-          <p:nvPr/>
-        </p:nvSpPr>
-        <p:spPr>
-          <a:xfrm>
-            <a:off x="7772400" y="2011680"/>
+          <p:cNvPr id="11" name="Text 8"/>
+          <p:cNvSpPr/>
+          <p:nvPr/>
+        </p:nvSpPr>
+        <p:spPr>
+          <a:xfrm>
+            <a:off x="7772400" y="3218688"/>
             <a:ext cx="3749040" cy="457200"/>
           </a:xfrm>
           <a:prstGeom prst="rect">
@@ -12148,112 +12253,7 @@
                 <a:ea typeface="PingFang SC" pitchFamily="34" charset="-122"/>
                 <a:cs typeface="PingFang SC" pitchFamily="34" charset="-120"/>
               </a:rPr>
-              <a:t>断点众数:地表变化多在 GRW 季度或前一季度</a:t>
-            </a:r>
-            <a:endParaRPr lang="en-US" sz="1150" dirty="0"/>
-          </a:p>
-        </p:txBody>
-      </p:sp>
-      <p:sp>
-        <p:nvSpPr>
-          <p:cNvPr id="9" name="Shape 6"/>
-          <p:cNvSpPr/>
-          <p:nvPr/>
-        </p:nvSpPr>
-        <p:spPr>
-          <a:xfrm>
-            <a:off x="7589520" y="2670048"/>
-            <a:ext cx="4069080" cy="1051560"/>
-          </a:xfrm>
-          <a:prstGeom prst="roundRect">
-            <a:avLst>
-              <a:gd name="adj" fmla="val 5217"/>
-            </a:avLst>
-          </a:prstGeom>
-          <a:solidFill>
-            <a:srgbClr val="F3E7E4"/>
-          </a:solidFill>
-          <a:ln w="12700">
-            <a:solidFill>
-              <a:srgbClr val="F3E7E4"/>
-            </a:solidFill>
-            <a:prstDash val="solid"/>
-          </a:ln>
-        </p:spPr>
-      </p:sp>
-      <p:sp>
-        <p:nvSpPr>
-          <p:cNvPr id="10" name="Text 7"/>
-          <p:cNvSpPr/>
-          <p:nvPr/>
-        </p:nvSpPr>
-        <p:spPr>
-          <a:xfrm>
-            <a:off x="7772400" y="2743200"/>
-            <a:ext cx="3749040" cy="457200"/>
-          </a:xfrm>
-          <a:prstGeom prst="rect">
-            <a:avLst/>
-          </a:prstGeom>
-          <a:noFill/>
-          <a:ln/>
-        </p:spPr>
-        <p:txBody>
-          <a:bodyPr wrap="square" lIns="0" tIns="0" rIns="0" bIns="0" rtlCol="0" anchor="ctr"/>
-          <a:lstStyle/>
-          <a:p>
-            <a:pPr indent="0" marL="0">
-              <a:buNone/>
-            </a:pPr>
-            <a:r>
-              <a:rPr lang="en-US" sz="2200" b="1" dirty="0">
-                <a:solidFill>
-                  <a:srgbClr val="0E2F3C"/>
-                </a:solidFill>
-                <a:latin typeface="Arial" pitchFamily="34" charset="0"/>
-                <a:ea typeface="Arial" pitchFamily="34" charset="-122"/>
-                <a:cs typeface="Arial" pitchFamily="34" charset="-120"/>
-              </a:rPr>
-              <a:t>77%</a:t>
-            </a:r>
-            <a:endParaRPr lang="en-US" sz="2200" dirty="0"/>
-          </a:p>
-        </p:txBody>
-      </p:sp>
-      <p:sp>
-        <p:nvSpPr>
-          <p:cNvPr id="11" name="Text 8"/>
-          <p:cNvSpPr/>
-          <p:nvPr/>
-        </p:nvSpPr>
-        <p:spPr>
-          <a:xfrm>
-            <a:off x="7772400" y="3218688"/>
-            <a:ext cx="3749040" cy="457200"/>
-          </a:xfrm>
-          <a:prstGeom prst="rect">
-            <a:avLst/>
-          </a:prstGeom>
-          <a:noFill/>
-          <a:ln/>
-        </p:spPr>
-        <p:txBody>
-          <a:bodyPr wrap="square" lIns="0" tIns="0" rIns="0" bIns="0" rtlCol="0" anchor="ctr"/>
-          <a:lstStyle/>
-          <a:p>
-            <a:pPr indent="0" marL="0">
-              <a:buNone/>
-            </a:pPr>
-            <a:r>
-              <a:rPr lang="en-US" sz="1150" dirty="0">
-                <a:solidFill>
-                  <a:srgbClr val="1D2A33"/>
-                </a:solidFill>
-                <a:latin typeface="PingFang SC" pitchFamily="34" charset="0"/>
-                <a:ea typeface="PingFang SC" pitchFamily="34" charset="-122"/>
-                <a:cs typeface="PingFang SC" pitchFamily="34" charset="-120"/>
-              </a:rPr>
-              <a:t>断点在 GRW 季度 ±2 内;低于预设 85%,G1 整体未通过</a:t>
+              <a:t>与 TZ-SAM 建设时间上下界一致(n = 7,987)</a:t>
             </a:r>
             <a:endParaRPr lang="en-US" sz="1150" dirty="0"/>
           </a:p>
@@ -12319,7 +12319,7 @@
                 <a:ea typeface="Arial" pitchFamily="34" charset="-122"/>
                 <a:cs typeface="Arial" pitchFamily="34" charset="-120"/>
               </a:rPr>
-              <a:t>96%</a:t>
+              <a:t>14.8%</a:t>
             </a:r>
             <a:endParaRPr lang="en-US" sz="2200" dirty="0"/>
           </a:p>
@@ -12358,7 +12358,7 @@
                 <a:ea typeface="PingFang SC" pitchFamily="34" charset="-122"/>
                 <a:cs typeface="PingFang SC" pitchFamily="34" charset="-120"/>
               </a:rPr>
-              <a:t>阶跃信号较强的一半站点落在 ±2 内</a:t>
+              <a:t>GRW 偏晚,中位数晚 4.1 季;目视复核 6 站中 5 站与 TZ 互证</a:t>
             </a:r>
             <a:endParaRPr lang="en-US" sz="1150" dirty="0"/>
           </a:p>
@@ -12397,7 +12397,7 @@
                 <a:ea typeface="PingFang SC" pitchFamily="34" charset="-122"/>
                 <a:cs typeface="PingFang SC" pitchFamily="34" charset="-120"/>
               </a:rPr>
-              <a:t>对策:GRW 季度前 2 季至当季设为过渡期;主分析用强信号站点,其余用年度窗作稳健性检验。自动判读,目视复核待做。</a:t>
+              <a:t>对策:主样本只用 GRW 与 TZ-SAM 一致的 6,355 站;处理时点取两者较早者;GRW 季度前 2 季至当季为过渡期。</a:t>
             </a:r>
             <a:endParaRPr lang="en-US" sz="1150" dirty="0"/>
           </a:p>
@@ -15187,7 +15187,7 @@
                 <a:ea typeface="PingFang SC" pitchFamily="34" charset="-122"/>
                 <a:cs typeface="PingFang SC" pitchFamily="34" charset="-120"/>
               </a:rPr>
-              <a:t>G1 自动判读 77%:目视复核强弱信号站点,定稿过渡期规则</a:t>
+              <a:t>下载 CLCD 2017–2023,复算光伏与风机的建设前覆盖</a:t>
             </a:r>
             <a:endParaRPr lang="en-US" sz="1800" dirty="0"/>
           </a:p>

</xml_diff>

<commit_message>
CLCD v1.0.5 recompute and NW dryland staggered-DiD pilot
- gee/04 run on local CLCD 2017-2023 (MD5 verified); gee/10 compares CLCD
  with GLC_FCS30D: barren shift and size split hold in both; dominant
  class agrees for 75.5% of PV sites; forest share of wind turbines is
  12.5% (CLCD) vs 6.3% (GLC), so the earlier 'CCI overestimates forest'
  claim is withdrawn and a range is reported
- gee/09 + analysis/: 365 NW sites, Landsat NDVI mean/SD on site and in a
  60-500 m ring, Callaway-Sant'Anna and Sun-Abraham; on-site pre-trend
  comparable to the effect (G2 not met); ring flat pre-trend, no spillover
- Page and deck: CLCD columns, wind correction, pilot section and slide
</commit_message>
<xml_diff>
--- a/RS_Renewables_Biodiversity_Workflow.pptx
+++ b/RS_Renewables_Biodiversity_Workflow.pptx
@@ -25,9 +25,10 @@
     <p:sldId id="273" r:id="rId19"/>
     <p:sldId id="274" r:id="rId20"/>
     <p:sldId id="275" r:id="rId21"/>
+    <p:sldId id="276" r:id="rId22"/>
   </p:sldIdLst>
   <p:notesMasterIdLst>
-    <p:notesMasterId r:id="rId22"/>
+    <p:notesMasterId r:id="rId23"/>
   </p:notesMasterIdLst>
   <p:sldSz cx="12192000" cy="6858000"/>
   <p:notesSz cx="6858000" cy="12192000"/>
@@ -152,7 +153,7 @@
                 </a:solidFill>
                 <a:latin typeface="PingFang SC"/>
               </a:rPr>
-              <a:t>2018 年后新建光伏:建设前一年土地覆盖(GLC_FCS30D,30 m,按面积)</a:t>
+              <a:t>2018 年后新建光伏:建设前一年 30 m 土地覆盖(按面积 %)</a:t>
             </a:r>
           </a:p>
         </c:rich>
@@ -176,14 +177,14 @@
               <c:strCache>
                 <c:ptCount val="1"/>
                 <c:pt idx="0">
-                  <c:v>光伏(面积 %)</c:v>
+                  <c:v>CLCD v1.0.5</c:v>
                 </c:pt>
               </c:strCache>
             </c:strRef>
           </c:tx>
           <c:spPr>
             <a:solidFill>
-              <a:srgbClr val="E9A23B"/>
+              <a:srgbClr val="1F6F78"/>
             </a:solidFill>
             <a:effectLst/>
           </c:spPr>
@@ -195,7 +196,7 @@
               <a:lstStyle/>
               <a:p>
                 <a:pPr>
-                  <a:defRPr b="0" i="0" strike="noStrike" sz="1100" u="none">
+                  <a:defRPr b="0" i="0" strike="noStrike" sz="900" u="none">
                     <a:solidFill>
                       <a:srgbClr val="000000"/>
                     </a:solidFill>
@@ -250,6 +251,113 @@
                 <c:formatCode>General</c:formatCode>
                 <c:ptCount val="7"/>
                 <c:pt idx="0">
+                  <c:v>36</c:v>
+                </c:pt>
+                <c:pt idx="1">
+                  <c:v>31.2</c:v>
+                </c:pt>
+                <c:pt idx="2">
+                  <c:v>23.2</c:v>
+                </c:pt>
+                <c:pt idx="3">
+                  <c:v>0</c:v>
+                </c:pt>
+                <c:pt idx="4">
+                  <c:v>3.7</c:v>
+                </c:pt>
+                <c:pt idx="5">
+                  <c:v>3.9</c:v>
+                </c:pt>
+                <c:pt idx="6">
+                  <c:v>2</c:v>
+                </c:pt>
+              </c:numCache>
+            </c:numRef>
+          </c:val>
+        </c:ser>
+        <c:ser>
+          <c:idx val="1"/>
+          <c:order val="1"/>
+          <c:tx>
+            <c:strRef>
+              <c:f>Sheet1!$C$1</c:f>
+              <c:strCache>
+                <c:ptCount val="1"/>
+                <c:pt idx="0">
+                  <c:v>GLC_FCS30D</c:v>
+                </c:pt>
+              </c:strCache>
+            </c:strRef>
+          </c:tx>
+          <c:spPr>
+            <a:solidFill>
+              <a:srgbClr val="E9A23B"/>
+            </a:solidFill>
+            <a:effectLst/>
+          </c:spPr>
+          <c:invertIfNegative val="0"/>
+          <c:dLbls>
+            <c:numFmt formatCode="0.0" sourceLinked="0"/>
+            <c:txPr>
+              <a:bodyPr/>
+              <a:lstStyle/>
+              <a:p>
+                <a:pPr>
+                  <a:defRPr b="0" i="0" strike="noStrike" sz="900" u="none">
+                    <a:solidFill>
+                      <a:srgbClr val="000000"/>
+                    </a:solidFill>
+                    <a:latin typeface="Arial"/>
+                  </a:defRPr>
+                </a:pPr>
+              </a:p>
+            </c:txPr>
+            <c:showLegendKey val="0"/>
+            <c:showVal val="1"/>
+            <c:showCatName val="0"/>
+            <c:showSerName val="0"/>
+            <c:showPercent val="0"/>
+            <c:showBubbleSize val="0"/>
+            <c:showLeaderLines val="0"/>
+          </c:dLbls>
+          <c:cat>
+            <c:multiLvlStrRef>
+              <c:f>Sheet1!$A$2:$A$8</c:f>
+              <c:multiLvlStrCache>
+                <c:ptCount val="7"/>
+                <c:lvl>
+                  <c:pt idx="0">
+                    <c:v>裸地</c:v>
+                  </c:pt>
+                  <c:pt idx="1">
+                    <c:v>草地</c:v>
+                  </c:pt>
+                  <c:pt idx="2">
+                    <c:v>耕地</c:v>
+                  </c:pt>
+                  <c:pt idx="3">
+                    <c:v>稀疏植被</c:v>
+                  </c:pt>
+                  <c:pt idx="4">
+                    <c:v>湿地+水体</c:v>
+                  </c:pt>
+                  <c:pt idx="5">
+                    <c:v>不透水面</c:v>
+                  </c:pt>
+                  <c:pt idx="6">
+                    <c:v>森林+灌丛</c:v>
+                  </c:pt>
+                </c:lvl>
+              </c:multiLvlStrCache>
+            </c:multiLvlStrRef>
+          </c:cat>
+          <c:val>
+            <c:numRef>
+              <c:f>Sheet1!$C$2:$C$8</c:f>
+              <c:numCache>
+                <c:formatCode>General</c:formatCode>
+                <c:ptCount val="7"/>
+                <c:pt idx="0">
                   <c:v>39.5</c:v>
                 </c:pt>
                 <c:pt idx="1">
@@ -281,7 +389,7 @@
             <a:lstStyle/>
             <a:p>
               <a:pPr>
-                <a:defRPr b="0" i="0" strike="noStrike" sz="1100" u="none">
+                <a:defRPr b="0" i="0" strike="noStrike" sz="900" u="none">
                   <a:solidFill>
                     <a:srgbClr val="000000"/>
                   </a:solidFill>
@@ -404,6 +512,23 @@
         <a:effectLst/>
       </c:spPr>
     </c:plotArea>
+    <c:legend>
+      <c:legendPos val="t"/>
+      <c:overlay val="0"/>
+      <c:txPr>
+        <a:bodyPr/>
+        <a:lstStyle/>
+        <a:p>
+          <a:pPr>
+            <a:defRPr sz="1100">
+              <a:latin typeface="PingFang SC"/>
+              <a:cs typeface="PingFang SC"/>
+            </a:defRPr>
+          </a:pPr>
+          <a:endParaRPr lang="en-US"/>
+        </a:p>
+      </c:txPr>
+    </c:legend>
     <c:plotVisOnly val="1"/>
     <c:dispBlanksAs val="span"/>
   </c:chart>
@@ -2651,6 +2776,94 @@
 </p:notes>
 </file>
 
+<file path=ppt/notesSlides/notesSlide21.xml><?xml version="1.0" encoding="utf-8"?>
+<p:notes xmlns:a="http://schemas.openxmlformats.org/drawingml/2006/main" xmlns:r="http://schemas.openxmlformats.org/officeDocument/2006/relationships" xmlns:p="http://schemas.openxmlformats.org/presentationml/2006/main">
+  <p:cSld>
+    <p:spTree>
+      <p:nvGrpSpPr>
+        <p:cNvPr id="1" name=""/>
+        <p:cNvGrpSpPr/>
+        <p:nvPr/>
+      </p:nvGrpSpPr>
+      <p:grpSpPr>
+        <a:xfrm>
+          <a:off x="0" y="0"/>
+          <a:ext cx="0" cy="0"/>
+          <a:chOff x="0" y="0"/>
+          <a:chExt cx="0" cy="0"/>
+        </a:xfrm>
+      </p:grpSpPr>
+      <p:sp>
+        <p:nvSpPr>
+          <p:cNvPr id="2" name="Slide Image Placeholder 1"/>
+          <p:cNvSpPr>
+            <a:spLocks noGrp="1" noRot="1" noChangeAspect="1"/>
+          </p:cNvSpPr>
+          <p:nvPr>
+            <p:ph type="sldImg"/>
+          </p:nvPr>
+        </p:nvSpPr>
+        <p:spPr/>
+      </p:sp>
+      <p:sp>
+        <p:nvSpPr>
+          <p:cNvPr id="3" name="Notes Placeholder 2"/>
+          <p:cNvSpPr>
+            <a:spLocks noGrp="1"/>
+          </p:cNvSpPr>
+          <p:nvPr>
+            <p:ph type="body" idx="1"/>
+          </p:nvPr>
+        </p:nvSpPr>
+        <p:spPr/>
+        <p:txBody>
+          <a:bodyPr/>
+          <a:lstStyle/>
+          <a:p>
+            <a:r>
+              <a:rPr lang="en-US" dirty="0"/>
+              <a:t/>
+            </a:r>
+            <a:endParaRPr lang="en-US" dirty="0"/>
+          </a:p>
+        </p:txBody>
+      </p:sp>
+      <p:sp>
+        <p:nvSpPr>
+          <p:cNvPr id="4" name="Slide Number Placeholder 3"/>
+          <p:cNvSpPr>
+            <a:spLocks noGrp="1"/>
+          </p:cNvSpPr>
+          <p:nvPr>
+            <p:ph type="sldNum" sz="quarter" idx="10"/>
+          </p:nvPr>
+        </p:nvSpPr>
+        <p:spPr/>
+        <p:txBody>
+          <a:bodyPr/>
+          <a:lstStyle/>
+          <a:p>
+            <a:fld id="{F7021451-1387-4CA6-816F-3879F97B5CBC}" type="slidenum">
+              <a:rPr lang="en-US"/>
+              <a:t>21</a:t>
+            </a:fld>
+            <a:endParaRPr lang="en-US"/>
+          </a:p>
+        </p:txBody>
+      </p:sp>
+    </p:spTree>
+    <p:extLst>
+      <p:ext uri="{BB962C8B-B14F-4D97-AF65-F5344CB8AC3E}">
+        <p14:creationId xmlns:p14="http://schemas.microsoft.com/office/powerpoint/2010/main" val="1024086991"/>
+      </p:ext>
+    </p:extLst>
+  </p:cSld>
+  <p:clrMapOvr>
+    <a:masterClrMapping/>
+  </p:clrMapOvr>
+</p:notes>
+</file>
+
 <file path=ppt/notesSlides/notesSlide3.xml><?xml version="1.0" encoding="utf-8"?>
 <p:notes xmlns:a="http://schemas.openxmlformats.org/drawingml/2006/main" xmlns:r="http://schemas.openxmlformats.org/officeDocument/2006/relationships" xmlns:p="http://schemas.openxmlformats.org/presentationml/2006/main">
   <p:cSld>
@@ -11846,7 +12059,7 @@
                 <a:ea typeface="PingFang SC" pitchFamily="34" charset="-122"/>
                 <a:cs typeface="PingFang SC" pitchFamily="34" charset="-120"/>
               </a:rPr>
-              <a:t>按站点数,近一半建在耕地上。对照 GRW 自带 ESA CCI 2018(300 m):裸地 33.2%、草地 31.2%、耕地 26.5%。风机(GLC_FCS30D 前一年 30 m,72,837 台):裸地 32.9%、耕地 23.3%、草地 21.2%、森林 6.3%(ESA CCI 300 m 给出森林 12.2%,高估约一倍)。</a:t>
+              <a:t>CLCD 无稀疏植被类(并入草地),湿地并入水体;两产品逐站主导类别一致 75.5%。按站点数一半建在耕地上。风机森林占比:CLCD 12.5%(9,067 台)、GLC 6.3%(4,613 台),只能报区间,需高分影像定标。</a:t>
             </a:r>
             <a:endParaRPr lang="en-US" sz="1150" dirty="0"/>
           </a:p>
@@ -12500,6 +12713,526 @@
                 <a:ea typeface="PingFang SC" pitchFamily="34" charset="-122"/>
                 <a:cs typeface="PingFang SC" pitchFamily="34" charset="-120"/>
               </a:rPr>
+              <a:t>西北旱区试点:交错 DiD 事件研究</a:t>
+            </a:r>
+            <a:endParaRPr lang="en-US" sz="3000" dirty="0"/>
+          </a:p>
+        </p:txBody>
+      </p:sp>
+      <p:sp>
+        <p:nvSpPr>
+          <p:cNvPr id="3" name="Text 1"/>
+          <p:cNvSpPr/>
+          <p:nvPr/>
+        </p:nvSpPr>
+        <p:spPr>
+          <a:xfrm>
+            <a:off x="548640" y="960120"/>
+            <a:ext cx="11094415" cy="365760"/>
+          </a:xfrm>
+          <a:prstGeom prst="rect">
+            <a:avLst/>
+          </a:prstGeom>
+          <a:noFill/>
+          <a:ln/>
+        </p:spPr>
+        <p:txBody>
+          <a:bodyPr wrap="square" lIns="0" tIns="0" rIns="0" bIns="0" rtlCol="0" anchor="ctr"/>
+          <a:lstStyle/>
+          <a:p>
+            <a:pPr indent="0" marL="0">
+              <a:buNone/>
+            </a:pPr>
+            <a:r>
+              <a:rPr lang="en-US" sz="1400" dirty="0">
+                <a:solidFill>
+                  <a:srgbClr val="5E6B75"/>
+                </a:solidFill>
+                <a:latin typeface="PingFang SC" pitchFamily="34" charset="0"/>
+                <a:ea typeface="PingFang SC" pitchFamily="34" charset="-122"/>
+                <a:cs typeface="PingFang SC" pitchFamily="34" charset="-120"/>
+              </a:rPr>
+              <a:t>365 站(2019–2021 处理 198,2022–2023 晚建对照 167);Landsat 生长季 NDVI,2016–2024</a:t>
+            </a:r>
+            <a:endParaRPr lang="en-US" sz="1400" dirty="0"/>
+          </a:p>
+        </p:txBody>
+      </p:sp>
+      <p:pic>
+        <p:nvPicPr>
+          <p:cNvPr id="4" name="Image 0" descr="results/figures/pilot_nw_eventstudy.png">    </p:cNvPr>
+          <p:cNvPicPr>
+            <a:picLocks noChangeAspect="1"/>
+          </p:cNvPicPr>
+          <p:nvPr/>
+        </p:nvPicPr>
+        <p:blipFill>
+          <a:blip r:embed="rId1"/>
+          <a:stretch>
+            <a:fillRect/>
+          </a:stretch>
+        </p:blipFill>
+        <p:spPr>
+          <a:xfrm>
+            <a:off x="457200" y="1417320"/>
+            <a:ext cx="6675120" cy="4983480"/>
+          </a:xfrm>
+          <a:prstGeom prst="rect">
+            <a:avLst/>
+          </a:prstGeom>
+        </p:spPr>
+      </p:pic>
+      <p:sp>
+        <p:nvSpPr>
+          <p:cNvPr id="5" name="Shape 2"/>
+          <p:cNvSpPr/>
+          <p:nvPr/>
+        </p:nvSpPr>
+        <p:spPr>
+          <a:xfrm>
+            <a:off x="7406640" y="1463040"/>
+            <a:ext cx="4251960" cy="1078992"/>
+          </a:xfrm>
+          <a:prstGeom prst="roundRect">
+            <a:avLst>
+              <a:gd name="adj" fmla="val 5085"/>
+            </a:avLst>
+          </a:prstGeom>
+          <a:solidFill>
+            <a:srgbClr val="F3E7E4"/>
+          </a:solidFill>
+          <a:ln w="12700">
+            <a:solidFill>
+              <a:srgbClr val="F3E7E4"/>
+            </a:solidFill>
+            <a:prstDash val="solid"/>
+          </a:ln>
+        </p:spPr>
+      </p:sp>
+      <p:sp>
+        <p:nvSpPr>
+          <p:cNvPr id="6" name="Text 3"/>
+          <p:cNvSpPr/>
+          <p:nvPr/>
+        </p:nvSpPr>
+        <p:spPr>
+          <a:xfrm>
+            <a:off x="7589520" y="1536192"/>
+            <a:ext cx="3931920" cy="365760"/>
+          </a:xfrm>
+          <a:prstGeom prst="rect">
+            <a:avLst/>
+          </a:prstGeom>
+          <a:noFill/>
+          <a:ln/>
+        </p:spPr>
+        <p:txBody>
+          <a:bodyPr wrap="square" lIns="0" tIns="0" rIns="0" bIns="0" rtlCol="0" anchor="ctr"/>
+          <a:lstStyle/>
+          <a:p>
+            <a:pPr indent="0" marL="0">
+              <a:buNone/>
+            </a:pPr>
+            <a:r>
+              <a:rPr lang="en-US" sz="1500" b="1" dirty="0">
+                <a:solidFill>
+                  <a:srgbClr val="0E2F3C"/>
+                </a:solidFill>
+                <a:latin typeface="PingFang SC" pitchFamily="34" charset="0"/>
+                <a:ea typeface="PingFang SC" pitchFamily="34" charset="-122"/>
+                <a:cs typeface="PingFang SC" pitchFamily="34" charset="-120"/>
+              </a:rPr>
+              <a:t>站内:G2 未通过</a:t>
+            </a:r>
+            <a:endParaRPr lang="en-US" sz="1500" dirty="0"/>
+          </a:p>
+        </p:txBody>
+      </p:sp>
+      <p:sp>
+        <p:nvSpPr>
+          <p:cNvPr id="7" name="Text 4"/>
+          <p:cNvSpPr/>
+          <p:nvPr/>
+        </p:nvSpPr>
+        <p:spPr>
+          <a:xfrm>
+            <a:off x="7589520" y="1920240"/>
+            <a:ext cx="3931920" cy="594360"/>
+          </a:xfrm>
+          <a:prstGeom prst="rect">
+            <a:avLst/>
+          </a:prstGeom>
+          <a:noFill/>
+          <a:ln/>
+        </p:spPr>
+        <p:txBody>
+          <a:bodyPr wrap="square" lIns="0" tIns="0" rIns="0" bIns="0" rtlCol="0" anchor="ctr"/>
+          <a:lstStyle/>
+          <a:p>
+            <a:pPr indent="0" marL="0">
+              <a:buNone/>
+            </a:pPr>
+            <a:r>
+              <a:rPr lang="en-US" sz="1100" dirty="0">
+                <a:solidFill>
+                  <a:srgbClr val="1D2A33"/>
+                </a:solidFill>
+                <a:latin typeface="PingFang SC" pitchFamily="34" charset="0"/>
+                <a:ea typeface="PingFang SC" pitchFamily="34" charset="-122"/>
+                <a:cs typeface="PingFang SC" pitchFamily="34" charset="-120"/>
+              </a:rPr>
+              <a:t>建后 1–3 年 −0.022(−0.042, −0.002),但建设前偏离达 0.025;设 2 年预期期后降为 −0.004</a:t>
+            </a:r>
+            <a:endParaRPr lang="en-US" sz="1100" dirty="0"/>
+          </a:p>
+        </p:txBody>
+      </p:sp>
+      <p:sp>
+        <p:nvSpPr>
+          <p:cNvPr id="8" name="Shape 5"/>
+          <p:cNvSpPr/>
+          <p:nvPr/>
+        </p:nvSpPr>
+        <p:spPr>
+          <a:xfrm>
+            <a:off x="7406640" y="2670048"/>
+            <a:ext cx="4251960" cy="1078992"/>
+          </a:xfrm>
+          <a:prstGeom prst="roundRect">
+            <a:avLst>
+              <a:gd name="adj" fmla="val 5085"/>
+            </a:avLst>
+          </a:prstGeom>
+          <a:solidFill>
+            <a:srgbClr val="EEF4F4"/>
+          </a:solidFill>
+          <a:ln w="12700">
+            <a:solidFill>
+              <a:srgbClr val="EEF4F4"/>
+            </a:solidFill>
+            <a:prstDash val="solid"/>
+          </a:ln>
+        </p:spPr>
+      </p:sp>
+      <p:sp>
+        <p:nvSpPr>
+          <p:cNvPr id="9" name="Text 6"/>
+          <p:cNvSpPr/>
+          <p:nvPr/>
+        </p:nvSpPr>
+        <p:spPr>
+          <a:xfrm>
+            <a:off x="7589520" y="2743200"/>
+            <a:ext cx="3931920" cy="365760"/>
+          </a:xfrm>
+          <a:prstGeom prst="rect">
+            <a:avLst/>
+          </a:prstGeom>
+          <a:noFill/>
+          <a:ln/>
+        </p:spPr>
+        <p:txBody>
+          <a:bodyPr wrap="square" lIns="0" tIns="0" rIns="0" bIns="0" rtlCol="0" anchor="ctr"/>
+          <a:lstStyle/>
+          <a:p>
+            <a:pPr indent="0" marL="0">
+              <a:buNone/>
+            </a:pPr>
+            <a:r>
+              <a:rPr lang="en-US" sz="1500" b="1" dirty="0">
+                <a:solidFill>
+                  <a:srgbClr val="0E2F3C"/>
+                </a:solidFill>
+                <a:latin typeface="PingFang SC" pitchFamily="34" charset="0"/>
+                <a:ea typeface="PingFang SC" pitchFamily="34" charset="-122"/>
+                <a:cs typeface="PingFang SC" pitchFamily="34" charset="-120"/>
+              </a:rPr>
+              <a:t>外围环:设计可用</a:t>
+            </a:r>
+            <a:endParaRPr lang="en-US" sz="1500" dirty="0"/>
+          </a:p>
+        </p:txBody>
+      </p:sp>
+      <p:sp>
+        <p:nvSpPr>
+          <p:cNvPr id="10" name="Text 7"/>
+          <p:cNvSpPr/>
+          <p:nvPr/>
+        </p:nvSpPr>
+        <p:spPr>
+          <a:xfrm>
+            <a:off x="7589520" y="3127248"/>
+            <a:ext cx="3931920" cy="594360"/>
+          </a:xfrm>
+          <a:prstGeom prst="rect">
+            <a:avLst/>
+          </a:prstGeom>
+          <a:noFill/>
+          <a:ln/>
+        </p:spPr>
+        <p:txBody>
+          <a:bodyPr wrap="square" lIns="0" tIns="0" rIns="0" bIns="0" rtlCol="0" anchor="ctr"/>
+          <a:lstStyle/>
+          <a:p>
+            <a:pPr indent="0" marL="0">
+              <a:buNone/>
+            </a:pPr>
+            <a:r>
+              <a:rPr lang="en-US" sz="1100" dirty="0">
+                <a:solidFill>
+                  <a:srgbClr val="1D2A33"/>
+                </a:solidFill>
+                <a:latin typeface="PingFang SC" pitchFamily="34" charset="0"/>
+                <a:ea typeface="PingFang SC" pitchFamily="34" charset="-122"/>
+                <a:cs typeface="PingFang SC" pitchFamily="34" charset="-120"/>
+              </a:rPr>
+              <a:t>建设前平坦(p = 0.60);60–500 m 未检出外溢,−0.009(−0.026, 0.007)</a:t>
+            </a:r>
+            <a:endParaRPr lang="en-US" sz="1100" dirty="0"/>
+          </a:p>
+        </p:txBody>
+      </p:sp>
+      <p:sp>
+        <p:nvSpPr>
+          <p:cNvPr id="11" name="Shape 8"/>
+          <p:cNvSpPr/>
+          <p:nvPr/>
+        </p:nvSpPr>
+        <p:spPr>
+          <a:xfrm>
+            <a:off x="7406640" y="3877056"/>
+            <a:ext cx="4251960" cy="1078992"/>
+          </a:xfrm>
+          <a:prstGeom prst="roundRect">
+            <a:avLst>
+              <a:gd name="adj" fmla="val 5085"/>
+            </a:avLst>
+          </a:prstGeom>
+          <a:solidFill>
+            <a:srgbClr val="FBF1DF"/>
+          </a:solidFill>
+          <a:ln w="12700">
+            <a:solidFill>
+              <a:srgbClr val="FBF1DF"/>
+            </a:solidFill>
+            <a:prstDash val="solid"/>
+          </a:ln>
+        </p:spPr>
+      </p:sp>
+      <p:sp>
+        <p:nvSpPr>
+          <p:cNvPr id="12" name="Text 9"/>
+          <p:cNvSpPr/>
+          <p:nvPr/>
+        </p:nvSpPr>
+        <p:spPr>
+          <a:xfrm>
+            <a:off x="7589520" y="3950208"/>
+            <a:ext cx="3931920" cy="365760"/>
+          </a:xfrm>
+          <a:prstGeom prst="rect">
+            <a:avLst/>
+          </a:prstGeom>
+          <a:noFill/>
+          <a:ln/>
+        </p:spPr>
+        <p:txBody>
+          <a:bodyPr wrap="square" lIns="0" tIns="0" rIns="0" bIns="0" rtlCol="0" anchor="ctr"/>
+          <a:lstStyle/>
+          <a:p>
+            <a:pPr indent="0" marL="0">
+              <a:buNone/>
+            </a:pPr>
+            <a:r>
+              <a:rPr lang="en-US" sz="1500" b="1" dirty="0">
+                <a:solidFill>
+                  <a:srgbClr val="0E2F3C"/>
+                </a:solidFill>
+                <a:latin typeface="PingFang SC" pitchFamily="34" charset="0"/>
+                <a:ea typeface="PingFang SC" pitchFamily="34" charset="-122"/>
+                <a:cs typeface="PingFang SC" pitchFamily="34" charset="-120"/>
+              </a:rPr>
+              <a:t>异质性:未检出</a:t>
+            </a:r>
+            <a:endParaRPr lang="en-US" sz="1500" dirty="0"/>
+          </a:p>
+        </p:txBody>
+      </p:sp>
+      <p:sp>
+        <p:nvSpPr>
+          <p:cNvPr id="13" name="Text 10"/>
+          <p:cNvSpPr/>
+          <p:nvPr/>
+        </p:nvSpPr>
+        <p:spPr>
+          <a:xfrm>
+            <a:off x="7589520" y="4334256"/>
+            <a:ext cx="3931920" cy="594360"/>
+          </a:xfrm>
+          <a:prstGeom prst="rect">
+            <a:avLst/>
+          </a:prstGeom>
+          <a:noFill/>
+          <a:ln/>
+        </p:spPr>
+        <p:txBody>
+          <a:bodyPr wrap="square" lIns="0" tIns="0" rIns="0" bIns="0" rtlCol="0" anchor="ctr"/>
+          <a:lstStyle/>
+          <a:p>
+            <a:pPr indent="0" marL="0">
+              <a:buNone/>
+            </a:pPr>
+            <a:r>
+              <a:rPr lang="en-US" sz="1100" dirty="0">
+                <a:solidFill>
+                  <a:srgbClr val="1D2A33"/>
+                </a:solidFill>
+                <a:latin typeface="PingFang SC" pitchFamily="34" charset="0"/>
+                <a:ea typeface="PingFang SC" pitchFamily="34" charset="-122"/>
+                <a:cs typeface="PingFang SC" pitchFamily="34" charset="-120"/>
+              </a:rPr>
+              <a:t>站内与外围环 NDVI 标准差均无变化;H3 未获支持也未被否定</a:t>
+            </a:r>
+            <a:endParaRPr lang="en-US" sz="1100" dirty="0"/>
+          </a:p>
+        </p:txBody>
+      </p:sp>
+      <p:sp>
+        <p:nvSpPr>
+          <p:cNvPr id="14" name="Text 11"/>
+          <p:cNvSpPr/>
+          <p:nvPr/>
+        </p:nvSpPr>
+        <p:spPr>
+          <a:xfrm>
+            <a:off x="7406640" y="5120640"/>
+            <a:ext cx="4251960" cy="914400"/>
+          </a:xfrm>
+          <a:prstGeom prst="rect">
+            <a:avLst/>
+          </a:prstGeom>
+          <a:noFill/>
+          <a:ln/>
+        </p:spPr>
+        <p:txBody>
+          <a:bodyPr wrap="square" lIns="0" tIns="0" rIns="0" bIns="0" rtlCol="0" anchor="ctr"/>
+          <a:lstStyle/>
+          <a:p>
+            <a:pPr indent="0" marL="0">
+              <a:buNone/>
+            </a:pPr>
+            <a:r>
+              <a:rPr lang="en-US" sz="1150" b="1" dirty="0">
+                <a:solidFill>
+                  <a:srgbClr val="1F6F78"/>
+                </a:solidFill>
+                <a:latin typeface="PingFang SC" pitchFamily="34" charset="0"/>
+                <a:ea typeface="PingFang SC" pitchFamily="34" charset="-122"/>
+                <a:cs typeface="PingFang SC" pitchFamily="34" charset="-120"/>
+              </a:rPr>
+              <a:t>修改:按建设前 NDVI 轨迹与选址变量匹配从未建设点;前期延至 2010;站内改用 10 m 板间像元;HonestDiD 报告界。</a:t>
+            </a:r>
+            <a:endParaRPr lang="en-US" sz="1150" dirty="0"/>
+          </a:p>
+        </p:txBody>
+      </p:sp>
+      <p:sp>
+        <p:nvSpPr>
+          <p:cNvPr id="15" name="Text 12"/>
+          <p:cNvSpPr/>
+          <p:nvPr/>
+        </p:nvSpPr>
+        <p:spPr>
+          <a:xfrm>
+            <a:off x="11277295" y="6400800"/>
+            <a:ext cx="457200" cy="274320"/>
+          </a:xfrm>
+          <a:prstGeom prst="rect">
+            <a:avLst/>
+          </a:prstGeom>
+          <a:noFill/>
+          <a:ln/>
+        </p:spPr>
+        <p:txBody>
+          <a:bodyPr wrap="square" lIns="0" tIns="0" rIns="0" bIns="0" rtlCol="0" anchor="ctr"/>
+          <a:lstStyle/>
+          <a:p>
+            <a:pPr algn="r" indent="0" marL="0">
+              <a:buNone/>
+            </a:pPr>
+            <a:r>
+              <a:rPr lang="en-US" sz="1000" dirty="0">
+                <a:solidFill>
+                  <a:srgbClr val="5E6B75"/>
+                </a:solidFill>
+                <a:latin typeface="Arial" pitchFamily="34" charset="0"/>
+                <a:ea typeface="Arial" pitchFamily="34" charset="-122"/>
+                <a:cs typeface="Arial" pitchFamily="34" charset="-120"/>
+              </a:rPr>
+              <a:t>18</a:t>
+            </a:r>
+            <a:endParaRPr lang="en-US" sz="1000" dirty="0"/>
+          </a:p>
+        </p:txBody>
+      </p:sp>
+    </p:spTree>
+  </p:cSld>
+  <p:clrMapOvr>
+    <a:masterClrMapping/>
+  </p:clrMapOvr>
+</p:sld>
+</file>
+
+<file path=ppt/slides/slide19.xml><?xml version="1.0" encoding="utf-8"?>
+<p:sld xmlns:a="http://schemas.openxmlformats.org/drawingml/2006/main" xmlns:r="http://schemas.openxmlformats.org/officeDocument/2006/relationships" xmlns:p="http://schemas.openxmlformats.org/presentationml/2006/main">
+  <p:cSld name="Slide 19">
+    <p:spTree>
+      <p:nvGrpSpPr>
+        <p:cNvPr id="1" name=""/>
+        <p:cNvGrpSpPr/>
+        <p:nvPr/>
+      </p:nvGrpSpPr>
+      <p:grpSpPr>
+        <a:xfrm>
+          <a:off x="0" y="0"/>
+          <a:ext cx="0" cy="0"/>
+          <a:chOff x="0" y="0"/>
+          <a:chExt cx="0" cy="0"/>
+        </a:xfrm>
+      </p:grpSpPr>
+      <p:sp>
+        <p:nvSpPr>
+          <p:cNvPr id="2" name="Text 0"/>
+          <p:cNvSpPr/>
+          <p:nvPr/>
+        </p:nvSpPr>
+        <p:spPr>
+          <a:xfrm>
+            <a:off x="548640" y="320040"/>
+            <a:ext cx="11094415" cy="685800"/>
+          </a:xfrm>
+          <a:prstGeom prst="rect">
+            <a:avLst/>
+          </a:prstGeom>
+          <a:noFill/>
+          <a:ln/>
+        </p:spPr>
+        <p:txBody>
+          <a:bodyPr wrap="square" lIns="0" tIns="0" rIns="0" bIns="0" rtlCol="0" anchor="ctr"/>
+          <a:lstStyle/>
+          <a:p>
+            <a:pPr indent="0" marL="0">
+              <a:buNone/>
+            </a:pPr>
+            <a:r>
+              <a:rPr lang="en-US" sz="3000" b="1" dirty="0">
+                <a:solidFill>
+                  <a:srgbClr val="0E2F3C"/>
+                </a:solidFill>
+                <a:latin typeface="PingFang SC" pitchFamily="34" charset="0"/>
+                <a:ea typeface="PingFang SC" pitchFamily="34" charset="-122"/>
+                <a:cs typeface="PingFang SC" pitchFamily="34" charset="-120"/>
+              </a:rPr>
               <a:t>主要风险与对策</a:t>
             </a:r>
             <a:endParaRPr lang="en-US" sz="3000" dirty="0"/>
@@ -12508,7 +13241,7 @@
       </p:sp>
       <p:graphicFrame>
         <p:nvGraphicFramePr>
-          <p:cNvPr id="19" name="Table 0"/>
+          <p:cNvPr id="20" name="Table 0"/>
           <p:cNvGraphicFramePr>
             <a:graphicFrameLocks noGrp="1"/>
           </p:cNvGraphicFramePr>
@@ -13631,431 +14364,6 @@
                 <a:ea typeface="Arial" pitchFamily="34" charset="-122"/>
                 <a:cs typeface="Arial" pitchFamily="34" charset="-120"/>
               </a:rPr>
-              <a:t>18</a:t>
-            </a:r>
-            <a:endParaRPr lang="en-US" sz="1000" dirty="0"/>
-          </a:p>
-        </p:txBody>
-      </p:sp>
-    </p:spTree>
-  </p:cSld>
-  <p:clrMapOvr>
-    <a:masterClrMapping/>
-  </p:clrMapOvr>
-</p:sld>
-</file>
-
-<file path=ppt/slides/slide19.xml><?xml version="1.0" encoding="utf-8"?>
-<p:sld xmlns:a="http://schemas.openxmlformats.org/drawingml/2006/main" xmlns:r="http://schemas.openxmlformats.org/officeDocument/2006/relationships" xmlns:p="http://schemas.openxmlformats.org/presentationml/2006/main">
-  <p:cSld name="Slide 19">
-    <p:spTree>
-      <p:nvGrpSpPr>
-        <p:cNvPr id="1" name=""/>
-        <p:cNvGrpSpPr/>
-        <p:nvPr/>
-      </p:nvGrpSpPr>
-      <p:grpSpPr>
-        <a:xfrm>
-          <a:off x="0" y="0"/>
-          <a:ext cx="0" cy="0"/>
-          <a:chOff x="0" y="0"/>
-          <a:chExt cx="0" cy="0"/>
-        </a:xfrm>
-      </p:grpSpPr>
-      <p:sp>
-        <p:nvSpPr>
-          <p:cNvPr id="2" name="Text 0"/>
-          <p:cNvSpPr/>
-          <p:nvPr/>
-        </p:nvSpPr>
-        <p:spPr>
-          <a:xfrm>
-            <a:off x="548640" y="320040"/>
-            <a:ext cx="11094415" cy="685800"/>
-          </a:xfrm>
-          <a:prstGeom prst="rect">
-            <a:avLst/>
-          </a:prstGeom>
-          <a:noFill/>
-          <a:ln/>
-        </p:spPr>
-        <p:txBody>
-          <a:bodyPr wrap="square" lIns="0" tIns="0" rIns="0" bIns="0" rtlCol="0" anchor="ctr"/>
-          <a:lstStyle/>
-          <a:p>
-            <a:pPr indent="0" marL="0">
-              <a:buNone/>
-            </a:pPr>
-            <a:r>
-              <a:rPr lang="en-US" sz="3000" b="1" dirty="0">
-                <a:solidFill>
-                  <a:srgbClr val="0E2F3C"/>
-                </a:solidFill>
-                <a:latin typeface="PingFang SC" pitchFamily="34" charset="0"/>
-                <a:ea typeface="PingFang SC" pitchFamily="34" charset="-122"/>
-                <a:cs typeface="PingFang SC" pitchFamily="34" charset="-120"/>
-              </a:rPr>
-              <a:t>相关文献</a:t>
-            </a:r>
-            <a:endParaRPr lang="en-US" sz="3000" dirty="0"/>
-          </a:p>
-        </p:txBody>
-      </p:sp>
-      <p:sp>
-        <p:nvSpPr>
-          <p:cNvPr id="3" name="Text 1"/>
-          <p:cNvSpPr/>
-          <p:nvPr/>
-        </p:nvSpPr>
-        <p:spPr>
-          <a:xfrm>
-            <a:off x="548640" y="1143000"/>
-            <a:ext cx="11094415" cy="5212080"/>
-          </a:xfrm>
-          <a:prstGeom prst="rect">
-            <a:avLst/>
-          </a:prstGeom>
-          <a:noFill/>
-          <a:ln/>
-        </p:spPr>
-        <p:txBody>
-          <a:bodyPr wrap="square" lIns="0" tIns="0" rIns="0" bIns="0" rtlCol="0" anchor="t"/>
-          <a:lstStyle/>
-          <a:p>
-            <a:pPr indent="0" marL="0">
-              <a:spcAft>
-                <a:spcPts val="400"/>
-              </a:spcAft>
-              <a:buNone/>
-            </a:pPr>
-            <a:r>
-              <a:rPr lang="en-US" sz="1100" dirty="0">
-                <a:solidFill>
-                  <a:srgbClr val="1D2A33"/>
-                </a:solidFill>
-                <a:latin typeface="PingFang SC" pitchFamily="34" charset="0"/>
-                <a:ea typeface="PingFang SC" pitchFamily="34" charset="-122"/>
-                <a:cs typeface="PingFang SC" pitchFamily="34" charset="-120"/>
-              </a:rPr>
-              <a:t>[1] Zhou Z., Sun S., Zhang J., Fang Y., Li B.V. (2026) Comparing potential biodiversity conflicts from renewable energy expansion in China at different centralization levels. Nat. Ecol. Evol. 10:1316–1328.</a:t>
-            </a:r>
-            <a:endParaRPr lang="en-US" sz="1100" dirty="0"/>
-          </a:p>
-          <a:p>
-            <a:pPr indent="0" marL="0">
-              <a:spcAft>
-                <a:spcPts val="400"/>
-              </a:spcAft>
-              <a:buNone/>
-            </a:pPr>
-            <a:r>
-              <a:rPr lang="en-US" sz="1100" dirty="0">
-                <a:solidFill>
-                  <a:srgbClr val="1D2A33"/>
-                </a:solidFill>
-                <a:latin typeface="PingFang SC" pitchFamily="34" charset="0"/>
-                <a:ea typeface="PingFang SC" pitchFamily="34" charset="-122"/>
-                <a:cs typeface="PingFang SC" pitchFamily="34" charset="-120"/>
-              </a:rPr>
-              <a:t>[2] Zhang H. et al. (2026) China's solar expansion policy reduces bird diversity. Science 393:831–836.</a:t>
-            </a:r>
-            <a:endParaRPr lang="en-US" sz="1100" dirty="0"/>
-          </a:p>
-          <a:p>
-            <a:pPr indent="0" marL="0">
-              <a:spcAft>
-                <a:spcPts val="400"/>
-              </a:spcAft>
-              <a:buNone/>
-            </a:pPr>
-            <a:r>
-              <a:rPr lang="en-US" sz="1100" dirty="0">
-                <a:solidFill>
-                  <a:srgbClr val="1D2A33"/>
-                </a:solidFill>
-                <a:latin typeface="PingFang SC" pitchFamily="34" charset="0"/>
-                <a:ea typeface="PingFang SC" pitchFamily="34" charset="-122"/>
-                <a:cs typeface="PingFang SC" pitchFamily="34" charset="-120"/>
-              </a:rPr>
-              <a:t>[3] Robinson C. et al. (2025) Global Renewables Watch: a temporal dataset of solar and wind energy derived from satellite imagery. arXiv:2503.14860.</a:t>
-            </a:r>
-            <a:endParaRPr lang="en-US" sz="1100" dirty="0"/>
-          </a:p>
-          <a:p>
-            <a:pPr indent="0" marL="0">
-              <a:spcAft>
-                <a:spcPts val="400"/>
-              </a:spcAft>
-              <a:buNone/>
-            </a:pPr>
-            <a:r>
-              <a:rPr lang="en-US" sz="1100" dirty="0">
-                <a:solidFill>
-                  <a:srgbClr val="1D2A33"/>
-                </a:solidFill>
-                <a:latin typeface="PingFang SC" pitchFamily="34" charset="0"/>
-                <a:ea typeface="PingFang SC" pitchFamily="34" charset="-122"/>
-                <a:cs typeface="PingFang SC" pitchFamily="34" charset="-120"/>
-              </a:rPr>
-              <a:t>[4] Vectorized solar photovoltaic installation dataset across China in 2015 and 2020. Scientific Data (s41597-024-04356-z).</a:t>
-            </a:r>
-            <a:endParaRPr lang="en-US" sz="1100" dirty="0"/>
-          </a:p>
-          <a:p>
-            <a:pPr indent="0" marL="0">
-              <a:spcAft>
-                <a:spcPts val="400"/>
-              </a:spcAft>
-              <a:buNone/>
-            </a:pPr>
-            <a:r>
-              <a:rPr lang="en-US" sz="1100" dirty="0">
-                <a:solidFill>
-                  <a:srgbClr val="1D2A33"/>
-                </a:solidFill>
-                <a:latin typeface="PingFang SC" pitchFamily="34" charset="0"/>
-                <a:ea typeface="PingFang SC" pitchFamily="34" charset="-122"/>
-                <a:cs typeface="PingFang SC" pitchFamily="34" charset="-120"/>
-              </a:rPr>
-              <a:t>[5] A 10-m national-scale map of ground-mounted photovoltaic power stations in China of 2020. Scientific Data (2024).</a:t>
-            </a:r>
-            <a:endParaRPr lang="en-US" sz="1100" dirty="0"/>
-          </a:p>
-          <a:p>
-            <a:pPr indent="0" marL="0">
-              <a:spcAft>
-                <a:spcPts val="400"/>
-              </a:spcAft>
-              <a:buNone/>
-            </a:pPr>
-            <a:r>
-              <a:rPr lang="en-US" sz="1100" dirty="0">
-                <a:solidFill>
-                  <a:srgbClr val="1D2A33"/>
-                </a:solidFill>
-                <a:latin typeface="PingFang SC" pitchFamily="34" charset="0"/>
-                <a:ea typeface="PingFang SC" pitchFamily="34" charset="-122"/>
-                <a:cs typeface="PingFang SC" pitchFamily="34" charset="-120"/>
-              </a:rPr>
-              <a:t>[6] Satellites reveal spatial heterogeneity in dryland photovoltaic plants' effects on vegetation dynamics. Earth's Future (2024).</a:t>
-            </a:r>
-            <a:endParaRPr lang="en-US" sz="1100" dirty="0"/>
-          </a:p>
-          <a:p>
-            <a:pPr indent="0" marL="0">
-              <a:spcAft>
-                <a:spcPts val="400"/>
-              </a:spcAft>
-              <a:buNone/>
-            </a:pPr>
-            <a:r>
-              <a:rPr lang="en-US" sz="1100" dirty="0">
-                <a:solidFill>
-                  <a:srgbClr val="1D2A33"/>
-                </a:solidFill>
-                <a:latin typeface="PingFang SC" pitchFamily="34" charset="0"/>
-                <a:ea typeface="PingFang SC" pitchFamily="34" charset="-122"/>
-                <a:cs typeface="PingFang SC" pitchFamily="34" charset="-120"/>
-              </a:rPr>
-              <a:t>[7] Diverse vegetation responses to solar farm installation are also driven by climate change. Commun. Earth Environ. (2025).</a:t>
-            </a:r>
-            <a:endParaRPr lang="en-US" sz="1100" dirty="0"/>
-          </a:p>
-          <a:p>
-            <a:pPr indent="0" marL="0">
-              <a:spcAft>
-                <a:spcPts val="400"/>
-              </a:spcAft>
-              <a:buNone/>
-            </a:pPr>
-            <a:r>
-              <a:rPr lang="en-US" sz="1100" dirty="0">
-                <a:solidFill>
-                  <a:srgbClr val="1D2A33"/>
-                </a:solidFill>
-                <a:latin typeface="PingFang SC" pitchFamily="34" charset="0"/>
-                <a:ea typeface="PingFang SC" pitchFamily="34" charset="-122"/>
-                <a:cs typeface="PingFang SC" pitchFamily="34" charset="-120"/>
-              </a:rPr>
-              <a:t>[8] Large-scale photovoltaic farms significantly change the vegetation diversity and biomass through influencing soil moisture. Vadose Zone J. (2025).</a:t>
-            </a:r>
-            <a:endParaRPr lang="en-US" sz="1100" dirty="0"/>
-          </a:p>
-          <a:p>
-            <a:pPr indent="0" marL="0">
-              <a:spcAft>
-                <a:spcPts val="400"/>
-              </a:spcAft>
-              <a:buNone/>
-            </a:pPr>
-            <a:r>
-              <a:rPr lang="en-US" sz="1100" dirty="0">
-                <a:solidFill>
-                  <a:srgbClr val="1D2A33"/>
-                </a:solidFill>
-                <a:latin typeface="PingFang SC" pitchFamily="34" charset="0"/>
-                <a:ea typeface="PingFang SC" pitchFamily="34" charset="-122"/>
-                <a:cs typeface="PingFang SC" pitchFamily="34" charset="-120"/>
-              </a:rPr>
-              <a:t>[9] Wind farms increase land surface temperature and reduce vegetation productivity in the Inner Mongolia. Geography and Sustainability (2024).</a:t>
-            </a:r>
-            <a:endParaRPr lang="en-US" sz="1100" dirty="0"/>
-          </a:p>
-          <a:p>
-            <a:pPr indent="0" marL="0">
-              <a:spcAft>
-                <a:spcPts val="400"/>
-              </a:spcAft>
-              <a:buNone/>
-            </a:pPr>
-            <a:r>
-              <a:rPr lang="en-US" sz="1100" dirty="0">
-                <a:solidFill>
-                  <a:srgbClr val="1D2A33"/>
-                </a:solidFill>
-                <a:latin typeface="PingFang SC" pitchFamily="34" charset="0"/>
-                <a:ea typeface="PingFang SC" pitchFamily="34" charset="-122"/>
-                <a:cs typeface="PingFang SC" pitchFamily="34" charset="-120"/>
-              </a:rPr>
-              <a:t>[10] Callaway B., Sant'Anna P.H.C. (2021) J. Econometrics 225:200–230;Sun L., Abraham S. (2021) J. Econometrics 225:175–199;Rambachan A., Roth J. (2023) Rev. Econ. Stud. 90:2555–2591.</a:t>
-            </a:r>
-            <a:endParaRPr lang="en-US" sz="1100" dirty="0"/>
-          </a:p>
-          <a:p>
-            <a:pPr indent="0" marL="0">
-              <a:spcAft>
-                <a:spcPts val="400"/>
-              </a:spcAft>
-              <a:buNone/>
-            </a:pPr>
-            <a:r>
-              <a:rPr lang="en-US" sz="1100" dirty="0">
-                <a:solidFill>
-                  <a:srgbClr val="1D2A33"/>
-                </a:solidFill>
-                <a:latin typeface="PingFang SC" pitchFamily="34" charset="0"/>
-                <a:ea typeface="PingFang SC" pitchFamily="34" charset="-122"/>
-                <a:cs typeface="PingFang SC" pitchFamily="34" charset="-120"/>
-              </a:rPr>
-              <a:t>[11] Brooks T.M. et al. (2019) Measuring terrestrial Area of Habitat (AOH) and its utility for the IUCN Red List. Trends Ecol. Evol. 34:977–986.</a:t>
-            </a:r>
-            <a:endParaRPr lang="en-US" sz="1100" dirty="0"/>
-          </a:p>
-          <a:p>
-            <a:pPr indent="0" marL="0">
-              <a:spcAft>
-                <a:spcPts val="400"/>
-              </a:spcAft>
-              <a:buNone/>
-            </a:pPr>
-            <a:r>
-              <a:rPr lang="en-US" sz="1100" dirty="0">
-                <a:solidFill>
-                  <a:srgbClr val="1D2A33"/>
-                </a:solidFill>
-                <a:latin typeface="PingFang SC" pitchFamily="34" charset="0"/>
-                <a:ea typeface="PingFang SC" pitchFamily="34" charset="-122"/>
-                <a:cs typeface="PingFang SC" pitchFamily="34" charset="-120"/>
-              </a:rPr>
-              <a:t>[12] Li X., He Z., Xia S., Yang Y. (2024) Greenness change associated with construction and operation of photovoltaic solar energy in China. Renewable Energy 226:120461.</a:t>
-            </a:r>
-            <a:endParaRPr lang="en-US" sz="1100" dirty="0"/>
-          </a:p>
-          <a:p>
-            <a:pPr indent="0" marL="0">
-              <a:spcAft>
-                <a:spcPts val="400"/>
-              </a:spcAft>
-              <a:buNone/>
-            </a:pPr>
-            <a:r>
-              <a:rPr lang="en-US" sz="1100" dirty="0">
-                <a:solidFill>
-                  <a:srgbClr val="1D2A33"/>
-                </a:solidFill>
-                <a:latin typeface="PingFang SC" pitchFamily="34" charset="0"/>
-                <a:ea typeface="PingFang SC" pitchFamily="34" charset="-122"/>
-                <a:cs typeface="PingFang SC" pitchFamily="34" charset="-120"/>
-              </a:rPr>
-              <a:t>[13] Li Y., Wang Z., Lei Y., Yu X., Che H., Zhang X. (2026) Ecological effects of photovoltaic deployment in China: a remote sensing assessment. Environ. Res. Commun. 8:041016.</a:t>
-            </a:r>
-            <a:endParaRPr lang="en-US" sz="1100" dirty="0"/>
-          </a:p>
-          <a:p>
-            <a:pPr indent="0" marL="0">
-              <a:spcAft>
-                <a:spcPts val="400"/>
-              </a:spcAft>
-              <a:buNone/>
-            </a:pPr>
-            <a:r>
-              <a:rPr lang="en-US" sz="1100" dirty="0">
-                <a:solidFill>
-                  <a:srgbClr val="1D2A33"/>
-                </a:solidFill>
-                <a:latin typeface="PingFang SC" pitchFamily="34" charset="0"/>
-                <a:ea typeface="PingFang SC" pitchFamily="34" charset="-122"/>
-                <a:cs typeface="PingFang SC" pitchFamily="34" charset="-120"/>
-              </a:rPr>
-              <a:t>[14] 彭昀月, 罗永梅, 徐泽楠, 靳彤 (2024) 集中式大型光伏及风电电场生态影响:进展与展望. 生物多样性 32(2):23212.</a:t>
-            </a:r>
-            <a:endParaRPr lang="en-US" sz="1100" dirty="0"/>
-          </a:p>
-          <a:p>
-            <a:pPr indent="0" marL="0">
-              <a:spcAft>
-                <a:spcPts val="400"/>
-              </a:spcAft>
-              <a:buNone/>
-            </a:pPr>
-            <a:r>
-              <a:rPr lang="en-US" sz="1100" dirty="0">
-                <a:solidFill>
-                  <a:srgbClr val="1D2A33"/>
-                </a:solidFill>
-                <a:latin typeface="PingFang SC" pitchFamily="34" charset="0"/>
-                <a:ea typeface="PingFang SC" pitchFamily="34" charset="-122"/>
-                <a:cs typeface="PingFang SC" pitchFamily="34" charset="-120"/>
-              </a:rPr>
-              <a:t>[15] 《中国可再生能源与生物多样性协同发展的机遇与挑战》(征求意见稿),发布机构与日期待核实。</a:t>
-            </a:r>
-            <a:endParaRPr lang="en-US" sz="1100" dirty="0"/>
-          </a:p>
-        </p:txBody>
-      </p:sp>
-      <p:sp>
-        <p:nvSpPr>
-          <p:cNvPr id="4" name="Text 2"/>
-          <p:cNvSpPr/>
-          <p:nvPr/>
-        </p:nvSpPr>
-        <p:spPr>
-          <a:xfrm>
-            <a:off x="11277295" y="6400800"/>
-            <a:ext cx="457200" cy="274320"/>
-          </a:xfrm>
-          <a:prstGeom prst="rect">
-            <a:avLst/>
-          </a:prstGeom>
-          <a:noFill/>
-          <a:ln/>
-        </p:spPr>
-        <p:txBody>
-          <a:bodyPr wrap="square" lIns="0" tIns="0" rIns="0" bIns="0" rtlCol="0" anchor="ctr"/>
-          <a:lstStyle/>
-          <a:p>
-            <a:pPr algn="r" indent="0" marL="0">
-              <a:buNone/>
-            </a:pPr>
-            <a:r>
-              <a:rPr lang="en-US" sz="1000" dirty="0">
-                <a:solidFill>
-                  <a:srgbClr val="5E6B75"/>
-                </a:solidFill>
-                <a:latin typeface="Arial" pitchFamily="34" charset="0"/>
-                <a:ea typeface="Arial" pitchFamily="34" charset="-122"/>
-                <a:cs typeface="Arial" pitchFamily="34" charset="-120"/>
-              </a:rPr>
               <a:t>19</a:t>
             </a:r>
             <a:endParaRPr lang="en-US" sz="1000" dirty="0"/>
@@ -14927,6 +15235,431 @@
 <file path=ppt/slides/slide20.xml><?xml version="1.0" encoding="utf-8"?>
 <p:sld xmlns:a="http://schemas.openxmlformats.org/drawingml/2006/main" xmlns:r="http://schemas.openxmlformats.org/officeDocument/2006/relationships" xmlns:p="http://schemas.openxmlformats.org/presentationml/2006/main">
   <p:cSld name="Slide 20">
+    <p:spTree>
+      <p:nvGrpSpPr>
+        <p:cNvPr id="1" name=""/>
+        <p:cNvGrpSpPr/>
+        <p:nvPr/>
+      </p:nvGrpSpPr>
+      <p:grpSpPr>
+        <a:xfrm>
+          <a:off x="0" y="0"/>
+          <a:ext cx="0" cy="0"/>
+          <a:chOff x="0" y="0"/>
+          <a:chExt cx="0" cy="0"/>
+        </a:xfrm>
+      </p:grpSpPr>
+      <p:sp>
+        <p:nvSpPr>
+          <p:cNvPr id="2" name="Text 0"/>
+          <p:cNvSpPr/>
+          <p:nvPr/>
+        </p:nvSpPr>
+        <p:spPr>
+          <a:xfrm>
+            <a:off x="548640" y="320040"/>
+            <a:ext cx="11094415" cy="685800"/>
+          </a:xfrm>
+          <a:prstGeom prst="rect">
+            <a:avLst/>
+          </a:prstGeom>
+          <a:noFill/>
+          <a:ln/>
+        </p:spPr>
+        <p:txBody>
+          <a:bodyPr wrap="square" lIns="0" tIns="0" rIns="0" bIns="0" rtlCol="0" anchor="ctr"/>
+          <a:lstStyle/>
+          <a:p>
+            <a:pPr indent="0" marL="0">
+              <a:buNone/>
+            </a:pPr>
+            <a:r>
+              <a:rPr lang="en-US" sz="3000" b="1" dirty="0">
+                <a:solidFill>
+                  <a:srgbClr val="0E2F3C"/>
+                </a:solidFill>
+                <a:latin typeface="PingFang SC" pitchFamily="34" charset="0"/>
+                <a:ea typeface="PingFang SC" pitchFamily="34" charset="-122"/>
+                <a:cs typeface="PingFang SC" pitchFamily="34" charset="-120"/>
+              </a:rPr>
+              <a:t>相关文献</a:t>
+            </a:r>
+            <a:endParaRPr lang="en-US" sz="3000" dirty="0"/>
+          </a:p>
+        </p:txBody>
+      </p:sp>
+      <p:sp>
+        <p:nvSpPr>
+          <p:cNvPr id="3" name="Text 1"/>
+          <p:cNvSpPr/>
+          <p:nvPr/>
+        </p:nvSpPr>
+        <p:spPr>
+          <a:xfrm>
+            <a:off x="548640" y="1143000"/>
+            <a:ext cx="11094415" cy="5212080"/>
+          </a:xfrm>
+          <a:prstGeom prst="rect">
+            <a:avLst/>
+          </a:prstGeom>
+          <a:noFill/>
+          <a:ln/>
+        </p:spPr>
+        <p:txBody>
+          <a:bodyPr wrap="square" lIns="0" tIns="0" rIns="0" bIns="0" rtlCol="0" anchor="t"/>
+          <a:lstStyle/>
+          <a:p>
+            <a:pPr indent="0" marL="0">
+              <a:spcAft>
+                <a:spcPts val="400"/>
+              </a:spcAft>
+              <a:buNone/>
+            </a:pPr>
+            <a:r>
+              <a:rPr lang="en-US" sz="1100" dirty="0">
+                <a:solidFill>
+                  <a:srgbClr val="1D2A33"/>
+                </a:solidFill>
+                <a:latin typeface="PingFang SC" pitchFamily="34" charset="0"/>
+                <a:ea typeface="PingFang SC" pitchFamily="34" charset="-122"/>
+                <a:cs typeface="PingFang SC" pitchFamily="34" charset="-120"/>
+              </a:rPr>
+              <a:t>[1] Zhou Z., Sun S., Zhang J., Fang Y., Li B.V. (2026) Comparing potential biodiversity conflicts from renewable energy expansion in China at different centralization levels. Nat. Ecol. Evol. 10:1316–1328.</a:t>
+            </a:r>
+            <a:endParaRPr lang="en-US" sz="1100" dirty="0"/>
+          </a:p>
+          <a:p>
+            <a:pPr indent="0" marL="0">
+              <a:spcAft>
+                <a:spcPts val="400"/>
+              </a:spcAft>
+              <a:buNone/>
+            </a:pPr>
+            <a:r>
+              <a:rPr lang="en-US" sz="1100" dirty="0">
+                <a:solidFill>
+                  <a:srgbClr val="1D2A33"/>
+                </a:solidFill>
+                <a:latin typeface="PingFang SC" pitchFamily="34" charset="0"/>
+                <a:ea typeface="PingFang SC" pitchFamily="34" charset="-122"/>
+                <a:cs typeface="PingFang SC" pitchFamily="34" charset="-120"/>
+              </a:rPr>
+              <a:t>[2] Zhang H. et al. (2026) China's solar expansion policy reduces bird diversity. Science 393:831–836.</a:t>
+            </a:r>
+            <a:endParaRPr lang="en-US" sz="1100" dirty="0"/>
+          </a:p>
+          <a:p>
+            <a:pPr indent="0" marL="0">
+              <a:spcAft>
+                <a:spcPts val="400"/>
+              </a:spcAft>
+              <a:buNone/>
+            </a:pPr>
+            <a:r>
+              <a:rPr lang="en-US" sz="1100" dirty="0">
+                <a:solidFill>
+                  <a:srgbClr val="1D2A33"/>
+                </a:solidFill>
+                <a:latin typeface="PingFang SC" pitchFamily="34" charset="0"/>
+                <a:ea typeface="PingFang SC" pitchFamily="34" charset="-122"/>
+                <a:cs typeface="PingFang SC" pitchFamily="34" charset="-120"/>
+              </a:rPr>
+              <a:t>[3] Robinson C. et al. (2025) Global Renewables Watch: a temporal dataset of solar and wind energy derived from satellite imagery. arXiv:2503.14860.</a:t>
+            </a:r>
+            <a:endParaRPr lang="en-US" sz="1100" dirty="0"/>
+          </a:p>
+          <a:p>
+            <a:pPr indent="0" marL="0">
+              <a:spcAft>
+                <a:spcPts val="400"/>
+              </a:spcAft>
+              <a:buNone/>
+            </a:pPr>
+            <a:r>
+              <a:rPr lang="en-US" sz="1100" dirty="0">
+                <a:solidFill>
+                  <a:srgbClr val="1D2A33"/>
+                </a:solidFill>
+                <a:latin typeface="PingFang SC" pitchFamily="34" charset="0"/>
+                <a:ea typeface="PingFang SC" pitchFamily="34" charset="-122"/>
+                <a:cs typeface="PingFang SC" pitchFamily="34" charset="-120"/>
+              </a:rPr>
+              <a:t>[4] Vectorized solar photovoltaic installation dataset across China in 2015 and 2020. Scientific Data (s41597-024-04356-z).</a:t>
+            </a:r>
+            <a:endParaRPr lang="en-US" sz="1100" dirty="0"/>
+          </a:p>
+          <a:p>
+            <a:pPr indent="0" marL="0">
+              <a:spcAft>
+                <a:spcPts val="400"/>
+              </a:spcAft>
+              <a:buNone/>
+            </a:pPr>
+            <a:r>
+              <a:rPr lang="en-US" sz="1100" dirty="0">
+                <a:solidFill>
+                  <a:srgbClr val="1D2A33"/>
+                </a:solidFill>
+                <a:latin typeface="PingFang SC" pitchFamily="34" charset="0"/>
+                <a:ea typeface="PingFang SC" pitchFamily="34" charset="-122"/>
+                <a:cs typeface="PingFang SC" pitchFamily="34" charset="-120"/>
+              </a:rPr>
+              <a:t>[5] A 10-m national-scale map of ground-mounted photovoltaic power stations in China of 2020. Scientific Data (2024).</a:t>
+            </a:r>
+            <a:endParaRPr lang="en-US" sz="1100" dirty="0"/>
+          </a:p>
+          <a:p>
+            <a:pPr indent="0" marL="0">
+              <a:spcAft>
+                <a:spcPts val="400"/>
+              </a:spcAft>
+              <a:buNone/>
+            </a:pPr>
+            <a:r>
+              <a:rPr lang="en-US" sz="1100" dirty="0">
+                <a:solidFill>
+                  <a:srgbClr val="1D2A33"/>
+                </a:solidFill>
+                <a:latin typeface="PingFang SC" pitchFamily="34" charset="0"/>
+                <a:ea typeface="PingFang SC" pitchFamily="34" charset="-122"/>
+                <a:cs typeface="PingFang SC" pitchFamily="34" charset="-120"/>
+              </a:rPr>
+              <a:t>[6] Satellites reveal spatial heterogeneity in dryland photovoltaic plants' effects on vegetation dynamics. Earth's Future (2024).</a:t>
+            </a:r>
+            <a:endParaRPr lang="en-US" sz="1100" dirty="0"/>
+          </a:p>
+          <a:p>
+            <a:pPr indent="0" marL="0">
+              <a:spcAft>
+                <a:spcPts val="400"/>
+              </a:spcAft>
+              <a:buNone/>
+            </a:pPr>
+            <a:r>
+              <a:rPr lang="en-US" sz="1100" dirty="0">
+                <a:solidFill>
+                  <a:srgbClr val="1D2A33"/>
+                </a:solidFill>
+                <a:latin typeface="PingFang SC" pitchFamily="34" charset="0"/>
+                <a:ea typeface="PingFang SC" pitchFamily="34" charset="-122"/>
+                <a:cs typeface="PingFang SC" pitchFamily="34" charset="-120"/>
+              </a:rPr>
+              <a:t>[7] Diverse vegetation responses to solar farm installation are also driven by climate change. Commun. Earth Environ. (2025).</a:t>
+            </a:r>
+            <a:endParaRPr lang="en-US" sz="1100" dirty="0"/>
+          </a:p>
+          <a:p>
+            <a:pPr indent="0" marL="0">
+              <a:spcAft>
+                <a:spcPts val="400"/>
+              </a:spcAft>
+              <a:buNone/>
+            </a:pPr>
+            <a:r>
+              <a:rPr lang="en-US" sz="1100" dirty="0">
+                <a:solidFill>
+                  <a:srgbClr val="1D2A33"/>
+                </a:solidFill>
+                <a:latin typeface="PingFang SC" pitchFamily="34" charset="0"/>
+                <a:ea typeface="PingFang SC" pitchFamily="34" charset="-122"/>
+                <a:cs typeface="PingFang SC" pitchFamily="34" charset="-120"/>
+              </a:rPr>
+              <a:t>[8] Large-scale photovoltaic farms significantly change the vegetation diversity and biomass through influencing soil moisture. Vadose Zone J. (2025).</a:t>
+            </a:r>
+            <a:endParaRPr lang="en-US" sz="1100" dirty="0"/>
+          </a:p>
+          <a:p>
+            <a:pPr indent="0" marL="0">
+              <a:spcAft>
+                <a:spcPts val="400"/>
+              </a:spcAft>
+              <a:buNone/>
+            </a:pPr>
+            <a:r>
+              <a:rPr lang="en-US" sz="1100" dirty="0">
+                <a:solidFill>
+                  <a:srgbClr val="1D2A33"/>
+                </a:solidFill>
+                <a:latin typeface="PingFang SC" pitchFamily="34" charset="0"/>
+                <a:ea typeface="PingFang SC" pitchFamily="34" charset="-122"/>
+                <a:cs typeface="PingFang SC" pitchFamily="34" charset="-120"/>
+              </a:rPr>
+              <a:t>[9] Wind farms increase land surface temperature and reduce vegetation productivity in the Inner Mongolia. Geography and Sustainability (2024).</a:t>
+            </a:r>
+            <a:endParaRPr lang="en-US" sz="1100" dirty="0"/>
+          </a:p>
+          <a:p>
+            <a:pPr indent="0" marL="0">
+              <a:spcAft>
+                <a:spcPts val="400"/>
+              </a:spcAft>
+              <a:buNone/>
+            </a:pPr>
+            <a:r>
+              <a:rPr lang="en-US" sz="1100" dirty="0">
+                <a:solidFill>
+                  <a:srgbClr val="1D2A33"/>
+                </a:solidFill>
+                <a:latin typeface="PingFang SC" pitchFamily="34" charset="0"/>
+                <a:ea typeface="PingFang SC" pitchFamily="34" charset="-122"/>
+                <a:cs typeface="PingFang SC" pitchFamily="34" charset="-120"/>
+              </a:rPr>
+              <a:t>[10] Callaway B., Sant'Anna P.H.C. (2021) J. Econometrics 225:200–230;Sun L., Abraham S. (2021) J. Econometrics 225:175–199;Rambachan A., Roth J. (2023) Rev. Econ. Stud. 90:2555–2591.</a:t>
+            </a:r>
+            <a:endParaRPr lang="en-US" sz="1100" dirty="0"/>
+          </a:p>
+          <a:p>
+            <a:pPr indent="0" marL="0">
+              <a:spcAft>
+                <a:spcPts val="400"/>
+              </a:spcAft>
+              <a:buNone/>
+            </a:pPr>
+            <a:r>
+              <a:rPr lang="en-US" sz="1100" dirty="0">
+                <a:solidFill>
+                  <a:srgbClr val="1D2A33"/>
+                </a:solidFill>
+                <a:latin typeface="PingFang SC" pitchFamily="34" charset="0"/>
+                <a:ea typeface="PingFang SC" pitchFamily="34" charset="-122"/>
+                <a:cs typeface="PingFang SC" pitchFamily="34" charset="-120"/>
+              </a:rPr>
+              <a:t>[11] Brooks T.M. et al. (2019) Measuring terrestrial Area of Habitat (AOH) and its utility for the IUCN Red List. Trends Ecol. Evol. 34:977–986.</a:t>
+            </a:r>
+            <a:endParaRPr lang="en-US" sz="1100" dirty="0"/>
+          </a:p>
+          <a:p>
+            <a:pPr indent="0" marL="0">
+              <a:spcAft>
+                <a:spcPts val="400"/>
+              </a:spcAft>
+              <a:buNone/>
+            </a:pPr>
+            <a:r>
+              <a:rPr lang="en-US" sz="1100" dirty="0">
+                <a:solidFill>
+                  <a:srgbClr val="1D2A33"/>
+                </a:solidFill>
+                <a:latin typeface="PingFang SC" pitchFamily="34" charset="0"/>
+                <a:ea typeface="PingFang SC" pitchFamily="34" charset="-122"/>
+                <a:cs typeface="PingFang SC" pitchFamily="34" charset="-120"/>
+              </a:rPr>
+              <a:t>[12] Li X., He Z., Xia S., Yang Y. (2024) Greenness change associated with construction and operation of photovoltaic solar energy in China. Renewable Energy 226:120461.</a:t>
+            </a:r>
+            <a:endParaRPr lang="en-US" sz="1100" dirty="0"/>
+          </a:p>
+          <a:p>
+            <a:pPr indent="0" marL="0">
+              <a:spcAft>
+                <a:spcPts val="400"/>
+              </a:spcAft>
+              <a:buNone/>
+            </a:pPr>
+            <a:r>
+              <a:rPr lang="en-US" sz="1100" dirty="0">
+                <a:solidFill>
+                  <a:srgbClr val="1D2A33"/>
+                </a:solidFill>
+                <a:latin typeface="PingFang SC" pitchFamily="34" charset="0"/>
+                <a:ea typeface="PingFang SC" pitchFamily="34" charset="-122"/>
+                <a:cs typeface="PingFang SC" pitchFamily="34" charset="-120"/>
+              </a:rPr>
+              <a:t>[13] Li Y., Wang Z., Lei Y., Yu X., Che H., Zhang X. (2026) Ecological effects of photovoltaic deployment in China: a remote sensing assessment. Environ. Res. Commun. 8:041016.</a:t>
+            </a:r>
+            <a:endParaRPr lang="en-US" sz="1100" dirty="0"/>
+          </a:p>
+          <a:p>
+            <a:pPr indent="0" marL="0">
+              <a:spcAft>
+                <a:spcPts val="400"/>
+              </a:spcAft>
+              <a:buNone/>
+            </a:pPr>
+            <a:r>
+              <a:rPr lang="en-US" sz="1100" dirty="0">
+                <a:solidFill>
+                  <a:srgbClr val="1D2A33"/>
+                </a:solidFill>
+                <a:latin typeface="PingFang SC" pitchFamily="34" charset="0"/>
+                <a:ea typeface="PingFang SC" pitchFamily="34" charset="-122"/>
+                <a:cs typeface="PingFang SC" pitchFamily="34" charset="-120"/>
+              </a:rPr>
+              <a:t>[14] 彭昀月, 罗永梅, 徐泽楠, 靳彤 (2024) 集中式大型光伏及风电电场生态影响:进展与展望. 生物多样性 32(2):23212.</a:t>
+            </a:r>
+            <a:endParaRPr lang="en-US" sz="1100" dirty="0"/>
+          </a:p>
+          <a:p>
+            <a:pPr indent="0" marL="0">
+              <a:spcAft>
+                <a:spcPts val="400"/>
+              </a:spcAft>
+              <a:buNone/>
+            </a:pPr>
+            <a:r>
+              <a:rPr lang="en-US" sz="1100" dirty="0">
+                <a:solidFill>
+                  <a:srgbClr val="1D2A33"/>
+                </a:solidFill>
+                <a:latin typeface="PingFang SC" pitchFamily="34" charset="0"/>
+                <a:ea typeface="PingFang SC" pitchFamily="34" charset="-122"/>
+                <a:cs typeface="PingFang SC" pitchFamily="34" charset="-120"/>
+              </a:rPr>
+              <a:t>[15] 《中国可再生能源与生物多样性协同发展的机遇与挑战》(征求意见稿),发布机构与日期待核实。</a:t>
+            </a:r>
+            <a:endParaRPr lang="en-US" sz="1100" dirty="0"/>
+          </a:p>
+        </p:txBody>
+      </p:sp>
+      <p:sp>
+        <p:nvSpPr>
+          <p:cNvPr id="4" name="Text 2"/>
+          <p:cNvSpPr/>
+          <p:nvPr/>
+        </p:nvSpPr>
+        <p:spPr>
+          <a:xfrm>
+            <a:off x="11277295" y="6400800"/>
+            <a:ext cx="457200" cy="274320"/>
+          </a:xfrm>
+          <a:prstGeom prst="rect">
+            <a:avLst/>
+          </a:prstGeom>
+          <a:noFill/>
+          <a:ln/>
+        </p:spPr>
+        <p:txBody>
+          <a:bodyPr wrap="square" lIns="0" tIns="0" rIns="0" bIns="0" rtlCol="0" anchor="ctr"/>
+          <a:lstStyle/>
+          <a:p>
+            <a:pPr algn="r" indent="0" marL="0">
+              <a:buNone/>
+            </a:pPr>
+            <a:r>
+              <a:rPr lang="en-US" sz="1000" dirty="0">
+                <a:solidFill>
+                  <a:srgbClr val="5E6B75"/>
+                </a:solidFill>
+                <a:latin typeface="Arial" pitchFamily="34" charset="0"/>
+                <a:ea typeface="Arial" pitchFamily="34" charset="-122"/>
+                <a:cs typeface="Arial" pitchFamily="34" charset="-120"/>
+              </a:rPr>
+              <a:t>20</a:t>
+            </a:r>
+            <a:endParaRPr lang="en-US" sz="1000" dirty="0"/>
+          </a:p>
+        </p:txBody>
+      </p:sp>
+    </p:spTree>
+  </p:cSld>
+  <p:clrMapOvr>
+    <a:masterClrMapping/>
+  </p:clrMapOvr>
+</p:sld>
+</file>
+
+<file path=ppt/slides/slide21.xml><?xml version="1.0" encoding="utf-8"?>
+<p:sld xmlns:a="http://schemas.openxmlformats.org/drawingml/2006/main" xmlns:r="http://schemas.openxmlformats.org/officeDocument/2006/relationships" xmlns:p="http://schemas.openxmlformats.org/presentationml/2006/main">
+  <p:cSld name="Slide 21">
     <p:bg>
       <p:bgPr>
         <a:solidFill>
@@ -15084,7 +15817,7 @@
                 <a:ea typeface="PingFang SC" pitchFamily="34" charset="-122"/>
                 <a:cs typeface="PingFang SC" pitchFamily="34" charset="-120"/>
               </a:rPr>
-              <a:t>西北旱区约 200 个 2019–2021 光伏站:绿度与异质性事件研究</a:t>
+              <a:t>重做对照:按建设前 NDVI 轨迹匹配从未建设点,前期延至 2010</a:t>
             </a:r>
             <a:endParaRPr lang="en-US" sz="1800" dirty="0"/>
           </a:p>
@@ -15187,7 +15920,7 @@
                 <a:ea typeface="PingFang SC" pitchFamily="34" charset="-122"/>
                 <a:cs typeface="PingFang SC" pitchFamily="34" charset="-120"/>
               </a:rPr>
-              <a:t>下载 CLCD 2017–2023,复算光伏与风机的建设前覆盖</a:t>
+              <a:t>森林风机 6–13% 区间:高分影像抽样定标</a:t>
             </a:r>
             <a:endParaRPr lang="en-US" sz="1800" dirty="0"/>
           </a:p>

</xml_diff>

<commit_message>
Forest-turbine calibration; matched-control pipeline (in progress)
- gee/12: per-turbine CLCD vs GLC cross-tab (3,721 both forest, 5,346 CLCD
  only, 892 GLC only); blind Sentinel-2 calls on a stratified sample put
  forest turbines at about 8,900 (5,300-9,600), close to CLCD
- gee/11, 11b, 11c: never-built candidates generated locally (3,000),
  matching covariates extracted; NDVI panel extraction still running
- analysis/pilot_nw_matched.R: matched never-treated CS-DiD with hold-out
  pre-test and HonestDiD (to run once the panel is complete)
</commit_message>
<xml_diff>
--- a/RS_Renewables_Biodiversity_Workflow.pptx
+++ b/RS_Renewables_Biodiversity_Workflow.pptx
@@ -12059,7 +12059,7 @@
                 <a:ea typeface="PingFang SC" pitchFamily="34" charset="-122"/>
                 <a:cs typeface="PingFang SC" pitchFamily="34" charset="-120"/>
               </a:rPr>
-              <a:t>CLCD 无稀疏植被类(并入草地),湿地并入水体;两产品逐站主导类别一致 75.5%。按站点数一半建在耕地上。风机森林占比:CLCD 12.5%(9,067 台)、GLC 6.3%(4,613 台),只能报区间,需高分影像定标。</a:t>
+              <a:t>CLCD 无稀疏植被类(并入草地),湿地并入水体;两产品逐站主导类别一致 75.5%。按站点数一半建在耕地上。风机森林:CLCD 12.5%、GLC 6.3%;分层抽 36 台哨兵-2 盲判定标后约 8,900 台(5,300–9,600),接近 CLCD。</a:t>
             </a:r>
             <a:endParaRPr lang="en-US" sz="1150" dirty="0"/>
           </a:p>
@@ -15920,7 +15920,7 @@
                 <a:ea typeface="PingFang SC" pitchFamily="34" charset="-122"/>
                 <a:cs typeface="PingFang SC" pitchFamily="34" charset="-120"/>
               </a:rPr>
-              <a:t>森林风机 6–13% 区间:高分影像抽样定标</a:t>
+              <a:t>森林风机定标扩大样本(含两产品都判非林的一层)</a:t>
             </a:r>
             <a:endParaRPr lang="en-US" sz="1800" dirty="0"/>
           </a:p>

</xml_diff>

<commit_message>
Matched never-built DiD with HonestDiD; site-level bird ring-BACI and occupancy
- gee/11b-11c: filter-before-map fix (>20 min to ~2 s per batch), one sensor
  family per year; 3,365 units x 2010-2024 NDVI panel
- analysis/pilot_nw_matched.R: 362 PV sites vs 530 matched never-built
  points; with 1-year anticipation, on-site NDVI -0.029 (-11%), robust at
  Mbar = 0.5; ring heterogeneity +0.007 (+10%); hold-out test still rejects
- analysis/site_birds_*: near (0-5 km) vs far (8-20 km) checklists with
  site x year FE; 38 data-rich sites; checklist richness -10% (n.s.);
  multispecies occupancy flips sign between 38 and 24 sites -> inconclusive
- analysis/grid_birds_pv.R: 100-km grid matched comparison, null
- Page and deck (23 slides) updated
</commit_message>
<xml_diff>
--- a/RS_Renewables_Biodiversity_Workflow.pptx
+++ b/RS_Renewables_Biodiversity_Workflow.pptx
@@ -26,9 +26,11 @@
     <p:sldId id="274" r:id="rId20"/>
     <p:sldId id="275" r:id="rId21"/>
     <p:sldId id="276" r:id="rId22"/>
+    <p:sldId id="277" r:id="rId23"/>
+    <p:sldId id="278" r:id="rId24"/>
   </p:sldIdLst>
   <p:notesMasterIdLst>
-    <p:notesMasterId r:id="rId23"/>
+    <p:notesMasterId r:id="rId25"/>
   </p:notesMasterIdLst>
   <p:sldSz cx="12192000" cy="6858000"/>
   <p:notesSz cx="6858000" cy="12192000"/>
@@ -2864,6 +2866,182 @@
 </p:notes>
 </file>
 
+<file path=ppt/notesSlides/notesSlide22.xml><?xml version="1.0" encoding="utf-8"?>
+<p:notes xmlns:a="http://schemas.openxmlformats.org/drawingml/2006/main" xmlns:r="http://schemas.openxmlformats.org/officeDocument/2006/relationships" xmlns:p="http://schemas.openxmlformats.org/presentationml/2006/main">
+  <p:cSld>
+    <p:spTree>
+      <p:nvGrpSpPr>
+        <p:cNvPr id="1" name=""/>
+        <p:cNvGrpSpPr/>
+        <p:nvPr/>
+      </p:nvGrpSpPr>
+      <p:grpSpPr>
+        <a:xfrm>
+          <a:off x="0" y="0"/>
+          <a:ext cx="0" cy="0"/>
+          <a:chOff x="0" y="0"/>
+          <a:chExt cx="0" cy="0"/>
+        </a:xfrm>
+      </p:grpSpPr>
+      <p:sp>
+        <p:nvSpPr>
+          <p:cNvPr id="2" name="Slide Image Placeholder 1"/>
+          <p:cNvSpPr>
+            <a:spLocks noGrp="1" noRot="1" noChangeAspect="1"/>
+          </p:cNvSpPr>
+          <p:nvPr>
+            <p:ph type="sldImg"/>
+          </p:nvPr>
+        </p:nvSpPr>
+        <p:spPr/>
+      </p:sp>
+      <p:sp>
+        <p:nvSpPr>
+          <p:cNvPr id="3" name="Notes Placeholder 2"/>
+          <p:cNvSpPr>
+            <a:spLocks noGrp="1"/>
+          </p:cNvSpPr>
+          <p:nvPr>
+            <p:ph type="body" idx="1"/>
+          </p:nvPr>
+        </p:nvSpPr>
+        <p:spPr/>
+        <p:txBody>
+          <a:bodyPr/>
+          <a:lstStyle/>
+          <a:p>
+            <a:r>
+              <a:rPr lang="en-US" dirty="0"/>
+              <a:t/>
+            </a:r>
+            <a:endParaRPr lang="en-US" dirty="0"/>
+          </a:p>
+        </p:txBody>
+      </p:sp>
+      <p:sp>
+        <p:nvSpPr>
+          <p:cNvPr id="4" name="Slide Number Placeholder 3"/>
+          <p:cNvSpPr>
+            <a:spLocks noGrp="1"/>
+          </p:cNvSpPr>
+          <p:nvPr>
+            <p:ph type="sldNum" sz="quarter" idx="10"/>
+          </p:nvPr>
+        </p:nvSpPr>
+        <p:spPr/>
+        <p:txBody>
+          <a:bodyPr/>
+          <a:lstStyle/>
+          <a:p>
+            <a:fld id="{F7021451-1387-4CA6-816F-3879F97B5CBC}" type="slidenum">
+              <a:rPr lang="en-US"/>
+              <a:t>22</a:t>
+            </a:fld>
+            <a:endParaRPr lang="en-US"/>
+          </a:p>
+        </p:txBody>
+      </p:sp>
+    </p:spTree>
+    <p:extLst>
+      <p:ext uri="{BB962C8B-B14F-4D97-AF65-F5344CB8AC3E}">
+        <p14:creationId xmlns:p14="http://schemas.microsoft.com/office/powerpoint/2010/main" val="1024086991"/>
+      </p:ext>
+    </p:extLst>
+  </p:cSld>
+  <p:clrMapOvr>
+    <a:masterClrMapping/>
+  </p:clrMapOvr>
+</p:notes>
+</file>
+
+<file path=ppt/notesSlides/notesSlide23.xml><?xml version="1.0" encoding="utf-8"?>
+<p:notes xmlns:a="http://schemas.openxmlformats.org/drawingml/2006/main" xmlns:r="http://schemas.openxmlformats.org/officeDocument/2006/relationships" xmlns:p="http://schemas.openxmlformats.org/presentationml/2006/main">
+  <p:cSld>
+    <p:spTree>
+      <p:nvGrpSpPr>
+        <p:cNvPr id="1" name=""/>
+        <p:cNvGrpSpPr/>
+        <p:nvPr/>
+      </p:nvGrpSpPr>
+      <p:grpSpPr>
+        <a:xfrm>
+          <a:off x="0" y="0"/>
+          <a:ext cx="0" cy="0"/>
+          <a:chOff x="0" y="0"/>
+          <a:chExt cx="0" cy="0"/>
+        </a:xfrm>
+      </p:grpSpPr>
+      <p:sp>
+        <p:nvSpPr>
+          <p:cNvPr id="2" name="Slide Image Placeholder 1"/>
+          <p:cNvSpPr>
+            <a:spLocks noGrp="1" noRot="1" noChangeAspect="1"/>
+          </p:cNvSpPr>
+          <p:nvPr>
+            <p:ph type="sldImg"/>
+          </p:nvPr>
+        </p:nvSpPr>
+        <p:spPr/>
+      </p:sp>
+      <p:sp>
+        <p:nvSpPr>
+          <p:cNvPr id="3" name="Notes Placeholder 2"/>
+          <p:cNvSpPr>
+            <a:spLocks noGrp="1"/>
+          </p:cNvSpPr>
+          <p:nvPr>
+            <p:ph type="body" idx="1"/>
+          </p:nvPr>
+        </p:nvSpPr>
+        <p:spPr/>
+        <p:txBody>
+          <a:bodyPr/>
+          <a:lstStyle/>
+          <a:p>
+            <a:r>
+              <a:rPr lang="en-US" dirty="0"/>
+              <a:t/>
+            </a:r>
+            <a:endParaRPr lang="en-US" dirty="0"/>
+          </a:p>
+        </p:txBody>
+      </p:sp>
+      <p:sp>
+        <p:nvSpPr>
+          <p:cNvPr id="4" name="Slide Number Placeholder 3"/>
+          <p:cNvSpPr>
+            <a:spLocks noGrp="1"/>
+          </p:cNvSpPr>
+          <p:nvPr>
+            <p:ph type="sldNum" sz="quarter" idx="10"/>
+          </p:nvPr>
+        </p:nvSpPr>
+        <p:spPr/>
+        <p:txBody>
+          <a:bodyPr/>
+          <a:lstStyle/>
+          <a:p>
+            <a:fld id="{F7021451-1387-4CA6-816F-3879F97B5CBC}" type="slidenum">
+              <a:rPr lang="en-US"/>
+              <a:t>23</a:t>
+            </a:fld>
+            <a:endParaRPr lang="en-US"/>
+          </a:p>
+        </p:txBody>
+      </p:sp>
+    </p:spTree>
+    <p:extLst>
+      <p:ext uri="{BB962C8B-B14F-4D97-AF65-F5344CB8AC3E}">
+        <p14:creationId xmlns:p14="http://schemas.microsoft.com/office/powerpoint/2010/main" val="1024086991"/>
+      </p:ext>
+    </p:extLst>
+  </p:cSld>
+  <p:clrMapOvr>
+    <a:masterClrMapping/>
+  </p:clrMapOvr>
+</p:notes>
+</file>
+
 <file path=ppt/notesSlides/notesSlide3.xml><?xml version="1.0" encoding="utf-8"?>
 <p:notes xmlns:a="http://schemas.openxmlformats.org/drawingml/2006/main" xmlns:r="http://schemas.openxmlformats.org/officeDocument/2006/relationships" xmlns:p="http://schemas.openxmlformats.org/presentationml/2006/main">
   <p:cSld>
@@ -13233,15 +13411,2685 @@
                 <a:ea typeface="PingFang SC" pitchFamily="34" charset="-122"/>
                 <a:cs typeface="PingFang SC" pitchFamily="34" charset="-120"/>
               </a:rPr>
-              <a:t>主要风险与对策</a:t>
+              <a:t>修正版:匹配的从未建设对照 + HonestDiD</a:t>
             </a:r>
             <a:endParaRPr lang="en-US" sz="3000" dirty="0"/>
+          </a:p>
+        </p:txBody>
+      </p:sp>
+      <p:sp>
+        <p:nvSpPr>
+          <p:cNvPr id="3" name="Text 1"/>
+          <p:cNvSpPr/>
+          <p:nvPr/>
+        </p:nvSpPr>
+        <p:spPr>
+          <a:xfrm>
+            <a:off x="548640" y="960120"/>
+            <a:ext cx="11094415" cy="365760"/>
+          </a:xfrm>
+          <a:prstGeom prst="rect">
+            <a:avLst/>
+          </a:prstGeom>
+          <a:noFill/>
+          <a:ln/>
+        </p:spPr>
+        <p:txBody>
+          <a:bodyPr wrap="square" lIns="0" tIns="0" rIns="0" bIns="0" rtlCol="0" anchor="ctr"/>
+          <a:lstStyle/>
+          <a:p>
+            <a:pPr indent="0" marL="0">
+              <a:buNone/>
+            </a:pPr>
+            <a:r>
+              <a:rPr lang="en-US" sz="1400" dirty="0">
+                <a:solidFill>
+                  <a:srgbClr val="5E6B75"/>
+                </a:solidFill>
+                <a:latin typeface="PingFang SC" pitchFamily="34" charset="0"/>
+                <a:ea typeface="PingFang SC" pitchFamily="34" charset="-122"/>
+                <a:cs typeface="PingFang SC" pitchFamily="34" charset="-120"/>
+              </a:rPr>
+              <a:t>362 站 vs 530 个匹配点(2010–2016 NDVI 轨迹、PVOUT、坡度、海拔;省份与 CLCD 覆盖精确匹配);1 年预期期</a:t>
+            </a:r>
+            <a:endParaRPr lang="en-US" sz="1400" dirty="0"/>
+          </a:p>
+        </p:txBody>
+      </p:sp>
+      <p:pic>
+        <p:nvPicPr>
+          <p:cNvPr id="4" name="Image 0" descr="results/figures/pilot_nw_matched.png">    </p:cNvPr>
+          <p:cNvPicPr>
+            <a:picLocks noChangeAspect="1"/>
+          </p:cNvPicPr>
+          <p:nvPr/>
+        </p:nvPicPr>
+        <p:blipFill>
+          <a:blip r:embed="rId1"/>
+          <a:stretch>
+            <a:fillRect/>
+          </a:stretch>
+        </p:blipFill>
+        <p:spPr>
+          <a:xfrm>
+            <a:off x="457200" y="1417320"/>
+            <a:ext cx="6583680" cy="4773168"/>
+          </a:xfrm>
+          <a:prstGeom prst="rect">
+            <a:avLst/>
+          </a:prstGeom>
+        </p:spPr>
+      </p:pic>
+      <p:sp>
+        <p:nvSpPr>
+          <p:cNvPr id="5" name="Shape 2"/>
+          <p:cNvSpPr/>
+          <p:nvPr/>
+        </p:nvSpPr>
+        <p:spPr>
+          <a:xfrm>
+            <a:off x="7315200" y="1463040"/>
+            <a:ext cx="4343400" cy="1298448"/>
+          </a:xfrm>
+          <a:prstGeom prst="roundRect">
+            <a:avLst>
+              <a:gd name="adj" fmla="val 4225"/>
+            </a:avLst>
+          </a:prstGeom>
+          <a:solidFill>
+            <a:srgbClr val="F3E7E4"/>
+          </a:solidFill>
+          <a:ln w="12700">
+            <a:solidFill>
+              <a:srgbClr val="F3E7E4"/>
+            </a:solidFill>
+            <a:prstDash val="solid"/>
+          </a:ln>
+        </p:spPr>
+      </p:sp>
+      <p:sp>
+        <p:nvSpPr>
+          <p:cNvPr id="6" name="Text 3"/>
+          <p:cNvSpPr/>
+          <p:nvPr/>
+        </p:nvSpPr>
+        <p:spPr>
+          <a:xfrm>
+            <a:off x="7498080" y="1554480"/>
+            <a:ext cx="4023360" cy="384048"/>
+          </a:xfrm>
+          <a:prstGeom prst="rect">
+            <a:avLst/>
+          </a:prstGeom>
+          <a:noFill/>
+          <a:ln/>
+        </p:spPr>
+        <p:txBody>
+          <a:bodyPr wrap="square" lIns="0" tIns="0" rIns="0" bIns="0" rtlCol="0" anchor="ctr"/>
+          <a:lstStyle/>
+          <a:p>
+            <a:pPr indent="0" marL="0">
+              <a:buNone/>
+            </a:pPr>
+            <a:r>
+              <a:rPr lang="en-US" sz="1500" b="1" dirty="0">
+                <a:solidFill>
+                  <a:srgbClr val="0E2F3C"/>
+                </a:solidFill>
+                <a:latin typeface="PingFang SC" pitchFamily="34" charset="0"/>
+                <a:ea typeface="PingFang SC" pitchFamily="34" charset="-122"/>
+                <a:cs typeface="PingFang SC" pitchFamily="34" charset="-120"/>
+              </a:rPr>
+              <a:t>站内 NDVI −0.029(约 −11%)</a:t>
+            </a:r>
+            <a:endParaRPr lang="en-US" sz="1500" dirty="0"/>
+          </a:p>
+        </p:txBody>
+      </p:sp>
+      <p:sp>
+        <p:nvSpPr>
+          <p:cNvPr id="7" name="Text 4"/>
+          <p:cNvSpPr/>
+          <p:nvPr/>
+        </p:nvSpPr>
+        <p:spPr>
+          <a:xfrm>
+            <a:off x="7498080" y="1965960"/>
+            <a:ext cx="4023360" cy="731520"/>
+          </a:xfrm>
+          <a:prstGeom prst="rect">
+            <a:avLst/>
+          </a:prstGeom>
+          <a:noFill/>
+          <a:ln/>
+        </p:spPr>
+        <p:txBody>
+          <a:bodyPr wrap="square" lIns="0" tIns="0" rIns="0" bIns="0" rtlCol="0" anchor="ctr"/>
+          <a:lstStyle/>
+          <a:p>
+            <a:pPr indent="0" marL="0">
+              <a:buNone/>
+            </a:pPr>
+            <a:r>
+              <a:rPr lang="en-US" sz="1150" dirty="0">
+                <a:solidFill>
+                  <a:srgbClr val="1D2A33"/>
+                </a:solidFill>
+                <a:latin typeface="PingFang SC" pitchFamily="34" charset="0"/>
+                <a:ea typeface="PingFang SC" pitchFamily="34" charset="-122"/>
+                <a:cs typeface="PingFang SC" pitchFamily="34" charset="-120"/>
+              </a:rPr>
+              <a:t>95% CI −0.043 至 −0.016;HonestDiD 在 Mbar = 0.5 仍显著(−0.054, −0.002)</a:t>
+            </a:r>
+            <a:endParaRPr lang="en-US" sz="1150" dirty="0"/>
+          </a:p>
+        </p:txBody>
+      </p:sp>
+      <p:sp>
+        <p:nvSpPr>
+          <p:cNvPr id="8" name="Shape 5"/>
+          <p:cNvSpPr/>
+          <p:nvPr/>
+        </p:nvSpPr>
+        <p:spPr>
+          <a:xfrm>
+            <a:off x="7315200" y="2926080"/>
+            <a:ext cx="4343400" cy="1298448"/>
+          </a:xfrm>
+          <a:prstGeom prst="roundRect">
+            <a:avLst>
+              <a:gd name="adj" fmla="val 4225"/>
+            </a:avLst>
+          </a:prstGeom>
+          <a:solidFill>
+            <a:srgbClr val="EEF4F4"/>
+          </a:solidFill>
+          <a:ln w="12700">
+            <a:solidFill>
+              <a:srgbClr val="EEF4F4"/>
+            </a:solidFill>
+            <a:prstDash val="solid"/>
+          </a:ln>
+        </p:spPr>
+      </p:sp>
+      <p:sp>
+        <p:nvSpPr>
+          <p:cNvPr id="9" name="Text 6"/>
+          <p:cNvSpPr/>
+          <p:nvPr/>
+        </p:nvSpPr>
+        <p:spPr>
+          <a:xfrm>
+            <a:off x="7498080" y="3017520"/>
+            <a:ext cx="4023360" cy="384048"/>
+          </a:xfrm>
+          <a:prstGeom prst="rect">
+            <a:avLst/>
+          </a:prstGeom>
+          <a:noFill/>
+          <a:ln/>
+        </p:spPr>
+        <p:txBody>
+          <a:bodyPr wrap="square" lIns="0" tIns="0" rIns="0" bIns="0" rtlCol="0" anchor="ctr"/>
+          <a:lstStyle/>
+          <a:p>
+            <a:pPr indent="0" marL="0">
+              <a:buNone/>
+            </a:pPr>
+            <a:r>
+              <a:rPr lang="en-US" sz="1500" b="1" dirty="0">
+                <a:solidFill>
+                  <a:srgbClr val="0E2F3C"/>
+                </a:solidFill>
+                <a:latin typeface="PingFang SC" pitchFamily="34" charset="0"/>
+                <a:ea typeface="PingFang SC" pitchFamily="34" charset="-122"/>
+                <a:cs typeface="PingFang SC" pitchFamily="34" charset="-120"/>
+              </a:rPr>
+              <a:t>外围环异质性 +0.007(约 +10%)</a:t>
+            </a:r>
+            <a:endParaRPr lang="en-US" sz="1500" dirty="0"/>
+          </a:p>
+        </p:txBody>
+      </p:sp>
+      <p:sp>
+        <p:nvSpPr>
+          <p:cNvPr id="10" name="Text 7"/>
+          <p:cNvSpPr/>
+          <p:nvPr/>
+        </p:nvSpPr>
+        <p:spPr>
+          <a:xfrm>
+            <a:off x="7498080" y="3429000"/>
+            <a:ext cx="4023360" cy="731520"/>
+          </a:xfrm>
+          <a:prstGeom prst="rect">
+            <a:avLst/>
+          </a:prstGeom>
+          <a:noFill/>
+          <a:ln/>
+        </p:spPr>
+        <p:txBody>
+          <a:bodyPr wrap="square" lIns="0" tIns="0" rIns="0" bIns="0" rtlCol="0" anchor="ctr"/>
+          <a:lstStyle/>
+          <a:p>
+            <a:pPr indent="0" marL="0">
+              <a:buNone/>
+            </a:pPr>
+            <a:r>
+              <a:rPr lang="en-US" sz="1150" dirty="0">
+                <a:solidFill>
+                  <a:srgbClr val="1D2A33"/>
+                </a:solidFill>
+                <a:latin typeface="PingFang SC" pitchFamily="34" charset="0"/>
+                <a:ea typeface="PingFang SC" pitchFamily="34" charset="-122"/>
+                <a:cs typeface="PingFang SC" pitchFamily="34" charset="-120"/>
+              </a:rPr>
+              <a:t>外围 NDVI 均值不变;异质性上升,方向与 H3 同质化相反</a:t>
+            </a:r>
+            <a:endParaRPr lang="en-US" sz="1150" dirty="0"/>
+          </a:p>
+        </p:txBody>
+      </p:sp>
+      <p:sp>
+        <p:nvSpPr>
+          <p:cNvPr id="11" name="Shape 8"/>
+          <p:cNvSpPr/>
+          <p:nvPr/>
+        </p:nvSpPr>
+        <p:spPr>
+          <a:xfrm>
+            <a:off x="7315200" y="4389120"/>
+            <a:ext cx="4343400" cy="1298448"/>
+          </a:xfrm>
+          <a:prstGeom prst="roundRect">
+            <a:avLst>
+              <a:gd name="adj" fmla="val 4225"/>
+            </a:avLst>
+          </a:prstGeom>
+          <a:solidFill>
+            <a:srgbClr val="FBF1DF"/>
+          </a:solidFill>
+          <a:ln w="12700">
+            <a:solidFill>
+              <a:srgbClr val="FBF1DF"/>
+            </a:solidFill>
+            <a:prstDash val="solid"/>
+          </a:ln>
+        </p:spPr>
+      </p:sp>
+      <p:sp>
+        <p:nvSpPr>
+          <p:cNvPr id="12" name="Text 9"/>
+          <p:cNvSpPr/>
+          <p:nvPr/>
+        </p:nvSpPr>
+        <p:spPr>
+          <a:xfrm>
+            <a:off x="7498080" y="4480560"/>
+            <a:ext cx="4023360" cy="384048"/>
+          </a:xfrm>
+          <a:prstGeom prst="rect">
+            <a:avLst/>
+          </a:prstGeom>
+          <a:noFill/>
+          <a:ln/>
+        </p:spPr>
+        <p:txBody>
+          <a:bodyPr wrap="square" lIns="0" tIns="0" rIns="0" bIns="0" rtlCol="0" anchor="ctr"/>
+          <a:lstStyle/>
+          <a:p>
+            <a:pPr indent="0" marL="0">
+              <a:buNone/>
+            </a:pPr>
+            <a:r>
+              <a:rPr lang="en-US" sz="1500" b="1" dirty="0">
+                <a:solidFill>
+                  <a:srgbClr val="0E2F3C"/>
+                </a:solidFill>
+                <a:latin typeface="PingFang SC" pitchFamily="34" charset="0"/>
+                <a:ea typeface="PingFang SC" pitchFamily="34" charset="-122"/>
+                <a:cs typeface="PingFang SC" pitchFamily="34" charset="-120"/>
+              </a:rPr>
+              <a:t>G2 有条件通过</a:t>
+            </a:r>
+            <a:endParaRPr lang="en-US" sz="1500" dirty="0"/>
+          </a:p>
+        </p:txBody>
+      </p:sp>
+      <p:sp>
+        <p:nvSpPr>
+          <p:cNvPr id="13" name="Text 10"/>
+          <p:cNvSpPr/>
+          <p:nvPr/>
+        </p:nvSpPr>
+        <p:spPr>
+          <a:xfrm>
+            <a:off x="7498080" y="4892040"/>
+            <a:ext cx="4023360" cy="731520"/>
+          </a:xfrm>
+          <a:prstGeom prst="rect">
+            <a:avLst/>
+          </a:prstGeom>
+          <a:noFill/>
+          <a:ln/>
+        </p:spPr>
+        <p:txBody>
+          <a:bodyPr wrap="square" lIns="0" tIns="0" rIns="0" bIns="0" rtlCol="0" anchor="ctr"/>
+          <a:lstStyle/>
+          <a:p>
+            <a:pPr indent="0" marL="0">
+              <a:buNone/>
+            </a:pPr>
+            <a:r>
+              <a:rPr lang="en-US" sz="1150" dirty="0">
+                <a:solidFill>
+                  <a:srgbClr val="1D2A33"/>
+                </a:solidFill>
+                <a:latin typeface="PingFang SC" pitchFamily="34" charset="0"/>
+                <a:ea typeface="PingFang SC" pitchFamily="34" charset="-122"/>
+                <a:cs typeface="PingFang SC" pitchFamily="34" charset="-120"/>
+              </a:rPr>
+              <a:t>e = −1 已先降一个台阶(清表早于面板可见);留出检验仍拒绝,稳健性靠 HonestDiD 的界</a:t>
+            </a:r>
+            <a:endParaRPr lang="en-US" sz="1150" dirty="0"/>
+          </a:p>
+        </p:txBody>
+      </p:sp>
+      <p:sp>
+        <p:nvSpPr>
+          <p:cNvPr id="14" name="Text 11"/>
+          <p:cNvSpPr/>
+          <p:nvPr/>
+        </p:nvSpPr>
+        <p:spPr>
+          <a:xfrm>
+            <a:off x="11277295" y="6400800"/>
+            <a:ext cx="457200" cy="274320"/>
+          </a:xfrm>
+          <a:prstGeom prst="rect">
+            <a:avLst/>
+          </a:prstGeom>
+          <a:noFill/>
+          <a:ln/>
+        </p:spPr>
+        <p:txBody>
+          <a:bodyPr wrap="square" lIns="0" tIns="0" rIns="0" bIns="0" rtlCol="0" anchor="ctr"/>
+          <a:lstStyle/>
+          <a:p>
+            <a:pPr algn="r" indent="0" marL="0">
+              <a:buNone/>
+            </a:pPr>
+            <a:r>
+              <a:rPr lang="en-US" sz="1000" dirty="0">
+                <a:solidFill>
+                  <a:srgbClr val="5E6B75"/>
+                </a:solidFill>
+                <a:latin typeface="Arial" pitchFamily="34" charset="0"/>
+                <a:ea typeface="Arial" pitchFamily="34" charset="-122"/>
+                <a:cs typeface="Arial" pitchFamily="34" charset="-120"/>
+              </a:rPr>
+              <a:t>19</a:t>
+            </a:r>
+            <a:endParaRPr lang="en-US" sz="1000" dirty="0"/>
+          </a:p>
+        </p:txBody>
+      </p:sp>
+    </p:spTree>
+  </p:cSld>
+  <p:clrMapOvr>
+    <a:masterClrMapping/>
+  </p:clrMapOvr>
+</p:sld>
+</file>
+
+<file path=ppt/slides/slide2.xml><?xml version="1.0" encoding="utf-8"?>
+<p:sld xmlns:a="http://schemas.openxmlformats.org/drawingml/2006/main" xmlns:r="http://schemas.openxmlformats.org/officeDocument/2006/relationships" xmlns:p="http://schemas.openxmlformats.org/presentationml/2006/main">
+  <p:cSld name="Slide 2">
+    <p:spTree>
+      <p:nvGrpSpPr>
+        <p:cNvPr id="1" name=""/>
+        <p:cNvGrpSpPr/>
+        <p:nvPr/>
+      </p:nvGrpSpPr>
+      <p:grpSpPr>
+        <a:xfrm>
+          <a:off x="0" y="0"/>
+          <a:ext cx="0" cy="0"/>
+          <a:chOff x="0" y="0"/>
+          <a:chExt cx="0" cy="0"/>
+        </a:xfrm>
+      </p:grpSpPr>
+      <p:sp>
+        <p:nvSpPr>
+          <p:cNvPr id="2" name="Text 0"/>
+          <p:cNvSpPr/>
+          <p:nvPr/>
+        </p:nvSpPr>
+        <p:spPr>
+          <a:xfrm>
+            <a:off x="548640" y="320040"/>
+            <a:ext cx="11094415" cy="685800"/>
+          </a:xfrm>
+          <a:prstGeom prst="rect">
+            <a:avLst/>
+          </a:prstGeom>
+          <a:noFill/>
+          <a:ln/>
+        </p:spPr>
+        <p:txBody>
+          <a:bodyPr wrap="square" lIns="0" tIns="0" rIns="0" bIns="0" rtlCol="0" anchor="ctr"/>
+          <a:lstStyle/>
+          <a:p>
+            <a:pPr indent="0" marL="0">
+              <a:buNone/>
+            </a:pPr>
+            <a:r>
+              <a:rPr lang="en-US" sz="3000" b="1" dirty="0">
+                <a:solidFill>
+                  <a:srgbClr val="0E2F3C"/>
+                </a:solidFill>
+                <a:latin typeface="PingFang SC" pitchFamily="34" charset="0"/>
+                <a:ea typeface="PingFang SC" pitchFamily="34" charset="-122"/>
+                <a:cs typeface="PingFang SC" pitchFamily="34" charset="-120"/>
+              </a:rPr>
+              <a:t>一句话判断</a:t>
+            </a:r>
+            <a:endParaRPr lang="en-US" sz="3000" dirty="0"/>
+          </a:p>
+        </p:txBody>
+      </p:sp>
+      <p:sp>
+        <p:nvSpPr>
+          <p:cNvPr id="3" name="Text 1"/>
+          <p:cNvSpPr/>
+          <p:nvPr/>
+        </p:nvSpPr>
+        <p:spPr>
+          <a:xfrm>
+            <a:off x="548640" y="960120"/>
+            <a:ext cx="11094415" cy="365760"/>
+          </a:xfrm>
+          <a:prstGeom prst="rect">
+            <a:avLst/>
+          </a:prstGeom>
+          <a:noFill/>
+          <a:ln/>
+        </p:spPr>
+        <p:txBody>
+          <a:bodyPr wrap="square" lIns="0" tIns="0" rIns="0" bIns="0" rtlCol="0" anchor="ctr"/>
+          <a:lstStyle/>
+          <a:p>
+            <a:pPr indent="0" marL="0">
+              <a:buNone/>
+            </a:pPr>
+            <a:r>
+              <a:rPr lang="en-US" sz="1400" dirty="0">
+                <a:solidFill>
+                  <a:srgbClr val="5E6B75"/>
+                </a:solidFill>
+                <a:latin typeface="PingFang SC" pitchFamily="34" charset="0"/>
+                <a:ea typeface="PingFang SC" pitchFamily="34" charset="-122"/>
+                <a:cs typeface="PingFang SC" pitchFamily="34" charset="-120"/>
+              </a:rPr>
+              <a:t>可以做,时机好;全国绿度评估已有(Li 等 2024),新意在因果对照、异质性、风电与物种暴露</a:t>
+            </a:r>
+            <a:endParaRPr lang="en-US" sz="1400" dirty="0"/>
+          </a:p>
+        </p:txBody>
+      </p:sp>
+      <p:sp>
+        <p:nvSpPr>
+          <p:cNvPr id="4" name="Shape 2"/>
+          <p:cNvSpPr/>
+          <p:nvPr/>
+        </p:nvSpPr>
+        <p:spPr>
+          <a:xfrm>
+            <a:off x="548640" y="1645920"/>
+            <a:ext cx="5120640" cy="4206240"/>
+          </a:xfrm>
+          <a:prstGeom prst="roundRect">
+            <a:avLst>
+              <a:gd name="adj" fmla="val 1739"/>
+            </a:avLst>
+          </a:prstGeom>
+          <a:solidFill>
+            <a:srgbClr val="0E2F3C"/>
+          </a:solidFill>
+          <a:ln w="12700">
+            <a:solidFill>
+              <a:srgbClr val="0E2F3C"/>
+            </a:solidFill>
+            <a:prstDash val="solid"/>
+          </a:ln>
+        </p:spPr>
+      </p:sp>
+      <p:sp>
+        <p:nvSpPr>
+          <p:cNvPr id="5" name="Text 3"/>
+          <p:cNvSpPr/>
+          <p:nvPr/>
+        </p:nvSpPr>
+        <p:spPr>
+          <a:xfrm>
+            <a:off x="822960" y="2011680"/>
+            <a:ext cx="4572000" cy="731520"/>
+          </a:xfrm>
+          <a:prstGeom prst="rect">
+            <a:avLst/>
+          </a:prstGeom>
+          <a:noFill/>
+          <a:ln/>
+        </p:spPr>
+        <p:txBody>
+          <a:bodyPr wrap="square" lIns="0" tIns="0" rIns="0" bIns="0" rtlCol="0" anchor="ctr"/>
+          <a:lstStyle/>
+          <a:p>
+            <a:pPr indent="0" marL="0">
+              <a:buNone/>
+            </a:pPr>
+            <a:r>
+              <a:rPr lang="en-US" sz="3400" b="1" dirty="0">
+                <a:solidFill>
+                  <a:srgbClr val="E9A23B"/>
+                </a:solidFill>
+                <a:latin typeface="Arial" pitchFamily="34" charset="0"/>
+                <a:ea typeface="Arial" pitchFamily="34" charset="-122"/>
+                <a:cs typeface="Arial" pitchFamily="34" charset="-120"/>
+              </a:rPr>
+              <a:t>2017Q4 – 2024Q2</a:t>
+            </a:r>
+            <a:endParaRPr lang="en-US" sz="3400" dirty="0"/>
+          </a:p>
+        </p:txBody>
+      </p:sp>
+      <p:sp>
+        <p:nvSpPr>
+          <p:cNvPr id="6" name="Text 4"/>
+          <p:cNvSpPr/>
+          <p:nvPr/>
+        </p:nvSpPr>
+        <p:spPr>
+          <a:xfrm>
+            <a:off x="822960" y="2834640"/>
+            <a:ext cx="4572000" cy="1097280"/>
+          </a:xfrm>
+          <a:prstGeom prst="rect">
+            <a:avLst/>
+          </a:prstGeom>
+          <a:noFill/>
+          <a:ln/>
+        </p:spPr>
+        <p:txBody>
+          <a:bodyPr wrap="square" lIns="0" tIns="0" rIns="0" bIns="0" rtlCol="0" anchor="ctr"/>
+          <a:lstStyle/>
+          <a:p>
+            <a:pPr indent="0" marL="0">
+              <a:buNone/>
+            </a:pPr>
+            <a:r>
+              <a:rPr lang="en-US" sz="1500" dirty="0">
+                <a:solidFill>
+                  <a:srgbClr val="FFFFFF"/>
+                </a:solidFill>
+                <a:latin typeface="PingFang SC" pitchFamily="34" charset="0"/>
+                <a:ea typeface="PingFang SC" pitchFamily="34" charset="-122"/>
+                <a:cs typeface="PingFang SC" pitchFamily="34" charset="-120"/>
+              </a:rPr>
+              <a:t>Global Renewables Watch 为全球每个光伏电站和陆上风机标注了季度精度的建设日期</a:t>
+            </a:r>
+            <a:endParaRPr lang="en-US" sz="1500" dirty="0"/>
+          </a:p>
+        </p:txBody>
+      </p:sp>
+      <p:sp>
+        <p:nvSpPr>
+          <p:cNvPr id="7" name="Text 5"/>
+          <p:cNvSpPr/>
+          <p:nvPr/>
+        </p:nvSpPr>
+        <p:spPr>
+          <a:xfrm>
+            <a:off x="822960" y="4114800"/>
+            <a:ext cx="4572000" cy="1097280"/>
+          </a:xfrm>
+          <a:prstGeom prst="rect">
+            <a:avLst/>
+          </a:prstGeom>
+          <a:noFill/>
+          <a:ln/>
+        </p:spPr>
+        <p:txBody>
+          <a:bodyPr wrap="square" lIns="0" tIns="0" rIns="0" bIns="0" rtlCol="0" anchor="ctr"/>
+          <a:lstStyle/>
+          <a:p>
+            <a:pPr indent="0" marL="0">
+              <a:buNone/>
+            </a:pPr>
+            <a:r>
+              <a:rPr lang="en-US" sz="1500" dirty="0">
+                <a:solidFill>
+                  <a:srgbClr val="CFE3E6"/>
+                </a:solidFill>
+                <a:latin typeface="PingFang SC" pitchFamily="34" charset="0"/>
+                <a:ea typeface="PingFang SC" pitchFamily="34" charset="-122"/>
+                <a:cs typeface="PingFang SC" pitchFamily="34" charset="-120"/>
+              </a:rPr>
+              <a:t>这让"建设前后、早建与晚建"的交错双重差分第一次可以在全国尺度上做</a:t>
+            </a:r>
+            <a:endParaRPr lang="en-US" sz="1500" dirty="0"/>
+          </a:p>
+        </p:txBody>
+      </p:sp>
+      <p:sp>
+        <p:nvSpPr>
+          <p:cNvPr id="8" name="Shape 6"/>
+          <p:cNvSpPr/>
+          <p:nvPr/>
+        </p:nvSpPr>
+        <p:spPr>
+          <a:xfrm>
+            <a:off x="6126480" y="1828800"/>
+            <a:ext cx="548640" cy="548640"/>
+          </a:xfrm>
+          <a:prstGeom prst="ellipse">
+            <a:avLst/>
+          </a:prstGeom>
+          <a:solidFill>
+            <a:srgbClr val="E9A23B"/>
+          </a:solidFill>
+          <a:ln w="12700">
+            <a:solidFill>
+              <a:srgbClr val="E9A23B"/>
+            </a:solidFill>
+            <a:prstDash val="solid"/>
+          </a:ln>
+        </p:spPr>
+      </p:sp>
+      <p:sp>
+        <p:nvSpPr>
+          <p:cNvPr id="9" name="Text 7"/>
+          <p:cNvSpPr/>
+          <p:nvPr/>
+        </p:nvSpPr>
+        <p:spPr>
+          <a:xfrm>
+            <a:off x="6126480" y="1828800"/>
+            <a:ext cx="548640" cy="548640"/>
+          </a:xfrm>
+          <a:prstGeom prst="rect">
+            <a:avLst/>
+          </a:prstGeom>
+          <a:noFill/>
+          <a:ln/>
+        </p:spPr>
+        <p:txBody>
+          <a:bodyPr wrap="square" lIns="0" tIns="0" rIns="0" bIns="0" rtlCol="0" anchor="ctr"/>
+          <a:lstStyle/>
+          <a:p>
+            <a:pPr algn="ctr" indent="0" marL="0">
+              <a:buNone/>
+            </a:pPr>
+            <a:r>
+              <a:rPr lang="en-US" sz="1400" b="1" dirty="0">
+                <a:solidFill>
+                  <a:srgbClr val="FFFFFF"/>
+                </a:solidFill>
+                <a:latin typeface="Arial" pitchFamily="34" charset="0"/>
+                <a:ea typeface="Arial" pitchFamily="34" charset="-122"/>
+                <a:cs typeface="Arial" pitchFamily="34" charset="-120"/>
+              </a:rPr>
+              <a:t>1</a:t>
+            </a:r>
+            <a:endParaRPr lang="en-US" sz="1400" dirty="0"/>
+          </a:p>
+        </p:txBody>
+      </p:sp>
+      <p:sp>
+        <p:nvSpPr>
+          <p:cNvPr id="10" name="Text 8"/>
+          <p:cNvSpPr/>
+          <p:nvPr/>
+        </p:nvSpPr>
+        <p:spPr>
+          <a:xfrm>
+            <a:off x="6858000" y="1691640"/>
+            <a:ext cx="4754880" cy="411480"/>
+          </a:xfrm>
+          <a:prstGeom prst="rect">
+            <a:avLst/>
+          </a:prstGeom>
+          <a:noFill/>
+          <a:ln/>
+        </p:spPr>
+        <p:txBody>
+          <a:bodyPr wrap="square" lIns="0" tIns="0" rIns="0" bIns="0" rtlCol="0" anchor="ctr"/>
+          <a:lstStyle/>
+          <a:p>
+            <a:pPr indent="0" marL="0">
+              <a:buNone/>
+            </a:pPr>
+            <a:r>
+              <a:rPr lang="en-US" sz="1700" b="1" dirty="0">
+                <a:solidFill>
+                  <a:srgbClr val="0E2F3C"/>
+                </a:solidFill>
+                <a:latin typeface="PingFang SC" pitchFamily="34" charset="0"/>
+                <a:ea typeface="PingFang SC" pitchFamily="34" charset="-122"/>
+                <a:cs typeface="PingFang SC" pitchFamily="34" charset="-120"/>
+              </a:rPr>
+              <a:t>暴露</a:t>
+            </a:r>
+            <a:endParaRPr lang="en-US" sz="1700" dirty="0"/>
+          </a:p>
+        </p:txBody>
+      </p:sp>
+      <p:sp>
+        <p:nvSpPr>
+          <p:cNvPr id="11" name="Text 9"/>
+          <p:cNvSpPr/>
+          <p:nvPr/>
+        </p:nvSpPr>
+        <p:spPr>
+          <a:xfrm>
+            <a:off x="6858000" y="2103120"/>
+            <a:ext cx="4754880" cy="502920"/>
+          </a:xfrm>
+          <a:prstGeom prst="rect">
+            <a:avLst/>
+          </a:prstGeom>
+          <a:noFill/>
+          <a:ln/>
+        </p:spPr>
+        <p:txBody>
+          <a:bodyPr wrap="square" lIns="0" tIns="0" rIns="0" bIns="0" rtlCol="0" anchor="ctr"/>
+          <a:lstStyle/>
+          <a:p>
+            <a:pPr indent="0" marL="0">
+              <a:buNone/>
+            </a:pPr>
+            <a:r>
+              <a:rPr lang="en-US" sz="1400" dirty="0">
+                <a:solidFill>
+                  <a:srgbClr val="1D2A33"/>
+                </a:solidFill>
+                <a:latin typeface="PingFang SC" pitchFamily="34" charset="0"/>
+                <a:ea typeface="PingFang SC" pitchFamily="34" charset="-122"/>
+                <a:cs typeface="PingFang SC" pitchFamily="34" charset="-120"/>
+              </a:rPr>
+              <a:t>真实设施足迹与建设日期,而非县级政策指数</a:t>
+            </a:r>
+            <a:endParaRPr lang="en-US" sz="1400" dirty="0"/>
+          </a:p>
+        </p:txBody>
+      </p:sp>
+      <p:sp>
+        <p:nvSpPr>
+          <p:cNvPr id="12" name="Shape 10"/>
+          <p:cNvSpPr/>
+          <p:nvPr/>
+        </p:nvSpPr>
+        <p:spPr>
+          <a:xfrm>
+            <a:off x="6126480" y="2880360"/>
+            <a:ext cx="548640" cy="548640"/>
+          </a:xfrm>
+          <a:prstGeom prst="ellipse">
+            <a:avLst/>
+          </a:prstGeom>
+          <a:solidFill>
+            <a:srgbClr val="1F6F78"/>
+          </a:solidFill>
+          <a:ln w="12700">
+            <a:solidFill>
+              <a:srgbClr val="1F6F78"/>
+            </a:solidFill>
+            <a:prstDash val="solid"/>
+          </a:ln>
+        </p:spPr>
+      </p:sp>
+      <p:sp>
+        <p:nvSpPr>
+          <p:cNvPr id="13" name="Text 11"/>
+          <p:cNvSpPr/>
+          <p:nvPr/>
+        </p:nvSpPr>
+        <p:spPr>
+          <a:xfrm>
+            <a:off x="6126480" y="2880360"/>
+            <a:ext cx="548640" cy="548640"/>
+          </a:xfrm>
+          <a:prstGeom prst="rect">
+            <a:avLst/>
+          </a:prstGeom>
+          <a:noFill/>
+          <a:ln/>
+        </p:spPr>
+        <p:txBody>
+          <a:bodyPr wrap="square" lIns="0" tIns="0" rIns="0" bIns="0" rtlCol="0" anchor="ctr"/>
+          <a:lstStyle/>
+          <a:p>
+            <a:pPr algn="ctr" indent="0" marL="0">
+              <a:buNone/>
+            </a:pPr>
+            <a:r>
+              <a:rPr lang="en-US" sz="1400" b="1" dirty="0">
+                <a:solidFill>
+                  <a:srgbClr val="FFFFFF"/>
+                </a:solidFill>
+                <a:latin typeface="Arial" pitchFamily="34" charset="0"/>
+                <a:ea typeface="Arial" pitchFamily="34" charset="-122"/>
+                <a:cs typeface="Arial" pitchFamily="34" charset="-120"/>
+              </a:rPr>
+              <a:t>2</a:t>
+            </a:r>
+            <a:endParaRPr lang="en-US" sz="1400" dirty="0"/>
+          </a:p>
+        </p:txBody>
+      </p:sp>
+      <p:sp>
+        <p:nvSpPr>
+          <p:cNvPr id="14" name="Text 12"/>
+          <p:cNvSpPr/>
+          <p:nvPr/>
+        </p:nvSpPr>
+        <p:spPr>
+          <a:xfrm>
+            <a:off x="6858000" y="2743200"/>
+            <a:ext cx="4754880" cy="411480"/>
+          </a:xfrm>
+          <a:prstGeom prst="rect">
+            <a:avLst/>
+          </a:prstGeom>
+          <a:noFill/>
+          <a:ln/>
+        </p:spPr>
+        <p:txBody>
+          <a:bodyPr wrap="square" lIns="0" tIns="0" rIns="0" bIns="0" rtlCol="0" anchor="ctr"/>
+          <a:lstStyle/>
+          <a:p>
+            <a:pPr indent="0" marL="0">
+              <a:buNone/>
+            </a:pPr>
+            <a:r>
+              <a:rPr lang="en-US" sz="1700" b="1" dirty="0">
+                <a:solidFill>
+                  <a:srgbClr val="0E2F3C"/>
+                </a:solidFill>
+                <a:latin typeface="PingFang SC" pitchFamily="34" charset="0"/>
+                <a:ea typeface="PingFang SC" pitchFamily="34" charset="-122"/>
+                <a:cs typeface="PingFang SC" pitchFamily="34" charset="-120"/>
+              </a:rPr>
+              <a:t>结局</a:t>
+            </a:r>
+            <a:endParaRPr lang="en-US" sz="1700" dirty="0"/>
+          </a:p>
+        </p:txBody>
+      </p:sp>
+      <p:sp>
+        <p:nvSpPr>
+          <p:cNvPr id="15" name="Text 13"/>
+          <p:cNvSpPr/>
+          <p:nvPr/>
+        </p:nvSpPr>
+        <p:spPr>
+          <a:xfrm>
+            <a:off x="6858000" y="3154680"/>
+            <a:ext cx="4754880" cy="502920"/>
+          </a:xfrm>
+          <a:prstGeom prst="rect">
+            <a:avLst/>
+          </a:prstGeom>
+          <a:noFill/>
+          <a:ln/>
+        </p:spPr>
+        <p:txBody>
+          <a:bodyPr wrap="square" lIns="0" tIns="0" rIns="0" bIns="0" rtlCol="0" anchor="ctr"/>
+          <a:lstStyle/>
+          <a:p>
+            <a:pPr indent="0" marL="0">
+              <a:buNone/>
+            </a:pPr>
+            <a:r>
+              <a:rPr lang="en-US" sz="1400" dirty="0">
+                <a:solidFill>
+                  <a:srgbClr val="1D2A33"/>
+                </a:solidFill>
+                <a:latin typeface="PingFang SC" pitchFamily="34" charset="0"/>
+                <a:ea typeface="PingFang SC" pitchFamily="34" charset="-122"/>
+                <a:cs typeface="PingFang SC" pitchFamily="34" charset="-120"/>
+              </a:rPr>
+              <a:t>栖息地状况的遥感指标与物种暴露,不依赖观测努力</a:t>
+            </a:r>
+            <a:endParaRPr lang="en-US" sz="1400" dirty="0"/>
+          </a:p>
+        </p:txBody>
+      </p:sp>
+      <p:sp>
+        <p:nvSpPr>
+          <p:cNvPr id="16" name="Shape 14"/>
+          <p:cNvSpPr/>
+          <p:nvPr/>
+        </p:nvSpPr>
+        <p:spPr>
+          <a:xfrm>
+            <a:off x="6126480" y="3931920"/>
+            <a:ext cx="548640" cy="548640"/>
+          </a:xfrm>
+          <a:prstGeom prst="ellipse">
+            <a:avLst/>
+          </a:prstGeom>
+          <a:solidFill>
+            <a:srgbClr val="E9A23B"/>
+          </a:solidFill>
+          <a:ln w="12700">
+            <a:solidFill>
+              <a:srgbClr val="E9A23B"/>
+            </a:solidFill>
+            <a:prstDash val="solid"/>
+          </a:ln>
+        </p:spPr>
+      </p:sp>
+      <p:sp>
+        <p:nvSpPr>
+          <p:cNvPr id="17" name="Text 15"/>
+          <p:cNvSpPr/>
+          <p:nvPr/>
+        </p:nvSpPr>
+        <p:spPr>
+          <a:xfrm>
+            <a:off x="6126480" y="3931920"/>
+            <a:ext cx="548640" cy="548640"/>
+          </a:xfrm>
+          <a:prstGeom prst="rect">
+            <a:avLst/>
+          </a:prstGeom>
+          <a:noFill/>
+          <a:ln/>
+        </p:spPr>
+        <p:txBody>
+          <a:bodyPr wrap="square" lIns="0" tIns="0" rIns="0" bIns="0" rtlCol="0" anchor="ctr"/>
+          <a:lstStyle/>
+          <a:p>
+            <a:pPr algn="ctr" indent="0" marL="0">
+              <a:buNone/>
+            </a:pPr>
+            <a:r>
+              <a:rPr lang="en-US" sz="1400" b="1" dirty="0">
+                <a:solidFill>
+                  <a:srgbClr val="FFFFFF"/>
+                </a:solidFill>
+                <a:latin typeface="Arial" pitchFamily="34" charset="0"/>
+                <a:ea typeface="Arial" pitchFamily="34" charset="-122"/>
+                <a:cs typeface="Arial" pitchFamily="34" charset="-120"/>
+              </a:rPr>
+              <a:t>3</a:t>
+            </a:r>
+            <a:endParaRPr lang="en-US" sz="1400" dirty="0"/>
+          </a:p>
+        </p:txBody>
+      </p:sp>
+      <p:sp>
+        <p:nvSpPr>
+          <p:cNvPr id="18" name="Text 16"/>
+          <p:cNvSpPr/>
+          <p:nvPr/>
+        </p:nvSpPr>
+        <p:spPr>
+          <a:xfrm>
+            <a:off x="6858000" y="3794760"/>
+            <a:ext cx="4754880" cy="411480"/>
+          </a:xfrm>
+          <a:prstGeom prst="rect">
+            <a:avLst/>
+          </a:prstGeom>
+          <a:noFill/>
+          <a:ln/>
+        </p:spPr>
+        <p:txBody>
+          <a:bodyPr wrap="square" lIns="0" tIns="0" rIns="0" bIns="0" rtlCol="0" anchor="ctr"/>
+          <a:lstStyle/>
+          <a:p>
+            <a:pPr indent="0" marL="0">
+              <a:buNone/>
+            </a:pPr>
+            <a:r>
+              <a:rPr lang="en-US" sz="1700" b="1" dirty="0">
+                <a:solidFill>
+                  <a:srgbClr val="0E2F3C"/>
+                </a:solidFill>
+                <a:latin typeface="PingFang SC" pitchFamily="34" charset="0"/>
+                <a:ea typeface="PingFang SC" pitchFamily="34" charset="-122"/>
+                <a:cs typeface="PingFang SC" pitchFamily="34" charset="-120"/>
+              </a:rPr>
+              <a:t>反事实</a:t>
+            </a:r>
+            <a:endParaRPr lang="en-US" sz="1700" dirty="0"/>
+          </a:p>
+        </p:txBody>
+      </p:sp>
+      <p:sp>
+        <p:nvSpPr>
+          <p:cNvPr id="19" name="Text 17"/>
+          <p:cNvSpPr/>
+          <p:nvPr/>
+        </p:nvSpPr>
+        <p:spPr>
+          <a:xfrm>
+            <a:off x="6858000" y="4206240"/>
+            <a:ext cx="4754880" cy="502920"/>
+          </a:xfrm>
+          <a:prstGeom prst="rect">
+            <a:avLst/>
+          </a:prstGeom>
+          <a:noFill/>
+          <a:ln/>
+        </p:spPr>
+        <p:txBody>
+          <a:bodyPr wrap="square" lIns="0" tIns="0" rIns="0" bIns="0" rtlCol="0" anchor="ctr"/>
+          <a:lstStyle/>
+          <a:p>
+            <a:pPr indent="0" marL="0">
+              <a:buNone/>
+            </a:pPr>
+            <a:r>
+              <a:rPr lang="en-US" sz="1400" dirty="0">
+                <a:solidFill>
+                  <a:srgbClr val="1D2A33"/>
+                </a:solidFill>
+                <a:latin typeface="PingFang SC" pitchFamily="34" charset="0"/>
+                <a:ea typeface="PingFang SC" pitchFamily="34" charset="-122"/>
+                <a:cs typeface="PingFang SC" pitchFamily="34" charset="-120"/>
+              </a:rPr>
+              <a:t>晚建站点与匹配的未建点,按资源潜力匹配</a:t>
+            </a:r>
+            <a:endParaRPr lang="en-US" sz="1400" dirty="0"/>
+          </a:p>
+        </p:txBody>
+      </p:sp>
+      <p:sp>
+        <p:nvSpPr>
+          <p:cNvPr id="20" name="Shape 18"/>
+          <p:cNvSpPr/>
+          <p:nvPr/>
+        </p:nvSpPr>
+        <p:spPr>
+          <a:xfrm>
+            <a:off x="6126480" y="4983480"/>
+            <a:ext cx="548640" cy="548640"/>
+          </a:xfrm>
+          <a:prstGeom prst="ellipse">
+            <a:avLst/>
+          </a:prstGeom>
+          <a:solidFill>
+            <a:srgbClr val="1F6F78"/>
+          </a:solidFill>
+          <a:ln w="12700">
+            <a:solidFill>
+              <a:srgbClr val="1F6F78"/>
+            </a:solidFill>
+            <a:prstDash val="solid"/>
+          </a:ln>
+        </p:spPr>
+      </p:sp>
+      <p:sp>
+        <p:nvSpPr>
+          <p:cNvPr id="21" name="Text 19"/>
+          <p:cNvSpPr/>
+          <p:nvPr/>
+        </p:nvSpPr>
+        <p:spPr>
+          <a:xfrm>
+            <a:off x="6126480" y="4983480"/>
+            <a:ext cx="548640" cy="548640"/>
+          </a:xfrm>
+          <a:prstGeom prst="rect">
+            <a:avLst/>
+          </a:prstGeom>
+          <a:noFill/>
+          <a:ln/>
+        </p:spPr>
+        <p:txBody>
+          <a:bodyPr wrap="square" lIns="0" tIns="0" rIns="0" bIns="0" rtlCol="0" anchor="ctr"/>
+          <a:lstStyle/>
+          <a:p>
+            <a:pPr algn="ctr" indent="0" marL="0">
+              <a:buNone/>
+            </a:pPr>
+            <a:r>
+              <a:rPr lang="en-US" sz="1400" b="1" dirty="0">
+                <a:solidFill>
+                  <a:srgbClr val="FFFFFF"/>
+                </a:solidFill>
+                <a:latin typeface="Arial" pitchFamily="34" charset="0"/>
+                <a:ea typeface="Arial" pitchFamily="34" charset="-122"/>
+                <a:cs typeface="Arial" pitchFamily="34" charset="-120"/>
+              </a:rPr>
+              <a:t>4</a:t>
+            </a:r>
+            <a:endParaRPr lang="en-US" sz="1400" dirty="0"/>
+          </a:p>
+        </p:txBody>
+      </p:sp>
+      <p:sp>
+        <p:nvSpPr>
+          <p:cNvPr id="22" name="Text 20"/>
+          <p:cNvSpPr/>
+          <p:nvPr/>
+        </p:nvSpPr>
+        <p:spPr>
+          <a:xfrm>
+            <a:off x="6858000" y="4846320"/>
+            <a:ext cx="4754880" cy="411480"/>
+          </a:xfrm>
+          <a:prstGeom prst="rect">
+            <a:avLst/>
+          </a:prstGeom>
+          <a:noFill/>
+          <a:ln/>
+        </p:spPr>
+        <p:txBody>
+          <a:bodyPr wrap="square" lIns="0" tIns="0" rIns="0" bIns="0" rtlCol="0" anchor="ctr"/>
+          <a:lstStyle/>
+          <a:p>
+            <a:pPr indent="0" marL="0">
+              <a:buNone/>
+            </a:pPr>
+            <a:r>
+              <a:rPr lang="en-US" sz="1700" b="1" dirty="0">
+                <a:solidFill>
+                  <a:srgbClr val="0E2F3C"/>
+                </a:solidFill>
+                <a:latin typeface="PingFang SC" pitchFamily="34" charset="0"/>
+                <a:ea typeface="PingFang SC" pitchFamily="34" charset="-122"/>
+                <a:cs typeface="PingFang SC" pitchFamily="34" charset="-120"/>
+              </a:rPr>
+              <a:t>检验对象</a:t>
+            </a:r>
+            <a:endParaRPr lang="en-US" sz="1700" dirty="0"/>
+          </a:p>
+        </p:txBody>
+      </p:sp>
+      <p:sp>
+        <p:nvSpPr>
+          <p:cNvPr id="23" name="Text 21"/>
+          <p:cNvSpPr/>
+          <p:nvPr/>
+        </p:nvSpPr>
+        <p:spPr>
+          <a:xfrm>
+            <a:off x="6858000" y="5257800"/>
+            <a:ext cx="4754880" cy="502920"/>
+          </a:xfrm>
+          <a:prstGeom prst="rect">
+            <a:avLst/>
+          </a:prstGeom>
+          <a:noFill/>
+          <a:ln/>
+        </p:spPr>
+        <p:txBody>
+          <a:bodyPr wrap="square" lIns="0" tIns="0" rIns="0" bIns="0" rtlCol="0" anchor="ctr"/>
+          <a:lstStyle/>
+          <a:p>
+            <a:pPr indent="0" marL="0">
+              <a:buNone/>
+            </a:pPr>
+            <a:r>
+              <a:rPr lang="en-US" sz="1400" dirty="0">
+                <a:solidFill>
+                  <a:srgbClr val="1D2A33"/>
+                </a:solidFill>
+                <a:latin typeface="PingFang SC" pitchFamily="34" charset="0"/>
+                <a:ea typeface="PingFang SC" pitchFamily="34" charset="-122"/>
+                <a:cs typeface="PingFang SC" pitchFamily="34" charset="-120"/>
+              </a:rPr>
+              <a:t>NEE 论文"全国集中"与"省级分散"两种情景的预测</a:t>
+            </a:r>
+            <a:endParaRPr lang="en-US" sz="1400" dirty="0"/>
+          </a:p>
+        </p:txBody>
+      </p:sp>
+      <p:sp>
+        <p:nvSpPr>
+          <p:cNvPr id="24" name="Text 22"/>
+          <p:cNvSpPr/>
+          <p:nvPr/>
+        </p:nvSpPr>
+        <p:spPr>
+          <a:xfrm>
+            <a:off x="11277295" y="6400800"/>
+            <a:ext cx="457200" cy="274320"/>
+          </a:xfrm>
+          <a:prstGeom prst="rect">
+            <a:avLst/>
+          </a:prstGeom>
+          <a:noFill/>
+          <a:ln/>
+        </p:spPr>
+        <p:txBody>
+          <a:bodyPr wrap="square" lIns="0" tIns="0" rIns="0" bIns="0" rtlCol="0" anchor="ctr"/>
+          <a:lstStyle/>
+          <a:p>
+            <a:pPr algn="r" indent="0" marL="0">
+              <a:buNone/>
+            </a:pPr>
+            <a:r>
+              <a:rPr lang="en-US" sz="1000" dirty="0">
+                <a:solidFill>
+                  <a:srgbClr val="5E6B75"/>
+                </a:solidFill>
+                <a:latin typeface="Arial" pitchFamily="34" charset="0"/>
+                <a:ea typeface="Arial" pitchFamily="34" charset="-122"/>
+                <a:cs typeface="Arial" pitchFamily="34" charset="-120"/>
+              </a:rPr>
+              <a:t>2</a:t>
+            </a:r>
+            <a:endParaRPr lang="en-US" sz="1000" dirty="0"/>
+          </a:p>
+        </p:txBody>
+      </p:sp>
+    </p:spTree>
+  </p:cSld>
+  <p:clrMapOvr>
+    <a:masterClrMapping/>
+  </p:clrMapOvr>
+</p:sld>
+</file>
+
+<file path=ppt/slides/slide20.xml><?xml version="1.0" encoding="utf-8"?>
+<p:sld xmlns:a="http://schemas.openxmlformats.org/drawingml/2006/main" xmlns:r="http://schemas.openxmlformats.org/officeDocument/2006/relationships" xmlns:p="http://schemas.openxmlformats.org/presentationml/2006/main">
+  <p:cSld name="Slide 20">
+    <p:spTree>
+      <p:nvGrpSpPr>
+        <p:cNvPr id="1" name=""/>
+        <p:cNvGrpSpPr/>
+        <p:nvPr/>
+      </p:nvGrpSpPr>
+      <p:grpSpPr>
+        <a:xfrm>
+          <a:off x="0" y="0"/>
+          <a:ext cx="0" cy="0"/>
+          <a:chOff x="0" y="0"/>
+          <a:chExt cx="0" cy="0"/>
+        </a:xfrm>
+      </p:grpSpPr>
+      <p:sp>
+        <p:nvSpPr>
+          <p:cNvPr id="2" name="Text 0"/>
+          <p:cNvSpPr/>
+          <p:nvPr/>
+        </p:nvSpPr>
+        <p:spPr>
+          <a:xfrm>
+            <a:off x="548640" y="320040"/>
+            <a:ext cx="11094415" cy="685800"/>
+          </a:xfrm>
+          <a:prstGeom prst="rect">
+            <a:avLst/>
+          </a:prstGeom>
+          <a:noFill/>
+          <a:ln/>
+        </p:spPr>
+        <p:txBody>
+          <a:bodyPr wrap="square" lIns="0" tIns="0" rIns="0" bIns="0" rtlCol="0" anchor="ctr"/>
+          <a:lstStyle/>
+          <a:p>
+            <a:pPr indent="0" marL="0">
+              <a:buNone/>
+            </a:pPr>
+            <a:r>
+              <a:rPr lang="en-US" sz="3000" b="1" dirty="0">
+                <a:solidFill>
+                  <a:srgbClr val="0E2F3C"/>
+                </a:solidFill>
+                <a:latin typeface="PingFang SC" pitchFamily="34" charset="0"/>
+                <a:ea typeface="PingFang SC" pitchFamily="34" charset="-122"/>
+                <a:cs typeface="PingFang SC" pitchFamily="34" charset="-120"/>
+              </a:rPr>
+              <a:t>鸟类:站点层面的近远区对照与多物种占域</a:t>
+            </a:r>
+            <a:endParaRPr lang="en-US" sz="3000" dirty="0"/>
+          </a:p>
+        </p:txBody>
+      </p:sp>
+      <p:sp>
+        <p:nvSpPr>
+          <p:cNvPr id="3" name="Text 1"/>
+          <p:cNvSpPr/>
+          <p:nvPr/>
+        </p:nvSpPr>
+        <p:spPr>
+          <a:xfrm>
+            <a:off x="548640" y="960120"/>
+            <a:ext cx="11094415" cy="365760"/>
+          </a:xfrm>
+          <a:prstGeom prst="rect">
+            <a:avLst/>
+          </a:prstGeom>
+          <a:noFill/>
+          <a:ln/>
+        </p:spPr>
+        <p:txBody>
+          <a:bodyPr wrap="square" lIns="0" tIns="0" rIns="0" bIns="0" rtlCol="0" anchor="ctr"/>
+          <a:lstStyle/>
+          <a:p>
+            <a:pPr indent="0" marL="0">
+              <a:buNone/>
+            </a:pPr>
+            <a:r>
+              <a:rPr lang="en-US" sz="1400" dirty="0">
+                <a:solidFill>
+                  <a:srgbClr val="5E6B75"/>
+                </a:solidFill>
+                <a:latin typeface="PingFang SC" pitchFamily="34" charset="0"/>
+                <a:ea typeface="PingFang SC" pitchFamily="34" charset="-122"/>
+                <a:cs typeface="PingFang SC" pitchFamily="34" charset="-120"/>
+              </a:rPr>
+              <a:t>近区 0–5 km vs 远区 8–20 km,站点 × 年份固定效应;CBRC + eBird/GBIF 合并去重清单</a:t>
+            </a:r>
+            <a:endParaRPr lang="en-US" sz="1400" dirty="0"/>
           </a:p>
         </p:txBody>
       </p:sp>
       <p:graphicFrame>
         <p:nvGraphicFramePr>
-          <p:cNvPr id="20" name="Table 0"/>
+          <p:cNvPr id="21" name="Table 0"/>
+          <p:cNvGraphicFramePr>
+            <a:graphicFrameLocks noGrp="1"/>
+          </p:cNvGraphicFramePr>
+          <p:nvPr>
+            <p:extLst>
+              <p:ext uri="{D42A27DB-BD31-4B8C-83A1-F6EECF244321}">
+                <p14:modId xmlns:p14="http://schemas.microsoft.com/office/powerpoint/2010/main" val="1579011935"/>
+              </p:ext>
+            </p:extLst>
+          </p:nvPr>
+        </p:nvGraphicFramePr>
+        <p:xfrm>
+          <a:off x="457200" y="1463040"/>
+          <a:ext cx="6400800" cy="914400"/>
+        </p:xfrm>
+        <a:graphic>
+          <a:graphicData uri="http://schemas.openxmlformats.org/drawingml/2006/table">
+            <a:tbl>
+              <a:tblPr/>
+              <a:tblGrid>
+                <a:gridCol w="2560320"/>
+                <a:gridCol w="1920240"/>
+                <a:gridCol w="1920240"/>
+              </a:tblGrid>
+              <a:tr h="502920">
+                <a:tc>
+                  <a:txBody>
+                    <a:bodyPr/>
+                    <a:lstStyle/>
+                    <a:p>
+                      <a:pPr indent="0" marL="0">
+                        <a:buNone/>
+                      </a:pPr>
+                      <a:r>
+                        <a:rPr lang="en-US" sz="1200" b="1" dirty="0">
+                          <a:solidFill>
+                            <a:srgbClr val="FFFFFF"/>
+                          </a:solidFill>
+                          <a:latin typeface="PingFang SC" pitchFamily="34" charset="0"/>
+                          <a:ea typeface="PingFang SC" pitchFamily="34" charset="-122"/>
+                          <a:cs typeface="PingFang SC" pitchFamily="34" charset="-120"/>
+                        </a:rPr>
+                        <a:t>近区 × 建设后</a:t>
+                      </a:r>
+                      <a:endParaRPr lang="en-US" sz="1200" dirty="0">
+                        <a:latin typeface="PingFang SC" charset="0"/>
+                        <a:ea typeface="PingFang SC" charset="0"/>
+                        <a:cs typeface="PingFang SC" charset="0"/>
+                      </a:endParaRPr>
+                    </a:p>
+                  </a:txBody>
+                  <a:tcPr marL="91440" marR="91440" marT="45720" marB="45720" anchor="ctr">
+                    <a:lnL w="9525" cap="flat" cmpd="sng" algn="ctr">
+                      <a:solidFill>
+                        <a:srgbClr val="D5DEE2"/>
+                      </a:solidFill>
+                      <a:prstDash val="solid"/>
+                      <a:round/>
+                      <a:headEnd type="none" w="med" len="med"/>
+                      <a:tailEnd type="none" w="med" len="med"/>
+                    </a:lnL>
+                    <a:lnR w="9525" cap="flat" cmpd="sng" algn="ctr">
+                      <a:solidFill>
+                        <a:srgbClr val="D5DEE2"/>
+                      </a:solidFill>
+                      <a:prstDash val="solid"/>
+                      <a:round/>
+                      <a:headEnd type="none" w="med" len="med"/>
+                      <a:tailEnd type="none" w="med" len="med"/>
+                    </a:lnR>
+                    <a:lnT w="9525" cap="flat" cmpd="sng" algn="ctr">
+                      <a:solidFill>
+                        <a:srgbClr val="D5DEE2"/>
+                      </a:solidFill>
+                      <a:prstDash val="solid"/>
+                      <a:round/>
+                      <a:headEnd type="none" w="med" len="med"/>
+                      <a:tailEnd type="none" w="med" len="med"/>
+                    </a:lnT>
+                    <a:lnB w="9525" cap="flat" cmpd="sng" algn="ctr">
+                      <a:solidFill>
+                        <a:srgbClr val="D5DEE2"/>
+                      </a:solidFill>
+                      <a:prstDash val="solid"/>
+                      <a:round/>
+                      <a:headEnd type="none" w="med" len="med"/>
+                      <a:tailEnd type="none" w="med" len="med"/>
+                    </a:lnB>
+                    <a:solidFill>
+                      <a:srgbClr val="0E2F3C"/>
+                    </a:solidFill>
+                  </a:tcPr>
+                </a:tc>
+                <a:tc>
+                  <a:txBody>
+                    <a:bodyPr/>
+                    <a:lstStyle/>
+                    <a:p>
+                      <a:pPr indent="0" marL="0">
+                        <a:buNone/>
+                      </a:pPr>
+                      <a:r>
+                        <a:rPr lang="en-US" sz="1200" b="1" dirty="0">
+                          <a:solidFill>
+                            <a:srgbClr val="FFFFFF"/>
+                          </a:solidFill>
+                          <a:latin typeface="PingFang SC" pitchFamily="34" charset="0"/>
+                          <a:ea typeface="PingFang SC" pitchFamily="34" charset="-122"/>
+                          <a:cs typeface="PingFang SC" pitchFamily="34" charset="-120"/>
+                        </a:rPr>
+                        <a:t>38 站(每格 ≥ 3)</a:t>
+                      </a:r>
+                      <a:endParaRPr lang="en-US" sz="1200" dirty="0">
+                        <a:latin typeface="PingFang SC" charset="0"/>
+                        <a:ea typeface="PingFang SC" charset="0"/>
+                        <a:cs typeface="PingFang SC" charset="0"/>
+                      </a:endParaRPr>
+                    </a:p>
+                  </a:txBody>
+                  <a:tcPr marL="91440" marR="91440" marT="45720" marB="45720" anchor="ctr">
+                    <a:lnL w="9525" cap="flat" cmpd="sng" algn="ctr">
+                      <a:solidFill>
+                        <a:srgbClr val="D5DEE2"/>
+                      </a:solidFill>
+                      <a:prstDash val="solid"/>
+                      <a:round/>
+                      <a:headEnd type="none" w="med" len="med"/>
+                      <a:tailEnd type="none" w="med" len="med"/>
+                    </a:lnL>
+                    <a:lnR w="9525" cap="flat" cmpd="sng" algn="ctr">
+                      <a:solidFill>
+                        <a:srgbClr val="D5DEE2"/>
+                      </a:solidFill>
+                      <a:prstDash val="solid"/>
+                      <a:round/>
+                      <a:headEnd type="none" w="med" len="med"/>
+                      <a:tailEnd type="none" w="med" len="med"/>
+                    </a:lnR>
+                    <a:lnT w="9525" cap="flat" cmpd="sng" algn="ctr">
+                      <a:solidFill>
+                        <a:srgbClr val="D5DEE2"/>
+                      </a:solidFill>
+                      <a:prstDash val="solid"/>
+                      <a:round/>
+                      <a:headEnd type="none" w="med" len="med"/>
+                      <a:tailEnd type="none" w="med" len="med"/>
+                    </a:lnT>
+                    <a:lnB w="9525" cap="flat" cmpd="sng" algn="ctr">
+                      <a:solidFill>
+                        <a:srgbClr val="D5DEE2"/>
+                      </a:solidFill>
+                      <a:prstDash val="solid"/>
+                      <a:round/>
+                      <a:headEnd type="none" w="med" len="med"/>
+                      <a:tailEnd type="none" w="med" len="med"/>
+                    </a:lnB>
+                    <a:solidFill>
+                      <a:srgbClr val="0E2F3C"/>
+                    </a:solidFill>
+                  </a:tcPr>
+                </a:tc>
+                <a:tc>
+                  <a:txBody>
+                    <a:bodyPr/>
+                    <a:lstStyle/>
+                    <a:p>
+                      <a:pPr indent="0" marL="0">
+                        <a:buNone/>
+                      </a:pPr>
+                      <a:r>
+                        <a:rPr lang="en-US" sz="1200" b="1" dirty="0">
+                          <a:solidFill>
+                            <a:srgbClr val="FFFFFF"/>
+                          </a:solidFill>
+                          <a:latin typeface="PingFang SC" pitchFamily="34" charset="0"/>
+                          <a:ea typeface="PingFang SC" pitchFamily="34" charset="-122"/>
+                          <a:cs typeface="PingFang SC" pitchFamily="34" charset="-120"/>
+                        </a:rPr>
+                        <a:t>24 站(每格 ≥ 5)</a:t>
+                      </a:r>
+                      <a:endParaRPr lang="en-US" sz="1200" dirty="0">
+                        <a:latin typeface="PingFang SC" charset="0"/>
+                        <a:ea typeface="PingFang SC" charset="0"/>
+                        <a:cs typeface="PingFang SC" charset="0"/>
+                      </a:endParaRPr>
+                    </a:p>
+                  </a:txBody>
+                  <a:tcPr marL="91440" marR="91440" marT="45720" marB="45720" anchor="ctr">
+                    <a:lnL w="9525" cap="flat" cmpd="sng" algn="ctr">
+                      <a:solidFill>
+                        <a:srgbClr val="D5DEE2"/>
+                      </a:solidFill>
+                      <a:prstDash val="solid"/>
+                      <a:round/>
+                      <a:headEnd type="none" w="med" len="med"/>
+                      <a:tailEnd type="none" w="med" len="med"/>
+                    </a:lnL>
+                    <a:lnR w="9525" cap="flat" cmpd="sng" algn="ctr">
+                      <a:solidFill>
+                        <a:srgbClr val="D5DEE2"/>
+                      </a:solidFill>
+                      <a:prstDash val="solid"/>
+                      <a:round/>
+                      <a:headEnd type="none" w="med" len="med"/>
+                      <a:tailEnd type="none" w="med" len="med"/>
+                    </a:lnR>
+                    <a:lnT w="9525" cap="flat" cmpd="sng" algn="ctr">
+                      <a:solidFill>
+                        <a:srgbClr val="D5DEE2"/>
+                      </a:solidFill>
+                      <a:prstDash val="solid"/>
+                      <a:round/>
+                      <a:headEnd type="none" w="med" len="med"/>
+                      <a:tailEnd type="none" w="med" len="med"/>
+                    </a:lnT>
+                    <a:lnB w="9525" cap="flat" cmpd="sng" algn="ctr">
+                      <a:solidFill>
+                        <a:srgbClr val="D5DEE2"/>
+                      </a:solidFill>
+                      <a:prstDash val="solid"/>
+                      <a:round/>
+                      <a:headEnd type="none" w="med" len="med"/>
+                      <a:tailEnd type="none" w="med" len="med"/>
+                    </a:lnB>
+                    <a:solidFill>
+                      <a:srgbClr val="0E2F3C"/>
+                    </a:solidFill>
+                  </a:tcPr>
+                </a:tc>
+              </a:tr>
+              <a:tr h="502920">
+                <a:tc>
+                  <a:txBody>
+                    <a:bodyPr/>
+                    <a:lstStyle/>
+                    <a:p>
+                      <a:pPr indent="0" marL="0">
+                        <a:buNone/>
+                      </a:pPr>
+                      <a:r>
+                        <a:rPr lang="en-US" sz="1150" dirty="0">
+                          <a:solidFill>
+                            <a:srgbClr val="1D2A33"/>
+                          </a:solidFill>
+                          <a:latin typeface="PingFang SC" pitchFamily="34" charset="0"/>
+                          <a:ea typeface="PingFang SC" pitchFamily="34" charset="-122"/>
+                          <a:cs typeface="PingFang SC" pitchFamily="34" charset="-120"/>
+                        </a:rPr>
+                        <a:t>清单物种数(控制时长、月份、来源)</a:t>
+                      </a:r>
+                      <a:endParaRPr lang="en-US" sz="1150" dirty="0">
+                        <a:latin typeface="PingFang SC" charset="0"/>
+                        <a:ea typeface="PingFang SC" charset="0"/>
+                        <a:cs typeface="PingFang SC" charset="0"/>
+                      </a:endParaRPr>
+                    </a:p>
+                  </a:txBody>
+                  <a:tcPr marL="91440" marR="91440" marT="45720" marB="45720" anchor="ctr">
+                    <a:lnL w="9525" cap="flat" cmpd="sng" algn="ctr">
+                      <a:solidFill>
+                        <a:srgbClr val="D5DEE2"/>
+                      </a:solidFill>
+                      <a:prstDash val="solid"/>
+                      <a:round/>
+                      <a:headEnd type="none" w="med" len="med"/>
+                      <a:tailEnd type="none" w="med" len="med"/>
+                    </a:lnL>
+                    <a:lnR w="9525" cap="flat" cmpd="sng" algn="ctr">
+                      <a:solidFill>
+                        <a:srgbClr val="D5DEE2"/>
+                      </a:solidFill>
+                      <a:prstDash val="solid"/>
+                      <a:round/>
+                      <a:headEnd type="none" w="med" len="med"/>
+                      <a:tailEnd type="none" w="med" len="med"/>
+                    </a:lnR>
+                    <a:lnT w="9525" cap="flat" cmpd="sng" algn="ctr">
+                      <a:solidFill>
+                        <a:srgbClr val="D5DEE2"/>
+                      </a:solidFill>
+                      <a:prstDash val="solid"/>
+                      <a:round/>
+                      <a:headEnd type="none" w="med" len="med"/>
+                      <a:tailEnd type="none" w="med" len="med"/>
+                    </a:lnT>
+                    <a:lnB w="9525" cap="flat" cmpd="sng" algn="ctr">
+                      <a:solidFill>
+                        <a:srgbClr val="D5DEE2"/>
+                      </a:solidFill>
+                      <a:prstDash val="solid"/>
+                      <a:round/>
+                      <a:headEnd type="none" w="med" len="med"/>
+                      <a:tailEnd type="none" w="med" len="med"/>
+                    </a:lnB>
+                  </a:tcPr>
+                </a:tc>
+                <a:tc>
+                  <a:txBody>
+                    <a:bodyPr/>
+                    <a:lstStyle/>
+                    <a:p>
+                      <a:pPr indent="0" marL="0">
+                        <a:buNone/>
+                      </a:pPr>
+                      <a:r>
+                        <a:rPr lang="en-US" sz="1150" dirty="0">
+                          <a:solidFill>
+                            <a:srgbClr val="1D2A33"/>
+                          </a:solidFill>
+                          <a:latin typeface="PingFang SC" pitchFamily="34" charset="0"/>
+                          <a:ea typeface="PingFang SC" pitchFamily="34" charset="-122"/>
+                          <a:cs typeface="PingFang SC" pitchFamily="34" charset="-120"/>
+                        </a:rPr>
+                        <a:t>−10.3%(−22.9, +4.5)</a:t>
+                      </a:r>
+                      <a:endParaRPr lang="en-US" sz="1150" dirty="0">
+                        <a:latin typeface="PingFang SC" charset="0"/>
+                        <a:ea typeface="PingFang SC" charset="0"/>
+                        <a:cs typeface="PingFang SC" charset="0"/>
+                      </a:endParaRPr>
+                    </a:p>
+                  </a:txBody>
+                  <a:tcPr marL="91440" marR="91440" marT="45720" marB="45720" anchor="ctr">
+                    <a:lnL w="9525" cap="flat" cmpd="sng" algn="ctr">
+                      <a:solidFill>
+                        <a:srgbClr val="D5DEE2"/>
+                      </a:solidFill>
+                      <a:prstDash val="solid"/>
+                      <a:round/>
+                      <a:headEnd type="none" w="med" len="med"/>
+                      <a:tailEnd type="none" w="med" len="med"/>
+                    </a:lnL>
+                    <a:lnR w="9525" cap="flat" cmpd="sng" algn="ctr">
+                      <a:solidFill>
+                        <a:srgbClr val="D5DEE2"/>
+                      </a:solidFill>
+                      <a:prstDash val="solid"/>
+                      <a:round/>
+                      <a:headEnd type="none" w="med" len="med"/>
+                      <a:tailEnd type="none" w="med" len="med"/>
+                    </a:lnR>
+                    <a:lnT w="9525" cap="flat" cmpd="sng" algn="ctr">
+                      <a:solidFill>
+                        <a:srgbClr val="D5DEE2"/>
+                      </a:solidFill>
+                      <a:prstDash val="solid"/>
+                      <a:round/>
+                      <a:headEnd type="none" w="med" len="med"/>
+                      <a:tailEnd type="none" w="med" len="med"/>
+                    </a:lnT>
+                    <a:lnB w="9525" cap="flat" cmpd="sng" algn="ctr">
+                      <a:solidFill>
+                        <a:srgbClr val="D5DEE2"/>
+                      </a:solidFill>
+                      <a:prstDash val="solid"/>
+                      <a:round/>
+                      <a:headEnd type="none" w="med" len="med"/>
+                      <a:tailEnd type="none" w="med" len="med"/>
+                    </a:lnB>
+                  </a:tcPr>
+                </a:tc>
+                <a:tc>
+                  <a:txBody>
+                    <a:bodyPr/>
+                    <a:lstStyle/>
+                    <a:p>
+                      <a:pPr indent="0" marL="0">
+                        <a:buNone/>
+                      </a:pPr>
+                      <a:r>
+                        <a:rPr lang="en-US" sz="1150" dirty="0">
+                          <a:solidFill>
+                            <a:srgbClr val="1D2A33"/>
+                          </a:solidFill>
+                          <a:latin typeface="PingFang SC" pitchFamily="34" charset="0"/>
+                          <a:ea typeface="PingFang SC" pitchFamily="34" charset="-122"/>
+                          <a:cs typeface="PingFang SC" pitchFamily="34" charset="-120"/>
+                        </a:rPr>
+                        <a:t>−10.2%(−23.0, +4.6)</a:t>
+                      </a:r>
+                      <a:endParaRPr lang="en-US" sz="1150" dirty="0">
+                        <a:latin typeface="PingFang SC" charset="0"/>
+                        <a:ea typeface="PingFang SC" charset="0"/>
+                        <a:cs typeface="PingFang SC" charset="0"/>
+                      </a:endParaRPr>
+                    </a:p>
+                  </a:txBody>
+                  <a:tcPr marL="91440" marR="91440" marT="45720" marB="45720" anchor="ctr">
+                    <a:lnL w="9525" cap="flat" cmpd="sng" algn="ctr">
+                      <a:solidFill>
+                        <a:srgbClr val="D5DEE2"/>
+                      </a:solidFill>
+                      <a:prstDash val="solid"/>
+                      <a:round/>
+                      <a:headEnd type="none" w="med" len="med"/>
+                      <a:tailEnd type="none" w="med" len="med"/>
+                    </a:lnL>
+                    <a:lnR w="9525" cap="flat" cmpd="sng" algn="ctr">
+                      <a:solidFill>
+                        <a:srgbClr val="D5DEE2"/>
+                      </a:solidFill>
+                      <a:prstDash val="solid"/>
+                      <a:round/>
+                      <a:headEnd type="none" w="med" len="med"/>
+                      <a:tailEnd type="none" w="med" len="med"/>
+                    </a:lnR>
+                    <a:lnT w="9525" cap="flat" cmpd="sng" algn="ctr">
+                      <a:solidFill>
+                        <a:srgbClr val="D5DEE2"/>
+                      </a:solidFill>
+                      <a:prstDash val="solid"/>
+                      <a:round/>
+                      <a:headEnd type="none" w="med" len="med"/>
+                      <a:tailEnd type="none" w="med" len="med"/>
+                    </a:lnT>
+                    <a:lnB w="9525" cap="flat" cmpd="sng" algn="ctr">
+                      <a:solidFill>
+                        <a:srgbClr val="D5DEE2"/>
+                      </a:solidFill>
+                      <a:prstDash val="solid"/>
+                      <a:round/>
+                      <a:headEnd type="none" w="med" len="med"/>
+                      <a:tailEnd type="none" w="med" len="med"/>
+                    </a:lnB>
+                  </a:tcPr>
+                </a:tc>
+              </a:tr>
+              <a:tr h="502920">
+                <a:tc>
+                  <a:txBody>
+                    <a:bodyPr/>
+                    <a:lstStyle/>
+                    <a:p>
+                      <a:pPr indent="0" marL="0">
+                        <a:buNone/>
+                      </a:pPr>
+                      <a:r>
+                        <a:rPr lang="en-US" sz="1150" dirty="0">
+                          <a:solidFill>
+                            <a:srgbClr val="1D2A33"/>
+                          </a:solidFill>
+                          <a:latin typeface="PingFang SC" pitchFamily="34" charset="0"/>
+                          <a:ea typeface="PingFang SC" pitchFamily="34" charset="-122"/>
+                          <a:cs typeface="PingFang SC" pitchFamily="34" charset="-120"/>
+                        </a:rPr>
+                        <a:t>+ 观察者固定效应</a:t>
+                      </a:r>
+                      <a:endParaRPr lang="en-US" sz="1150" dirty="0">
+                        <a:latin typeface="PingFang SC" charset="0"/>
+                        <a:ea typeface="PingFang SC" charset="0"/>
+                        <a:cs typeface="PingFang SC" charset="0"/>
+                      </a:endParaRPr>
+                    </a:p>
+                  </a:txBody>
+                  <a:tcPr marL="91440" marR="91440" marT="45720" marB="45720" anchor="ctr">
+                    <a:lnL w="9525" cap="flat" cmpd="sng" algn="ctr">
+                      <a:solidFill>
+                        <a:srgbClr val="D5DEE2"/>
+                      </a:solidFill>
+                      <a:prstDash val="solid"/>
+                      <a:round/>
+                      <a:headEnd type="none" w="med" len="med"/>
+                      <a:tailEnd type="none" w="med" len="med"/>
+                    </a:lnL>
+                    <a:lnR w="9525" cap="flat" cmpd="sng" algn="ctr">
+                      <a:solidFill>
+                        <a:srgbClr val="D5DEE2"/>
+                      </a:solidFill>
+                      <a:prstDash val="solid"/>
+                      <a:round/>
+                      <a:headEnd type="none" w="med" len="med"/>
+                      <a:tailEnd type="none" w="med" len="med"/>
+                    </a:lnR>
+                    <a:lnT w="9525" cap="flat" cmpd="sng" algn="ctr">
+                      <a:solidFill>
+                        <a:srgbClr val="D5DEE2"/>
+                      </a:solidFill>
+                      <a:prstDash val="solid"/>
+                      <a:round/>
+                      <a:headEnd type="none" w="med" len="med"/>
+                      <a:tailEnd type="none" w="med" len="med"/>
+                    </a:lnT>
+                    <a:lnB w="9525" cap="flat" cmpd="sng" algn="ctr">
+                      <a:solidFill>
+                        <a:srgbClr val="D5DEE2"/>
+                      </a:solidFill>
+                      <a:prstDash val="solid"/>
+                      <a:round/>
+                      <a:headEnd type="none" w="med" len="med"/>
+                      <a:tailEnd type="none" w="med" len="med"/>
+                    </a:lnB>
+                  </a:tcPr>
+                </a:tc>
+                <a:tc>
+                  <a:txBody>
+                    <a:bodyPr/>
+                    <a:lstStyle/>
+                    <a:p>
+                      <a:pPr indent="0" marL="0">
+                        <a:buNone/>
+                      </a:pPr>
+                      <a:r>
+                        <a:rPr lang="en-US" sz="1150" dirty="0">
+                          <a:solidFill>
+                            <a:srgbClr val="1D2A33"/>
+                          </a:solidFill>
+                          <a:latin typeface="PingFang SC" pitchFamily="34" charset="0"/>
+                          <a:ea typeface="PingFang SC" pitchFamily="34" charset="-122"/>
+                          <a:cs typeface="PingFang SC" pitchFamily="34" charset="-120"/>
+                        </a:rPr>
+                        <a:t>−9.6%(−24.3, +8.0)</a:t>
+                      </a:r>
+                      <a:endParaRPr lang="en-US" sz="1150" dirty="0">
+                        <a:latin typeface="PingFang SC" charset="0"/>
+                        <a:ea typeface="PingFang SC" charset="0"/>
+                        <a:cs typeface="PingFang SC" charset="0"/>
+                      </a:endParaRPr>
+                    </a:p>
+                  </a:txBody>
+                  <a:tcPr marL="91440" marR="91440" marT="45720" marB="45720" anchor="ctr">
+                    <a:lnL w="9525" cap="flat" cmpd="sng" algn="ctr">
+                      <a:solidFill>
+                        <a:srgbClr val="D5DEE2"/>
+                      </a:solidFill>
+                      <a:prstDash val="solid"/>
+                      <a:round/>
+                      <a:headEnd type="none" w="med" len="med"/>
+                      <a:tailEnd type="none" w="med" len="med"/>
+                    </a:lnL>
+                    <a:lnR w="9525" cap="flat" cmpd="sng" algn="ctr">
+                      <a:solidFill>
+                        <a:srgbClr val="D5DEE2"/>
+                      </a:solidFill>
+                      <a:prstDash val="solid"/>
+                      <a:round/>
+                      <a:headEnd type="none" w="med" len="med"/>
+                      <a:tailEnd type="none" w="med" len="med"/>
+                    </a:lnR>
+                    <a:lnT w="9525" cap="flat" cmpd="sng" algn="ctr">
+                      <a:solidFill>
+                        <a:srgbClr val="D5DEE2"/>
+                      </a:solidFill>
+                      <a:prstDash val="solid"/>
+                      <a:round/>
+                      <a:headEnd type="none" w="med" len="med"/>
+                      <a:tailEnd type="none" w="med" len="med"/>
+                    </a:lnT>
+                    <a:lnB w="9525" cap="flat" cmpd="sng" algn="ctr">
+                      <a:solidFill>
+                        <a:srgbClr val="D5DEE2"/>
+                      </a:solidFill>
+                      <a:prstDash val="solid"/>
+                      <a:round/>
+                      <a:headEnd type="none" w="med" len="med"/>
+                      <a:tailEnd type="none" w="med" len="med"/>
+                    </a:lnB>
+                  </a:tcPr>
+                </a:tc>
+                <a:tc>
+                  <a:txBody>
+                    <a:bodyPr/>
+                    <a:lstStyle/>
+                    <a:p>
+                      <a:pPr indent="0" marL="0">
+                        <a:buNone/>
+                      </a:pPr>
+                      <a:r>
+                        <a:rPr lang="en-US" sz="1150" dirty="0">
+                          <a:solidFill>
+                            <a:srgbClr val="1D2A33"/>
+                          </a:solidFill>
+                          <a:latin typeface="PingFang SC" pitchFamily="34" charset="0"/>
+                          <a:ea typeface="PingFang SC" pitchFamily="34" charset="-122"/>
+                          <a:cs typeface="PingFang SC" pitchFamily="34" charset="-120"/>
+                        </a:rPr>
+                        <a:t>−9.7%(−24.3, +7.7)</a:t>
+                      </a:r>
+                      <a:endParaRPr lang="en-US" sz="1150" dirty="0">
+                        <a:latin typeface="PingFang SC" charset="0"/>
+                        <a:ea typeface="PingFang SC" charset="0"/>
+                        <a:cs typeface="PingFang SC" charset="0"/>
+                      </a:endParaRPr>
+                    </a:p>
+                  </a:txBody>
+                  <a:tcPr marL="91440" marR="91440" marT="45720" marB="45720" anchor="ctr">
+                    <a:lnL w="9525" cap="flat" cmpd="sng" algn="ctr">
+                      <a:solidFill>
+                        <a:srgbClr val="D5DEE2"/>
+                      </a:solidFill>
+                      <a:prstDash val="solid"/>
+                      <a:round/>
+                      <a:headEnd type="none" w="med" len="med"/>
+                      <a:tailEnd type="none" w="med" len="med"/>
+                    </a:lnL>
+                    <a:lnR w="9525" cap="flat" cmpd="sng" algn="ctr">
+                      <a:solidFill>
+                        <a:srgbClr val="D5DEE2"/>
+                      </a:solidFill>
+                      <a:prstDash val="solid"/>
+                      <a:round/>
+                      <a:headEnd type="none" w="med" len="med"/>
+                      <a:tailEnd type="none" w="med" len="med"/>
+                    </a:lnR>
+                    <a:lnT w="9525" cap="flat" cmpd="sng" algn="ctr">
+                      <a:solidFill>
+                        <a:srgbClr val="D5DEE2"/>
+                      </a:solidFill>
+                      <a:prstDash val="solid"/>
+                      <a:round/>
+                      <a:headEnd type="none" w="med" len="med"/>
+                      <a:tailEnd type="none" w="med" len="med"/>
+                    </a:lnT>
+                    <a:lnB w="9525" cap="flat" cmpd="sng" algn="ctr">
+                      <a:solidFill>
+                        <a:srgbClr val="D5DEE2"/>
+                      </a:solidFill>
+                      <a:prstDash val="solid"/>
+                      <a:round/>
+                      <a:headEnd type="none" w="med" len="med"/>
+                      <a:tailEnd type="none" w="med" len="med"/>
+                    </a:lnB>
+                  </a:tcPr>
+                </a:tc>
+              </a:tr>
+              <a:tr h="502920">
+                <a:tc>
+                  <a:txBody>
+                    <a:bodyPr/>
+                    <a:lstStyle/>
+                    <a:p>
+                      <a:pPr indent="0" marL="0">
+                        <a:buNone/>
+                      </a:pPr>
+                      <a:r>
+                        <a:rPr lang="en-US" sz="1150" dirty="0">
+                          <a:solidFill>
+                            <a:srgbClr val="1D2A33"/>
+                          </a:solidFill>
+                          <a:latin typeface="PingFang SC" pitchFamily="34" charset="0"/>
+                          <a:ea typeface="PingFang SC" pitchFamily="34" charset="-122"/>
+                          <a:cs typeface="PingFang SC" pitchFamily="34" charset="-120"/>
+                        </a:rPr>
+                        <a:t>占域模型:群落平均(logit)</a:t>
+                      </a:r>
+                      <a:endParaRPr lang="en-US" sz="1150" dirty="0">
+                        <a:latin typeface="PingFang SC" charset="0"/>
+                        <a:ea typeface="PingFang SC" charset="0"/>
+                        <a:cs typeface="PingFang SC" charset="0"/>
+                      </a:endParaRPr>
+                    </a:p>
+                  </a:txBody>
+                  <a:tcPr marL="91440" marR="91440" marT="45720" marB="45720" anchor="ctr">
+                    <a:lnL w="9525" cap="flat" cmpd="sng" algn="ctr">
+                      <a:solidFill>
+                        <a:srgbClr val="D5DEE2"/>
+                      </a:solidFill>
+                      <a:prstDash val="solid"/>
+                      <a:round/>
+                      <a:headEnd type="none" w="med" len="med"/>
+                      <a:tailEnd type="none" w="med" len="med"/>
+                    </a:lnL>
+                    <a:lnR w="9525" cap="flat" cmpd="sng" algn="ctr">
+                      <a:solidFill>
+                        <a:srgbClr val="D5DEE2"/>
+                      </a:solidFill>
+                      <a:prstDash val="solid"/>
+                      <a:round/>
+                      <a:headEnd type="none" w="med" len="med"/>
+                      <a:tailEnd type="none" w="med" len="med"/>
+                    </a:lnR>
+                    <a:lnT w="9525" cap="flat" cmpd="sng" algn="ctr">
+                      <a:solidFill>
+                        <a:srgbClr val="D5DEE2"/>
+                      </a:solidFill>
+                      <a:prstDash val="solid"/>
+                      <a:round/>
+                      <a:headEnd type="none" w="med" len="med"/>
+                      <a:tailEnd type="none" w="med" len="med"/>
+                    </a:lnT>
+                    <a:lnB w="9525" cap="flat" cmpd="sng" algn="ctr">
+                      <a:solidFill>
+                        <a:srgbClr val="D5DEE2"/>
+                      </a:solidFill>
+                      <a:prstDash val="solid"/>
+                      <a:round/>
+                      <a:headEnd type="none" w="med" len="med"/>
+                      <a:tailEnd type="none" w="med" len="med"/>
+                    </a:lnB>
+                  </a:tcPr>
+                </a:tc>
+                <a:tc>
+                  <a:txBody>
+                    <a:bodyPr/>
+                    <a:lstStyle/>
+                    <a:p>
+                      <a:pPr indent="0" marL="0">
+                        <a:buNone/>
+                      </a:pPr>
+                      <a:r>
+                        <a:rPr lang="en-US" sz="1150" dirty="0">
+                          <a:solidFill>
+                            <a:srgbClr val="1D2A33"/>
+                          </a:solidFill>
+                          <a:latin typeface="PingFang SC" pitchFamily="34" charset="0"/>
+                          <a:ea typeface="PingFang SC" pitchFamily="34" charset="-122"/>
+                          <a:cs typeface="PingFang SC" pitchFamily="34" charset="-120"/>
+                        </a:rPr>
+                        <a:t>+0.22(−0.11, 0.59)</a:t>
+                      </a:r>
+                      <a:endParaRPr lang="en-US" sz="1150" dirty="0">
+                        <a:latin typeface="PingFang SC" charset="0"/>
+                        <a:ea typeface="PingFang SC" charset="0"/>
+                        <a:cs typeface="PingFang SC" charset="0"/>
+                      </a:endParaRPr>
+                    </a:p>
+                  </a:txBody>
+                  <a:tcPr marL="91440" marR="91440" marT="45720" marB="45720" anchor="ctr">
+                    <a:lnL w="9525" cap="flat" cmpd="sng" algn="ctr">
+                      <a:solidFill>
+                        <a:srgbClr val="D5DEE2"/>
+                      </a:solidFill>
+                      <a:prstDash val="solid"/>
+                      <a:round/>
+                      <a:headEnd type="none" w="med" len="med"/>
+                      <a:tailEnd type="none" w="med" len="med"/>
+                    </a:lnL>
+                    <a:lnR w="9525" cap="flat" cmpd="sng" algn="ctr">
+                      <a:solidFill>
+                        <a:srgbClr val="D5DEE2"/>
+                      </a:solidFill>
+                      <a:prstDash val="solid"/>
+                      <a:round/>
+                      <a:headEnd type="none" w="med" len="med"/>
+                      <a:tailEnd type="none" w="med" len="med"/>
+                    </a:lnR>
+                    <a:lnT w="9525" cap="flat" cmpd="sng" algn="ctr">
+                      <a:solidFill>
+                        <a:srgbClr val="D5DEE2"/>
+                      </a:solidFill>
+                      <a:prstDash val="solid"/>
+                      <a:round/>
+                      <a:headEnd type="none" w="med" len="med"/>
+                      <a:tailEnd type="none" w="med" len="med"/>
+                    </a:lnT>
+                    <a:lnB w="9525" cap="flat" cmpd="sng" algn="ctr">
+                      <a:solidFill>
+                        <a:srgbClr val="D5DEE2"/>
+                      </a:solidFill>
+                      <a:prstDash val="solid"/>
+                      <a:round/>
+                      <a:headEnd type="none" w="med" len="med"/>
+                      <a:tailEnd type="none" w="med" len="med"/>
+                    </a:lnB>
+                  </a:tcPr>
+                </a:tc>
+                <a:tc>
+                  <a:txBody>
+                    <a:bodyPr/>
+                    <a:lstStyle/>
+                    <a:p>
+                      <a:pPr indent="0" marL="0">
+                        <a:buNone/>
+                      </a:pPr>
+                      <a:r>
+                        <a:rPr lang="en-US" sz="1150" b="1" dirty="0">
+                          <a:solidFill>
+                            <a:srgbClr val="B5523B"/>
+                          </a:solidFill>
+                          <a:latin typeface="PingFang SC" pitchFamily="34" charset="0"/>
+                          <a:ea typeface="PingFang SC" pitchFamily="34" charset="-122"/>
+                          <a:cs typeface="PingFang SC" pitchFamily="34" charset="-120"/>
+                        </a:rPr>
+                        <a:t>−0.41(−0.75, −0.04)</a:t>
+                      </a:r>
+                      <a:endParaRPr lang="en-US" sz="1150" dirty="0">
+                        <a:latin typeface="PingFang SC" charset="0"/>
+                        <a:ea typeface="PingFang SC" charset="0"/>
+                        <a:cs typeface="PingFang SC" charset="0"/>
+                      </a:endParaRPr>
+                    </a:p>
+                  </a:txBody>
+                  <a:tcPr marL="91440" marR="91440" marT="45720" marB="45720" anchor="ctr">
+                    <a:lnL w="9525" cap="flat" cmpd="sng" algn="ctr">
+                      <a:solidFill>
+                        <a:srgbClr val="D5DEE2"/>
+                      </a:solidFill>
+                      <a:prstDash val="solid"/>
+                      <a:round/>
+                      <a:headEnd type="none" w="med" len="med"/>
+                      <a:tailEnd type="none" w="med" len="med"/>
+                    </a:lnL>
+                    <a:lnR w="9525" cap="flat" cmpd="sng" algn="ctr">
+                      <a:solidFill>
+                        <a:srgbClr val="D5DEE2"/>
+                      </a:solidFill>
+                      <a:prstDash val="solid"/>
+                      <a:round/>
+                      <a:headEnd type="none" w="med" len="med"/>
+                      <a:tailEnd type="none" w="med" len="med"/>
+                    </a:lnR>
+                    <a:lnT w="9525" cap="flat" cmpd="sng" algn="ctr">
+                      <a:solidFill>
+                        <a:srgbClr val="D5DEE2"/>
+                      </a:solidFill>
+                      <a:prstDash val="solid"/>
+                      <a:round/>
+                      <a:headEnd type="none" w="med" len="med"/>
+                      <a:tailEnd type="none" w="med" len="med"/>
+                    </a:lnT>
+                    <a:lnB w="9525" cap="flat" cmpd="sng" algn="ctr">
+                      <a:solidFill>
+                        <a:srgbClr val="D5DEE2"/>
+                      </a:solidFill>
+                      <a:prstDash val="solid"/>
+                      <a:round/>
+                      <a:headEnd type="none" w="med" len="med"/>
+                      <a:tailEnd type="none" w="med" len="med"/>
+                    </a:lnB>
+                  </a:tcPr>
+                </a:tc>
+              </a:tr>
+              <a:tr h="502920">
+                <a:tc>
+                  <a:txBody>
+                    <a:bodyPr/>
+                    <a:lstStyle/>
+                    <a:p>
+                      <a:pPr indent="0" marL="0">
+                        <a:buNone/>
+                      </a:pPr>
+                      <a:r>
+                        <a:rPr lang="en-US" sz="1150" dirty="0">
+                          <a:solidFill>
+                            <a:srgbClr val="1D2A33"/>
+                          </a:solidFill>
+                          <a:latin typeface="PingFang SC" pitchFamily="34" charset="0"/>
+                          <a:ea typeface="PingFang SC" pitchFamily="34" charset="-122"/>
+                          <a:cs typeface="PingFang SC" pitchFamily="34" charset="-120"/>
+                        </a:rPr>
+                        <a:t>派生丰富度 DiD</a:t>
+                      </a:r>
+                      <a:endParaRPr lang="en-US" sz="1150" dirty="0">
+                        <a:latin typeface="PingFang SC" charset="0"/>
+                        <a:ea typeface="PingFang SC" charset="0"/>
+                        <a:cs typeface="PingFang SC" charset="0"/>
+                      </a:endParaRPr>
+                    </a:p>
+                  </a:txBody>
+                  <a:tcPr marL="91440" marR="91440" marT="45720" marB="45720" anchor="ctr">
+                    <a:lnL w="9525" cap="flat" cmpd="sng" algn="ctr">
+                      <a:solidFill>
+                        <a:srgbClr val="D5DEE2"/>
+                      </a:solidFill>
+                      <a:prstDash val="solid"/>
+                      <a:round/>
+                      <a:headEnd type="none" w="med" len="med"/>
+                      <a:tailEnd type="none" w="med" len="med"/>
+                    </a:lnL>
+                    <a:lnR w="9525" cap="flat" cmpd="sng" algn="ctr">
+                      <a:solidFill>
+                        <a:srgbClr val="D5DEE2"/>
+                      </a:solidFill>
+                      <a:prstDash val="solid"/>
+                      <a:round/>
+                      <a:headEnd type="none" w="med" len="med"/>
+                      <a:tailEnd type="none" w="med" len="med"/>
+                    </a:lnR>
+                    <a:lnT w="9525" cap="flat" cmpd="sng" algn="ctr">
+                      <a:solidFill>
+                        <a:srgbClr val="D5DEE2"/>
+                      </a:solidFill>
+                      <a:prstDash val="solid"/>
+                      <a:round/>
+                      <a:headEnd type="none" w="med" len="med"/>
+                      <a:tailEnd type="none" w="med" len="med"/>
+                    </a:lnT>
+                    <a:lnB w="9525" cap="flat" cmpd="sng" algn="ctr">
+                      <a:solidFill>
+                        <a:srgbClr val="D5DEE2"/>
+                      </a:solidFill>
+                      <a:prstDash val="solid"/>
+                      <a:round/>
+                      <a:headEnd type="none" w="med" len="med"/>
+                      <a:tailEnd type="none" w="med" len="med"/>
+                    </a:lnB>
+                  </a:tcPr>
+                </a:tc>
+                <a:tc>
+                  <a:txBody>
+                    <a:bodyPr/>
+                    <a:lstStyle/>
+                    <a:p>
+                      <a:pPr indent="0" marL="0">
+                        <a:buNone/>
+                      </a:pPr>
+                      <a:r>
+                        <a:rPr lang="en-US" sz="1150" dirty="0">
+                          <a:solidFill>
+                            <a:srgbClr val="1D2A33"/>
+                          </a:solidFill>
+                          <a:latin typeface="PingFang SC" pitchFamily="34" charset="0"/>
+                          <a:ea typeface="PingFang SC" pitchFamily="34" charset="-122"/>
+                          <a:cs typeface="PingFang SC" pitchFamily="34" charset="-120"/>
+                        </a:rPr>
+                        <a:t>+1.6 种(−0.6, 3.9)</a:t>
+                      </a:r>
+                      <a:endParaRPr lang="en-US" sz="1150" dirty="0">
+                        <a:latin typeface="PingFang SC" charset="0"/>
+                        <a:ea typeface="PingFang SC" charset="0"/>
+                        <a:cs typeface="PingFang SC" charset="0"/>
+                      </a:endParaRPr>
+                    </a:p>
+                  </a:txBody>
+                  <a:tcPr marL="91440" marR="91440" marT="45720" marB="45720" anchor="ctr">
+                    <a:lnL w="9525" cap="flat" cmpd="sng" algn="ctr">
+                      <a:solidFill>
+                        <a:srgbClr val="D5DEE2"/>
+                      </a:solidFill>
+                      <a:prstDash val="solid"/>
+                      <a:round/>
+                      <a:headEnd type="none" w="med" len="med"/>
+                      <a:tailEnd type="none" w="med" len="med"/>
+                    </a:lnL>
+                    <a:lnR w="9525" cap="flat" cmpd="sng" algn="ctr">
+                      <a:solidFill>
+                        <a:srgbClr val="D5DEE2"/>
+                      </a:solidFill>
+                      <a:prstDash val="solid"/>
+                      <a:round/>
+                      <a:headEnd type="none" w="med" len="med"/>
+                      <a:tailEnd type="none" w="med" len="med"/>
+                    </a:lnR>
+                    <a:lnT w="9525" cap="flat" cmpd="sng" algn="ctr">
+                      <a:solidFill>
+                        <a:srgbClr val="D5DEE2"/>
+                      </a:solidFill>
+                      <a:prstDash val="solid"/>
+                      <a:round/>
+                      <a:headEnd type="none" w="med" len="med"/>
+                      <a:tailEnd type="none" w="med" len="med"/>
+                    </a:lnT>
+                    <a:lnB w="9525" cap="flat" cmpd="sng" algn="ctr">
+                      <a:solidFill>
+                        <a:srgbClr val="D5DEE2"/>
+                      </a:solidFill>
+                      <a:prstDash val="solid"/>
+                      <a:round/>
+                      <a:headEnd type="none" w="med" len="med"/>
+                      <a:tailEnd type="none" w="med" len="med"/>
+                    </a:lnB>
+                  </a:tcPr>
+                </a:tc>
+                <a:tc>
+                  <a:txBody>
+                    <a:bodyPr/>
+                    <a:lstStyle/>
+                    <a:p>
+                      <a:pPr indent="0" marL="0">
+                        <a:buNone/>
+                      </a:pPr>
+                      <a:r>
+                        <a:rPr lang="en-US" sz="1150" b="1" dirty="0">
+                          <a:solidFill>
+                            <a:srgbClr val="B5523B"/>
+                          </a:solidFill>
+                          <a:latin typeface="PingFang SC" pitchFamily="34" charset="0"/>
+                          <a:ea typeface="PingFang SC" pitchFamily="34" charset="-122"/>
+                          <a:cs typeface="PingFang SC" pitchFamily="34" charset="-120"/>
+                        </a:rPr>
+                        <a:t>−3.9 种(−6.1, −1.7)</a:t>
+                      </a:r>
+                      <a:endParaRPr lang="en-US" sz="1150" dirty="0">
+                        <a:latin typeface="PingFang SC" charset="0"/>
+                        <a:ea typeface="PingFang SC" charset="0"/>
+                        <a:cs typeface="PingFang SC" charset="0"/>
+                      </a:endParaRPr>
+                    </a:p>
+                  </a:txBody>
+                  <a:tcPr marL="91440" marR="91440" marT="45720" marB="45720" anchor="ctr">
+                    <a:lnL w="9525" cap="flat" cmpd="sng" algn="ctr">
+                      <a:solidFill>
+                        <a:srgbClr val="D5DEE2"/>
+                      </a:solidFill>
+                      <a:prstDash val="solid"/>
+                      <a:round/>
+                      <a:headEnd type="none" w="med" len="med"/>
+                      <a:tailEnd type="none" w="med" len="med"/>
+                    </a:lnL>
+                    <a:lnR w="9525" cap="flat" cmpd="sng" algn="ctr">
+                      <a:solidFill>
+                        <a:srgbClr val="D5DEE2"/>
+                      </a:solidFill>
+                      <a:prstDash val="solid"/>
+                      <a:round/>
+                      <a:headEnd type="none" w="med" len="med"/>
+                      <a:tailEnd type="none" w="med" len="med"/>
+                    </a:lnR>
+                    <a:lnT w="9525" cap="flat" cmpd="sng" algn="ctr">
+                      <a:solidFill>
+                        <a:srgbClr val="D5DEE2"/>
+                      </a:solidFill>
+                      <a:prstDash val="solid"/>
+                      <a:round/>
+                      <a:headEnd type="none" w="med" len="med"/>
+                      <a:tailEnd type="none" w="med" len="med"/>
+                    </a:lnT>
+                    <a:lnB w="9525" cap="flat" cmpd="sng" algn="ctr">
+                      <a:solidFill>
+                        <a:srgbClr val="D5DEE2"/>
+                      </a:solidFill>
+                      <a:prstDash val="solid"/>
+                      <a:round/>
+                      <a:headEnd type="none" w="med" len="med"/>
+                      <a:tailEnd type="none" w="med" len="med"/>
+                    </a:lnB>
+                  </a:tcPr>
+                </a:tc>
+              </a:tr>
+            </a:tbl>
+          </a:graphicData>
+        </a:graphic>
+      </p:graphicFrame>
+      <p:sp>
+        <p:nvSpPr>
+          <p:cNvPr id="5" name="Text 2"/>
+          <p:cNvSpPr/>
+          <p:nvPr/>
+        </p:nvSpPr>
+        <p:spPr>
+          <a:xfrm>
+            <a:off x="457200" y="4160520"/>
+            <a:ext cx="6400800" cy="457200"/>
+          </a:xfrm>
+          <a:prstGeom prst="rect">
+            <a:avLst/>
+          </a:prstGeom>
+          <a:noFill/>
+          <a:ln/>
+        </p:spPr>
+        <p:txBody>
+          <a:bodyPr wrap="square" lIns="0" tIns="0" rIns="0" bIns="0" rtlCol="0" anchor="ctr"/>
+          <a:lstStyle/>
+          <a:p>
+            <a:pPr indent="0" marL="0">
+              <a:buNone/>
+            </a:pPr>
+            <a:r>
+              <a:rPr lang="en-US" sz="1150" dirty="0">
+                <a:solidFill>
+                  <a:srgbClr val="5E6B75"/>
+                </a:solidFill>
+                <a:latin typeface="PingFang SC" pitchFamily="34" charset="0"/>
+                <a:ea typeface="PingFang SC" pitchFamily="34" charset="-122"/>
+                <a:cs typeface="PingFang SC" pitchFamily="34" charset="-120"/>
+              </a:rPr>
+              <a:t>6,682 个研究站点中只有 38 个(&lt;1%)四格各 ≥ 3 份清单;西北试点与大站全部不合格。</a:t>
+            </a:r>
+            <a:endParaRPr lang="en-US" sz="1150" dirty="0"/>
+          </a:p>
+        </p:txBody>
+      </p:sp>
+      <p:sp>
+        <p:nvSpPr>
+          <p:cNvPr id="6" name="Shape 3"/>
+          <p:cNvSpPr/>
+          <p:nvPr/>
+        </p:nvSpPr>
+        <p:spPr>
+          <a:xfrm>
+            <a:off x="457200" y="4709160"/>
+            <a:ext cx="6400800" cy="1463040"/>
+          </a:xfrm>
+          <a:prstGeom prst="roundRect">
+            <a:avLst>
+              <a:gd name="adj" fmla="val 3750"/>
+            </a:avLst>
+          </a:prstGeom>
+          <a:solidFill>
+            <a:srgbClr val="F3E7E4"/>
+          </a:solidFill>
+          <a:ln w="12700">
+            <a:solidFill>
+              <a:srgbClr val="F3E7E4"/>
+            </a:solidFill>
+            <a:prstDash val="solid"/>
+          </a:ln>
+        </p:spPr>
+      </p:sp>
+      <p:sp>
+        <p:nvSpPr>
+          <p:cNvPr id="7" name="Text 4"/>
+          <p:cNvSpPr/>
+          <p:nvPr/>
+        </p:nvSpPr>
+        <p:spPr>
+          <a:xfrm>
+            <a:off x="640080" y="4800600"/>
+            <a:ext cx="6035040" cy="1280160"/>
+          </a:xfrm>
+          <a:prstGeom prst="rect">
+            <a:avLst/>
+          </a:prstGeom>
+          <a:noFill/>
+          <a:ln/>
+        </p:spPr>
+        <p:txBody>
+          <a:bodyPr wrap="square" lIns="0" tIns="0" rIns="0" bIns="0" rtlCol="0" anchor="ctr"/>
+          <a:lstStyle/>
+          <a:p>
+            <a:pPr indent="0" marL="0">
+              <a:buNone/>
+            </a:pPr>
+            <a:r>
+              <a:rPr lang="en-US" sz="1200" dirty="0">
+                <a:solidFill>
+                  <a:srgbClr val="1D2A33"/>
+                </a:solidFill>
+                <a:latin typeface="PingFang SC" pitchFamily="34" charset="0"/>
+                <a:ea typeface="PingFang SC" pitchFamily="34" charset="-122"/>
+                <a:cs typeface="PingFang SC" pitchFamily="34" charset="-120"/>
+              </a:rPr>
+              <a:t>判断:不稳定,暂不下结论。占域结果随纳入门槛翻转(38 站已收敛,R-hat ≤ 1.03),由 14 个稀疏站点驱动;近区建设前 3 年偏高,存在预趋势。大型荒漠基地需结构化监测或 China BON-Birds。</a:t>
+            </a:r>
+            <a:endParaRPr lang="en-US" sz="1200" dirty="0"/>
+          </a:p>
+        </p:txBody>
+      </p:sp>
+      <p:pic>
+        <p:nvPicPr>
+          <p:cNvPr id="8" name="Image 0" descr="results/figures/site_birds_did.png">    </p:cNvPr>
+          <p:cNvPicPr>
+            <a:picLocks noChangeAspect="1"/>
+          </p:cNvPicPr>
+          <p:nvPr/>
+        </p:nvPicPr>
+        <p:blipFill>
+          <a:blip r:embed="rId1"/>
+          <a:stretch>
+            <a:fillRect/>
+          </a:stretch>
+        </p:blipFill>
+        <p:spPr>
+          <a:xfrm>
+            <a:off x="7132320" y="1463040"/>
+            <a:ext cx="4572000" cy="2898648"/>
+          </a:xfrm>
+          <a:prstGeom prst="rect">
+            <a:avLst/>
+          </a:prstGeom>
+        </p:spPr>
+      </p:pic>
+      <p:sp>
+        <p:nvSpPr>
+          <p:cNvPr id="9" name="Text 5"/>
+          <p:cNvSpPr/>
+          <p:nvPr/>
+        </p:nvSpPr>
+        <p:spPr>
+          <a:xfrm>
+            <a:off x="7132320" y="4434840"/>
+            <a:ext cx="4572000" cy="320040"/>
+          </a:xfrm>
+          <a:prstGeom prst="rect">
+            <a:avLst/>
+          </a:prstGeom>
+          <a:noFill/>
+          <a:ln/>
+        </p:spPr>
+        <p:txBody>
+          <a:bodyPr wrap="square" lIns="0" tIns="0" rIns="0" bIns="0" rtlCol="0" anchor="ctr"/>
+          <a:lstStyle/>
+          <a:p>
+            <a:pPr indent="0" marL="0">
+              <a:buNone/>
+            </a:pPr>
+            <a:r>
+              <a:rPr lang="en-US" sz="1100" dirty="0">
+                <a:solidFill>
+                  <a:srgbClr val="5E6B75"/>
+                </a:solidFill>
+                <a:latin typeface="PingFang SC" pitchFamily="34" charset="0"/>
+                <a:ea typeface="PingFang SC" pitchFamily="34" charset="-122"/>
+                <a:cs typeface="PingFang SC" pitchFamily="34" charset="-120"/>
+              </a:rPr>
+              <a:t>清单层面事件研究(38 站)</a:t>
+            </a:r>
+            <a:endParaRPr lang="en-US" sz="1100" dirty="0"/>
+          </a:p>
+        </p:txBody>
+      </p:sp>
+      <p:sp>
+        <p:nvSpPr>
+          <p:cNvPr id="10" name="Text 6"/>
+          <p:cNvSpPr/>
+          <p:nvPr/>
+        </p:nvSpPr>
+        <p:spPr>
+          <a:xfrm>
+            <a:off x="11277295" y="6400800"/>
+            <a:ext cx="457200" cy="274320"/>
+          </a:xfrm>
+          <a:prstGeom prst="rect">
+            <a:avLst/>
+          </a:prstGeom>
+          <a:noFill/>
+          <a:ln/>
+        </p:spPr>
+        <p:txBody>
+          <a:bodyPr wrap="square" lIns="0" tIns="0" rIns="0" bIns="0" rtlCol="0" anchor="ctr"/>
+          <a:lstStyle/>
+          <a:p>
+            <a:pPr algn="r" indent="0" marL="0">
+              <a:buNone/>
+            </a:pPr>
+            <a:r>
+              <a:rPr lang="en-US" sz="1000" dirty="0">
+                <a:solidFill>
+                  <a:srgbClr val="5E6B75"/>
+                </a:solidFill>
+                <a:latin typeface="Arial" pitchFamily="34" charset="0"/>
+                <a:ea typeface="Arial" pitchFamily="34" charset="-122"/>
+                <a:cs typeface="Arial" pitchFamily="34" charset="-120"/>
+              </a:rPr>
+              <a:t>20</a:t>
+            </a:r>
+            <a:endParaRPr lang="en-US" sz="1000" dirty="0"/>
+          </a:p>
+        </p:txBody>
+      </p:sp>
+    </p:spTree>
+  </p:cSld>
+  <p:clrMapOvr>
+    <a:masterClrMapping/>
+  </p:clrMapOvr>
+</p:sld>
+</file>
+
+<file path=ppt/slides/slide21.xml><?xml version="1.0" encoding="utf-8"?>
+<p:sld xmlns:a="http://schemas.openxmlformats.org/drawingml/2006/main" xmlns:r="http://schemas.openxmlformats.org/officeDocument/2006/relationships" xmlns:p="http://schemas.openxmlformats.org/presentationml/2006/main">
+  <p:cSld name="Slide 21">
+    <p:spTree>
+      <p:nvGrpSpPr>
+        <p:cNvPr id="1" name=""/>
+        <p:cNvGrpSpPr/>
+        <p:nvPr/>
+      </p:nvGrpSpPr>
+      <p:grpSpPr>
+        <a:xfrm>
+          <a:off x="0" y="0"/>
+          <a:ext cx="0" cy="0"/>
+          <a:chOff x="0" y="0"/>
+          <a:chExt cx="0" cy="0"/>
+        </a:xfrm>
+      </p:grpSpPr>
+      <p:sp>
+        <p:nvSpPr>
+          <p:cNvPr id="2" name="Text 0"/>
+          <p:cNvSpPr/>
+          <p:nvPr/>
+        </p:nvSpPr>
+        <p:spPr>
+          <a:xfrm>
+            <a:off x="548640" y="320040"/>
+            <a:ext cx="11094415" cy="685800"/>
+          </a:xfrm>
+          <a:prstGeom prst="rect">
+            <a:avLst/>
+          </a:prstGeom>
+          <a:noFill/>
+          <a:ln/>
+        </p:spPr>
+        <p:txBody>
+          <a:bodyPr wrap="square" lIns="0" tIns="0" rIns="0" bIns="0" rtlCol="0" anchor="ctr"/>
+          <a:lstStyle/>
+          <a:p>
+            <a:pPr indent="0" marL="0">
+              <a:buNone/>
+            </a:pPr>
+            <a:r>
+              <a:rPr lang="en-US" sz="3000" b="1" dirty="0">
+                <a:solidFill>
+                  <a:srgbClr val="0E2F3C"/>
+                </a:solidFill>
+                <a:latin typeface="PingFang SC" pitchFamily="34" charset="0"/>
+                <a:ea typeface="PingFang SC" pitchFamily="34" charset="-122"/>
+                <a:cs typeface="PingFang SC" pitchFamily="34" charset="-120"/>
+              </a:rPr>
+              <a:t>主要风险与对策</a:t>
+            </a:r>
+            <a:endParaRPr lang="en-US" sz="3000" dirty="0"/>
+          </a:p>
+        </p:txBody>
+      </p:sp>
+      <p:graphicFrame>
+        <p:nvGraphicFramePr>
+          <p:cNvPr id="22" name="Table 0"/>
           <p:cNvGraphicFramePr>
             <a:graphicFrameLocks noGrp="1"/>
           </p:cNvGraphicFramePr>
@@ -14364,7 +17212,7 @@
                 <a:ea typeface="Arial" pitchFamily="34" charset="-122"/>
                 <a:cs typeface="Arial" pitchFamily="34" charset="-120"/>
               </a:rPr>
-              <a:t>19</a:t>
+              <a:t>21</a:t>
             </a:r>
             <a:endParaRPr lang="en-US" sz="1000" dirty="0"/>
           </a:p>
@@ -14378,9 +17226,9 @@
 </p:sld>
 </file>
 
-<file path=ppt/slides/slide2.xml><?xml version="1.0" encoding="utf-8"?>
+<file path=ppt/slides/slide22.xml><?xml version="1.0" encoding="utf-8"?>
 <p:sld xmlns:a="http://schemas.openxmlformats.org/drawingml/2006/main" xmlns:r="http://schemas.openxmlformats.org/officeDocument/2006/relationships" xmlns:p="http://schemas.openxmlformats.org/presentationml/2006/main">
-  <p:cSld name="Slide 2">
+  <p:cSld name="Slide 22">
     <p:spTree>
       <p:nvGrpSpPr>
         <p:cNvPr id="1" name=""/>
@@ -14428,7 +17276,7 @@
                 <a:ea typeface="PingFang SC" pitchFamily="34" charset="-122"/>
                 <a:cs typeface="PingFang SC" pitchFamily="34" charset="-120"/>
               </a:rPr>
-              <a:t>一句话判断</a:t>
+              <a:t>相关文献</a:t>
             </a:r>
             <a:endParaRPr lang="en-US" sz="3000" dirty="0"/>
           </a:p>
@@ -14442,8 +17290,330 @@
         </p:nvSpPr>
         <p:spPr>
           <a:xfrm>
-            <a:off x="548640" y="960120"/>
-            <a:ext cx="11094415" cy="365760"/>
+            <a:off x="548640" y="1143000"/>
+            <a:ext cx="11094415" cy="5212080"/>
+          </a:xfrm>
+          <a:prstGeom prst="rect">
+            <a:avLst/>
+          </a:prstGeom>
+          <a:noFill/>
+          <a:ln/>
+        </p:spPr>
+        <p:txBody>
+          <a:bodyPr wrap="square" lIns="0" tIns="0" rIns="0" bIns="0" rtlCol="0" anchor="t"/>
+          <a:lstStyle/>
+          <a:p>
+            <a:pPr indent="0" marL="0">
+              <a:spcAft>
+                <a:spcPts val="400"/>
+              </a:spcAft>
+              <a:buNone/>
+            </a:pPr>
+            <a:r>
+              <a:rPr lang="en-US" sz="1100" dirty="0">
+                <a:solidFill>
+                  <a:srgbClr val="1D2A33"/>
+                </a:solidFill>
+                <a:latin typeface="PingFang SC" pitchFamily="34" charset="0"/>
+                <a:ea typeface="PingFang SC" pitchFamily="34" charset="-122"/>
+                <a:cs typeface="PingFang SC" pitchFamily="34" charset="-120"/>
+              </a:rPr>
+              <a:t>[1] Zhou Z., Sun S., Zhang J., Fang Y., Li B.V. (2026) Comparing potential biodiversity conflicts from renewable energy expansion in China at different centralization levels. Nat. Ecol. Evol. 10:1316–1328.</a:t>
+            </a:r>
+            <a:endParaRPr lang="en-US" sz="1100" dirty="0"/>
+          </a:p>
+          <a:p>
+            <a:pPr indent="0" marL="0">
+              <a:spcAft>
+                <a:spcPts val="400"/>
+              </a:spcAft>
+              <a:buNone/>
+            </a:pPr>
+            <a:r>
+              <a:rPr lang="en-US" sz="1100" dirty="0">
+                <a:solidFill>
+                  <a:srgbClr val="1D2A33"/>
+                </a:solidFill>
+                <a:latin typeface="PingFang SC" pitchFamily="34" charset="0"/>
+                <a:ea typeface="PingFang SC" pitchFamily="34" charset="-122"/>
+                <a:cs typeface="PingFang SC" pitchFamily="34" charset="-120"/>
+              </a:rPr>
+              <a:t>[2] Zhang H. et al. (2026) China's solar expansion policy reduces bird diversity. Science 393:831–836.</a:t>
+            </a:r>
+            <a:endParaRPr lang="en-US" sz="1100" dirty="0"/>
+          </a:p>
+          <a:p>
+            <a:pPr indent="0" marL="0">
+              <a:spcAft>
+                <a:spcPts val="400"/>
+              </a:spcAft>
+              <a:buNone/>
+            </a:pPr>
+            <a:r>
+              <a:rPr lang="en-US" sz="1100" dirty="0">
+                <a:solidFill>
+                  <a:srgbClr val="1D2A33"/>
+                </a:solidFill>
+                <a:latin typeface="PingFang SC" pitchFamily="34" charset="0"/>
+                <a:ea typeface="PingFang SC" pitchFamily="34" charset="-122"/>
+                <a:cs typeface="PingFang SC" pitchFamily="34" charset="-120"/>
+              </a:rPr>
+              <a:t>[3] Robinson C. et al. (2025) Global Renewables Watch: a temporal dataset of solar and wind energy derived from satellite imagery. arXiv:2503.14860.</a:t>
+            </a:r>
+            <a:endParaRPr lang="en-US" sz="1100" dirty="0"/>
+          </a:p>
+          <a:p>
+            <a:pPr indent="0" marL="0">
+              <a:spcAft>
+                <a:spcPts val="400"/>
+              </a:spcAft>
+              <a:buNone/>
+            </a:pPr>
+            <a:r>
+              <a:rPr lang="en-US" sz="1100" dirty="0">
+                <a:solidFill>
+                  <a:srgbClr val="1D2A33"/>
+                </a:solidFill>
+                <a:latin typeface="PingFang SC" pitchFamily="34" charset="0"/>
+                <a:ea typeface="PingFang SC" pitchFamily="34" charset="-122"/>
+                <a:cs typeface="PingFang SC" pitchFamily="34" charset="-120"/>
+              </a:rPr>
+              <a:t>[4] Vectorized solar photovoltaic installation dataset across China in 2015 and 2020. Scientific Data (s41597-024-04356-z).</a:t>
+            </a:r>
+            <a:endParaRPr lang="en-US" sz="1100" dirty="0"/>
+          </a:p>
+          <a:p>
+            <a:pPr indent="0" marL="0">
+              <a:spcAft>
+                <a:spcPts val="400"/>
+              </a:spcAft>
+              <a:buNone/>
+            </a:pPr>
+            <a:r>
+              <a:rPr lang="en-US" sz="1100" dirty="0">
+                <a:solidFill>
+                  <a:srgbClr val="1D2A33"/>
+                </a:solidFill>
+                <a:latin typeface="PingFang SC" pitchFamily="34" charset="0"/>
+                <a:ea typeface="PingFang SC" pitchFamily="34" charset="-122"/>
+                <a:cs typeface="PingFang SC" pitchFamily="34" charset="-120"/>
+              </a:rPr>
+              <a:t>[5] A 10-m national-scale map of ground-mounted photovoltaic power stations in China of 2020. Scientific Data (2024).</a:t>
+            </a:r>
+            <a:endParaRPr lang="en-US" sz="1100" dirty="0"/>
+          </a:p>
+          <a:p>
+            <a:pPr indent="0" marL="0">
+              <a:spcAft>
+                <a:spcPts val="400"/>
+              </a:spcAft>
+              <a:buNone/>
+            </a:pPr>
+            <a:r>
+              <a:rPr lang="en-US" sz="1100" dirty="0">
+                <a:solidFill>
+                  <a:srgbClr val="1D2A33"/>
+                </a:solidFill>
+                <a:latin typeface="PingFang SC" pitchFamily="34" charset="0"/>
+                <a:ea typeface="PingFang SC" pitchFamily="34" charset="-122"/>
+                <a:cs typeface="PingFang SC" pitchFamily="34" charset="-120"/>
+              </a:rPr>
+              <a:t>[6] Satellites reveal spatial heterogeneity in dryland photovoltaic plants' effects on vegetation dynamics. Earth's Future (2024).</a:t>
+            </a:r>
+            <a:endParaRPr lang="en-US" sz="1100" dirty="0"/>
+          </a:p>
+          <a:p>
+            <a:pPr indent="0" marL="0">
+              <a:spcAft>
+                <a:spcPts val="400"/>
+              </a:spcAft>
+              <a:buNone/>
+            </a:pPr>
+            <a:r>
+              <a:rPr lang="en-US" sz="1100" dirty="0">
+                <a:solidFill>
+                  <a:srgbClr val="1D2A33"/>
+                </a:solidFill>
+                <a:latin typeface="PingFang SC" pitchFamily="34" charset="0"/>
+                <a:ea typeface="PingFang SC" pitchFamily="34" charset="-122"/>
+                <a:cs typeface="PingFang SC" pitchFamily="34" charset="-120"/>
+              </a:rPr>
+              <a:t>[7] Diverse vegetation responses to solar farm installation are also driven by climate change. Commun. Earth Environ. (2025).</a:t>
+            </a:r>
+            <a:endParaRPr lang="en-US" sz="1100" dirty="0"/>
+          </a:p>
+          <a:p>
+            <a:pPr indent="0" marL="0">
+              <a:spcAft>
+                <a:spcPts val="400"/>
+              </a:spcAft>
+              <a:buNone/>
+            </a:pPr>
+            <a:r>
+              <a:rPr lang="en-US" sz="1100" dirty="0">
+                <a:solidFill>
+                  <a:srgbClr val="1D2A33"/>
+                </a:solidFill>
+                <a:latin typeface="PingFang SC" pitchFamily="34" charset="0"/>
+                <a:ea typeface="PingFang SC" pitchFamily="34" charset="-122"/>
+                <a:cs typeface="PingFang SC" pitchFamily="34" charset="-120"/>
+              </a:rPr>
+              <a:t>[8] Large-scale photovoltaic farms significantly change the vegetation diversity and biomass through influencing soil moisture. Vadose Zone J. (2025).</a:t>
+            </a:r>
+            <a:endParaRPr lang="en-US" sz="1100" dirty="0"/>
+          </a:p>
+          <a:p>
+            <a:pPr indent="0" marL="0">
+              <a:spcAft>
+                <a:spcPts val="400"/>
+              </a:spcAft>
+              <a:buNone/>
+            </a:pPr>
+            <a:r>
+              <a:rPr lang="en-US" sz="1100" dirty="0">
+                <a:solidFill>
+                  <a:srgbClr val="1D2A33"/>
+                </a:solidFill>
+                <a:latin typeface="PingFang SC" pitchFamily="34" charset="0"/>
+                <a:ea typeface="PingFang SC" pitchFamily="34" charset="-122"/>
+                <a:cs typeface="PingFang SC" pitchFamily="34" charset="-120"/>
+              </a:rPr>
+              <a:t>[9] Wind farms increase land surface temperature and reduce vegetation productivity in the Inner Mongolia. Geography and Sustainability (2024).</a:t>
+            </a:r>
+            <a:endParaRPr lang="en-US" sz="1100" dirty="0"/>
+          </a:p>
+          <a:p>
+            <a:pPr indent="0" marL="0">
+              <a:spcAft>
+                <a:spcPts val="400"/>
+              </a:spcAft>
+              <a:buNone/>
+            </a:pPr>
+            <a:r>
+              <a:rPr lang="en-US" sz="1100" dirty="0">
+                <a:solidFill>
+                  <a:srgbClr val="1D2A33"/>
+                </a:solidFill>
+                <a:latin typeface="PingFang SC" pitchFamily="34" charset="0"/>
+                <a:ea typeface="PingFang SC" pitchFamily="34" charset="-122"/>
+                <a:cs typeface="PingFang SC" pitchFamily="34" charset="-120"/>
+              </a:rPr>
+              <a:t>[10] Callaway B., Sant'Anna P.H.C. (2021) J. Econometrics 225:200–230;Sun L., Abraham S. (2021) J. Econometrics 225:175–199;Rambachan A., Roth J. (2023) Rev. Econ. Stud. 90:2555–2591.</a:t>
+            </a:r>
+            <a:endParaRPr lang="en-US" sz="1100" dirty="0"/>
+          </a:p>
+          <a:p>
+            <a:pPr indent="0" marL="0">
+              <a:spcAft>
+                <a:spcPts val="400"/>
+              </a:spcAft>
+              <a:buNone/>
+            </a:pPr>
+            <a:r>
+              <a:rPr lang="en-US" sz="1100" dirty="0">
+                <a:solidFill>
+                  <a:srgbClr val="1D2A33"/>
+                </a:solidFill>
+                <a:latin typeface="PingFang SC" pitchFamily="34" charset="0"/>
+                <a:ea typeface="PingFang SC" pitchFamily="34" charset="-122"/>
+                <a:cs typeface="PingFang SC" pitchFamily="34" charset="-120"/>
+              </a:rPr>
+              <a:t>[11] Brooks T.M. et al. (2019) Measuring terrestrial Area of Habitat (AOH) and its utility for the IUCN Red List. Trends Ecol. Evol. 34:977–986.</a:t>
+            </a:r>
+            <a:endParaRPr lang="en-US" sz="1100" dirty="0"/>
+          </a:p>
+          <a:p>
+            <a:pPr indent="0" marL="0">
+              <a:spcAft>
+                <a:spcPts val="400"/>
+              </a:spcAft>
+              <a:buNone/>
+            </a:pPr>
+            <a:r>
+              <a:rPr lang="en-US" sz="1100" dirty="0">
+                <a:solidFill>
+                  <a:srgbClr val="1D2A33"/>
+                </a:solidFill>
+                <a:latin typeface="PingFang SC" pitchFamily="34" charset="0"/>
+                <a:ea typeface="PingFang SC" pitchFamily="34" charset="-122"/>
+                <a:cs typeface="PingFang SC" pitchFamily="34" charset="-120"/>
+              </a:rPr>
+              <a:t>[12] Li X., He Z., Xia S., Yang Y. (2024) Greenness change associated with construction and operation of photovoltaic solar energy in China. Renewable Energy 226:120461.</a:t>
+            </a:r>
+            <a:endParaRPr lang="en-US" sz="1100" dirty="0"/>
+          </a:p>
+          <a:p>
+            <a:pPr indent="0" marL="0">
+              <a:spcAft>
+                <a:spcPts val="400"/>
+              </a:spcAft>
+              <a:buNone/>
+            </a:pPr>
+            <a:r>
+              <a:rPr lang="en-US" sz="1100" dirty="0">
+                <a:solidFill>
+                  <a:srgbClr val="1D2A33"/>
+                </a:solidFill>
+                <a:latin typeface="PingFang SC" pitchFamily="34" charset="0"/>
+                <a:ea typeface="PingFang SC" pitchFamily="34" charset="-122"/>
+                <a:cs typeface="PingFang SC" pitchFamily="34" charset="-120"/>
+              </a:rPr>
+              <a:t>[13] Li Y., Wang Z., Lei Y., Yu X., Che H., Zhang X. (2026) Ecological effects of photovoltaic deployment in China: a remote sensing assessment. Environ. Res. Commun. 8:041016.</a:t>
+            </a:r>
+            <a:endParaRPr lang="en-US" sz="1100" dirty="0"/>
+          </a:p>
+          <a:p>
+            <a:pPr indent="0" marL="0">
+              <a:spcAft>
+                <a:spcPts val="400"/>
+              </a:spcAft>
+              <a:buNone/>
+            </a:pPr>
+            <a:r>
+              <a:rPr lang="en-US" sz="1100" dirty="0">
+                <a:solidFill>
+                  <a:srgbClr val="1D2A33"/>
+                </a:solidFill>
+                <a:latin typeface="PingFang SC" pitchFamily="34" charset="0"/>
+                <a:ea typeface="PingFang SC" pitchFamily="34" charset="-122"/>
+                <a:cs typeface="PingFang SC" pitchFamily="34" charset="-120"/>
+              </a:rPr>
+              <a:t>[14] 彭昀月, 罗永梅, 徐泽楠, 靳彤 (2024) 集中式大型光伏及风电电场生态影响:进展与展望. 生物多样性 32(2):23212.</a:t>
+            </a:r>
+            <a:endParaRPr lang="en-US" sz="1100" dirty="0"/>
+          </a:p>
+          <a:p>
+            <a:pPr indent="0" marL="0">
+              <a:spcAft>
+                <a:spcPts val="400"/>
+              </a:spcAft>
+              <a:buNone/>
+            </a:pPr>
+            <a:r>
+              <a:rPr lang="en-US" sz="1100" dirty="0">
+                <a:solidFill>
+                  <a:srgbClr val="1D2A33"/>
+                </a:solidFill>
+                <a:latin typeface="PingFang SC" pitchFamily="34" charset="0"/>
+                <a:ea typeface="PingFang SC" pitchFamily="34" charset="-122"/>
+                <a:cs typeface="PingFang SC" pitchFamily="34" charset="-120"/>
+              </a:rPr>
+              <a:t>[15] 《中国可再生能源与生物多样性协同发展的机遇与挑战》(征求意见稿),发布机构与日期待核实。</a:t>
+            </a:r>
+            <a:endParaRPr lang="en-US" sz="1100" dirty="0"/>
+          </a:p>
+        </p:txBody>
+      </p:sp>
+      <p:sp>
+        <p:nvSpPr>
+          <p:cNvPr id="4" name="Text 2"/>
+          <p:cNvSpPr/>
+          <p:nvPr/>
+        </p:nvSpPr>
+        <p:spPr>
+          <a:xfrm>
+            <a:off x="11277295" y="6400800"/>
+            <a:ext cx="457200" cy="274320"/>
           </a:xfrm>
           <a:prstGeom prst="rect">
             <a:avLst/>
@@ -14455,770 +17625,19 @@
           <a:bodyPr wrap="square" lIns="0" tIns="0" rIns="0" bIns="0" rtlCol="0" anchor="ctr"/>
           <a:lstStyle/>
           <a:p>
-            <a:pPr indent="0" marL="0">
+            <a:pPr algn="r" indent="0" marL="0">
               <a:buNone/>
             </a:pPr>
             <a:r>
-              <a:rPr lang="en-US" sz="1400" dirty="0">
+              <a:rPr lang="en-US" sz="1000" dirty="0">
                 <a:solidFill>
                   <a:srgbClr val="5E6B75"/>
-                </a:solidFill>
-                <a:latin typeface="PingFang SC" pitchFamily="34" charset="0"/>
-                <a:ea typeface="PingFang SC" pitchFamily="34" charset="-122"/>
-                <a:cs typeface="PingFang SC" pitchFamily="34" charset="-120"/>
-              </a:rPr>
-              <a:t>可以做,时机好;全国绿度评估已有(Li 等 2024),新意在因果对照、异质性、风电与物种暴露</a:t>
-            </a:r>
-            <a:endParaRPr lang="en-US" sz="1400" dirty="0"/>
-          </a:p>
-        </p:txBody>
-      </p:sp>
-      <p:sp>
-        <p:nvSpPr>
-          <p:cNvPr id="4" name="Shape 2"/>
-          <p:cNvSpPr/>
-          <p:nvPr/>
-        </p:nvSpPr>
-        <p:spPr>
-          <a:xfrm>
-            <a:off x="548640" y="1645920"/>
-            <a:ext cx="5120640" cy="4206240"/>
-          </a:xfrm>
-          <a:prstGeom prst="roundRect">
-            <a:avLst>
-              <a:gd name="adj" fmla="val 1739"/>
-            </a:avLst>
-          </a:prstGeom>
-          <a:solidFill>
-            <a:srgbClr val="0E2F3C"/>
-          </a:solidFill>
-          <a:ln w="12700">
-            <a:solidFill>
-              <a:srgbClr val="0E2F3C"/>
-            </a:solidFill>
-            <a:prstDash val="solid"/>
-          </a:ln>
-        </p:spPr>
-      </p:sp>
-      <p:sp>
-        <p:nvSpPr>
-          <p:cNvPr id="5" name="Text 3"/>
-          <p:cNvSpPr/>
-          <p:nvPr/>
-        </p:nvSpPr>
-        <p:spPr>
-          <a:xfrm>
-            <a:off x="822960" y="2011680"/>
-            <a:ext cx="4572000" cy="731520"/>
-          </a:xfrm>
-          <a:prstGeom prst="rect">
-            <a:avLst/>
-          </a:prstGeom>
-          <a:noFill/>
-          <a:ln/>
-        </p:spPr>
-        <p:txBody>
-          <a:bodyPr wrap="square" lIns="0" tIns="0" rIns="0" bIns="0" rtlCol="0" anchor="ctr"/>
-          <a:lstStyle/>
-          <a:p>
-            <a:pPr indent="0" marL="0">
-              <a:buNone/>
-            </a:pPr>
-            <a:r>
-              <a:rPr lang="en-US" sz="3400" b="1" dirty="0">
-                <a:solidFill>
-                  <a:srgbClr val="E9A23B"/>
                 </a:solidFill>
                 <a:latin typeface="Arial" pitchFamily="34" charset="0"/>
                 <a:ea typeface="Arial" pitchFamily="34" charset="-122"/>
                 <a:cs typeface="Arial" pitchFamily="34" charset="-120"/>
               </a:rPr>
-              <a:t>2017Q4 – 2024Q2</a:t>
-            </a:r>
-            <a:endParaRPr lang="en-US" sz="3400" dirty="0"/>
-          </a:p>
-        </p:txBody>
-      </p:sp>
-      <p:sp>
-        <p:nvSpPr>
-          <p:cNvPr id="6" name="Text 4"/>
-          <p:cNvSpPr/>
-          <p:nvPr/>
-        </p:nvSpPr>
-        <p:spPr>
-          <a:xfrm>
-            <a:off x="822960" y="2834640"/>
-            <a:ext cx="4572000" cy="1097280"/>
-          </a:xfrm>
-          <a:prstGeom prst="rect">
-            <a:avLst/>
-          </a:prstGeom>
-          <a:noFill/>
-          <a:ln/>
-        </p:spPr>
-        <p:txBody>
-          <a:bodyPr wrap="square" lIns="0" tIns="0" rIns="0" bIns="0" rtlCol="0" anchor="ctr"/>
-          <a:lstStyle/>
-          <a:p>
-            <a:pPr indent="0" marL="0">
-              <a:buNone/>
-            </a:pPr>
-            <a:r>
-              <a:rPr lang="en-US" sz="1500" dirty="0">
-                <a:solidFill>
-                  <a:srgbClr val="FFFFFF"/>
-                </a:solidFill>
-                <a:latin typeface="PingFang SC" pitchFamily="34" charset="0"/>
-                <a:ea typeface="PingFang SC" pitchFamily="34" charset="-122"/>
-                <a:cs typeface="PingFang SC" pitchFamily="34" charset="-120"/>
-              </a:rPr>
-              <a:t>Global Renewables Watch 为全球每个光伏电站和陆上风机标注了季度精度的建设日期</a:t>
-            </a:r>
-            <a:endParaRPr lang="en-US" sz="1500" dirty="0"/>
-          </a:p>
-        </p:txBody>
-      </p:sp>
-      <p:sp>
-        <p:nvSpPr>
-          <p:cNvPr id="7" name="Text 5"/>
-          <p:cNvSpPr/>
-          <p:nvPr/>
-        </p:nvSpPr>
-        <p:spPr>
-          <a:xfrm>
-            <a:off x="822960" y="4114800"/>
-            <a:ext cx="4572000" cy="1097280"/>
-          </a:xfrm>
-          <a:prstGeom prst="rect">
-            <a:avLst/>
-          </a:prstGeom>
-          <a:noFill/>
-          <a:ln/>
-        </p:spPr>
-        <p:txBody>
-          <a:bodyPr wrap="square" lIns="0" tIns="0" rIns="0" bIns="0" rtlCol="0" anchor="ctr"/>
-          <a:lstStyle/>
-          <a:p>
-            <a:pPr indent="0" marL="0">
-              <a:buNone/>
-            </a:pPr>
-            <a:r>
-              <a:rPr lang="en-US" sz="1500" dirty="0">
-                <a:solidFill>
-                  <a:srgbClr val="CFE3E6"/>
-                </a:solidFill>
-                <a:latin typeface="PingFang SC" pitchFamily="34" charset="0"/>
-                <a:ea typeface="PingFang SC" pitchFamily="34" charset="-122"/>
-                <a:cs typeface="PingFang SC" pitchFamily="34" charset="-120"/>
-              </a:rPr>
-              <a:t>这让"建设前后、早建与晚建"的交错双重差分第一次可以在全国尺度上做</a:t>
-            </a:r>
-            <a:endParaRPr lang="en-US" sz="1500" dirty="0"/>
-          </a:p>
-        </p:txBody>
-      </p:sp>
-      <p:sp>
-        <p:nvSpPr>
-          <p:cNvPr id="8" name="Shape 6"/>
-          <p:cNvSpPr/>
-          <p:nvPr/>
-        </p:nvSpPr>
-        <p:spPr>
-          <a:xfrm>
-            <a:off x="6126480" y="1828800"/>
-            <a:ext cx="548640" cy="548640"/>
-          </a:xfrm>
-          <a:prstGeom prst="ellipse">
-            <a:avLst/>
-          </a:prstGeom>
-          <a:solidFill>
-            <a:srgbClr val="E9A23B"/>
-          </a:solidFill>
-          <a:ln w="12700">
-            <a:solidFill>
-              <a:srgbClr val="E9A23B"/>
-            </a:solidFill>
-            <a:prstDash val="solid"/>
-          </a:ln>
-        </p:spPr>
-      </p:sp>
-      <p:sp>
-        <p:nvSpPr>
-          <p:cNvPr id="9" name="Text 7"/>
-          <p:cNvSpPr/>
-          <p:nvPr/>
-        </p:nvSpPr>
-        <p:spPr>
-          <a:xfrm>
-            <a:off x="6126480" y="1828800"/>
-            <a:ext cx="548640" cy="548640"/>
-          </a:xfrm>
-          <a:prstGeom prst="rect">
-            <a:avLst/>
-          </a:prstGeom>
-          <a:noFill/>
-          <a:ln/>
-        </p:spPr>
-        <p:txBody>
-          <a:bodyPr wrap="square" lIns="0" tIns="0" rIns="0" bIns="0" rtlCol="0" anchor="ctr"/>
-          <a:lstStyle/>
-          <a:p>
-            <a:pPr algn="ctr" indent="0" marL="0">
-              <a:buNone/>
-            </a:pPr>
-            <a:r>
-              <a:rPr lang="en-US" sz="1400" b="1" dirty="0">
-                <a:solidFill>
-                  <a:srgbClr val="FFFFFF"/>
-                </a:solidFill>
-                <a:latin typeface="Arial" pitchFamily="34" charset="0"/>
-                <a:ea typeface="Arial" pitchFamily="34" charset="-122"/>
-                <a:cs typeface="Arial" pitchFamily="34" charset="-120"/>
-              </a:rPr>
-              <a:t>1</a:t>
-            </a:r>
-            <a:endParaRPr lang="en-US" sz="1400" dirty="0"/>
-          </a:p>
-        </p:txBody>
-      </p:sp>
-      <p:sp>
-        <p:nvSpPr>
-          <p:cNvPr id="10" name="Text 8"/>
-          <p:cNvSpPr/>
-          <p:nvPr/>
-        </p:nvSpPr>
-        <p:spPr>
-          <a:xfrm>
-            <a:off x="6858000" y="1691640"/>
-            <a:ext cx="4754880" cy="411480"/>
-          </a:xfrm>
-          <a:prstGeom prst="rect">
-            <a:avLst/>
-          </a:prstGeom>
-          <a:noFill/>
-          <a:ln/>
-        </p:spPr>
-        <p:txBody>
-          <a:bodyPr wrap="square" lIns="0" tIns="0" rIns="0" bIns="0" rtlCol="0" anchor="ctr"/>
-          <a:lstStyle/>
-          <a:p>
-            <a:pPr indent="0" marL="0">
-              <a:buNone/>
-            </a:pPr>
-            <a:r>
-              <a:rPr lang="en-US" sz="1700" b="1" dirty="0">
-                <a:solidFill>
-                  <a:srgbClr val="0E2F3C"/>
-                </a:solidFill>
-                <a:latin typeface="PingFang SC" pitchFamily="34" charset="0"/>
-                <a:ea typeface="PingFang SC" pitchFamily="34" charset="-122"/>
-                <a:cs typeface="PingFang SC" pitchFamily="34" charset="-120"/>
-              </a:rPr>
-              <a:t>暴露</a:t>
-            </a:r>
-            <a:endParaRPr lang="en-US" sz="1700" dirty="0"/>
-          </a:p>
-        </p:txBody>
-      </p:sp>
-      <p:sp>
-        <p:nvSpPr>
-          <p:cNvPr id="11" name="Text 9"/>
-          <p:cNvSpPr/>
-          <p:nvPr/>
-        </p:nvSpPr>
-        <p:spPr>
-          <a:xfrm>
-            <a:off x="6858000" y="2103120"/>
-            <a:ext cx="4754880" cy="502920"/>
-          </a:xfrm>
-          <a:prstGeom prst="rect">
-            <a:avLst/>
-          </a:prstGeom>
-          <a:noFill/>
-          <a:ln/>
-        </p:spPr>
-        <p:txBody>
-          <a:bodyPr wrap="square" lIns="0" tIns="0" rIns="0" bIns="0" rtlCol="0" anchor="ctr"/>
-          <a:lstStyle/>
-          <a:p>
-            <a:pPr indent="0" marL="0">
-              <a:buNone/>
-            </a:pPr>
-            <a:r>
-              <a:rPr lang="en-US" sz="1400" dirty="0">
-                <a:solidFill>
-                  <a:srgbClr val="1D2A33"/>
-                </a:solidFill>
-                <a:latin typeface="PingFang SC" pitchFamily="34" charset="0"/>
-                <a:ea typeface="PingFang SC" pitchFamily="34" charset="-122"/>
-                <a:cs typeface="PingFang SC" pitchFamily="34" charset="-120"/>
-              </a:rPr>
-              <a:t>真实设施足迹与建设日期,而非县级政策指数</a:t>
-            </a:r>
-            <a:endParaRPr lang="en-US" sz="1400" dirty="0"/>
-          </a:p>
-        </p:txBody>
-      </p:sp>
-      <p:sp>
-        <p:nvSpPr>
-          <p:cNvPr id="12" name="Shape 10"/>
-          <p:cNvSpPr/>
-          <p:nvPr/>
-        </p:nvSpPr>
-        <p:spPr>
-          <a:xfrm>
-            <a:off x="6126480" y="2880360"/>
-            <a:ext cx="548640" cy="548640"/>
-          </a:xfrm>
-          <a:prstGeom prst="ellipse">
-            <a:avLst/>
-          </a:prstGeom>
-          <a:solidFill>
-            <a:srgbClr val="1F6F78"/>
-          </a:solidFill>
-          <a:ln w="12700">
-            <a:solidFill>
-              <a:srgbClr val="1F6F78"/>
-            </a:solidFill>
-            <a:prstDash val="solid"/>
-          </a:ln>
-        </p:spPr>
-      </p:sp>
-      <p:sp>
-        <p:nvSpPr>
-          <p:cNvPr id="13" name="Text 11"/>
-          <p:cNvSpPr/>
-          <p:nvPr/>
-        </p:nvSpPr>
-        <p:spPr>
-          <a:xfrm>
-            <a:off x="6126480" y="2880360"/>
-            <a:ext cx="548640" cy="548640"/>
-          </a:xfrm>
-          <a:prstGeom prst="rect">
-            <a:avLst/>
-          </a:prstGeom>
-          <a:noFill/>
-          <a:ln/>
-        </p:spPr>
-        <p:txBody>
-          <a:bodyPr wrap="square" lIns="0" tIns="0" rIns="0" bIns="0" rtlCol="0" anchor="ctr"/>
-          <a:lstStyle/>
-          <a:p>
-            <a:pPr algn="ctr" indent="0" marL="0">
-              <a:buNone/>
-            </a:pPr>
-            <a:r>
-              <a:rPr lang="en-US" sz="1400" b="1" dirty="0">
-                <a:solidFill>
-                  <a:srgbClr val="FFFFFF"/>
-                </a:solidFill>
-                <a:latin typeface="Arial" pitchFamily="34" charset="0"/>
-                <a:ea typeface="Arial" pitchFamily="34" charset="-122"/>
-                <a:cs typeface="Arial" pitchFamily="34" charset="-120"/>
-              </a:rPr>
-              <a:t>2</a:t>
-            </a:r>
-            <a:endParaRPr lang="en-US" sz="1400" dirty="0"/>
-          </a:p>
-        </p:txBody>
-      </p:sp>
-      <p:sp>
-        <p:nvSpPr>
-          <p:cNvPr id="14" name="Text 12"/>
-          <p:cNvSpPr/>
-          <p:nvPr/>
-        </p:nvSpPr>
-        <p:spPr>
-          <a:xfrm>
-            <a:off x="6858000" y="2743200"/>
-            <a:ext cx="4754880" cy="411480"/>
-          </a:xfrm>
-          <a:prstGeom prst="rect">
-            <a:avLst/>
-          </a:prstGeom>
-          <a:noFill/>
-          <a:ln/>
-        </p:spPr>
-        <p:txBody>
-          <a:bodyPr wrap="square" lIns="0" tIns="0" rIns="0" bIns="0" rtlCol="0" anchor="ctr"/>
-          <a:lstStyle/>
-          <a:p>
-            <a:pPr indent="0" marL="0">
-              <a:buNone/>
-            </a:pPr>
-            <a:r>
-              <a:rPr lang="en-US" sz="1700" b="1" dirty="0">
-                <a:solidFill>
-                  <a:srgbClr val="0E2F3C"/>
-                </a:solidFill>
-                <a:latin typeface="PingFang SC" pitchFamily="34" charset="0"/>
-                <a:ea typeface="PingFang SC" pitchFamily="34" charset="-122"/>
-                <a:cs typeface="PingFang SC" pitchFamily="34" charset="-120"/>
-              </a:rPr>
-              <a:t>结局</a:t>
-            </a:r>
-            <a:endParaRPr lang="en-US" sz="1700" dirty="0"/>
-          </a:p>
-        </p:txBody>
-      </p:sp>
-      <p:sp>
-        <p:nvSpPr>
-          <p:cNvPr id="15" name="Text 13"/>
-          <p:cNvSpPr/>
-          <p:nvPr/>
-        </p:nvSpPr>
-        <p:spPr>
-          <a:xfrm>
-            <a:off x="6858000" y="3154680"/>
-            <a:ext cx="4754880" cy="502920"/>
-          </a:xfrm>
-          <a:prstGeom prst="rect">
-            <a:avLst/>
-          </a:prstGeom>
-          <a:noFill/>
-          <a:ln/>
-        </p:spPr>
-        <p:txBody>
-          <a:bodyPr wrap="square" lIns="0" tIns="0" rIns="0" bIns="0" rtlCol="0" anchor="ctr"/>
-          <a:lstStyle/>
-          <a:p>
-            <a:pPr indent="0" marL="0">
-              <a:buNone/>
-            </a:pPr>
-            <a:r>
-              <a:rPr lang="en-US" sz="1400" dirty="0">
-                <a:solidFill>
-                  <a:srgbClr val="1D2A33"/>
-                </a:solidFill>
-                <a:latin typeface="PingFang SC" pitchFamily="34" charset="0"/>
-                <a:ea typeface="PingFang SC" pitchFamily="34" charset="-122"/>
-                <a:cs typeface="PingFang SC" pitchFamily="34" charset="-120"/>
-              </a:rPr>
-              <a:t>栖息地状况的遥感指标与物种暴露,不依赖观测努力</a:t>
-            </a:r>
-            <a:endParaRPr lang="en-US" sz="1400" dirty="0"/>
-          </a:p>
-        </p:txBody>
-      </p:sp>
-      <p:sp>
-        <p:nvSpPr>
-          <p:cNvPr id="16" name="Shape 14"/>
-          <p:cNvSpPr/>
-          <p:nvPr/>
-        </p:nvSpPr>
-        <p:spPr>
-          <a:xfrm>
-            <a:off x="6126480" y="3931920"/>
-            <a:ext cx="548640" cy="548640"/>
-          </a:xfrm>
-          <a:prstGeom prst="ellipse">
-            <a:avLst/>
-          </a:prstGeom>
-          <a:solidFill>
-            <a:srgbClr val="E9A23B"/>
-          </a:solidFill>
-          <a:ln w="12700">
-            <a:solidFill>
-              <a:srgbClr val="E9A23B"/>
-            </a:solidFill>
-            <a:prstDash val="solid"/>
-          </a:ln>
-        </p:spPr>
-      </p:sp>
-      <p:sp>
-        <p:nvSpPr>
-          <p:cNvPr id="17" name="Text 15"/>
-          <p:cNvSpPr/>
-          <p:nvPr/>
-        </p:nvSpPr>
-        <p:spPr>
-          <a:xfrm>
-            <a:off x="6126480" y="3931920"/>
-            <a:ext cx="548640" cy="548640"/>
-          </a:xfrm>
-          <a:prstGeom prst="rect">
-            <a:avLst/>
-          </a:prstGeom>
-          <a:noFill/>
-          <a:ln/>
-        </p:spPr>
-        <p:txBody>
-          <a:bodyPr wrap="square" lIns="0" tIns="0" rIns="0" bIns="0" rtlCol="0" anchor="ctr"/>
-          <a:lstStyle/>
-          <a:p>
-            <a:pPr algn="ctr" indent="0" marL="0">
-              <a:buNone/>
-            </a:pPr>
-            <a:r>
-              <a:rPr lang="en-US" sz="1400" b="1" dirty="0">
-                <a:solidFill>
-                  <a:srgbClr val="FFFFFF"/>
-                </a:solidFill>
-                <a:latin typeface="Arial" pitchFamily="34" charset="0"/>
-                <a:ea typeface="Arial" pitchFamily="34" charset="-122"/>
-                <a:cs typeface="Arial" pitchFamily="34" charset="-120"/>
-              </a:rPr>
-              <a:t>3</a:t>
-            </a:r>
-            <a:endParaRPr lang="en-US" sz="1400" dirty="0"/>
-          </a:p>
-        </p:txBody>
-      </p:sp>
-      <p:sp>
-        <p:nvSpPr>
-          <p:cNvPr id="18" name="Text 16"/>
-          <p:cNvSpPr/>
-          <p:nvPr/>
-        </p:nvSpPr>
-        <p:spPr>
-          <a:xfrm>
-            <a:off x="6858000" y="3794760"/>
-            <a:ext cx="4754880" cy="411480"/>
-          </a:xfrm>
-          <a:prstGeom prst="rect">
-            <a:avLst/>
-          </a:prstGeom>
-          <a:noFill/>
-          <a:ln/>
-        </p:spPr>
-        <p:txBody>
-          <a:bodyPr wrap="square" lIns="0" tIns="0" rIns="0" bIns="0" rtlCol="0" anchor="ctr"/>
-          <a:lstStyle/>
-          <a:p>
-            <a:pPr indent="0" marL="0">
-              <a:buNone/>
-            </a:pPr>
-            <a:r>
-              <a:rPr lang="en-US" sz="1700" b="1" dirty="0">
-                <a:solidFill>
-                  <a:srgbClr val="0E2F3C"/>
-                </a:solidFill>
-                <a:latin typeface="PingFang SC" pitchFamily="34" charset="0"/>
-                <a:ea typeface="PingFang SC" pitchFamily="34" charset="-122"/>
-                <a:cs typeface="PingFang SC" pitchFamily="34" charset="-120"/>
-              </a:rPr>
-              <a:t>反事实</a:t>
-            </a:r>
-            <a:endParaRPr lang="en-US" sz="1700" dirty="0"/>
-          </a:p>
-        </p:txBody>
-      </p:sp>
-      <p:sp>
-        <p:nvSpPr>
-          <p:cNvPr id="19" name="Text 17"/>
-          <p:cNvSpPr/>
-          <p:nvPr/>
-        </p:nvSpPr>
-        <p:spPr>
-          <a:xfrm>
-            <a:off x="6858000" y="4206240"/>
-            <a:ext cx="4754880" cy="502920"/>
-          </a:xfrm>
-          <a:prstGeom prst="rect">
-            <a:avLst/>
-          </a:prstGeom>
-          <a:noFill/>
-          <a:ln/>
-        </p:spPr>
-        <p:txBody>
-          <a:bodyPr wrap="square" lIns="0" tIns="0" rIns="0" bIns="0" rtlCol="0" anchor="ctr"/>
-          <a:lstStyle/>
-          <a:p>
-            <a:pPr indent="0" marL="0">
-              <a:buNone/>
-            </a:pPr>
-            <a:r>
-              <a:rPr lang="en-US" sz="1400" dirty="0">
-                <a:solidFill>
-                  <a:srgbClr val="1D2A33"/>
-                </a:solidFill>
-                <a:latin typeface="PingFang SC" pitchFamily="34" charset="0"/>
-                <a:ea typeface="PingFang SC" pitchFamily="34" charset="-122"/>
-                <a:cs typeface="PingFang SC" pitchFamily="34" charset="-120"/>
-              </a:rPr>
-              <a:t>晚建站点与匹配的未建点,按资源潜力匹配</a:t>
-            </a:r>
-            <a:endParaRPr lang="en-US" sz="1400" dirty="0"/>
-          </a:p>
-        </p:txBody>
-      </p:sp>
-      <p:sp>
-        <p:nvSpPr>
-          <p:cNvPr id="20" name="Shape 18"/>
-          <p:cNvSpPr/>
-          <p:nvPr/>
-        </p:nvSpPr>
-        <p:spPr>
-          <a:xfrm>
-            <a:off x="6126480" y="4983480"/>
-            <a:ext cx="548640" cy="548640"/>
-          </a:xfrm>
-          <a:prstGeom prst="ellipse">
-            <a:avLst/>
-          </a:prstGeom>
-          <a:solidFill>
-            <a:srgbClr val="1F6F78"/>
-          </a:solidFill>
-          <a:ln w="12700">
-            <a:solidFill>
-              <a:srgbClr val="1F6F78"/>
-            </a:solidFill>
-            <a:prstDash val="solid"/>
-          </a:ln>
-        </p:spPr>
-      </p:sp>
-      <p:sp>
-        <p:nvSpPr>
-          <p:cNvPr id="21" name="Text 19"/>
-          <p:cNvSpPr/>
-          <p:nvPr/>
-        </p:nvSpPr>
-        <p:spPr>
-          <a:xfrm>
-            <a:off x="6126480" y="4983480"/>
-            <a:ext cx="548640" cy="548640"/>
-          </a:xfrm>
-          <a:prstGeom prst="rect">
-            <a:avLst/>
-          </a:prstGeom>
-          <a:noFill/>
-          <a:ln/>
-        </p:spPr>
-        <p:txBody>
-          <a:bodyPr wrap="square" lIns="0" tIns="0" rIns="0" bIns="0" rtlCol="0" anchor="ctr"/>
-          <a:lstStyle/>
-          <a:p>
-            <a:pPr algn="ctr" indent="0" marL="0">
-              <a:buNone/>
-            </a:pPr>
-            <a:r>
-              <a:rPr lang="en-US" sz="1400" b="1" dirty="0">
-                <a:solidFill>
-                  <a:srgbClr val="FFFFFF"/>
-                </a:solidFill>
-                <a:latin typeface="Arial" pitchFamily="34" charset="0"/>
-                <a:ea typeface="Arial" pitchFamily="34" charset="-122"/>
-                <a:cs typeface="Arial" pitchFamily="34" charset="-120"/>
-              </a:rPr>
-              <a:t>4</a:t>
-            </a:r>
-            <a:endParaRPr lang="en-US" sz="1400" dirty="0"/>
-          </a:p>
-        </p:txBody>
-      </p:sp>
-      <p:sp>
-        <p:nvSpPr>
-          <p:cNvPr id="22" name="Text 20"/>
-          <p:cNvSpPr/>
-          <p:nvPr/>
-        </p:nvSpPr>
-        <p:spPr>
-          <a:xfrm>
-            <a:off x="6858000" y="4846320"/>
-            <a:ext cx="4754880" cy="411480"/>
-          </a:xfrm>
-          <a:prstGeom prst="rect">
-            <a:avLst/>
-          </a:prstGeom>
-          <a:noFill/>
-          <a:ln/>
-        </p:spPr>
-        <p:txBody>
-          <a:bodyPr wrap="square" lIns="0" tIns="0" rIns="0" bIns="0" rtlCol="0" anchor="ctr"/>
-          <a:lstStyle/>
-          <a:p>
-            <a:pPr indent="0" marL="0">
-              <a:buNone/>
-            </a:pPr>
-            <a:r>
-              <a:rPr lang="en-US" sz="1700" b="1" dirty="0">
-                <a:solidFill>
-                  <a:srgbClr val="0E2F3C"/>
-                </a:solidFill>
-                <a:latin typeface="PingFang SC" pitchFamily="34" charset="0"/>
-                <a:ea typeface="PingFang SC" pitchFamily="34" charset="-122"/>
-                <a:cs typeface="PingFang SC" pitchFamily="34" charset="-120"/>
-              </a:rPr>
-              <a:t>检验对象</a:t>
-            </a:r>
-            <a:endParaRPr lang="en-US" sz="1700" dirty="0"/>
-          </a:p>
-        </p:txBody>
-      </p:sp>
-      <p:sp>
-        <p:nvSpPr>
-          <p:cNvPr id="23" name="Text 21"/>
-          <p:cNvSpPr/>
-          <p:nvPr/>
-        </p:nvSpPr>
-        <p:spPr>
-          <a:xfrm>
-            <a:off x="6858000" y="5257800"/>
-            <a:ext cx="4754880" cy="502920"/>
-          </a:xfrm>
-          <a:prstGeom prst="rect">
-            <a:avLst/>
-          </a:prstGeom>
-          <a:noFill/>
-          <a:ln/>
-        </p:spPr>
-        <p:txBody>
-          <a:bodyPr wrap="square" lIns="0" tIns="0" rIns="0" bIns="0" rtlCol="0" anchor="ctr"/>
-          <a:lstStyle/>
-          <a:p>
-            <a:pPr indent="0" marL="0">
-              <a:buNone/>
-            </a:pPr>
-            <a:r>
-              <a:rPr lang="en-US" sz="1400" dirty="0">
-                <a:solidFill>
-                  <a:srgbClr val="1D2A33"/>
-                </a:solidFill>
-                <a:latin typeface="PingFang SC" pitchFamily="34" charset="0"/>
-                <a:ea typeface="PingFang SC" pitchFamily="34" charset="-122"/>
-                <a:cs typeface="PingFang SC" pitchFamily="34" charset="-120"/>
-              </a:rPr>
-              <a:t>NEE 论文"全国集中"与"省级分散"两种情景的预测</a:t>
-            </a:r>
-            <a:endParaRPr lang="en-US" sz="1400" dirty="0"/>
-          </a:p>
-        </p:txBody>
-      </p:sp>
-      <p:sp>
-        <p:nvSpPr>
-          <p:cNvPr id="24" name="Text 22"/>
-          <p:cNvSpPr/>
-          <p:nvPr/>
-        </p:nvSpPr>
-        <p:spPr>
-          <a:xfrm>
-            <a:off x="11277295" y="6400800"/>
-            <a:ext cx="457200" cy="274320"/>
-          </a:xfrm>
-          <a:prstGeom prst="rect">
-            <a:avLst/>
-          </a:prstGeom>
-          <a:noFill/>
-          <a:ln/>
-        </p:spPr>
-        <p:txBody>
-          <a:bodyPr wrap="square" lIns="0" tIns="0" rIns="0" bIns="0" rtlCol="0" anchor="ctr"/>
-          <a:lstStyle/>
-          <a:p>
-            <a:pPr algn="r" indent="0" marL="0">
-              <a:buNone/>
-            </a:pPr>
-            <a:r>
-              <a:rPr lang="en-US" sz="1000" dirty="0">
-                <a:solidFill>
-                  <a:srgbClr val="5E6B75"/>
-                </a:solidFill>
-                <a:latin typeface="Arial" pitchFamily="34" charset="0"/>
-                <a:ea typeface="Arial" pitchFamily="34" charset="-122"/>
-                <a:cs typeface="Arial" pitchFamily="34" charset="-120"/>
-              </a:rPr>
-              <a:t>2</a:t>
+              <a:t>22</a:t>
             </a:r>
             <a:endParaRPr lang="en-US" sz="1000" dirty="0"/>
           </a:p>
@@ -15232,434 +17651,9 @@
 </p:sld>
 </file>
 
-<file path=ppt/slides/slide20.xml><?xml version="1.0" encoding="utf-8"?>
+<file path=ppt/slides/slide23.xml><?xml version="1.0" encoding="utf-8"?>
 <p:sld xmlns:a="http://schemas.openxmlformats.org/drawingml/2006/main" xmlns:r="http://schemas.openxmlformats.org/officeDocument/2006/relationships" xmlns:p="http://schemas.openxmlformats.org/presentationml/2006/main">
-  <p:cSld name="Slide 20">
-    <p:spTree>
-      <p:nvGrpSpPr>
-        <p:cNvPr id="1" name=""/>
-        <p:cNvGrpSpPr/>
-        <p:nvPr/>
-      </p:nvGrpSpPr>
-      <p:grpSpPr>
-        <a:xfrm>
-          <a:off x="0" y="0"/>
-          <a:ext cx="0" cy="0"/>
-          <a:chOff x="0" y="0"/>
-          <a:chExt cx="0" cy="0"/>
-        </a:xfrm>
-      </p:grpSpPr>
-      <p:sp>
-        <p:nvSpPr>
-          <p:cNvPr id="2" name="Text 0"/>
-          <p:cNvSpPr/>
-          <p:nvPr/>
-        </p:nvSpPr>
-        <p:spPr>
-          <a:xfrm>
-            <a:off x="548640" y="320040"/>
-            <a:ext cx="11094415" cy="685800"/>
-          </a:xfrm>
-          <a:prstGeom prst="rect">
-            <a:avLst/>
-          </a:prstGeom>
-          <a:noFill/>
-          <a:ln/>
-        </p:spPr>
-        <p:txBody>
-          <a:bodyPr wrap="square" lIns="0" tIns="0" rIns="0" bIns="0" rtlCol="0" anchor="ctr"/>
-          <a:lstStyle/>
-          <a:p>
-            <a:pPr indent="0" marL="0">
-              <a:buNone/>
-            </a:pPr>
-            <a:r>
-              <a:rPr lang="en-US" sz="3000" b="1" dirty="0">
-                <a:solidFill>
-                  <a:srgbClr val="0E2F3C"/>
-                </a:solidFill>
-                <a:latin typeface="PingFang SC" pitchFamily="34" charset="0"/>
-                <a:ea typeface="PingFang SC" pitchFamily="34" charset="-122"/>
-                <a:cs typeface="PingFang SC" pitchFamily="34" charset="-120"/>
-              </a:rPr>
-              <a:t>相关文献</a:t>
-            </a:r>
-            <a:endParaRPr lang="en-US" sz="3000" dirty="0"/>
-          </a:p>
-        </p:txBody>
-      </p:sp>
-      <p:sp>
-        <p:nvSpPr>
-          <p:cNvPr id="3" name="Text 1"/>
-          <p:cNvSpPr/>
-          <p:nvPr/>
-        </p:nvSpPr>
-        <p:spPr>
-          <a:xfrm>
-            <a:off x="548640" y="1143000"/>
-            <a:ext cx="11094415" cy="5212080"/>
-          </a:xfrm>
-          <a:prstGeom prst="rect">
-            <a:avLst/>
-          </a:prstGeom>
-          <a:noFill/>
-          <a:ln/>
-        </p:spPr>
-        <p:txBody>
-          <a:bodyPr wrap="square" lIns="0" tIns="0" rIns="0" bIns="0" rtlCol="0" anchor="t"/>
-          <a:lstStyle/>
-          <a:p>
-            <a:pPr indent="0" marL="0">
-              <a:spcAft>
-                <a:spcPts val="400"/>
-              </a:spcAft>
-              <a:buNone/>
-            </a:pPr>
-            <a:r>
-              <a:rPr lang="en-US" sz="1100" dirty="0">
-                <a:solidFill>
-                  <a:srgbClr val="1D2A33"/>
-                </a:solidFill>
-                <a:latin typeface="PingFang SC" pitchFamily="34" charset="0"/>
-                <a:ea typeface="PingFang SC" pitchFamily="34" charset="-122"/>
-                <a:cs typeface="PingFang SC" pitchFamily="34" charset="-120"/>
-              </a:rPr>
-              <a:t>[1] Zhou Z., Sun S., Zhang J., Fang Y., Li B.V. (2026) Comparing potential biodiversity conflicts from renewable energy expansion in China at different centralization levels. Nat. Ecol. Evol. 10:1316–1328.</a:t>
-            </a:r>
-            <a:endParaRPr lang="en-US" sz="1100" dirty="0"/>
-          </a:p>
-          <a:p>
-            <a:pPr indent="0" marL="0">
-              <a:spcAft>
-                <a:spcPts val="400"/>
-              </a:spcAft>
-              <a:buNone/>
-            </a:pPr>
-            <a:r>
-              <a:rPr lang="en-US" sz="1100" dirty="0">
-                <a:solidFill>
-                  <a:srgbClr val="1D2A33"/>
-                </a:solidFill>
-                <a:latin typeface="PingFang SC" pitchFamily="34" charset="0"/>
-                <a:ea typeface="PingFang SC" pitchFamily="34" charset="-122"/>
-                <a:cs typeface="PingFang SC" pitchFamily="34" charset="-120"/>
-              </a:rPr>
-              <a:t>[2] Zhang H. et al. (2026) China's solar expansion policy reduces bird diversity. Science 393:831–836.</a:t>
-            </a:r>
-            <a:endParaRPr lang="en-US" sz="1100" dirty="0"/>
-          </a:p>
-          <a:p>
-            <a:pPr indent="0" marL="0">
-              <a:spcAft>
-                <a:spcPts val="400"/>
-              </a:spcAft>
-              <a:buNone/>
-            </a:pPr>
-            <a:r>
-              <a:rPr lang="en-US" sz="1100" dirty="0">
-                <a:solidFill>
-                  <a:srgbClr val="1D2A33"/>
-                </a:solidFill>
-                <a:latin typeface="PingFang SC" pitchFamily="34" charset="0"/>
-                <a:ea typeface="PingFang SC" pitchFamily="34" charset="-122"/>
-                <a:cs typeface="PingFang SC" pitchFamily="34" charset="-120"/>
-              </a:rPr>
-              <a:t>[3] Robinson C. et al. (2025) Global Renewables Watch: a temporal dataset of solar and wind energy derived from satellite imagery. arXiv:2503.14860.</a:t>
-            </a:r>
-            <a:endParaRPr lang="en-US" sz="1100" dirty="0"/>
-          </a:p>
-          <a:p>
-            <a:pPr indent="0" marL="0">
-              <a:spcAft>
-                <a:spcPts val="400"/>
-              </a:spcAft>
-              <a:buNone/>
-            </a:pPr>
-            <a:r>
-              <a:rPr lang="en-US" sz="1100" dirty="0">
-                <a:solidFill>
-                  <a:srgbClr val="1D2A33"/>
-                </a:solidFill>
-                <a:latin typeface="PingFang SC" pitchFamily="34" charset="0"/>
-                <a:ea typeface="PingFang SC" pitchFamily="34" charset="-122"/>
-                <a:cs typeface="PingFang SC" pitchFamily="34" charset="-120"/>
-              </a:rPr>
-              <a:t>[4] Vectorized solar photovoltaic installation dataset across China in 2015 and 2020. Scientific Data (s41597-024-04356-z).</a:t>
-            </a:r>
-            <a:endParaRPr lang="en-US" sz="1100" dirty="0"/>
-          </a:p>
-          <a:p>
-            <a:pPr indent="0" marL="0">
-              <a:spcAft>
-                <a:spcPts val="400"/>
-              </a:spcAft>
-              <a:buNone/>
-            </a:pPr>
-            <a:r>
-              <a:rPr lang="en-US" sz="1100" dirty="0">
-                <a:solidFill>
-                  <a:srgbClr val="1D2A33"/>
-                </a:solidFill>
-                <a:latin typeface="PingFang SC" pitchFamily="34" charset="0"/>
-                <a:ea typeface="PingFang SC" pitchFamily="34" charset="-122"/>
-                <a:cs typeface="PingFang SC" pitchFamily="34" charset="-120"/>
-              </a:rPr>
-              <a:t>[5] A 10-m national-scale map of ground-mounted photovoltaic power stations in China of 2020. Scientific Data (2024).</a:t>
-            </a:r>
-            <a:endParaRPr lang="en-US" sz="1100" dirty="0"/>
-          </a:p>
-          <a:p>
-            <a:pPr indent="0" marL="0">
-              <a:spcAft>
-                <a:spcPts val="400"/>
-              </a:spcAft>
-              <a:buNone/>
-            </a:pPr>
-            <a:r>
-              <a:rPr lang="en-US" sz="1100" dirty="0">
-                <a:solidFill>
-                  <a:srgbClr val="1D2A33"/>
-                </a:solidFill>
-                <a:latin typeface="PingFang SC" pitchFamily="34" charset="0"/>
-                <a:ea typeface="PingFang SC" pitchFamily="34" charset="-122"/>
-                <a:cs typeface="PingFang SC" pitchFamily="34" charset="-120"/>
-              </a:rPr>
-              <a:t>[6] Satellites reveal spatial heterogeneity in dryland photovoltaic plants' effects on vegetation dynamics. Earth's Future (2024).</a:t>
-            </a:r>
-            <a:endParaRPr lang="en-US" sz="1100" dirty="0"/>
-          </a:p>
-          <a:p>
-            <a:pPr indent="0" marL="0">
-              <a:spcAft>
-                <a:spcPts val="400"/>
-              </a:spcAft>
-              <a:buNone/>
-            </a:pPr>
-            <a:r>
-              <a:rPr lang="en-US" sz="1100" dirty="0">
-                <a:solidFill>
-                  <a:srgbClr val="1D2A33"/>
-                </a:solidFill>
-                <a:latin typeface="PingFang SC" pitchFamily="34" charset="0"/>
-                <a:ea typeface="PingFang SC" pitchFamily="34" charset="-122"/>
-                <a:cs typeface="PingFang SC" pitchFamily="34" charset="-120"/>
-              </a:rPr>
-              <a:t>[7] Diverse vegetation responses to solar farm installation are also driven by climate change. Commun. Earth Environ. (2025).</a:t>
-            </a:r>
-            <a:endParaRPr lang="en-US" sz="1100" dirty="0"/>
-          </a:p>
-          <a:p>
-            <a:pPr indent="0" marL="0">
-              <a:spcAft>
-                <a:spcPts val="400"/>
-              </a:spcAft>
-              <a:buNone/>
-            </a:pPr>
-            <a:r>
-              <a:rPr lang="en-US" sz="1100" dirty="0">
-                <a:solidFill>
-                  <a:srgbClr val="1D2A33"/>
-                </a:solidFill>
-                <a:latin typeface="PingFang SC" pitchFamily="34" charset="0"/>
-                <a:ea typeface="PingFang SC" pitchFamily="34" charset="-122"/>
-                <a:cs typeface="PingFang SC" pitchFamily="34" charset="-120"/>
-              </a:rPr>
-              <a:t>[8] Large-scale photovoltaic farms significantly change the vegetation diversity and biomass through influencing soil moisture. Vadose Zone J. (2025).</a:t>
-            </a:r>
-            <a:endParaRPr lang="en-US" sz="1100" dirty="0"/>
-          </a:p>
-          <a:p>
-            <a:pPr indent="0" marL="0">
-              <a:spcAft>
-                <a:spcPts val="400"/>
-              </a:spcAft>
-              <a:buNone/>
-            </a:pPr>
-            <a:r>
-              <a:rPr lang="en-US" sz="1100" dirty="0">
-                <a:solidFill>
-                  <a:srgbClr val="1D2A33"/>
-                </a:solidFill>
-                <a:latin typeface="PingFang SC" pitchFamily="34" charset="0"/>
-                <a:ea typeface="PingFang SC" pitchFamily="34" charset="-122"/>
-                <a:cs typeface="PingFang SC" pitchFamily="34" charset="-120"/>
-              </a:rPr>
-              <a:t>[9] Wind farms increase land surface temperature and reduce vegetation productivity in the Inner Mongolia. Geography and Sustainability (2024).</a:t>
-            </a:r>
-            <a:endParaRPr lang="en-US" sz="1100" dirty="0"/>
-          </a:p>
-          <a:p>
-            <a:pPr indent="0" marL="0">
-              <a:spcAft>
-                <a:spcPts val="400"/>
-              </a:spcAft>
-              <a:buNone/>
-            </a:pPr>
-            <a:r>
-              <a:rPr lang="en-US" sz="1100" dirty="0">
-                <a:solidFill>
-                  <a:srgbClr val="1D2A33"/>
-                </a:solidFill>
-                <a:latin typeface="PingFang SC" pitchFamily="34" charset="0"/>
-                <a:ea typeface="PingFang SC" pitchFamily="34" charset="-122"/>
-                <a:cs typeface="PingFang SC" pitchFamily="34" charset="-120"/>
-              </a:rPr>
-              <a:t>[10] Callaway B., Sant'Anna P.H.C. (2021) J. Econometrics 225:200–230;Sun L., Abraham S. (2021) J. Econometrics 225:175–199;Rambachan A., Roth J. (2023) Rev. Econ. Stud. 90:2555–2591.</a:t>
-            </a:r>
-            <a:endParaRPr lang="en-US" sz="1100" dirty="0"/>
-          </a:p>
-          <a:p>
-            <a:pPr indent="0" marL="0">
-              <a:spcAft>
-                <a:spcPts val="400"/>
-              </a:spcAft>
-              <a:buNone/>
-            </a:pPr>
-            <a:r>
-              <a:rPr lang="en-US" sz="1100" dirty="0">
-                <a:solidFill>
-                  <a:srgbClr val="1D2A33"/>
-                </a:solidFill>
-                <a:latin typeface="PingFang SC" pitchFamily="34" charset="0"/>
-                <a:ea typeface="PingFang SC" pitchFamily="34" charset="-122"/>
-                <a:cs typeface="PingFang SC" pitchFamily="34" charset="-120"/>
-              </a:rPr>
-              <a:t>[11] Brooks T.M. et al. (2019) Measuring terrestrial Area of Habitat (AOH) and its utility for the IUCN Red List. Trends Ecol. Evol. 34:977–986.</a:t>
-            </a:r>
-            <a:endParaRPr lang="en-US" sz="1100" dirty="0"/>
-          </a:p>
-          <a:p>
-            <a:pPr indent="0" marL="0">
-              <a:spcAft>
-                <a:spcPts val="400"/>
-              </a:spcAft>
-              <a:buNone/>
-            </a:pPr>
-            <a:r>
-              <a:rPr lang="en-US" sz="1100" dirty="0">
-                <a:solidFill>
-                  <a:srgbClr val="1D2A33"/>
-                </a:solidFill>
-                <a:latin typeface="PingFang SC" pitchFamily="34" charset="0"/>
-                <a:ea typeface="PingFang SC" pitchFamily="34" charset="-122"/>
-                <a:cs typeface="PingFang SC" pitchFamily="34" charset="-120"/>
-              </a:rPr>
-              <a:t>[12] Li X., He Z., Xia S., Yang Y. (2024) Greenness change associated with construction and operation of photovoltaic solar energy in China. Renewable Energy 226:120461.</a:t>
-            </a:r>
-            <a:endParaRPr lang="en-US" sz="1100" dirty="0"/>
-          </a:p>
-          <a:p>
-            <a:pPr indent="0" marL="0">
-              <a:spcAft>
-                <a:spcPts val="400"/>
-              </a:spcAft>
-              <a:buNone/>
-            </a:pPr>
-            <a:r>
-              <a:rPr lang="en-US" sz="1100" dirty="0">
-                <a:solidFill>
-                  <a:srgbClr val="1D2A33"/>
-                </a:solidFill>
-                <a:latin typeface="PingFang SC" pitchFamily="34" charset="0"/>
-                <a:ea typeface="PingFang SC" pitchFamily="34" charset="-122"/>
-                <a:cs typeface="PingFang SC" pitchFamily="34" charset="-120"/>
-              </a:rPr>
-              <a:t>[13] Li Y., Wang Z., Lei Y., Yu X., Che H., Zhang X. (2026) Ecological effects of photovoltaic deployment in China: a remote sensing assessment. Environ. Res. Commun. 8:041016.</a:t>
-            </a:r>
-            <a:endParaRPr lang="en-US" sz="1100" dirty="0"/>
-          </a:p>
-          <a:p>
-            <a:pPr indent="0" marL="0">
-              <a:spcAft>
-                <a:spcPts val="400"/>
-              </a:spcAft>
-              <a:buNone/>
-            </a:pPr>
-            <a:r>
-              <a:rPr lang="en-US" sz="1100" dirty="0">
-                <a:solidFill>
-                  <a:srgbClr val="1D2A33"/>
-                </a:solidFill>
-                <a:latin typeface="PingFang SC" pitchFamily="34" charset="0"/>
-                <a:ea typeface="PingFang SC" pitchFamily="34" charset="-122"/>
-                <a:cs typeface="PingFang SC" pitchFamily="34" charset="-120"/>
-              </a:rPr>
-              <a:t>[14] 彭昀月, 罗永梅, 徐泽楠, 靳彤 (2024) 集中式大型光伏及风电电场生态影响:进展与展望. 生物多样性 32(2):23212.</a:t>
-            </a:r>
-            <a:endParaRPr lang="en-US" sz="1100" dirty="0"/>
-          </a:p>
-          <a:p>
-            <a:pPr indent="0" marL="0">
-              <a:spcAft>
-                <a:spcPts val="400"/>
-              </a:spcAft>
-              <a:buNone/>
-            </a:pPr>
-            <a:r>
-              <a:rPr lang="en-US" sz="1100" dirty="0">
-                <a:solidFill>
-                  <a:srgbClr val="1D2A33"/>
-                </a:solidFill>
-                <a:latin typeface="PingFang SC" pitchFamily="34" charset="0"/>
-                <a:ea typeface="PingFang SC" pitchFamily="34" charset="-122"/>
-                <a:cs typeface="PingFang SC" pitchFamily="34" charset="-120"/>
-              </a:rPr>
-              <a:t>[15] 《中国可再生能源与生物多样性协同发展的机遇与挑战》(征求意见稿),发布机构与日期待核实。</a:t>
-            </a:r>
-            <a:endParaRPr lang="en-US" sz="1100" dirty="0"/>
-          </a:p>
-        </p:txBody>
-      </p:sp>
-      <p:sp>
-        <p:nvSpPr>
-          <p:cNvPr id="4" name="Text 2"/>
-          <p:cNvSpPr/>
-          <p:nvPr/>
-        </p:nvSpPr>
-        <p:spPr>
-          <a:xfrm>
-            <a:off x="11277295" y="6400800"/>
-            <a:ext cx="457200" cy="274320"/>
-          </a:xfrm>
-          <a:prstGeom prst="rect">
-            <a:avLst/>
-          </a:prstGeom>
-          <a:noFill/>
-          <a:ln/>
-        </p:spPr>
-        <p:txBody>
-          <a:bodyPr wrap="square" lIns="0" tIns="0" rIns="0" bIns="0" rtlCol="0" anchor="ctr"/>
-          <a:lstStyle/>
-          <a:p>
-            <a:pPr algn="r" indent="0" marL="0">
-              <a:buNone/>
-            </a:pPr>
-            <a:r>
-              <a:rPr lang="en-US" sz="1000" dirty="0">
-                <a:solidFill>
-                  <a:srgbClr val="5E6B75"/>
-                </a:solidFill>
-                <a:latin typeface="Arial" pitchFamily="34" charset="0"/>
-                <a:ea typeface="Arial" pitchFamily="34" charset="-122"/>
-                <a:cs typeface="Arial" pitchFamily="34" charset="-120"/>
-              </a:rPr>
-              <a:t>20</a:t>
-            </a:r>
-            <a:endParaRPr lang="en-US" sz="1000" dirty="0"/>
-          </a:p>
-        </p:txBody>
-      </p:sp>
-    </p:spTree>
-  </p:cSld>
-  <p:clrMapOvr>
-    <a:masterClrMapping/>
-  </p:clrMapOvr>
-</p:sld>
-</file>
-
-<file path=ppt/slides/slide21.xml><?xml version="1.0" encoding="utf-8"?>
-<p:sld xmlns:a="http://schemas.openxmlformats.org/drawingml/2006/main" xmlns:r="http://schemas.openxmlformats.org/officeDocument/2006/relationships" xmlns:p="http://schemas.openxmlformats.org/presentationml/2006/main">
-  <p:cSld name="Slide 21">
+  <p:cSld name="Slide 23">
     <p:bg>
       <p:bgPr>
         <a:solidFill>
@@ -15817,7 +17811,7 @@
                 <a:ea typeface="PingFang SC" pitchFamily="34" charset="-122"/>
                 <a:cs typeface="PingFang SC" pitchFamily="34" charset="-120"/>
               </a:rPr>
-              <a:t>重做对照:按建设前 NDVI 轨迹匹配从未建设点,前期延至 2010</a:t>
+              <a:t>站内结局改用哨兵-2 10 m 板间像元,分离面板机械效应</a:t>
             </a:r>
             <a:endParaRPr lang="en-US" sz="1800" dirty="0"/>
           </a:p>
@@ -15920,7 +17914,7 @@
                 <a:ea typeface="PingFang SC" pitchFamily="34" charset="-122"/>
                 <a:cs typeface="PingFang SC" pitchFamily="34" charset="-120"/>
               </a:rPr>
-              <a:t>森林风机定标扩大样本(含两产品都判非林的一层)</a:t>
+              <a:t>鸟类:24 站留一检验与更长时窗;大型基地布设结构化监测</a:t>
             </a:r>
             <a:endParaRPr lang="en-US" sz="1800" dirty="0"/>
           </a:p>

</xml_diff>

<commit_message>
Abundance-based bird diversity with cleaning and effort correction
- analysis/site_birds_abundance.R: same near/far design; tier 1 naive
  Shannon (as in Zhang et al.), tier 2 cleaned surveys (multi-observer
  merge, presence-only removal, 99% caps, single-species kept) with effort
  controls, tier 3 coverage-standardised Hill numbers (iNEXT)
- All tiers null in 38 and 24 sites; total individuals -14% (n.s.)
- Page, deck (24 slides) and README updated
</commit_message>
<xml_diff>
--- a/RS_Renewables_Biodiversity_Workflow.pptx
+++ b/RS_Renewables_Biodiversity_Workflow.pptx
@@ -28,9 +28,10 @@
     <p:sldId id="276" r:id="rId22"/>
     <p:sldId id="277" r:id="rId23"/>
     <p:sldId id="278" r:id="rId24"/>
+    <p:sldId id="279" r:id="rId25"/>
   </p:sldIdLst>
   <p:notesMasterIdLst>
-    <p:notesMasterId r:id="rId25"/>
+    <p:notesMasterId r:id="rId26"/>
   </p:notesMasterIdLst>
   <p:sldSz cx="12192000" cy="6858000"/>
   <p:notesSz cx="6858000" cy="12192000"/>
@@ -3042,6 +3043,94 @@
 </p:notes>
 </file>
 
+<file path=ppt/notesSlides/notesSlide24.xml><?xml version="1.0" encoding="utf-8"?>
+<p:notes xmlns:a="http://schemas.openxmlformats.org/drawingml/2006/main" xmlns:r="http://schemas.openxmlformats.org/officeDocument/2006/relationships" xmlns:p="http://schemas.openxmlformats.org/presentationml/2006/main">
+  <p:cSld>
+    <p:spTree>
+      <p:nvGrpSpPr>
+        <p:cNvPr id="1" name=""/>
+        <p:cNvGrpSpPr/>
+        <p:nvPr/>
+      </p:nvGrpSpPr>
+      <p:grpSpPr>
+        <a:xfrm>
+          <a:off x="0" y="0"/>
+          <a:ext cx="0" cy="0"/>
+          <a:chOff x="0" y="0"/>
+          <a:chExt cx="0" cy="0"/>
+        </a:xfrm>
+      </p:grpSpPr>
+      <p:sp>
+        <p:nvSpPr>
+          <p:cNvPr id="2" name="Slide Image Placeholder 1"/>
+          <p:cNvSpPr>
+            <a:spLocks noGrp="1" noRot="1" noChangeAspect="1"/>
+          </p:cNvSpPr>
+          <p:nvPr>
+            <p:ph type="sldImg"/>
+          </p:nvPr>
+        </p:nvSpPr>
+        <p:spPr/>
+      </p:sp>
+      <p:sp>
+        <p:nvSpPr>
+          <p:cNvPr id="3" name="Notes Placeholder 2"/>
+          <p:cNvSpPr>
+            <a:spLocks noGrp="1"/>
+          </p:cNvSpPr>
+          <p:nvPr>
+            <p:ph type="body" idx="1"/>
+          </p:nvPr>
+        </p:nvSpPr>
+        <p:spPr/>
+        <p:txBody>
+          <a:bodyPr/>
+          <a:lstStyle/>
+          <a:p>
+            <a:r>
+              <a:rPr lang="en-US" dirty="0"/>
+              <a:t/>
+            </a:r>
+            <a:endParaRPr lang="en-US" dirty="0"/>
+          </a:p>
+        </p:txBody>
+      </p:sp>
+      <p:sp>
+        <p:nvSpPr>
+          <p:cNvPr id="4" name="Slide Number Placeholder 3"/>
+          <p:cNvSpPr>
+            <a:spLocks noGrp="1"/>
+          </p:cNvSpPr>
+          <p:nvPr>
+            <p:ph type="sldNum" sz="quarter" idx="10"/>
+          </p:nvPr>
+        </p:nvSpPr>
+        <p:spPr/>
+        <p:txBody>
+          <a:bodyPr/>
+          <a:lstStyle/>
+          <a:p>
+            <a:fld id="{F7021451-1387-4CA6-816F-3879F97B5CBC}" type="slidenum">
+              <a:rPr lang="en-US"/>
+              <a:t>24</a:t>
+            </a:fld>
+            <a:endParaRPr lang="en-US"/>
+          </a:p>
+        </p:txBody>
+      </p:sp>
+    </p:spTree>
+    <p:extLst>
+      <p:ext uri="{BB962C8B-B14F-4D97-AF65-F5344CB8AC3E}">
+        <p14:creationId xmlns:p14="http://schemas.microsoft.com/office/powerpoint/2010/main" val="1024086991"/>
+      </p:ext>
+    </p:extLst>
+  </p:cSld>
+  <p:clrMapOvr>
+    <a:masterClrMapping/>
+  </p:clrMapOvr>
+</p:notes>
+</file>
+
 <file path=ppt/notesSlides/notesSlide3.xml><?xml version="1.0" encoding="utf-8"?>
 <p:notes xmlns:a="http://schemas.openxmlformats.org/drawingml/2006/main" xmlns:r="http://schemas.openxmlformats.org/officeDocument/2006/relationships" xmlns:p="http://schemas.openxmlformats.org/presentationml/2006/main">
   <p:cSld>
@@ -16081,6 +16170,526 @@
                 <a:ea typeface="PingFang SC" pitchFamily="34" charset="-122"/>
                 <a:cs typeface="PingFang SC" pitchFamily="34" charset="-120"/>
               </a:rPr>
+              <a:t>鸟类丰度型多样性:Science 指标 + 评论文章的清洗与努力校正</a:t>
+            </a:r>
+            <a:endParaRPr lang="en-US" sz="3000" dirty="0"/>
+          </a:p>
+        </p:txBody>
+      </p:sp>
+      <p:sp>
+        <p:nvSpPr>
+          <p:cNvPr id="3" name="Text 1"/>
+          <p:cNvSpPr/>
+          <p:nvPr/>
+        </p:nvSpPr>
+        <p:spPr>
+          <a:xfrm>
+            <a:off x="548640" y="960120"/>
+            <a:ext cx="11094415" cy="365760"/>
+          </a:xfrm>
+          <a:prstGeom prst="rect">
+            <a:avLst/>
+          </a:prstGeom>
+          <a:noFill/>
+          <a:ln/>
+        </p:spPr>
+        <p:txBody>
+          <a:bodyPr wrap="square" lIns="0" tIns="0" rIns="0" bIns="0" rtlCol="0" anchor="ctr"/>
+          <a:lstStyle/>
+          <a:p>
+            <a:pPr indent="0" marL="0">
+              <a:buNone/>
+            </a:pPr>
+            <a:r>
+              <a:rPr lang="en-US" sz="1400" dirty="0">
+                <a:solidFill>
+                  <a:srgbClr val="5E6B75"/>
+                </a:solidFill>
+                <a:latin typeface="PingFang SC" pitchFamily="34" charset="0"/>
+                <a:ea typeface="PingFang SC" pitchFamily="34" charset="-122"/>
+                <a:cs typeface="PingFang SC" pitchFamily="34" charset="-120"/>
+              </a:rPr>
+              <a:t>同一近远区设计;38 站 33,327 份清单 → 合并重复 26,972 → 剔除仅记有无 5,767 → 21,205 次调查</a:t>
+            </a:r>
+            <a:endParaRPr lang="en-US" sz="1400" dirty="0"/>
+          </a:p>
+        </p:txBody>
+      </p:sp>
+      <p:pic>
+        <p:nvPicPr>
+          <p:cNvPr id="4" name="Image 0" descr="results/figures/site_birds_abundance.png">    </p:cNvPr>
+          <p:cNvPicPr>
+            <a:picLocks noChangeAspect="1"/>
+          </p:cNvPicPr>
+          <p:nvPr/>
+        </p:nvPicPr>
+        <p:blipFill>
+          <a:blip r:embed="rId1"/>
+          <a:stretch>
+            <a:fillRect/>
+          </a:stretch>
+        </p:blipFill>
+        <p:spPr>
+          <a:xfrm>
+            <a:off x="457200" y="1417320"/>
+            <a:ext cx="7315200" cy="3511296"/>
+          </a:xfrm>
+          <a:prstGeom prst="rect">
+            <a:avLst/>
+          </a:prstGeom>
+        </p:spPr>
+      </p:pic>
+      <p:sp>
+        <p:nvSpPr>
+          <p:cNvPr id="5" name="Shape 2"/>
+          <p:cNvSpPr/>
+          <p:nvPr/>
+        </p:nvSpPr>
+        <p:spPr>
+          <a:xfrm>
+            <a:off x="8046720" y="1463040"/>
+            <a:ext cx="3611880" cy="1207008"/>
+          </a:xfrm>
+          <a:prstGeom prst="roundRect">
+            <a:avLst>
+              <a:gd name="adj" fmla="val 4545"/>
+            </a:avLst>
+          </a:prstGeom>
+          <a:solidFill>
+            <a:srgbClr val="EEF4F4"/>
+          </a:solidFill>
+          <a:ln w="12700">
+            <a:solidFill>
+              <a:srgbClr val="EEF4F4"/>
+            </a:solidFill>
+            <a:prstDash val="solid"/>
+          </a:ln>
+        </p:spPr>
+      </p:sp>
+      <p:sp>
+        <p:nvSpPr>
+          <p:cNvPr id="6" name="Text 3"/>
+          <p:cNvSpPr/>
+          <p:nvPr/>
+        </p:nvSpPr>
+        <p:spPr>
+          <a:xfrm>
+            <a:off x="8229600" y="1554480"/>
+            <a:ext cx="3291840" cy="365760"/>
+          </a:xfrm>
+          <a:prstGeom prst="rect">
+            <a:avLst/>
+          </a:prstGeom>
+          <a:noFill/>
+          <a:ln/>
+        </p:spPr>
+        <p:txBody>
+          <a:bodyPr wrap="square" lIns="0" tIns="0" rIns="0" bIns="0" rtlCol="0" anchor="ctr"/>
+          <a:lstStyle/>
+          <a:p>
+            <a:pPr indent="0" marL="0">
+              <a:buNone/>
+            </a:pPr>
+            <a:r>
+              <a:rPr lang="en-US" sz="1400" b="1" dirty="0">
+                <a:solidFill>
+                  <a:srgbClr val="0E2F3C"/>
+                </a:solidFill>
+                <a:latin typeface="PingFang SC" pitchFamily="34" charset="0"/>
+                <a:ea typeface="PingFang SC" pitchFamily="34" charset="-122"/>
+                <a:cs typeface="PingFang SC" pitchFamily="34" charset="-120"/>
+              </a:rPr>
+              <a:t>全部与零无差异</a:t>
+            </a:r>
+            <a:endParaRPr lang="en-US" sz="1400" dirty="0"/>
+          </a:p>
+        </p:txBody>
+      </p:sp>
+      <p:sp>
+        <p:nvSpPr>
+          <p:cNvPr id="7" name="Text 4"/>
+          <p:cNvSpPr/>
+          <p:nvPr/>
+        </p:nvSpPr>
+        <p:spPr>
+          <a:xfrm>
+            <a:off x="8229600" y="1920240"/>
+            <a:ext cx="3291840" cy="713232"/>
+          </a:xfrm>
+          <a:prstGeom prst="rect">
+            <a:avLst/>
+          </a:prstGeom>
+          <a:noFill/>
+          <a:ln/>
+        </p:spPr>
+        <p:txBody>
+          <a:bodyPr wrap="square" lIns="0" tIns="0" rIns="0" bIns="0" rtlCol="0" anchor="ctr"/>
+          <a:lstStyle/>
+          <a:p>
+            <a:pPr indent="0" marL="0">
+              <a:buNone/>
+            </a:pPr>
+            <a:r>
+              <a:rPr lang="en-US" sz="1100" dirty="0">
+                <a:solidFill>
+                  <a:srgbClr val="1D2A33"/>
+                </a:solidFill>
+                <a:latin typeface="PingFang SC" pitchFamily="34" charset="0"/>
+                <a:ea typeface="PingFang SC" pitchFamily="34" charset="-122"/>
+                <a:cs typeface="PingFang SC" pitchFamily="34" charset="-120"/>
+              </a:rPr>
+              <a:t>朴素 Shannon、清洗后 q = 1/2、观察者 FE、覆盖度标准化 q = 0/1/2;24 站结果一致</a:t>
+            </a:r>
+            <a:endParaRPr lang="en-US" sz="1100" dirty="0"/>
+          </a:p>
+        </p:txBody>
+      </p:sp>
+      <p:sp>
+        <p:nvSpPr>
+          <p:cNvPr id="8" name="Shape 5"/>
+          <p:cNvSpPr/>
+          <p:nvPr/>
+        </p:nvSpPr>
+        <p:spPr>
+          <a:xfrm>
+            <a:off x="8046720" y="2834640"/>
+            <a:ext cx="3611880" cy="1207008"/>
+          </a:xfrm>
+          <a:prstGeom prst="roundRect">
+            <a:avLst>
+              <a:gd name="adj" fmla="val 4545"/>
+            </a:avLst>
+          </a:prstGeom>
+          <a:solidFill>
+            <a:srgbClr val="FBF1DF"/>
+          </a:solidFill>
+          <a:ln w="12700">
+            <a:solidFill>
+              <a:srgbClr val="FBF1DF"/>
+            </a:solidFill>
+            <a:prstDash val="solid"/>
+          </a:ln>
+        </p:spPr>
+      </p:sp>
+      <p:sp>
+        <p:nvSpPr>
+          <p:cNvPr id="9" name="Text 6"/>
+          <p:cNvSpPr/>
+          <p:nvPr/>
+        </p:nvSpPr>
+        <p:spPr>
+          <a:xfrm>
+            <a:off x="8229600" y="2926080"/>
+            <a:ext cx="3291840" cy="365760"/>
+          </a:xfrm>
+          <a:prstGeom prst="rect">
+            <a:avLst/>
+          </a:prstGeom>
+          <a:noFill/>
+          <a:ln/>
+        </p:spPr>
+        <p:txBody>
+          <a:bodyPr wrap="square" lIns="0" tIns="0" rIns="0" bIns="0" rtlCol="0" anchor="ctr"/>
+          <a:lstStyle/>
+          <a:p>
+            <a:pPr indent="0" marL="0">
+              <a:buNone/>
+            </a:pPr>
+            <a:r>
+              <a:rPr lang="en-US" sz="1400" b="1" dirty="0">
+                <a:solidFill>
+                  <a:srgbClr val="0E2F3C"/>
+                </a:solidFill>
+                <a:latin typeface="PingFang SC" pitchFamily="34" charset="0"/>
+                <a:ea typeface="PingFang SC" pitchFamily="34" charset="-122"/>
+                <a:cs typeface="PingFang SC" pitchFamily="34" charset="-120"/>
+              </a:rPr>
+              <a:t>总个体数 −14%(n.s.)</a:t>
+            </a:r>
+            <a:endParaRPr lang="en-US" sz="1400" dirty="0"/>
+          </a:p>
+        </p:txBody>
+      </p:sp>
+      <p:sp>
+        <p:nvSpPr>
+          <p:cNvPr id="10" name="Text 7"/>
+          <p:cNvSpPr/>
+          <p:nvPr/>
+        </p:nvSpPr>
+        <p:spPr>
+          <a:xfrm>
+            <a:off x="8229600" y="3291840"/>
+            <a:ext cx="3291840" cy="713232"/>
+          </a:xfrm>
+          <a:prstGeom prst="rect">
+            <a:avLst/>
+          </a:prstGeom>
+          <a:noFill/>
+          <a:ln/>
+        </p:spPr>
+        <p:txBody>
+          <a:bodyPr wrap="square" lIns="0" tIns="0" rIns="0" bIns="0" rtlCol="0" anchor="ctr"/>
+          <a:lstStyle/>
+          <a:p>
+            <a:pPr indent="0" marL="0">
+              <a:buNone/>
+            </a:pPr>
+            <a:r>
+              <a:rPr lang="en-US" sz="1100" dirty="0">
+                <a:solidFill>
+                  <a:srgbClr val="1D2A33"/>
+                </a:solidFill>
+                <a:latin typeface="PingFang SC" pitchFamily="34" charset="0"/>
+                <a:ea typeface="PingFang SC" pitchFamily="34" charset="-122"/>
+                <a:cs typeface="PingFang SC" pitchFamily="34" charset="-120"/>
+              </a:rPr>
+              <a:t>两个样本方向一致,区间很宽</a:t>
+            </a:r>
+            <a:endParaRPr lang="en-US" sz="1100" dirty="0"/>
+          </a:p>
+        </p:txBody>
+      </p:sp>
+      <p:sp>
+        <p:nvSpPr>
+          <p:cNvPr id="11" name="Shape 8"/>
+          <p:cNvSpPr/>
+          <p:nvPr/>
+        </p:nvSpPr>
+        <p:spPr>
+          <a:xfrm>
+            <a:off x="8046720" y="4206240"/>
+            <a:ext cx="3611880" cy="1207008"/>
+          </a:xfrm>
+          <a:prstGeom prst="roundRect">
+            <a:avLst>
+              <a:gd name="adj" fmla="val 4545"/>
+            </a:avLst>
+          </a:prstGeom>
+          <a:solidFill>
+            <a:srgbClr val="F3E7E4"/>
+          </a:solidFill>
+          <a:ln w="12700">
+            <a:solidFill>
+              <a:srgbClr val="F3E7E4"/>
+            </a:solidFill>
+            <a:prstDash val="solid"/>
+          </a:ln>
+        </p:spPr>
+      </p:sp>
+      <p:sp>
+        <p:nvSpPr>
+          <p:cNvPr id="12" name="Text 9"/>
+          <p:cNvSpPr/>
+          <p:nvPr/>
+        </p:nvSpPr>
+        <p:spPr>
+          <a:xfrm>
+            <a:off x="8229600" y="4297680"/>
+            <a:ext cx="3291840" cy="365760"/>
+          </a:xfrm>
+          <a:prstGeom prst="rect">
+            <a:avLst/>
+          </a:prstGeom>
+          <a:noFill/>
+          <a:ln/>
+        </p:spPr>
+        <p:txBody>
+          <a:bodyPr wrap="square" lIns="0" tIns="0" rIns="0" bIns="0" rtlCol="0" anchor="ctr"/>
+          <a:lstStyle/>
+          <a:p>
+            <a:pPr indent="0" marL="0">
+              <a:buNone/>
+            </a:pPr>
+            <a:r>
+              <a:rPr lang="en-US" sz="1400" b="1" dirty="0">
+                <a:solidFill>
+                  <a:srgbClr val="0E2F3C"/>
+                </a:solidFill>
+                <a:latin typeface="PingFang SC" pitchFamily="34" charset="0"/>
+                <a:ea typeface="PingFang SC" pitchFamily="34" charset="-122"/>
+                <a:cs typeface="PingFang SC" pitchFamily="34" charset="-120"/>
+              </a:rPr>
+              <a:t>功效有限</a:t>
+            </a:r>
+            <a:endParaRPr lang="en-US" sz="1400" dirty="0"/>
+          </a:p>
+        </p:txBody>
+      </p:sp>
+      <p:sp>
+        <p:nvSpPr>
+          <p:cNvPr id="13" name="Text 10"/>
+          <p:cNvSpPr/>
+          <p:nvPr/>
+        </p:nvSpPr>
+        <p:spPr>
+          <a:xfrm>
+            <a:off x="8229600" y="4663440"/>
+            <a:ext cx="3291840" cy="713232"/>
+          </a:xfrm>
+          <a:prstGeom prst="rect">
+            <a:avLst/>
+          </a:prstGeom>
+          <a:noFill/>
+          <a:ln/>
+        </p:spPr>
+        <p:txBody>
+          <a:bodyPr wrap="square" lIns="0" tIns="0" rIns="0" bIns="0" rtlCol="0" anchor="ctr"/>
+          <a:lstStyle/>
+          <a:p>
+            <a:pPr indent="0" marL="0">
+              <a:buNone/>
+            </a:pPr>
+            <a:r>
+              <a:rPr lang="en-US" sz="1100" dirty="0">
+                <a:solidFill>
+                  <a:srgbClr val="1D2A33"/>
+                </a:solidFill>
+                <a:latin typeface="PingFang SC" pitchFamily="34" charset="0"/>
+                <a:ea typeface="PingFang SC" pitchFamily="34" charset="-122"/>
+                <a:cs typeface="PingFang SC" pitchFamily="34" charset="-120"/>
+              </a:rPr>
+              <a:t>覆盖度标准化的共同覆盖度仅 0.60,区间约 ±25%;只能排除大效应,且仅代表城郊站点</a:t>
+            </a:r>
+            <a:endParaRPr lang="en-US" sz="1100" dirty="0"/>
+          </a:p>
+        </p:txBody>
+      </p:sp>
+      <p:sp>
+        <p:nvSpPr>
+          <p:cNvPr id="14" name="Text 11"/>
+          <p:cNvSpPr/>
+          <p:nvPr/>
+        </p:nvSpPr>
+        <p:spPr>
+          <a:xfrm>
+            <a:off x="457200" y="5074920"/>
+            <a:ext cx="7315200" cy="822960"/>
+          </a:xfrm>
+          <a:prstGeom prst="rect">
+            <a:avLst/>
+          </a:prstGeom>
+          <a:noFill/>
+          <a:ln/>
+        </p:spPr>
+        <p:txBody>
+          <a:bodyPr wrap="square" lIns="0" tIns="0" rIns="0" bIns="0" rtlCol="0" anchor="ctr"/>
+          <a:lstStyle/>
+          <a:p>
+            <a:pPr indent="0" marL="0">
+              <a:buNone/>
+            </a:pPr>
+            <a:r>
+              <a:rPr lang="en-US" sz="1200" b="1" dirty="0">
+                <a:solidFill>
+                  <a:srgbClr val="1F6F78"/>
+                </a:solidFill>
+                <a:latin typeface="PingFang SC" pitchFamily="34" charset="0"/>
+                <a:ea typeface="PingFang SC" pitchFamily="34" charset="-122"/>
+                <a:cs typeface="PingFang SC" pitchFamily="34" charset="-120"/>
+              </a:rPr>
+              <a:t>清洗:同日同点多人清单合并(计数取最大);剔除所有计数为 1 的调查(观鸟中心占 40%);99% 截尾;保留单物种调查(按因变量剔除即样本选择)。</a:t>
+            </a:r>
+            <a:endParaRPr lang="en-US" sz="1200" dirty="0"/>
+          </a:p>
+        </p:txBody>
+      </p:sp>
+      <p:sp>
+        <p:nvSpPr>
+          <p:cNvPr id="15" name="Text 12"/>
+          <p:cNvSpPr/>
+          <p:nvPr/>
+        </p:nvSpPr>
+        <p:spPr>
+          <a:xfrm>
+            <a:off x="11277295" y="6400800"/>
+            <a:ext cx="457200" cy="274320"/>
+          </a:xfrm>
+          <a:prstGeom prst="rect">
+            <a:avLst/>
+          </a:prstGeom>
+          <a:noFill/>
+          <a:ln/>
+        </p:spPr>
+        <p:txBody>
+          <a:bodyPr wrap="square" lIns="0" tIns="0" rIns="0" bIns="0" rtlCol="0" anchor="ctr"/>
+          <a:lstStyle/>
+          <a:p>
+            <a:pPr algn="r" indent="0" marL="0">
+              <a:buNone/>
+            </a:pPr>
+            <a:r>
+              <a:rPr lang="en-US" sz="1000" dirty="0">
+                <a:solidFill>
+                  <a:srgbClr val="5E6B75"/>
+                </a:solidFill>
+                <a:latin typeface="Arial" pitchFamily="34" charset="0"/>
+                <a:ea typeface="Arial" pitchFamily="34" charset="-122"/>
+                <a:cs typeface="Arial" pitchFamily="34" charset="-120"/>
+              </a:rPr>
+              <a:t>21</a:t>
+            </a:r>
+            <a:endParaRPr lang="en-US" sz="1000" dirty="0"/>
+          </a:p>
+        </p:txBody>
+      </p:sp>
+    </p:spTree>
+  </p:cSld>
+  <p:clrMapOvr>
+    <a:masterClrMapping/>
+  </p:clrMapOvr>
+</p:sld>
+</file>
+
+<file path=ppt/slides/slide22.xml><?xml version="1.0" encoding="utf-8"?>
+<p:sld xmlns:a="http://schemas.openxmlformats.org/drawingml/2006/main" xmlns:r="http://schemas.openxmlformats.org/officeDocument/2006/relationships" xmlns:p="http://schemas.openxmlformats.org/presentationml/2006/main">
+  <p:cSld name="Slide 22">
+    <p:spTree>
+      <p:nvGrpSpPr>
+        <p:cNvPr id="1" name=""/>
+        <p:cNvGrpSpPr/>
+        <p:nvPr/>
+      </p:nvGrpSpPr>
+      <p:grpSpPr>
+        <a:xfrm>
+          <a:off x="0" y="0"/>
+          <a:ext cx="0" cy="0"/>
+          <a:chOff x="0" y="0"/>
+          <a:chExt cx="0" cy="0"/>
+        </a:xfrm>
+      </p:grpSpPr>
+      <p:sp>
+        <p:nvSpPr>
+          <p:cNvPr id="2" name="Text 0"/>
+          <p:cNvSpPr/>
+          <p:nvPr/>
+        </p:nvSpPr>
+        <p:spPr>
+          <a:xfrm>
+            <a:off x="548640" y="320040"/>
+            <a:ext cx="11094415" cy="685800"/>
+          </a:xfrm>
+          <a:prstGeom prst="rect">
+            <a:avLst/>
+          </a:prstGeom>
+          <a:noFill/>
+          <a:ln/>
+        </p:spPr>
+        <p:txBody>
+          <a:bodyPr wrap="square" lIns="0" tIns="0" rIns="0" bIns="0" rtlCol="0" anchor="ctr"/>
+          <a:lstStyle/>
+          <a:p>
+            <a:pPr indent="0" marL="0">
+              <a:buNone/>
+            </a:pPr>
+            <a:r>
+              <a:rPr lang="en-US" sz="3000" b="1" dirty="0">
+                <a:solidFill>
+                  <a:srgbClr val="0E2F3C"/>
+                </a:solidFill>
+                <a:latin typeface="PingFang SC" pitchFamily="34" charset="0"/>
+                <a:ea typeface="PingFang SC" pitchFamily="34" charset="-122"/>
+                <a:cs typeface="PingFang SC" pitchFamily="34" charset="-120"/>
+              </a:rPr>
               <a:t>主要风险与对策</a:t>
             </a:r>
             <a:endParaRPr lang="en-US" sz="3000" dirty="0"/>
@@ -16089,7 +16698,7 @@
       </p:sp>
       <p:graphicFrame>
         <p:nvGraphicFramePr>
-          <p:cNvPr id="22" name="Table 0"/>
+          <p:cNvPr id="23" name="Table 0"/>
           <p:cNvGraphicFramePr>
             <a:graphicFrameLocks noGrp="1"/>
           </p:cNvGraphicFramePr>
@@ -17212,7 +17821,7 @@
                 <a:ea typeface="Arial" pitchFamily="34" charset="-122"/>
                 <a:cs typeface="Arial" pitchFamily="34" charset="-120"/>
               </a:rPr>
-              <a:t>21</a:t>
+              <a:t>22</a:t>
             </a:r>
             <a:endParaRPr lang="en-US" sz="1000" dirty="0"/>
           </a:p>
@@ -17226,9 +17835,9 @@
 </p:sld>
 </file>
 
-<file path=ppt/slides/slide22.xml><?xml version="1.0" encoding="utf-8"?>
+<file path=ppt/slides/slide23.xml><?xml version="1.0" encoding="utf-8"?>
 <p:sld xmlns:a="http://schemas.openxmlformats.org/drawingml/2006/main" xmlns:r="http://schemas.openxmlformats.org/officeDocument/2006/relationships" xmlns:p="http://schemas.openxmlformats.org/presentationml/2006/main">
-  <p:cSld name="Slide 22">
+  <p:cSld name="Slide 23">
     <p:spTree>
       <p:nvGrpSpPr>
         <p:cNvPr id="1" name=""/>
@@ -17637,7 +18246,7 @@
                 <a:ea typeface="Arial" pitchFamily="34" charset="-122"/>
                 <a:cs typeface="Arial" pitchFamily="34" charset="-120"/>
               </a:rPr>
-              <a:t>22</a:t>
+              <a:t>23</a:t>
             </a:r>
             <a:endParaRPr lang="en-US" sz="1000" dirty="0"/>
           </a:p>
@@ -17651,9 +18260,9 @@
 </p:sld>
 </file>
 
-<file path=ppt/slides/slide23.xml><?xml version="1.0" encoding="utf-8"?>
+<file path=ppt/slides/slide24.xml><?xml version="1.0" encoding="utf-8"?>
 <p:sld xmlns:a="http://schemas.openxmlformats.org/drawingml/2006/main" xmlns:r="http://schemas.openxmlformats.org/officeDocument/2006/relationships" xmlns:p="http://schemas.openxmlformats.org/presentationml/2006/main">
-  <p:cSld name="Slide 23">
+  <p:cSld name="Slide 24">
     <p:bg>
       <p:bgPr>
         <a:solidFill>

</xml_diff>

<commit_message>
v0.3: species exposure from BirdLife/IUCN ranges; page rewritten as research notes
- analysis/exposure_iucn.R: 3,165 species (422 threatened) rasterised to a
  5 km grid; after 2022 PV moved to cells with fewer species (richness
  percentile 50 -> 37, threatened 44 -> 37) while the share of new PV in
  ranges of dryland threatened species rose (saker falcon 57% -> 82%,
  goitered gazelle 43% -> 70%, steppe eagle 49% -> 69%)
- index.html rewritten in the first-person voice of a research notebook;
  numbers and methods unchanged; visual interpretation noted as pending
  independent second-reader review
- Deck: exposure slide (25 slides)
</commit_message>
<xml_diff>
--- a/RS_Renewables_Biodiversity_Workflow.pptx
+++ b/RS_Renewables_Biodiversity_Workflow.pptx
@@ -29,9 +29,10 @@
     <p:sldId id="277" r:id="rId23"/>
     <p:sldId id="278" r:id="rId24"/>
     <p:sldId id="279" r:id="rId25"/>
+    <p:sldId id="280" r:id="rId26"/>
   </p:sldIdLst>
   <p:notesMasterIdLst>
-    <p:notesMasterId r:id="rId26"/>
+    <p:notesMasterId r:id="rId27"/>
   </p:notesMasterIdLst>
   <p:sldSz cx="12192000" cy="6858000"/>
   <p:notesSz cx="6858000" cy="12192000"/>
@@ -3131,6 +3132,94 @@
 </p:notes>
 </file>
 
+<file path=ppt/notesSlides/notesSlide25.xml><?xml version="1.0" encoding="utf-8"?>
+<p:notes xmlns:a="http://schemas.openxmlformats.org/drawingml/2006/main" xmlns:r="http://schemas.openxmlformats.org/officeDocument/2006/relationships" xmlns:p="http://schemas.openxmlformats.org/presentationml/2006/main">
+  <p:cSld>
+    <p:spTree>
+      <p:nvGrpSpPr>
+        <p:cNvPr id="1" name=""/>
+        <p:cNvGrpSpPr/>
+        <p:nvPr/>
+      </p:nvGrpSpPr>
+      <p:grpSpPr>
+        <a:xfrm>
+          <a:off x="0" y="0"/>
+          <a:ext cx="0" cy="0"/>
+          <a:chOff x="0" y="0"/>
+          <a:chExt cx="0" cy="0"/>
+        </a:xfrm>
+      </p:grpSpPr>
+      <p:sp>
+        <p:nvSpPr>
+          <p:cNvPr id="2" name="Slide Image Placeholder 1"/>
+          <p:cNvSpPr>
+            <a:spLocks noGrp="1" noRot="1" noChangeAspect="1"/>
+          </p:cNvSpPr>
+          <p:nvPr>
+            <p:ph type="sldImg"/>
+          </p:nvPr>
+        </p:nvSpPr>
+        <p:spPr/>
+      </p:sp>
+      <p:sp>
+        <p:nvSpPr>
+          <p:cNvPr id="3" name="Notes Placeholder 2"/>
+          <p:cNvSpPr>
+            <a:spLocks noGrp="1"/>
+          </p:cNvSpPr>
+          <p:nvPr>
+            <p:ph type="body" idx="1"/>
+          </p:nvPr>
+        </p:nvSpPr>
+        <p:spPr/>
+        <p:txBody>
+          <a:bodyPr/>
+          <a:lstStyle/>
+          <a:p>
+            <a:r>
+              <a:rPr lang="en-US" dirty="0"/>
+              <a:t/>
+            </a:r>
+            <a:endParaRPr lang="en-US" dirty="0"/>
+          </a:p>
+        </p:txBody>
+      </p:sp>
+      <p:sp>
+        <p:nvSpPr>
+          <p:cNvPr id="4" name="Slide Number Placeholder 3"/>
+          <p:cNvSpPr>
+            <a:spLocks noGrp="1"/>
+          </p:cNvSpPr>
+          <p:nvPr>
+            <p:ph type="sldNum" sz="quarter" idx="10"/>
+          </p:nvPr>
+        </p:nvSpPr>
+        <p:spPr/>
+        <p:txBody>
+          <a:bodyPr/>
+          <a:lstStyle/>
+          <a:p>
+            <a:fld id="{F7021451-1387-4CA6-816F-3879F97B5CBC}" type="slidenum">
+              <a:rPr lang="en-US"/>
+              <a:t>25</a:t>
+            </a:fld>
+            <a:endParaRPr lang="en-US"/>
+          </a:p>
+        </p:txBody>
+      </p:sp>
+    </p:spTree>
+    <p:extLst>
+      <p:ext uri="{BB962C8B-B14F-4D97-AF65-F5344CB8AC3E}">
+        <p14:creationId xmlns:p14="http://schemas.microsoft.com/office/powerpoint/2010/main" val="1024086991"/>
+      </p:ext>
+    </p:extLst>
+  </p:cSld>
+  <p:clrMapOvr>
+    <a:masterClrMapping/>
+  </p:clrMapOvr>
+</p:notes>
+</file>
+
 <file path=ppt/notesSlides/notesSlide3.xml><?xml version="1.0" encoding="utf-8"?>
 <p:notes xmlns:a="http://schemas.openxmlformats.org/drawingml/2006/main" xmlns:r="http://schemas.openxmlformats.org/officeDocument/2006/relationships" xmlns:p="http://schemas.openxmlformats.org/presentationml/2006/main">
   <p:cSld>
@@ -12980,7 +13069,7 @@
                 <a:ea typeface="PingFang SC" pitchFamily="34" charset="-122"/>
                 <a:cs typeface="PingFang SC" pitchFamily="34" charset="-120"/>
               </a:rPr>
-              <a:t>西北旱区试点:交错 DiD 事件研究</a:t>
+              <a:t>落进了谁的分布区:物种暴露</a:t>
             </a:r>
             <a:endParaRPr lang="en-US" sz="3000" dirty="0"/>
           </a:p>
@@ -13019,7 +13108,7 @@
                 <a:ea typeface="PingFang SC" pitchFamily="34" charset="-122"/>
                 <a:cs typeface="PingFang SC" pitchFamily="34" charset="-120"/>
               </a:rPr>
-              <a:t>365 站(2019–2021 处理 198,2022–2023 晚建对照 167);Landsat 生长季 NDVI,2016–2024</a:t>
+              <a:t>BirdLife BOTW 2025 + IUCN 分布图,5 km 网格;中国 3,165 种,受威胁 422 种</a:t>
             </a:r>
             <a:endParaRPr lang="en-US" sz="1400" dirty="0"/>
           </a:p>
@@ -13027,7 +13116,7 @@
       </p:sp>
       <p:pic>
         <p:nvPicPr>
-          <p:cNvPr id="4" name="Image 0" descr="results/figures/pilot_nw_eventstudy.png">    </p:cNvPr>
+          <p:cNvPr id="4" name="Image 0" descr="results/figures/exposure_threatened_shift.png">    </p:cNvPr>
           <p:cNvPicPr>
             <a:picLocks noChangeAspect="1"/>
           </p:cNvPicPr>
@@ -13042,7 +13131,7 @@
         <p:spPr>
           <a:xfrm>
             <a:off x="457200" y="1417320"/>
-            <a:ext cx="6675120" cy="4983480"/>
+            <a:ext cx="6766560" cy="3758184"/>
           </a:xfrm>
           <a:prstGeom prst="rect">
             <a:avLst/>
@@ -13051,18 +13140,162 @@
       </p:pic>
       <p:sp>
         <p:nvSpPr>
-          <p:cNvPr id="5" name="Shape 2"/>
-          <p:cNvSpPr/>
-          <p:nvPr/>
-        </p:nvSpPr>
-        <p:spPr>
-          <a:xfrm>
-            <a:off x="7406640" y="1463040"/>
-            <a:ext cx="4251960" cy="1078992"/>
+          <p:cNvPr id="5" name="Text 2"/>
+          <p:cNvSpPr/>
+          <p:nvPr/>
+        </p:nvSpPr>
+        <p:spPr>
+          <a:xfrm>
+            <a:off x="457200" y="5230368"/>
+            <a:ext cx="6766560" cy="320040"/>
+          </a:xfrm>
+          <a:prstGeom prst="rect">
+            <a:avLst/>
+          </a:prstGeom>
+          <a:noFill/>
+          <a:ln/>
+        </p:spPr>
+        <p:txBody>
+          <a:bodyPr wrap="square" lIns="0" tIns="0" rIns="0" bIns="0" rtlCol="0" anchor="ctr"/>
+          <a:lstStyle/>
+          <a:p>
+            <a:pPr indent="0" marL="0">
+              <a:buNone/>
+            </a:pPr>
+            <a:r>
+              <a:rPr lang="en-US" sz="1100" dirty="0">
+                <a:solidFill>
+                  <a:srgbClr val="5E6B75"/>
+                </a:solidFill>
+                <a:latin typeface="PingFang SC" pitchFamily="34" charset="0"/>
+                <a:ea typeface="PingFang SC" pitchFamily="34" charset="-122"/>
+                <a:cs typeface="PingFang SC" pitchFamily="34" charset="-120"/>
+              </a:rPr>
+              <a:t>当期新建光伏面积落在该物种分布区内的比例</a:t>
+            </a:r>
+            <a:endParaRPr lang="en-US" sz="1100" dirty="0"/>
+          </a:p>
+        </p:txBody>
+      </p:sp>
+      <p:sp>
+        <p:nvSpPr>
+          <p:cNvPr id="6" name="Shape 3"/>
+          <p:cNvSpPr/>
+          <p:nvPr/>
+        </p:nvSpPr>
+        <p:spPr>
+          <a:xfrm>
+            <a:off x="7498080" y="1463040"/>
+            <a:ext cx="4160520" cy="1207008"/>
           </a:xfrm>
           <a:prstGeom prst="roundRect">
             <a:avLst>
-              <a:gd name="adj" fmla="val 5085"/>
+              <a:gd name="adj" fmla="val 4545"/>
+            </a:avLst>
+          </a:prstGeom>
+          <a:solidFill>
+            <a:srgbClr val="EEF4F4"/>
+          </a:solidFill>
+          <a:ln w="12700">
+            <a:solidFill>
+              <a:srgbClr val="EEF4F4"/>
+            </a:solidFill>
+            <a:prstDash val="solid"/>
+          </a:ln>
+        </p:spPr>
+      </p:sp>
+      <p:sp>
+        <p:nvSpPr>
+          <p:cNvPr id="7" name="Text 4"/>
+          <p:cNvSpPr/>
+          <p:nvPr/>
+        </p:nvSpPr>
+        <p:spPr>
+          <a:xfrm>
+            <a:off x="7680960" y="1554480"/>
+            <a:ext cx="3840480" cy="365760"/>
+          </a:xfrm>
+          <a:prstGeom prst="rect">
+            <a:avLst/>
+          </a:prstGeom>
+          <a:noFill/>
+          <a:ln/>
+        </p:spPr>
+        <p:txBody>
+          <a:bodyPr wrap="square" lIns="0" tIns="0" rIns="0" bIns="0" rtlCol="0" anchor="ctr"/>
+          <a:lstStyle/>
+          <a:p>
+            <a:pPr indent="0" marL="0">
+              <a:buNone/>
+            </a:pPr>
+            <a:r>
+              <a:rPr lang="en-US" sz="1400" b="1" dirty="0">
+                <a:solidFill>
+                  <a:srgbClr val="0E2F3C"/>
+                </a:solidFill>
+                <a:latin typeface="PingFang SC" pitchFamily="34" charset="0"/>
+                <a:ea typeface="PingFang SC" pitchFamily="34" charset="-122"/>
+                <a:cs typeface="PingFang SC" pitchFamily="34" charset="-120"/>
+              </a:rPr>
+              <a:t>平均暴露下降</a:t>
+            </a:r>
+            <a:endParaRPr lang="en-US" sz="1400" dirty="0"/>
+          </a:p>
+        </p:txBody>
+      </p:sp>
+      <p:sp>
+        <p:nvSpPr>
+          <p:cNvPr id="8" name="Text 5"/>
+          <p:cNvSpPr/>
+          <p:nvPr/>
+        </p:nvSpPr>
+        <p:spPr>
+          <a:xfrm>
+            <a:off x="7680960" y="1920240"/>
+            <a:ext cx="3840480" cy="713232"/>
+          </a:xfrm>
+          <a:prstGeom prst="rect">
+            <a:avLst/>
+          </a:prstGeom>
+          <a:noFill/>
+          <a:ln/>
+        </p:spPr>
+        <p:txBody>
+          <a:bodyPr wrap="square" lIns="0" tIns="0" rIns="0" bIns="0" rtlCol="0" anchor="ctr"/>
+          <a:lstStyle/>
+          <a:p>
+            <a:pPr indent="0" marL="0">
+              <a:buNone/>
+            </a:pPr>
+            <a:r>
+              <a:rPr lang="en-US" sz="1100" dirty="0">
+                <a:solidFill>
+                  <a:srgbClr val="1D2A33"/>
+                </a:solidFill>
+                <a:latin typeface="PingFang SC" pitchFamily="34" charset="0"/>
+                <a:ea typeface="PingFang SC" pitchFamily="34" charset="-122"/>
+                <a:cs typeface="PingFang SC" pitchFamily="34" charset="-120"/>
+              </a:rPr>
+              <a:t>新建光伏所在网格的物种数百分位 50 → 37,受威胁物种 44 → 37(2018–21 → 2022–24)</a:t>
+            </a:r>
+            <a:endParaRPr lang="en-US" sz="1100" dirty="0"/>
+          </a:p>
+        </p:txBody>
+      </p:sp>
+      <p:sp>
+        <p:nvSpPr>
+          <p:cNvPr id="9" name="Shape 6"/>
+          <p:cNvSpPr/>
+          <p:nvPr/>
+        </p:nvSpPr>
+        <p:spPr>
+          <a:xfrm>
+            <a:off x="7498080" y="2834640"/>
+            <a:ext cx="4160520" cy="1207008"/>
+          </a:xfrm>
+          <a:prstGeom prst="roundRect">
+            <a:avLst>
+              <a:gd name="adj" fmla="val 4545"/>
             </a:avLst>
           </a:prstGeom>
           <a:solidFill>
@@ -13078,14 +13311,14 @@
       </p:sp>
       <p:sp>
         <p:nvSpPr>
-          <p:cNvPr id="6" name="Text 3"/>
-          <p:cNvSpPr/>
-          <p:nvPr/>
-        </p:nvSpPr>
-        <p:spPr>
-          <a:xfrm>
-            <a:off x="7589520" y="1536192"/>
-            <a:ext cx="3931920" cy="365760"/>
+          <p:cNvPr id="10" name="Text 7"/>
+          <p:cNvSpPr/>
+          <p:nvPr/>
+        </p:nvSpPr>
+        <p:spPr>
+          <a:xfrm>
+            <a:off x="7680960" y="2926080"/>
+            <a:ext cx="3840480" cy="365760"/>
           </a:xfrm>
           <a:prstGeom prst="rect">
             <a:avLst/>
@@ -13101,7 +13334,7 @@
               <a:buNone/>
             </a:pPr>
             <a:r>
-              <a:rPr lang="en-US" sz="1500" b="1" dirty="0">
+              <a:rPr lang="en-US" sz="1400" b="1" dirty="0">
                 <a:solidFill>
                   <a:srgbClr val="0E2F3C"/>
                 </a:solidFill>
@@ -13109,22 +13342,22 @@
                 <a:ea typeface="PingFang SC" pitchFamily="34" charset="-122"/>
                 <a:cs typeface="PingFang SC" pitchFamily="34" charset="-120"/>
               </a:rPr>
-              <a:t>站内:G2 未通过</a:t>
-            </a:r>
-            <a:endParaRPr lang="en-US" sz="1500" dirty="0"/>
-          </a:p>
-        </p:txBody>
-      </p:sp>
-      <p:sp>
-        <p:nvSpPr>
-          <p:cNvPr id="7" name="Text 4"/>
-          <p:cNvSpPr/>
-          <p:nvPr/>
-        </p:nvSpPr>
-        <p:spPr>
-          <a:xfrm>
-            <a:off x="7589520" y="1920240"/>
-            <a:ext cx="3931920" cy="594360"/>
+              <a:t>旱地物种暴露上升</a:t>
+            </a:r>
+            <a:endParaRPr lang="en-US" sz="1400" dirty="0"/>
+          </a:p>
+        </p:txBody>
+      </p:sp>
+      <p:sp>
+        <p:nvSpPr>
+          <p:cNvPr id="11" name="Text 8"/>
+          <p:cNvSpPr/>
+          <p:nvPr/>
+        </p:nvSpPr>
+        <p:spPr>
+          <a:xfrm>
+            <a:off x="7680960" y="3291840"/>
+            <a:ext cx="3840480" cy="713232"/>
           </a:xfrm>
           <a:prstGeom prst="rect">
             <a:avLst/>
@@ -13148,7 +13381,7 @@
                 <a:ea typeface="PingFang SC" pitchFamily="34" charset="-122"/>
                 <a:cs typeface="PingFang SC" pitchFamily="34" charset="-120"/>
               </a:rPr>
-              <a:t>建后 1–3 年 −0.022(−0.042, −0.002),但建设前偏离达 0.025;设 2 年预期期后降为 −0.004</a:t>
+              <a:t>猎隼分布区内新建光伏占比 57% → 82%,鹅喉羚 43% → 70%,草原雕 49% → 69%</a:t>
             </a:r>
             <a:endParaRPr lang="en-US" sz="1100" dirty="0"/>
           </a:p>
@@ -13156,123 +13389,18 @@
       </p:sp>
       <p:sp>
         <p:nvSpPr>
-          <p:cNvPr id="8" name="Shape 5"/>
-          <p:cNvSpPr/>
-          <p:nvPr/>
-        </p:nvSpPr>
-        <p:spPr>
-          <a:xfrm>
-            <a:off x="7406640" y="2670048"/>
-            <a:ext cx="4251960" cy="1078992"/>
+          <p:cNvPr id="12" name="Shape 9"/>
+          <p:cNvSpPr/>
+          <p:nvPr/>
+        </p:nvSpPr>
+        <p:spPr>
+          <a:xfrm>
+            <a:off x="7498080" y="4206240"/>
+            <a:ext cx="4160520" cy="1207008"/>
           </a:xfrm>
           <a:prstGeom prst="roundRect">
             <a:avLst>
-              <a:gd name="adj" fmla="val 5085"/>
-            </a:avLst>
-          </a:prstGeom>
-          <a:solidFill>
-            <a:srgbClr val="EEF4F4"/>
-          </a:solidFill>
-          <a:ln w="12700">
-            <a:solidFill>
-              <a:srgbClr val="EEF4F4"/>
-            </a:solidFill>
-            <a:prstDash val="solid"/>
-          </a:ln>
-        </p:spPr>
-      </p:sp>
-      <p:sp>
-        <p:nvSpPr>
-          <p:cNvPr id="9" name="Text 6"/>
-          <p:cNvSpPr/>
-          <p:nvPr/>
-        </p:nvSpPr>
-        <p:spPr>
-          <a:xfrm>
-            <a:off x="7589520" y="2743200"/>
-            <a:ext cx="3931920" cy="365760"/>
-          </a:xfrm>
-          <a:prstGeom prst="rect">
-            <a:avLst/>
-          </a:prstGeom>
-          <a:noFill/>
-          <a:ln/>
-        </p:spPr>
-        <p:txBody>
-          <a:bodyPr wrap="square" lIns="0" tIns="0" rIns="0" bIns="0" rtlCol="0" anchor="ctr"/>
-          <a:lstStyle/>
-          <a:p>
-            <a:pPr indent="0" marL="0">
-              <a:buNone/>
-            </a:pPr>
-            <a:r>
-              <a:rPr lang="en-US" sz="1500" b="1" dirty="0">
-                <a:solidFill>
-                  <a:srgbClr val="0E2F3C"/>
-                </a:solidFill>
-                <a:latin typeface="PingFang SC" pitchFamily="34" charset="0"/>
-                <a:ea typeface="PingFang SC" pitchFamily="34" charset="-122"/>
-                <a:cs typeface="PingFang SC" pitchFamily="34" charset="-120"/>
-              </a:rPr>
-              <a:t>外围环:设计可用</a:t>
-            </a:r>
-            <a:endParaRPr lang="en-US" sz="1500" dirty="0"/>
-          </a:p>
-        </p:txBody>
-      </p:sp>
-      <p:sp>
-        <p:nvSpPr>
-          <p:cNvPr id="10" name="Text 7"/>
-          <p:cNvSpPr/>
-          <p:nvPr/>
-        </p:nvSpPr>
-        <p:spPr>
-          <a:xfrm>
-            <a:off x="7589520" y="3127248"/>
-            <a:ext cx="3931920" cy="594360"/>
-          </a:xfrm>
-          <a:prstGeom prst="rect">
-            <a:avLst/>
-          </a:prstGeom>
-          <a:noFill/>
-          <a:ln/>
-        </p:spPr>
-        <p:txBody>
-          <a:bodyPr wrap="square" lIns="0" tIns="0" rIns="0" bIns="0" rtlCol="0" anchor="ctr"/>
-          <a:lstStyle/>
-          <a:p>
-            <a:pPr indent="0" marL="0">
-              <a:buNone/>
-            </a:pPr>
-            <a:r>
-              <a:rPr lang="en-US" sz="1100" dirty="0">
-                <a:solidFill>
-                  <a:srgbClr val="1D2A33"/>
-                </a:solidFill>
-                <a:latin typeface="PingFang SC" pitchFamily="34" charset="0"/>
-                <a:ea typeface="PingFang SC" pitchFamily="34" charset="-122"/>
-                <a:cs typeface="PingFang SC" pitchFamily="34" charset="-120"/>
-              </a:rPr>
-              <a:t>建设前平坦(p = 0.60);60–500 m 未检出外溢,−0.009(−0.026, 0.007)</a:t>
-            </a:r>
-            <a:endParaRPr lang="en-US" sz="1100" dirty="0"/>
-          </a:p>
-        </p:txBody>
-      </p:sp>
-      <p:sp>
-        <p:nvSpPr>
-          <p:cNvPr id="11" name="Shape 8"/>
-          <p:cNvSpPr/>
-          <p:nvPr/>
-        </p:nvSpPr>
-        <p:spPr>
-          <a:xfrm>
-            <a:off x="7406640" y="3877056"/>
-            <a:ext cx="4251960" cy="1078992"/>
-          </a:xfrm>
-          <a:prstGeom prst="roundRect">
-            <a:avLst>
-              <a:gd name="adj" fmla="val 5085"/>
+              <a:gd name="adj" fmla="val 4545"/>
             </a:avLst>
           </a:prstGeom>
           <a:solidFill>
@@ -13288,14 +13416,14 @@
       </p:sp>
       <p:sp>
         <p:nvSpPr>
-          <p:cNvPr id="12" name="Text 9"/>
-          <p:cNvSpPr/>
-          <p:nvPr/>
-        </p:nvSpPr>
-        <p:spPr>
-          <a:xfrm>
-            <a:off x="7589520" y="3950208"/>
-            <a:ext cx="3931920" cy="365760"/>
+          <p:cNvPr id="13" name="Text 10"/>
+          <p:cNvSpPr/>
+          <p:nvPr/>
+        </p:nvSpPr>
+        <p:spPr>
+          <a:xfrm>
+            <a:off x="7680960" y="4297680"/>
+            <a:ext cx="3840480" cy="365760"/>
           </a:xfrm>
           <a:prstGeom prst="rect">
             <a:avLst/>
@@ -13311,7 +13439,7 @@
               <a:buNone/>
             </a:pPr>
             <a:r>
-              <a:rPr lang="en-US" sz="1500" b="1" dirty="0">
+              <a:rPr lang="en-US" sz="1400" b="1" dirty="0">
                 <a:solidFill>
                   <a:srgbClr val="0E2F3C"/>
                 </a:solidFill>
@@ -13319,22 +13447,22 @@
                 <a:ea typeface="PingFang SC" pitchFamily="34" charset="-122"/>
                 <a:cs typeface="PingFang SC" pitchFamily="34" charset="-120"/>
               </a:rPr>
-              <a:t>异质性:未检出</a:t>
-            </a:r>
-            <a:endParaRPr lang="en-US" sz="1500" dirty="0"/>
-          </a:p>
-        </p:txBody>
-      </p:sp>
-      <p:sp>
-        <p:nvSpPr>
-          <p:cNvPr id="13" name="Text 10"/>
-          <p:cNvSpPr/>
-          <p:nvPr/>
-        </p:nvSpPr>
-        <p:spPr>
-          <a:xfrm>
-            <a:off x="7589520" y="4334256"/>
-            <a:ext cx="3931920" cy="594360"/>
+              <a:t>风电:普氏原羚</a:t>
+            </a:r>
+            <a:endParaRPr lang="en-US" sz="1400" dirty="0"/>
+          </a:p>
+        </p:txBody>
+      </p:sp>
+      <p:sp>
+        <p:nvSpPr>
+          <p:cNvPr id="14" name="Text 11"/>
+          <p:cNvSpPr/>
+          <p:nvPr/>
+        </p:nvSpPr>
+        <p:spPr>
+          <a:xfrm>
+            <a:off x="7680960" y="4663440"/>
+            <a:ext cx="3840480" cy="713232"/>
           </a:xfrm>
           <a:prstGeom prst="rect">
             <a:avLst/>
@@ -13358,7 +13486,7 @@
                 <a:ea typeface="PingFang SC" pitchFamily="34" charset="-122"/>
                 <a:cs typeface="PingFang SC" pitchFamily="34" charset="-120"/>
               </a:rPr>
-              <a:t>站内与外围环 NDVI 标准差均无变化;H3 未获支持也未被否定</a:t>
+              <a:t>88 个分布网格中 22 个出现新风机(208 台);只是分布区重叠,需局地数据确认</a:t>
             </a:r>
             <a:endParaRPr lang="en-US" sz="1100" dirty="0"/>
           </a:p>
@@ -13366,14 +13494,14 @@
       </p:sp>
       <p:sp>
         <p:nvSpPr>
-          <p:cNvPr id="14" name="Text 11"/>
-          <p:cNvSpPr/>
-          <p:nvPr/>
-        </p:nvSpPr>
-        <p:spPr>
-          <a:xfrm>
-            <a:off x="7406640" y="5120640"/>
-            <a:ext cx="4251960" cy="914400"/>
+          <p:cNvPr id="15" name="Text 12"/>
+          <p:cNvSpPr/>
+          <p:nvPr/>
+        </p:nvSpPr>
+        <p:spPr>
+          <a:xfrm>
+            <a:off x="7498080" y="5577840"/>
+            <a:ext cx="4160520" cy="640080"/>
           </a:xfrm>
           <a:prstGeom prst="rect">
             <a:avLst/>
@@ -13397,7 +13525,7 @@
                 <a:ea typeface="PingFang SC" pitchFamily="34" charset="-122"/>
                 <a:cs typeface="PingFang SC" pitchFamily="34" charset="-120"/>
               </a:rPr>
-              <a:t>修改:按建设前 NDVI 轨迹与选址变量匹配从未建设点;前期延至 2010;站内改用 10 m 板间像元;HonestDiD 报告界。</a:t>
+              <a:t>与 NEE 预测一致:集中选址降低了丰富度冲突,代价转移到少数开阔、干旱生境物种上。</a:t>
             </a:r>
             <a:endParaRPr lang="en-US" sz="1150" dirty="0"/>
           </a:p>
@@ -13405,7 +13533,7 @@
       </p:sp>
       <p:sp>
         <p:nvSpPr>
-          <p:cNvPr id="15" name="Text 12"/>
+          <p:cNvPr id="16" name="Text 13"/>
           <p:cNvSpPr/>
           <p:nvPr/>
         </p:nvSpPr>
@@ -13500,7 +13628,7 @@
                 <a:ea typeface="PingFang SC" pitchFamily="34" charset="-122"/>
                 <a:cs typeface="PingFang SC" pitchFamily="34" charset="-120"/>
               </a:rPr>
-              <a:t>修正版:匹配的从未建设对照 + HonestDiD</a:t>
+              <a:t>西北旱区试点:交错 DiD 事件研究</a:t>
             </a:r>
             <a:endParaRPr lang="en-US" sz="3000" dirty="0"/>
           </a:p>
@@ -13539,7 +13667,7 @@
                 <a:ea typeface="PingFang SC" pitchFamily="34" charset="-122"/>
                 <a:cs typeface="PingFang SC" pitchFamily="34" charset="-120"/>
               </a:rPr>
-              <a:t>362 站 vs 530 个匹配点(2010–2016 NDVI 轨迹、PVOUT、坡度、海拔;省份与 CLCD 覆盖精确匹配);1 年预期期</a:t>
+              <a:t>365 站(2019–2021 处理 198,2022–2023 晚建对照 167);Landsat 生长季 NDVI,2016–2024</a:t>
             </a:r>
             <a:endParaRPr lang="en-US" sz="1400" dirty="0"/>
           </a:p>
@@ -13547,7 +13675,7 @@
       </p:sp>
       <p:pic>
         <p:nvPicPr>
-          <p:cNvPr id="4" name="Image 0" descr="results/figures/pilot_nw_matched.png">    </p:cNvPr>
+          <p:cNvPr id="4" name="Image 0" descr="results/figures/pilot_nw_eventstudy.png">    </p:cNvPr>
           <p:cNvPicPr>
             <a:picLocks noChangeAspect="1"/>
           </p:cNvPicPr>
@@ -13562,7 +13690,7 @@
         <p:spPr>
           <a:xfrm>
             <a:off x="457200" y="1417320"/>
-            <a:ext cx="6583680" cy="4773168"/>
+            <a:ext cx="6675120" cy="4983480"/>
           </a:xfrm>
           <a:prstGeom prst="rect">
             <a:avLst/>
@@ -13577,12 +13705,12 @@
         </p:nvSpPr>
         <p:spPr>
           <a:xfrm>
-            <a:off x="7315200" y="1463040"/>
-            <a:ext cx="4343400" cy="1298448"/>
+            <a:off x="7406640" y="1463040"/>
+            <a:ext cx="4251960" cy="1078992"/>
           </a:xfrm>
           <a:prstGeom prst="roundRect">
             <a:avLst>
-              <a:gd name="adj" fmla="val 4225"/>
+              <a:gd name="adj" fmla="val 5085"/>
             </a:avLst>
           </a:prstGeom>
           <a:solidFill>
@@ -13604,8 +13732,8 @@
         </p:nvSpPr>
         <p:spPr>
           <a:xfrm>
-            <a:off x="7498080" y="1554480"/>
-            <a:ext cx="4023360" cy="384048"/>
+            <a:off x="7589520" y="1536192"/>
+            <a:ext cx="3931920" cy="365760"/>
           </a:xfrm>
           <a:prstGeom prst="rect">
             <a:avLst/>
@@ -13629,7 +13757,7 @@
                 <a:ea typeface="PingFang SC" pitchFamily="34" charset="-122"/>
                 <a:cs typeface="PingFang SC" pitchFamily="34" charset="-120"/>
               </a:rPr>
-              <a:t>站内 NDVI −0.029(约 −11%)</a:t>
+              <a:t>站内:G2 未通过</a:t>
             </a:r>
             <a:endParaRPr lang="en-US" sz="1500" dirty="0"/>
           </a:p>
@@ -13643,8 +13771,8 @@
         </p:nvSpPr>
         <p:spPr>
           <a:xfrm>
-            <a:off x="7498080" y="1965960"/>
-            <a:ext cx="4023360" cy="731520"/>
+            <a:off x="7589520" y="1920240"/>
+            <a:ext cx="3931920" cy="594360"/>
           </a:xfrm>
           <a:prstGeom prst="rect">
             <a:avLst/>
@@ -13660,7 +13788,7 @@
               <a:buNone/>
             </a:pPr>
             <a:r>
-              <a:rPr lang="en-US" sz="1150" dirty="0">
+              <a:rPr lang="en-US" sz="1100" dirty="0">
                 <a:solidFill>
                   <a:srgbClr val="1D2A33"/>
                 </a:solidFill>
@@ -13668,9 +13796,9 @@
                 <a:ea typeface="PingFang SC" pitchFamily="34" charset="-122"/>
                 <a:cs typeface="PingFang SC" pitchFamily="34" charset="-120"/>
               </a:rPr>
-              <a:t>95% CI −0.043 至 −0.016;HonestDiD 在 Mbar = 0.5 仍显著(−0.054, −0.002)</a:t>
-            </a:r>
-            <a:endParaRPr lang="en-US" sz="1150" dirty="0"/>
+              <a:t>建后 1–3 年 −0.022(−0.042, −0.002),但建设前偏离达 0.025;设 2 年预期期后降为 −0.004</a:t>
+            </a:r>
+            <a:endParaRPr lang="en-US" sz="1100" dirty="0"/>
           </a:p>
         </p:txBody>
       </p:sp>
@@ -13682,12 +13810,12 @@
         </p:nvSpPr>
         <p:spPr>
           <a:xfrm>
-            <a:off x="7315200" y="2926080"/>
-            <a:ext cx="4343400" cy="1298448"/>
+            <a:off x="7406640" y="2670048"/>
+            <a:ext cx="4251960" cy="1078992"/>
           </a:xfrm>
           <a:prstGeom prst="roundRect">
             <a:avLst>
-              <a:gd name="adj" fmla="val 4225"/>
+              <a:gd name="adj" fmla="val 5085"/>
             </a:avLst>
           </a:prstGeom>
           <a:solidFill>
@@ -13709,8 +13837,8 @@
         </p:nvSpPr>
         <p:spPr>
           <a:xfrm>
-            <a:off x="7498080" y="3017520"/>
-            <a:ext cx="4023360" cy="384048"/>
+            <a:off x="7589520" y="2743200"/>
+            <a:ext cx="3931920" cy="365760"/>
           </a:xfrm>
           <a:prstGeom prst="rect">
             <a:avLst/>
@@ -13734,7 +13862,7 @@
                 <a:ea typeface="PingFang SC" pitchFamily="34" charset="-122"/>
                 <a:cs typeface="PingFang SC" pitchFamily="34" charset="-120"/>
               </a:rPr>
-              <a:t>外围环异质性 +0.007(约 +10%)</a:t>
+              <a:t>外围环:设计可用</a:t>
             </a:r>
             <a:endParaRPr lang="en-US" sz="1500" dirty="0"/>
           </a:p>
@@ -13748,8 +13876,8 @@
         </p:nvSpPr>
         <p:spPr>
           <a:xfrm>
-            <a:off x="7498080" y="3429000"/>
-            <a:ext cx="4023360" cy="731520"/>
+            <a:off x="7589520" y="3127248"/>
+            <a:ext cx="3931920" cy="594360"/>
           </a:xfrm>
           <a:prstGeom prst="rect">
             <a:avLst/>
@@ -13765,7 +13893,7 @@
               <a:buNone/>
             </a:pPr>
             <a:r>
-              <a:rPr lang="en-US" sz="1150" dirty="0">
+              <a:rPr lang="en-US" sz="1100" dirty="0">
                 <a:solidFill>
                   <a:srgbClr val="1D2A33"/>
                 </a:solidFill>
@@ -13773,9 +13901,9 @@
                 <a:ea typeface="PingFang SC" pitchFamily="34" charset="-122"/>
                 <a:cs typeface="PingFang SC" pitchFamily="34" charset="-120"/>
               </a:rPr>
-              <a:t>外围 NDVI 均值不变;异质性上升,方向与 H3 同质化相反</a:t>
-            </a:r>
-            <a:endParaRPr lang="en-US" sz="1150" dirty="0"/>
+              <a:t>建设前平坦(p = 0.60);60–500 m 未检出外溢,−0.009(−0.026, 0.007)</a:t>
+            </a:r>
+            <a:endParaRPr lang="en-US" sz="1100" dirty="0"/>
           </a:p>
         </p:txBody>
       </p:sp>
@@ -13787,12 +13915,12 @@
         </p:nvSpPr>
         <p:spPr>
           <a:xfrm>
-            <a:off x="7315200" y="4389120"/>
-            <a:ext cx="4343400" cy="1298448"/>
+            <a:off x="7406640" y="3877056"/>
+            <a:ext cx="4251960" cy="1078992"/>
           </a:xfrm>
           <a:prstGeom prst="roundRect">
             <a:avLst>
-              <a:gd name="adj" fmla="val 4225"/>
+              <a:gd name="adj" fmla="val 5085"/>
             </a:avLst>
           </a:prstGeom>
           <a:solidFill>
@@ -13814,8 +13942,8 @@
         </p:nvSpPr>
         <p:spPr>
           <a:xfrm>
-            <a:off x="7498080" y="4480560"/>
-            <a:ext cx="4023360" cy="384048"/>
+            <a:off x="7589520" y="3950208"/>
+            <a:ext cx="3931920" cy="365760"/>
           </a:xfrm>
           <a:prstGeom prst="rect">
             <a:avLst/>
@@ -13839,7 +13967,7 @@
                 <a:ea typeface="PingFang SC" pitchFamily="34" charset="-122"/>
                 <a:cs typeface="PingFang SC" pitchFamily="34" charset="-120"/>
               </a:rPr>
-              <a:t>G2 有条件通过</a:t>
+              <a:t>异质性:未检出</a:t>
             </a:r>
             <a:endParaRPr lang="en-US" sz="1500" dirty="0"/>
           </a:p>
@@ -13853,8 +13981,8 @@
         </p:nvSpPr>
         <p:spPr>
           <a:xfrm>
-            <a:off x="7498080" y="4892040"/>
-            <a:ext cx="4023360" cy="731520"/>
+            <a:off x="7589520" y="4334256"/>
+            <a:ext cx="3931920" cy="594360"/>
           </a:xfrm>
           <a:prstGeom prst="rect">
             <a:avLst/>
@@ -13870,7 +13998,7 @@
               <a:buNone/>
             </a:pPr>
             <a:r>
-              <a:rPr lang="en-US" sz="1150" dirty="0">
+              <a:rPr lang="en-US" sz="1100" dirty="0">
                 <a:solidFill>
                   <a:srgbClr val="1D2A33"/>
                 </a:solidFill>
@@ -13878,7 +14006,46 @@
                 <a:ea typeface="PingFang SC" pitchFamily="34" charset="-122"/>
                 <a:cs typeface="PingFang SC" pitchFamily="34" charset="-120"/>
               </a:rPr>
-              <a:t>e = −1 已先降一个台阶(清表早于面板可见);留出检验仍拒绝,稳健性靠 HonestDiD 的界</a:t>
+              <a:t>站内与外围环 NDVI 标准差均无变化;H3 未获支持也未被否定</a:t>
+            </a:r>
+            <a:endParaRPr lang="en-US" sz="1100" dirty="0"/>
+          </a:p>
+        </p:txBody>
+      </p:sp>
+      <p:sp>
+        <p:nvSpPr>
+          <p:cNvPr id="14" name="Text 11"/>
+          <p:cNvSpPr/>
+          <p:nvPr/>
+        </p:nvSpPr>
+        <p:spPr>
+          <a:xfrm>
+            <a:off x="7406640" y="5120640"/>
+            <a:ext cx="4251960" cy="914400"/>
+          </a:xfrm>
+          <a:prstGeom prst="rect">
+            <a:avLst/>
+          </a:prstGeom>
+          <a:noFill/>
+          <a:ln/>
+        </p:spPr>
+        <p:txBody>
+          <a:bodyPr wrap="square" lIns="0" tIns="0" rIns="0" bIns="0" rtlCol="0" anchor="ctr"/>
+          <a:lstStyle/>
+          <a:p>
+            <a:pPr indent="0" marL="0">
+              <a:buNone/>
+            </a:pPr>
+            <a:r>
+              <a:rPr lang="en-US" sz="1150" b="1" dirty="0">
+                <a:solidFill>
+                  <a:srgbClr val="1F6F78"/>
+                </a:solidFill>
+                <a:latin typeface="PingFang SC" pitchFamily="34" charset="0"/>
+                <a:ea typeface="PingFang SC" pitchFamily="34" charset="-122"/>
+                <a:cs typeface="PingFang SC" pitchFamily="34" charset="-120"/>
+              </a:rPr>
+              <a:t>修改:按建设前 NDVI 轨迹与选址变量匹配从未建设点;前期延至 2010;站内改用 10 m 板间像元;HonestDiD 报告界。</a:t>
             </a:r>
             <a:endParaRPr lang="en-US" sz="1150" dirty="0"/>
           </a:p>
@@ -13886,7 +14053,7 @@
       </p:sp>
       <p:sp>
         <p:nvSpPr>
-          <p:cNvPr id="14" name="Text 11"/>
+          <p:cNvPr id="15" name="Text 12"/>
           <p:cNvSpPr/>
           <p:nvPr/>
         </p:nvSpPr>
@@ -14835,7 +15002,7 @@
                 <a:ea typeface="PingFang SC" pitchFamily="34" charset="-122"/>
                 <a:cs typeface="PingFang SC" pitchFamily="34" charset="-120"/>
               </a:rPr>
-              <a:t>鸟类:站点层面的近远区对照与多物种占域</a:t>
+              <a:t>修正版:匹配的从未建设对照 + HonestDiD</a:t>
             </a:r>
             <a:endParaRPr lang="en-US" sz="3000" dirty="0"/>
           </a:p>
@@ -14874,6 +15041,487 @@
                 <a:ea typeface="PingFang SC" pitchFamily="34" charset="-122"/>
                 <a:cs typeface="PingFang SC" pitchFamily="34" charset="-120"/>
               </a:rPr>
+              <a:t>362 站 vs 530 个匹配点(2010–2016 NDVI 轨迹、PVOUT、坡度、海拔;省份与 CLCD 覆盖精确匹配);1 年预期期</a:t>
+            </a:r>
+            <a:endParaRPr lang="en-US" sz="1400" dirty="0"/>
+          </a:p>
+        </p:txBody>
+      </p:sp>
+      <p:pic>
+        <p:nvPicPr>
+          <p:cNvPr id="4" name="Image 0" descr="results/figures/pilot_nw_matched.png">    </p:cNvPr>
+          <p:cNvPicPr>
+            <a:picLocks noChangeAspect="1"/>
+          </p:cNvPicPr>
+          <p:nvPr/>
+        </p:nvPicPr>
+        <p:blipFill>
+          <a:blip r:embed="rId1"/>
+          <a:stretch>
+            <a:fillRect/>
+          </a:stretch>
+        </p:blipFill>
+        <p:spPr>
+          <a:xfrm>
+            <a:off x="457200" y="1417320"/>
+            <a:ext cx="6583680" cy="4773168"/>
+          </a:xfrm>
+          <a:prstGeom prst="rect">
+            <a:avLst/>
+          </a:prstGeom>
+        </p:spPr>
+      </p:pic>
+      <p:sp>
+        <p:nvSpPr>
+          <p:cNvPr id="5" name="Shape 2"/>
+          <p:cNvSpPr/>
+          <p:nvPr/>
+        </p:nvSpPr>
+        <p:spPr>
+          <a:xfrm>
+            <a:off x="7315200" y="1463040"/>
+            <a:ext cx="4343400" cy="1298448"/>
+          </a:xfrm>
+          <a:prstGeom prst="roundRect">
+            <a:avLst>
+              <a:gd name="adj" fmla="val 4225"/>
+            </a:avLst>
+          </a:prstGeom>
+          <a:solidFill>
+            <a:srgbClr val="F3E7E4"/>
+          </a:solidFill>
+          <a:ln w="12700">
+            <a:solidFill>
+              <a:srgbClr val="F3E7E4"/>
+            </a:solidFill>
+            <a:prstDash val="solid"/>
+          </a:ln>
+        </p:spPr>
+      </p:sp>
+      <p:sp>
+        <p:nvSpPr>
+          <p:cNvPr id="6" name="Text 3"/>
+          <p:cNvSpPr/>
+          <p:nvPr/>
+        </p:nvSpPr>
+        <p:spPr>
+          <a:xfrm>
+            <a:off x="7498080" y="1554480"/>
+            <a:ext cx="4023360" cy="384048"/>
+          </a:xfrm>
+          <a:prstGeom prst="rect">
+            <a:avLst/>
+          </a:prstGeom>
+          <a:noFill/>
+          <a:ln/>
+        </p:spPr>
+        <p:txBody>
+          <a:bodyPr wrap="square" lIns="0" tIns="0" rIns="0" bIns="0" rtlCol="0" anchor="ctr"/>
+          <a:lstStyle/>
+          <a:p>
+            <a:pPr indent="0" marL="0">
+              <a:buNone/>
+            </a:pPr>
+            <a:r>
+              <a:rPr lang="en-US" sz="1500" b="1" dirty="0">
+                <a:solidFill>
+                  <a:srgbClr val="0E2F3C"/>
+                </a:solidFill>
+                <a:latin typeface="PingFang SC" pitchFamily="34" charset="0"/>
+                <a:ea typeface="PingFang SC" pitchFamily="34" charset="-122"/>
+                <a:cs typeface="PingFang SC" pitchFamily="34" charset="-120"/>
+              </a:rPr>
+              <a:t>站内 NDVI −0.029(约 −11%)</a:t>
+            </a:r>
+            <a:endParaRPr lang="en-US" sz="1500" dirty="0"/>
+          </a:p>
+        </p:txBody>
+      </p:sp>
+      <p:sp>
+        <p:nvSpPr>
+          <p:cNvPr id="7" name="Text 4"/>
+          <p:cNvSpPr/>
+          <p:nvPr/>
+        </p:nvSpPr>
+        <p:spPr>
+          <a:xfrm>
+            <a:off x="7498080" y="1965960"/>
+            <a:ext cx="4023360" cy="731520"/>
+          </a:xfrm>
+          <a:prstGeom prst="rect">
+            <a:avLst/>
+          </a:prstGeom>
+          <a:noFill/>
+          <a:ln/>
+        </p:spPr>
+        <p:txBody>
+          <a:bodyPr wrap="square" lIns="0" tIns="0" rIns="0" bIns="0" rtlCol="0" anchor="ctr"/>
+          <a:lstStyle/>
+          <a:p>
+            <a:pPr indent="0" marL="0">
+              <a:buNone/>
+            </a:pPr>
+            <a:r>
+              <a:rPr lang="en-US" sz="1150" dirty="0">
+                <a:solidFill>
+                  <a:srgbClr val="1D2A33"/>
+                </a:solidFill>
+                <a:latin typeface="PingFang SC" pitchFamily="34" charset="0"/>
+                <a:ea typeface="PingFang SC" pitchFamily="34" charset="-122"/>
+                <a:cs typeface="PingFang SC" pitchFamily="34" charset="-120"/>
+              </a:rPr>
+              <a:t>95% CI −0.043 至 −0.016;HonestDiD 在 Mbar = 0.5 仍显著(−0.054, −0.002)</a:t>
+            </a:r>
+            <a:endParaRPr lang="en-US" sz="1150" dirty="0"/>
+          </a:p>
+        </p:txBody>
+      </p:sp>
+      <p:sp>
+        <p:nvSpPr>
+          <p:cNvPr id="8" name="Shape 5"/>
+          <p:cNvSpPr/>
+          <p:nvPr/>
+        </p:nvSpPr>
+        <p:spPr>
+          <a:xfrm>
+            <a:off x="7315200" y="2926080"/>
+            <a:ext cx="4343400" cy="1298448"/>
+          </a:xfrm>
+          <a:prstGeom prst="roundRect">
+            <a:avLst>
+              <a:gd name="adj" fmla="val 4225"/>
+            </a:avLst>
+          </a:prstGeom>
+          <a:solidFill>
+            <a:srgbClr val="EEF4F4"/>
+          </a:solidFill>
+          <a:ln w="12700">
+            <a:solidFill>
+              <a:srgbClr val="EEF4F4"/>
+            </a:solidFill>
+            <a:prstDash val="solid"/>
+          </a:ln>
+        </p:spPr>
+      </p:sp>
+      <p:sp>
+        <p:nvSpPr>
+          <p:cNvPr id="9" name="Text 6"/>
+          <p:cNvSpPr/>
+          <p:nvPr/>
+        </p:nvSpPr>
+        <p:spPr>
+          <a:xfrm>
+            <a:off x="7498080" y="3017520"/>
+            <a:ext cx="4023360" cy="384048"/>
+          </a:xfrm>
+          <a:prstGeom prst="rect">
+            <a:avLst/>
+          </a:prstGeom>
+          <a:noFill/>
+          <a:ln/>
+        </p:spPr>
+        <p:txBody>
+          <a:bodyPr wrap="square" lIns="0" tIns="0" rIns="0" bIns="0" rtlCol="0" anchor="ctr"/>
+          <a:lstStyle/>
+          <a:p>
+            <a:pPr indent="0" marL="0">
+              <a:buNone/>
+            </a:pPr>
+            <a:r>
+              <a:rPr lang="en-US" sz="1500" b="1" dirty="0">
+                <a:solidFill>
+                  <a:srgbClr val="0E2F3C"/>
+                </a:solidFill>
+                <a:latin typeface="PingFang SC" pitchFamily="34" charset="0"/>
+                <a:ea typeface="PingFang SC" pitchFamily="34" charset="-122"/>
+                <a:cs typeface="PingFang SC" pitchFamily="34" charset="-120"/>
+              </a:rPr>
+              <a:t>外围环异质性 +0.007(约 +10%)</a:t>
+            </a:r>
+            <a:endParaRPr lang="en-US" sz="1500" dirty="0"/>
+          </a:p>
+        </p:txBody>
+      </p:sp>
+      <p:sp>
+        <p:nvSpPr>
+          <p:cNvPr id="10" name="Text 7"/>
+          <p:cNvSpPr/>
+          <p:nvPr/>
+        </p:nvSpPr>
+        <p:spPr>
+          <a:xfrm>
+            <a:off x="7498080" y="3429000"/>
+            <a:ext cx="4023360" cy="731520"/>
+          </a:xfrm>
+          <a:prstGeom prst="rect">
+            <a:avLst/>
+          </a:prstGeom>
+          <a:noFill/>
+          <a:ln/>
+        </p:spPr>
+        <p:txBody>
+          <a:bodyPr wrap="square" lIns="0" tIns="0" rIns="0" bIns="0" rtlCol="0" anchor="ctr"/>
+          <a:lstStyle/>
+          <a:p>
+            <a:pPr indent="0" marL="0">
+              <a:buNone/>
+            </a:pPr>
+            <a:r>
+              <a:rPr lang="en-US" sz="1150" dirty="0">
+                <a:solidFill>
+                  <a:srgbClr val="1D2A33"/>
+                </a:solidFill>
+                <a:latin typeface="PingFang SC" pitchFamily="34" charset="0"/>
+                <a:ea typeface="PingFang SC" pitchFamily="34" charset="-122"/>
+                <a:cs typeface="PingFang SC" pitchFamily="34" charset="-120"/>
+              </a:rPr>
+              <a:t>外围 NDVI 均值不变;异质性上升,方向与 H3 同质化相反</a:t>
+            </a:r>
+            <a:endParaRPr lang="en-US" sz="1150" dirty="0"/>
+          </a:p>
+        </p:txBody>
+      </p:sp>
+      <p:sp>
+        <p:nvSpPr>
+          <p:cNvPr id="11" name="Shape 8"/>
+          <p:cNvSpPr/>
+          <p:nvPr/>
+        </p:nvSpPr>
+        <p:spPr>
+          <a:xfrm>
+            <a:off x="7315200" y="4389120"/>
+            <a:ext cx="4343400" cy="1298448"/>
+          </a:xfrm>
+          <a:prstGeom prst="roundRect">
+            <a:avLst>
+              <a:gd name="adj" fmla="val 4225"/>
+            </a:avLst>
+          </a:prstGeom>
+          <a:solidFill>
+            <a:srgbClr val="FBF1DF"/>
+          </a:solidFill>
+          <a:ln w="12700">
+            <a:solidFill>
+              <a:srgbClr val="FBF1DF"/>
+            </a:solidFill>
+            <a:prstDash val="solid"/>
+          </a:ln>
+        </p:spPr>
+      </p:sp>
+      <p:sp>
+        <p:nvSpPr>
+          <p:cNvPr id="12" name="Text 9"/>
+          <p:cNvSpPr/>
+          <p:nvPr/>
+        </p:nvSpPr>
+        <p:spPr>
+          <a:xfrm>
+            <a:off x="7498080" y="4480560"/>
+            <a:ext cx="4023360" cy="384048"/>
+          </a:xfrm>
+          <a:prstGeom prst="rect">
+            <a:avLst/>
+          </a:prstGeom>
+          <a:noFill/>
+          <a:ln/>
+        </p:spPr>
+        <p:txBody>
+          <a:bodyPr wrap="square" lIns="0" tIns="0" rIns="0" bIns="0" rtlCol="0" anchor="ctr"/>
+          <a:lstStyle/>
+          <a:p>
+            <a:pPr indent="0" marL="0">
+              <a:buNone/>
+            </a:pPr>
+            <a:r>
+              <a:rPr lang="en-US" sz="1500" b="1" dirty="0">
+                <a:solidFill>
+                  <a:srgbClr val="0E2F3C"/>
+                </a:solidFill>
+                <a:latin typeface="PingFang SC" pitchFamily="34" charset="0"/>
+                <a:ea typeface="PingFang SC" pitchFamily="34" charset="-122"/>
+                <a:cs typeface="PingFang SC" pitchFamily="34" charset="-120"/>
+              </a:rPr>
+              <a:t>G2 有条件通过</a:t>
+            </a:r>
+            <a:endParaRPr lang="en-US" sz="1500" dirty="0"/>
+          </a:p>
+        </p:txBody>
+      </p:sp>
+      <p:sp>
+        <p:nvSpPr>
+          <p:cNvPr id="13" name="Text 10"/>
+          <p:cNvSpPr/>
+          <p:nvPr/>
+        </p:nvSpPr>
+        <p:spPr>
+          <a:xfrm>
+            <a:off x="7498080" y="4892040"/>
+            <a:ext cx="4023360" cy="731520"/>
+          </a:xfrm>
+          <a:prstGeom prst="rect">
+            <a:avLst/>
+          </a:prstGeom>
+          <a:noFill/>
+          <a:ln/>
+        </p:spPr>
+        <p:txBody>
+          <a:bodyPr wrap="square" lIns="0" tIns="0" rIns="0" bIns="0" rtlCol="0" anchor="ctr"/>
+          <a:lstStyle/>
+          <a:p>
+            <a:pPr indent="0" marL="0">
+              <a:buNone/>
+            </a:pPr>
+            <a:r>
+              <a:rPr lang="en-US" sz="1150" dirty="0">
+                <a:solidFill>
+                  <a:srgbClr val="1D2A33"/>
+                </a:solidFill>
+                <a:latin typeface="PingFang SC" pitchFamily="34" charset="0"/>
+                <a:ea typeface="PingFang SC" pitchFamily="34" charset="-122"/>
+                <a:cs typeface="PingFang SC" pitchFamily="34" charset="-120"/>
+              </a:rPr>
+              <a:t>e = −1 已先降一个台阶(清表早于面板可见);留出检验仍拒绝,稳健性靠 HonestDiD 的界</a:t>
+            </a:r>
+            <a:endParaRPr lang="en-US" sz="1150" dirty="0"/>
+          </a:p>
+        </p:txBody>
+      </p:sp>
+      <p:sp>
+        <p:nvSpPr>
+          <p:cNvPr id="14" name="Text 11"/>
+          <p:cNvSpPr/>
+          <p:nvPr/>
+        </p:nvSpPr>
+        <p:spPr>
+          <a:xfrm>
+            <a:off x="11277295" y="6400800"/>
+            <a:ext cx="457200" cy="274320"/>
+          </a:xfrm>
+          <a:prstGeom prst="rect">
+            <a:avLst/>
+          </a:prstGeom>
+          <a:noFill/>
+          <a:ln/>
+        </p:spPr>
+        <p:txBody>
+          <a:bodyPr wrap="square" lIns="0" tIns="0" rIns="0" bIns="0" rtlCol="0" anchor="ctr"/>
+          <a:lstStyle/>
+          <a:p>
+            <a:pPr algn="r" indent="0" marL="0">
+              <a:buNone/>
+            </a:pPr>
+            <a:r>
+              <a:rPr lang="en-US" sz="1000" dirty="0">
+                <a:solidFill>
+                  <a:srgbClr val="5E6B75"/>
+                </a:solidFill>
+                <a:latin typeface="Arial" pitchFamily="34" charset="0"/>
+                <a:ea typeface="Arial" pitchFamily="34" charset="-122"/>
+                <a:cs typeface="Arial" pitchFamily="34" charset="-120"/>
+              </a:rPr>
+              <a:t>20</a:t>
+            </a:r>
+            <a:endParaRPr lang="en-US" sz="1000" dirty="0"/>
+          </a:p>
+        </p:txBody>
+      </p:sp>
+    </p:spTree>
+  </p:cSld>
+  <p:clrMapOvr>
+    <a:masterClrMapping/>
+  </p:clrMapOvr>
+</p:sld>
+</file>
+
+<file path=ppt/slides/slide21.xml><?xml version="1.0" encoding="utf-8"?>
+<p:sld xmlns:a="http://schemas.openxmlformats.org/drawingml/2006/main" xmlns:r="http://schemas.openxmlformats.org/officeDocument/2006/relationships" xmlns:p="http://schemas.openxmlformats.org/presentationml/2006/main">
+  <p:cSld name="Slide 21">
+    <p:spTree>
+      <p:nvGrpSpPr>
+        <p:cNvPr id="1" name=""/>
+        <p:cNvGrpSpPr/>
+        <p:nvPr/>
+      </p:nvGrpSpPr>
+      <p:grpSpPr>
+        <a:xfrm>
+          <a:off x="0" y="0"/>
+          <a:ext cx="0" cy="0"/>
+          <a:chOff x="0" y="0"/>
+          <a:chExt cx="0" cy="0"/>
+        </a:xfrm>
+      </p:grpSpPr>
+      <p:sp>
+        <p:nvSpPr>
+          <p:cNvPr id="2" name="Text 0"/>
+          <p:cNvSpPr/>
+          <p:nvPr/>
+        </p:nvSpPr>
+        <p:spPr>
+          <a:xfrm>
+            <a:off x="548640" y="320040"/>
+            <a:ext cx="11094415" cy="685800"/>
+          </a:xfrm>
+          <a:prstGeom prst="rect">
+            <a:avLst/>
+          </a:prstGeom>
+          <a:noFill/>
+          <a:ln/>
+        </p:spPr>
+        <p:txBody>
+          <a:bodyPr wrap="square" lIns="0" tIns="0" rIns="0" bIns="0" rtlCol="0" anchor="ctr"/>
+          <a:lstStyle/>
+          <a:p>
+            <a:pPr indent="0" marL="0">
+              <a:buNone/>
+            </a:pPr>
+            <a:r>
+              <a:rPr lang="en-US" sz="3000" b="1" dirty="0">
+                <a:solidFill>
+                  <a:srgbClr val="0E2F3C"/>
+                </a:solidFill>
+                <a:latin typeface="PingFang SC" pitchFamily="34" charset="0"/>
+                <a:ea typeface="PingFang SC" pitchFamily="34" charset="-122"/>
+                <a:cs typeface="PingFang SC" pitchFamily="34" charset="-120"/>
+              </a:rPr>
+              <a:t>鸟类:站点层面的近远区对照与多物种占域</a:t>
+            </a:r>
+            <a:endParaRPr lang="en-US" sz="3000" dirty="0"/>
+          </a:p>
+        </p:txBody>
+      </p:sp>
+      <p:sp>
+        <p:nvSpPr>
+          <p:cNvPr id="3" name="Text 1"/>
+          <p:cNvSpPr/>
+          <p:nvPr/>
+        </p:nvSpPr>
+        <p:spPr>
+          <a:xfrm>
+            <a:off x="548640" y="960120"/>
+            <a:ext cx="11094415" cy="365760"/>
+          </a:xfrm>
+          <a:prstGeom prst="rect">
+            <a:avLst/>
+          </a:prstGeom>
+          <a:noFill/>
+          <a:ln/>
+        </p:spPr>
+        <p:txBody>
+          <a:bodyPr wrap="square" lIns="0" tIns="0" rIns="0" bIns="0" rtlCol="0" anchor="ctr"/>
+          <a:lstStyle/>
+          <a:p>
+            <a:pPr indent="0" marL="0">
+              <a:buNone/>
+            </a:pPr>
+            <a:r>
+              <a:rPr lang="en-US" sz="1400" dirty="0">
+                <a:solidFill>
+                  <a:srgbClr val="5E6B75"/>
+                </a:solidFill>
+                <a:latin typeface="PingFang SC" pitchFamily="34" charset="0"/>
+                <a:ea typeface="PingFang SC" pitchFamily="34" charset="-122"/>
+                <a:cs typeface="PingFang SC" pitchFamily="34" charset="-120"/>
+              </a:rPr>
               <a:t>近区 0–5 km vs 远区 8–20 km,站点 × 年份固定效应;CBRC + eBird/GBIF 合并去重清单</a:t>
             </a:r>
             <a:endParaRPr lang="en-US" sz="1400" dirty="0"/>
@@ -14882,7 +15530,7 @@
       </p:sp>
       <p:graphicFrame>
         <p:nvGraphicFramePr>
-          <p:cNvPr id="21" name="Table 0"/>
+          <p:cNvPr id="22" name="Table 0"/>
           <p:cNvGraphicFramePr>
             <a:graphicFrameLocks noGrp="1"/>
           </p:cNvGraphicFramePr>
@@ -16106,526 +16754,6 @@
                 <a:ea typeface="Arial" pitchFamily="34" charset="-122"/>
                 <a:cs typeface="Arial" pitchFamily="34" charset="-120"/>
               </a:rPr>
-              <a:t>20</a:t>
-            </a:r>
-            <a:endParaRPr lang="en-US" sz="1000" dirty="0"/>
-          </a:p>
-        </p:txBody>
-      </p:sp>
-    </p:spTree>
-  </p:cSld>
-  <p:clrMapOvr>
-    <a:masterClrMapping/>
-  </p:clrMapOvr>
-</p:sld>
-</file>
-
-<file path=ppt/slides/slide21.xml><?xml version="1.0" encoding="utf-8"?>
-<p:sld xmlns:a="http://schemas.openxmlformats.org/drawingml/2006/main" xmlns:r="http://schemas.openxmlformats.org/officeDocument/2006/relationships" xmlns:p="http://schemas.openxmlformats.org/presentationml/2006/main">
-  <p:cSld name="Slide 21">
-    <p:spTree>
-      <p:nvGrpSpPr>
-        <p:cNvPr id="1" name=""/>
-        <p:cNvGrpSpPr/>
-        <p:nvPr/>
-      </p:nvGrpSpPr>
-      <p:grpSpPr>
-        <a:xfrm>
-          <a:off x="0" y="0"/>
-          <a:ext cx="0" cy="0"/>
-          <a:chOff x="0" y="0"/>
-          <a:chExt cx="0" cy="0"/>
-        </a:xfrm>
-      </p:grpSpPr>
-      <p:sp>
-        <p:nvSpPr>
-          <p:cNvPr id="2" name="Text 0"/>
-          <p:cNvSpPr/>
-          <p:nvPr/>
-        </p:nvSpPr>
-        <p:spPr>
-          <a:xfrm>
-            <a:off x="548640" y="320040"/>
-            <a:ext cx="11094415" cy="685800"/>
-          </a:xfrm>
-          <a:prstGeom prst="rect">
-            <a:avLst/>
-          </a:prstGeom>
-          <a:noFill/>
-          <a:ln/>
-        </p:spPr>
-        <p:txBody>
-          <a:bodyPr wrap="square" lIns="0" tIns="0" rIns="0" bIns="0" rtlCol="0" anchor="ctr"/>
-          <a:lstStyle/>
-          <a:p>
-            <a:pPr indent="0" marL="0">
-              <a:buNone/>
-            </a:pPr>
-            <a:r>
-              <a:rPr lang="en-US" sz="3000" b="1" dirty="0">
-                <a:solidFill>
-                  <a:srgbClr val="0E2F3C"/>
-                </a:solidFill>
-                <a:latin typeface="PingFang SC" pitchFamily="34" charset="0"/>
-                <a:ea typeface="PingFang SC" pitchFamily="34" charset="-122"/>
-                <a:cs typeface="PingFang SC" pitchFamily="34" charset="-120"/>
-              </a:rPr>
-              <a:t>鸟类丰度型多样性:Science 指标 + 评论文章的清洗与努力校正</a:t>
-            </a:r>
-            <a:endParaRPr lang="en-US" sz="3000" dirty="0"/>
-          </a:p>
-        </p:txBody>
-      </p:sp>
-      <p:sp>
-        <p:nvSpPr>
-          <p:cNvPr id="3" name="Text 1"/>
-          <p:cNvSpPr/>
-          <p:nvPr/>
-        </p:nvSpPr>
-        <p:spPr>
-          <a:xfrm>
-            <a:off x="548640" y="960120"/>
-            <a:ext cx="11094415" cy="365760"/>
-          </a:xfrm>
-          <a:prstGeom prst="rect">
-            <a:avLst/>
-          </a:prstGeom>
-          <a:noFill/>
-          <a:ln/>
-        </p:spPr>
-        <p:txBody>
-          <a:bodyPr wrap="square" lIns="0" tIns="0" rIns="0" bIns="0" rtlCol="0" anchor="ctr"/>
-          <a:lstStyle/>
-          <a:p>
-            <a:pPr indent="0" marL="0">
-              <a:buNone/>
-            </a:pPr>
-            <a:r>
-              <a:rPr lang="en-US" sz="1400" dirty="0">
-                <a:solidFill>
-                  <a:srgbClr val="5E6B75"/>
-                </a:solidFill>
-                <a:latin typeface="PingFang SC" pitchFamily="34" charset="0"/>
-                <a:ea typeface="PingFang SC" pitchFamily="34" charset="-122"/>
-                <a:cs typeface="PingFang SC" pitchFamily="34" charset="-120"/>
-              </a:rPr>
-              <a:t>同一近远区设计;38 站 33,327 份清单 → 合并重复 26,972 → 剔除仅记有无 5,767 → 21,205 次调查</a:t>
-            </a:r>
-            <a:endParaRPr lang="en-US" sz="1400" dirty="0"/>
-          </a:p>
-        </p:txBody>
-      </p:sp>
-      <p:pic>
-        <p:nvPicPr>
-          <p:cNvPr id="4" name="Image 0" descr="results/figures/site_birds_abundance.png">    </p:cNvPr>
-          <p:cNvPicPr>
-            <a:picLocks noChangeAspect="1"/>
-          </p:cNvPicPr>
-          <p:nvPr/>
-        </p:nvPicPr>
-        <p:blipFill>
-          <a:blip r:embed="rId1"/>
-          <a:stretch>
-            <a:fillRect/>
-          </a:stretch>
-        </p:blipFill>
-        <p:spPr>
-          <a:xfrm>
-            <a:off x="457200" y="1417320"/>
-            <a:ext cx="7315200" cy="3511296"/>
-          </a:xfrm>
-          <a:prstGeom prst="rect">
-            <a:avLst/>
-          </a:prstGeom>
-        </p:spPr>
-      </p:pic>
-      <p:sp>
-        <p:nvSpPr>
-          <p:cNvPr id="5" name="Shape 2"/>
-          <p:cNvSpPr/>
-          <p:nvPr/>
-        </p:nvSpPr>
-        <p:spPr>
-          <a:xfrm>
-            <a:off x="8046720" y="1463040"/>
-            <a:ext cx="3611880" cy="1207008"/>
-          </a:xfrm>
-          <a:prstGeom prst="roundRect">
-            <a:avLst>
-              <a:gd name="adj" fmla="val 4545"/>
-            </a:avLst>
-          </a:prstGeom>
-          <a:solidFill>
-            <a:srgbClr val="EEF4F4"/>
-          </a:solidFill>
-          <a:ln w="12700">
-            <a:solidFill>
-              <a:srgbClr val="EEF4F4"/>
-            </a:solidFill>
-            <a:prstDash val="solid"/>
-          </a:ln>
-        </p:spPr>
-      </p:sp>
-      <p:sp>
-        <p:nvSpPr>
-          <p:cNvPr id="6" name="Text 3"/>
-          <p:cNvSpPr/>
-          <p:nvPr/>
-        </p:nvSpPr>
-        <p:spPr>
-          <a:xfrm>
-            <a:off x="8229600" y="1554480"/>
-            <a:ext cx="3291840" cy="365760"/>
-          </a:xfrm>
-          <a:prstGeom prst="rect">
-            <a:avLst/>
-          </a:prstGeom>
-          <a:noFill/>
-          <a:ln/>
-        </p:spPr>
-        <p:txBody>
-          <a:bodyPr wrap="square" lIns="0" tIns="0" rIns="0" bIns="0" rtlCol="0" anchor="ctr"/>
-          <a:lstStyle/>
-          <a:p>
-            <a:pPr indent="0" marL="0">
-              <a:buNone/>
-            </a:pPr>
-            <a:r>
-              <a:rPr lang="en-US" sz="1400" b="1" dirty="0">
-                <a:solidFill>
-                  <a:srgbClr val="0E2F3C"/>
-                </a:solidFill>
-                <a:latin typeface="PingFang SC" pitchFamily="34" charset="0"/>
-                <a:ea typeface="PingFang SC" pitchFamily="34" charset="-122"/>
-                <a:cs typeface="PingFang SC" pitchFamily="34" charset="-120"/>
-              </a:rPr>
-              <a:t>全部与零无差异</a:t>
-            </a:r>
-            <a:endParaRPr lang="en-US" sz="1400" dirty="0"/>
-          </a:p>
-        </p:txBody>
-      </p:sp>
-      <p:sp>
-        <p:nvSpPr>
-          <p:cNvPr id="7" name="Text 4"/>
-          <p:cNvSpPr/>
-          <p:nvPr/>
-        </p:nvSpPr>
-        <p:spPr>
-          <a:xfrm>
-            <a:off x="8229600" y="1920240"/>
-            <a:ext cx="3291840" cy="713232"/>
-          </a:xfrm>
-          <a:prstGeom prst="rect">
-            <a:avLst/>
-          </a:prstGeom>
-          <a:noFill/>
-          <a:ln/>
-        </p:spPr>
-        <p:txBody>
-          <a:bodyPr wrap="square" lIns="0" tIns="0" rIns="0" bIns="0" rtlCol="0" anchor="ctr"/>
-          <a:lstStyle/>
-          <a:p>
-            <a:pPr indent="0" marL="0">
-              <a:buNone/>
-            </a:pPr>
-            <a:r>
-              <a:rPr lang="en-US" sz="1100" dirty="0">
-                <a:solidFill>
-                  <a:srgbClr val="1D2A33"/>
-                </a:solidFill>
-                <a:latin typeface="PingFang SC" pitchFamily="34" charset="0"/>
-                <a:ea typeface="PingFang SC" pitchFamily="34" charset="-122"/>
-                <a:cs typeface="PingFang SC" pitchFamily="34" charset="-120"/>
-              </a:rPr>
-              <a:t>朴素 Shannon、清洗后 q = 1/2、观察者 FE、覆盖度标准化 q = 0/1/2;24 站结果一致</a:t>
-            </a:r>
-            <a:endParaRPr lang="en-US" sz="1100" dirty="0"/>
-          </a:p>
-        </p:txBody>
-      </p:sp>
-      <p:sp>
-        <p:nvSpPr>
-          <p:cNvPr id="8" name="Shape 5"/>
-          <p:cNvSpPr/>
-          <p:nvPr/>
-        </p:nvSpPr>
-        <p:spPr>
-          <a:xfrm>
-            <a:off x="8046720" y="2834640"/>
-            <a:ext cx="3611880" cy="1207008"/>
-          </a:xfrm>
-          <a:prstGeom prst="roundRect">
-            <a:avLst>
-              <a:gd name="adj" fmla="val 4545"/>
-            </a:avLst>
-          </a:prstGeom>
-          <a:solidFill>
-            <a:srgbClr val="FBF1DF"/>
-          </a:solidFill>
-          <a:ln w="12700">
-            <a:solidFill>
-              <a:srgbClr val="FBF1DF"/>
-            </a:solidFill>
-            <a:prstDash val="solid"/>
-          </a:ln>
-        </p:spPr>
-      </p:sp>
-      <p:sp>
-        <p:nvSpPr>
-          <p:cNvPr id="9" name="Text 6"/>
-          <p:cNvSpPr/>
-          <p:nvPr/>
-        </p:nvSpPr>
-        <p:spPr>
-          <a:xfrm>
-            <a:off x="8229600" y="2926080"/>
-            <a:ext cx="3291840" cy="365760"/>
-          </a:xfrm>
-          <a:prstGeom prst="rect">
-            <a:avLst/>
-          </a:prstGeom>
-          <a:noFill/>
-          <a:ln/>
-        </p:spPr>
-        <p:txBody>
-          <a:bodyPr wrap="square" lIns="0" tIns="0" rIns="0" bIns="0" rtlCol="0" anchor="ctr"/>
-          <a:lstStyle/>
-          <a:p>
-            <a:pPr indent="0" marL="0">
-              <a:buNone/>
-            </a:pPr>
-            <a:r>
-              <a:rPr lang="en-US" sz="1400" b="1" dirty="0">
-                <a:solidFill>
-                  <a:srgbClr val="0E2F3C"/>
-                </a:solidFill>
-                <a:latin typeface="PingFang SC" pitchFamily="34" charset="0"/>
-                <a:ea typeface="PingFang SC" pitchFamily="34" charset="-122"/>
-                <a:cs typeface="PingFang SC" pitchFamily="34" charset="-120"/>
-              </a:rPr>
-              <a:t>总个体数 −14%(n.s.)</a:t>
-            </a:r>
-            <a:endParaRPr lang="en-US" sz="1400" dirty="0"/>
-          </a:p>
-        </p:txBody>
-      </p:sp>
-      <p:sp>
-        <p:nvSpPr>
-          <p:cNvPr id="10" name="Text 7"/>
-          <p:cNvSpPr/>
-          <p:nvPr/>
-        </p:nvSpPr>
-        <p:spPr>
-          <a:xfrm>
-            <a:off x="8229600" y="3291840"/>
-            <a:ext cx="3291840" cy="713232"/>
-          </a:xfrm>
-          <a:prstGeom prst="rect">
-            <a:avLst/>
-          </a:prstGeom>
-          <a:noFill/>
-          <a:ln/>
-        </p:spPr>
-        <p:txBody>
-          <a:bodyPr wrap="square" lIns="0" tIns="0" rIns="0" bIns="0" rtlCol="0" anchor="ctr"/>
-          <a:lstStyle/>
-          <a:p>
-            <a:pPr indent="0" marL="0">
-              <a:buNone/>
-            </a:pPr>
-            <a:r>
-              <a:rPr lang="en-US" sz="1100" dirty="0">
-                <a:solidFill>
-                  <a:srgbClr val="1D2A33"/>
-                </a:solidFill>
-                <a:latin typeface="PingFang SC" pitchFamily="34" charset="0"/>
-                <a:ea typeface="PingFang SC" pitchFamily="34" charset="-122"/>
-                <a:cs typeface="PingFang SC" pitchFamily="34" charset="-120"/>
-              </a:rPr>
-              <a:t>两个样本方向一致,区间很宽</a:t>
-            </a:r>
-            <a:endParaRPr lang="en-US" sz="1100" dirty="0"/>
-          </a:p>
-        </p:txBody>
-      </p:sp>
-      <p:sp>
-        <p:nvSpPr>
-          <p:cNvPr id="11" name="Shape 8"/>
-          <p:cNvSpPr/>
-          <p:nvPr/>
-        </p:nvSpPr>
-        <p:spPr>
-          <a:xfrm>
-            <a:off x="8046720" y="4206240"/>
-            <a:ext cx="3611880" cy="1207008"/>
-          </a:xfrm>
-          <a:prstGeom prst="roundRect">
-            <a:avLst>
-              <a:gd name="adj" fmla="val 4545"/>
-            </a:avLst>
-          </a:prstGeom>
-          <a:solidFill>
-            <a:srgbClr val="F3E7E4"/>
-          </a:solidFill>
-          <a:ln w="12700">
-            <a:solidFill>
-              <a:srgbClr val="F3E7E4"/>
-            </a:solidFill>
-            <a:prstDash val="solid"/>
-          </a:ln>
-        </p:spPr>
-      </p:sp>
-      <p:sp>
-        <p:nvSpPr>
-          <p:cNvPr id="12" name="Text 9"/>
-          <p:cNvSpPr/>
-          <p:nvPr/>
-        </p:nvSpPr>
-        <p:spPr>
-          <a:xfrm>
-            <a:off x="8229600" y="4297680"/>
-            <a:ext cx="3291840" cy="365760"/>
-          </a:xfrm>
-          <a:prstGeom prst="rect">
-            <a:avLst/>
-          </a:prstGeom>
-          <a:noFill/>
-          <a:ln/>
-        </p:spPr>
-        <p:txBody>
-          <a:bodyPr wrap="square" lIns="0" tIns="0" rIns="0" bIns="0" rtlCol="0" anchor="ctr"/>
-          <a:lstStyle/>
-          <a:p>
-            <a:pPr indent="0" marL="0">
-              <a:buNone/>
-            </a:pPr>
-            <a:r>
-              <a:rPr lang="en-US" sz="1400" b="1" dirty="0">
-                <a:solidFill>
-                  <a:srgbClr val="0E2F3C"/>
-                </a:solidFill>
-                <a:latin typeface="PingFang SC" pitchFamily="34" charset="0"/>
-                <a:ea typeface="PingFang SC" pitchFamily="34" charset="-122"/>
-                <a:cs typeface="PingFang SC" pitchFamily="34" charset="-120"/>
-              </a:rPr>
-              <a:t>功效有限</a:t>
-            </a:r>
-            <a:endParaRPr lang="en-US" sz="1400" dirty="0"/>
-          </a:p>
-        </p:txBody>
-      </p:sp>
-      <p:sp>
-        <p:nvSpPr>
-          <p:cNvPr id="13" name="Text 10"/>
-          <p:cNvSpPr/>
-          <p:nvPr/>
-        </p:nvSpPr>
-        <p:spPr>
-          <a:xfrm>
-            <a:off x="8229600" y="4663440"/>
-            <a:ext cx="3291840" cy="713232"/>
-          </a:xfrm>
-          <a:prstGeom prst="rect">
-            <a:avLst/>
-          </a:prstGeom>
-          <a:noFill/>
-          <a:ln/>
-        </p:spPr>
-        <p:txBody>
-          <a:bodyPr wrap="square" lIns="0" tIns="0" rIns="0" bIns="0" rtlCol="0" anchor="ctr"/>
-          <a:lstStyle/>
-          <a:p>
-            <a:pPr indent="0" marL="0">
-              <a:buNone/>
-            </a:pPr>
-            <a:r>
-              <a:rPr lang="en-US" sz="1100" dirty="0">
-                <a:solidFill>
-                  <a:srgbClr val="1D2A33"/>
-                </a:solidFill>
-                <a:latin typeface="PingFang SC" pitchFamily="34" charset="0"/>
-                <a:ea typeface="PingFang SC" pitchFamily="34" charset="-122"/>
-                <a:cs typeface="PingFang SC" pitchFamily="34" charset="-120"/>
-              </a:rPr>
-              <a:t>覆盖度标准化的共同覆盖度仅 0.60,区间约 ±25%;只能排除大效应,且仅代表城郊站点</a:t>
-            </a:r>
-            <a:endParaRPr lang="en-US" sz="1100" dirty="0"/>
-          </a:p>
-        </p:txBody>
-      </p:sp>
-      <p:sp>
-        <p:nvSpPr>
-          <p:cNvPr id="14" name="Text 11"/>
-          <p:cNvSpPr/>
-          <p:nvPr/>
-        </p:nvSpPr>
-        <p:spPr>
-          <a:xfrm>
-            <a:off x="457200" y="5074920"/>
-            <a:ext cx="7315200" cy="822960"/>
-          </a:xfrm>
-          <a:prstGeom prst="rect">
-            <a:avLst/>
-          </a:prstGeom>
-          <a:noFill/>
-          <a:ln/>
-        </p:spPr>
-        <p:txBody>
-          <a:bodyPr wrap="square" lIns="0" tIns="0" rIns="0" bIns="0" rtlCol="0" anchor="ctr"/>
-          <a:lstStyle/>
-          <a:p>
-            <a:pPr indent="0" marL="0">
-              <a:buNone/>
-            </a:pPr>
-            <a:r>
-              <a:rPr lang="en-US" sz="1200" b="1" dirty="0">
-                <a:solidFill>
-                  <a:srgbClr val="1F6F78"/>
-                </a:solidFill>
-                <a:latin typeface="PingFang SC" pitchFamily="34" charset="0"/>
-                <a:ea typeface="PingFang SC" pitchFamily="34" charset="-122"/>
-                <a:cs typeface="PingFang SC" pitchFamily="34" charset="-120"/>
-              </a:rPr>
-              <a:t>清洗:同日同点多人清单合并(计数取最大);剔除所有计数为 1 的调查(观鸟中心占 40%);99% 截尾;保留单物种调查(按因变量剔除即样本选择)。</a:t>
-            </a:r>
-            <a:endParaRPr lang="en-US" sz="1200" dirty="0"/>
-          </a:p>
-        </p:txBody>
-      </p:sp>
-      <p:sp>
-        <p:nvSpPr>
-          <p:cNvPr id="15" name="Text 12"/>
-          <p:cNvSpPr/>
-          <p:nvPr/>
-        </p:nvSpPr>
-        <p:spPr>
-          <a:xfrm>
-            <a:off x="11277295" y="6400800"/>
-            <a:ext cx="457200" cy="274320"/>
-          </a:xfrm>
-          <a:prstGeom prst="rect">
-            <a:avLst/>
-          </a:prstGeom>
-          <a:noFill/>
-          <a:ln/>
-        </p:spPr>
-        <p:txBody>
-          <a:bodyPr wrap="square" lIns="0" tIns="0" rIns="0" bIns="0" rtlCol="0" anchor="ctr"/>
-          <a:lstStyle/>
-          <a:p>
-            <a:pPr algn="r" indent="0" marL="0">
-              <a:buNone/>
-            </a:pPr>
-            <a:r>
-              <a:rPr lang="en-US" sz="1000" dirty="0">
-                <a:solidFill>
-                  <a:srgbClr val="5E6B75"/>
-                </a:solidFill>
-                <a:latin typeface="Arial" pitchFamily="34" charset="0"/>
-                <a:ea typeface="Arial" pitchFamily="34" charset="-122"/>
-                <a:cs typeface="Arial" pitchFamily="34" charset="-120"/>
-              </a:rPr>
               <a:t>21</a:t>
             </a:r>
             <a:endParaRPr lang="en-US" sz="1000" dirty="0"/>
@@ -16690,6 +16818,526 @@
                 <a:ea typeface="PingFang SC" pitchFamily="34" charset="-122"/>
                 <a:cs typeface="PingFang SC" pitchFamily="34" charset="-120"/>
               </a:rPr>
+              <a:t>鸟类丰度型多样性:Science 指标 + 评论文章的清洗与努力校正</a:t>
+            </a:r>
+            <a:endParaRPr lang="en-US" sz="3000" dirty="0"/>
+          </a:p>
+        </p:txBody>
+      </p:sp>
+      <p:sp>
+        <p:nvSpPr>
+          <p:cNvPr id="3" name="Text 1"/>
+          <p:cNvSpPr/>
+          <p:nvPr/>
+        </p:nvSpPr>
+        <p:spPr>
+          <a:xfrm>
+            <a:off x="548640" y="960120"/>
+            <a:ext cx="11094415" cy="365760"/>
+          </a:xfrm>
+          <a:prstGeom prst="rect">
+            <a:avLst/>
+          </a:prstGeom>
+          <a:noFill/>
+          <a:ln/>
+        </p:spPr>
+        <p:txBody>
+          <a:bodyPr wrap="square" lIns="0" tIns="0" rIns="0" bIns="0" rtlCol="0" anchor="ctr"/>
+          <a:lstStyle/>
+          <a:p>
+            <a:pPr indent="0" marL="0">
+              <a:buNone/>
+            </a:pPr>
+            <a:r>
+              <a:rPr lang="en-US" sz="1400" dirty="0">
+                <a:solidFill>
+                  <a:srgbClr val="5E6B75"/>
+                </a:solidFill>
+                <a:latin typeface="PingFang SC" pitchFamily="34" charset="0"/>
+                <a:ea typeface="PingFang SC" pitchFamily="34" charset="-122"/>
+                <a:cs typeface="PingFang SC" pitchFamily="34" charset="-120"/>
+              </a:rPr>
+              <a:t>同一近远区设计;38 站 33,327 份清单 → 合并重复 26,972 → 剔除仅记有无 5,767 → 21,205 次调查</a:t>
+            </a:r>
+            <a:endParaRPr lang="en-US" sz="1400" dirty="0"/>
+          </a:p>
+        </p:txBody>
+      </p:sp>
+      <p:pic>
+        <p:nvPicPr>
+          <p:cNvPr id="4" name="Image 0" descr="results/figures/site_birds_abundance.png">    </p:cNvPr>
+          <p:cNvPicPr>
+            <a:picLocks noChangeAspect="1"/>
+          </p:cNvPicPr>
+          <p:nvPr/>
+        </p:nvPicPr>
+        <p:blipFill>
+          <a:blip r:embed="rId1"/>
+          <a:stretch>
+            <a:fillRect/>
+          </a:stretch>
+        </p:blipFill>
+        <p:spPr>
+          <a:xfrm>
+            <a:off x="457200" y="1417320"/>
+            <a:ext cx="7315200" cy="3511296"/>
+          </a:xfrm>
+          <a:prstGeom prst="rect">
+            <a:avLst/>
+          </a:prstGeom>
+        </p:spPr>
+      </p:pic>
+      <p:sp>
+        <p:nvSpPr>
+          <p:cNvPr id="5" name="Shape 2"/>
+          <p:cNvSpPr/>
+          <p:nvPr/>
+        </p:nvSpPr>
+        <p:spPr>
+          <a:xfrm>
+            <a:off x="8046720" y="1463040"/>
+            <a:ext cx="3611880" cy="1207008"/>
+          </a:xfrm>
+          <a:prstGeom prst="roundRect">
+            <a:avLst>
+              <a:gd name="adj" fmla="val 4545"/>
+            </a:avLst>
+          </a:prstGeom>
+          <a:solidFill>
+            <a:srgbClr val="EEF4F4"/>
+          </a:solidFill>
+          <a:ln w="12700">
+            <a:solidFill>
+              <a:srgbClr val="EEF4F4"/>
+            </a:solidFill>
+            <a:prstDash val="solid"/>
+          </a:ln>
+        </p:spPr>
+      </p:sp>
+      <p:sp>
+        <p:nvSpPr>
+          <p:cNvPr id="6" name="Text 3"/>
+          <p:cNvSpPr/>
+          <p:nvPr/>
+        </p:nvSpPr>
+        <p:spPr>
+          <a:xfrm>
+            <a:off x="8229600" y="1554480"/>
+            <a:ext cx="3291840" cy="365760"/>
+          </a:xfrm>
+          <a:prstGeom prst="rect">
+            <a:avLst/>
+          </a:prstGeom>
+          <a:noFill/>
+          <a:ln/>
+        </p:spPr>
+        <p:txBody>
+          <a:bodyPr wrap="square" lIns="0" tIns="0" rIns="0" bIns="0" rtlCol="0" anchor="ctr"/>
+          <a:lstStyle/>
+          <a:p>
+            <a:pPr indent="0" marL="0">
+              <a:buNone/>
+            </a:pPr>
+            <a:r>
+              <a:rPr lang="en-US" sz="1400" b="1" dirty="0">
+                <a:solidFill>
+                  <a:srgbClr val="0E2F3C"/>
+                </a:solidFill>
+                <a:latin typeface="PingFang SC" pitchFamily="34" charset="0"/>
+                <a:ea typeface="PingFang SC" pitchFamily="34" charset="-122"/>
+                <a:cs typeface="PingFang SC" pitchFamily="34" charset="-120"/>
+              </a:rPr>
+              <a:t>全部与零无差异</a:t>
+            </a:r>
+            <a:endParaRPr lang="en-US" sz="1400" dirty="0"/>
+          </a:p>
+        </p:txBody>
+      </p:sp>
+      <p:sp>
+        <p:nvSpPr>
+          <p:cNvPr id="7" name="Text 4"/>
+          <p:cNvSpPr/>
+          <p:nvPr/>
+        </p:nvSpPr>
+        <p:spPr>
+          <a:xfrm>
+            <a:off x="8229600" y="1920240"/>
+            <a:ext cx="3291840" cy="713232"/>
+          </a:xfrm>
+          <a:prstGeom prst="rect">
+            <a:avLst/>
+          </a:prstGeom>
+          <a:noFill/>
+          <a:ln/>
+        </p:spPr>
+        <p:txBody>
+          <a:bodyPr wrap="square" lIns="0" tIns="0" rIns="0" bIns="0" rtlCol="0" anchor="ctr"/>
+          <a:lstStyle/>
+          <a:p>
+            <a:pPr indent="0" marL="0">
+              <a:buNone/>
+            </a:pPr>
+            <a:r>
+              <a:rPr lang="en-US" sz="1100" dirty="0">
+                <a:solidFill>
+                  <a:srgbClr val="1D2A33"/>
+                </a:solidFill>
+                <a:latin typeface="PingFang SC" pitchFamily="34" charset="0"/>
+                <a:ea typeface="PingFang SC" pitchFamily="34" charset="-122"/>
+                <a:cs typeface="PingFang SC" pitchFamily="34" charset="-120"/>
+              </a:rPr>
+              <a:t>朴素 Shannon、清洗后 q = 1/2、观察者 FE、覆盖度标准化 q = 0/1/2;24 站结果一致</a:t>
+            </a:r>
+            <a:endParaRPr lang="en-US" sz="1100" dirty="0"/>
+          </a:p>
+        </p:txBody>
+      </p:sp>
+      <p:sp>
+        <p:nvSpPr>
+          <p:cNvPr id="8" name="Shape 5"/>
+          <p:cNvSpPr/>
+          <p:nvPr/>
+        </p:nvSpPr>
+        <p:spPr>
+          <a:xfrm>
+            <a:off x="8046720" y="2834640"/>
+            <a:ext cx="3611880" cy="1207008"/>
+          </a:xfrm>
+          <a:prstGeom prst="roundRect">
+            <a:avLst>
+              <a:gd name="adj" fmla="val 4545"/>
+            </a:avLst>
+          </a:prstGeom>
+          <a:solidFill>
+            <a:srgbClr val="FBF1DF"/>
+          </a:solidFill>
+          <a:ln w="12700">
+            <a:solidFill>
+              <a:srgbClr val="FBF1DF"/>
+            </a:solidFill>
+            <a:prstDash val="solid"/>
+          </a:ln>
+        </p:spPr>
+      </p:sp>
+      <p:sp>
+        <p:nvSpPr>
+          <p:cNvPr id="9" name="Text 6"/>
+          <p:cNvSpPr/>
+          <p:nvPr/>
+        </p:nvSpPr>
+        <p:spPr>
+          <a:xfrm>
+            <a:off x="8229600" y="2926080"/>
+            <a:ext cx="3291840" cy="365760"/>
+          </a:xfrm>
+          <a:prstGeom prst="rect">
+            <a:avLst/>
+          </a:prstGeom>
+          <a:noFill/>
+          <a:ln/>
+        </p:spPr>
+        <p:txBody>
+          <a:bodyPr wrap="square" lIns="0" tIns="0" rIns="0" bIns="0" rtlCol="0" anchor="ctr"/>
+          <a:lstStyle/>
+          <a:p>
+            <a:pPr indent="0" marL="0">
+              <a:buNone/>
+            </a:pPr>
+            <a:r>
+              <a:rPr lang="en-US" sz="1400" b="1" dirty="0">
+                <a:solidFill>
+                  <a:srgbClr val="0E2F3C"/>
+                </a:solidFill>
+                <a:latin typeface="PingFang SC" pitchFamily="34" charset="0"/>
+                <a:ea typeface="PingFang SC" pitchFamily="34" charset="-122"/>
+                <a:cs typeface="PingFang SC" pitchFamily="34" charset="-120"/>
+              </a:rPr>
+              <a:t>总个体数 −14%(n.s.)</a:t>
+            </a:r>
+            <a:endParaRPr lang="en-US" sz="1400" dirty="0"/>
+          </a:p>
+        </p:txBody>
+      </p:sp>
+      <p:sp>
+        <p:nvSpPr>
+          <p:cNvPr id="10" name="Text 7"/>
+          <p:cNvSpPr/>
+          <p:nvPr/>
+        </p:nvSpPr>
+        <p:spPr>
+          <a:xfrm>
+            <a:off x="8229600" y="3291840"/>
+            <a:ext cx="3291840" cy="713232"/>
+          </a:xfrm>
+          <a:prstGeom prst="rect">
+            <a:avLst/>
+          </a:prstGeom>
+          <a:noFill/>
+          <a:ln/>
+        </p:spPr>
+        <p:txBody>
+          <a:bodyPr wrap="square" lIns="0" tIns="0" rIns="0" bIns="0" rtlCol="0" anchor="ctr"/>
+          <a:lstStyle/>
+          <a:p>
+            <a:pPr indent="0" marL="0">
+              <a:buNone/>
+            </a:pPr>
+            <a:r>
+              <a:rPr lang="en-US" sz="1100" dirty="0">
+                <a:solidFill>
+                  <a:srgbClr val="1D2A33"/>
+                </a:solidFill>
+                <a:latin typeface="PingFang SC" pitchFamily="34" charset="0"/>
+                <a:ea typeface="PingFang SC" pitchFamily="34" charset="-122"/>
+                <a:cs typeface="PingFang SC" pitchFamily="34" charset="-120"/>
+              </a:rPr>
+              <a:t>两个样本方向一致,区间很宽</a:t>
+            </a:r>
+            <a:endParaRPr lang="en-US" sz="1100" dirty="0"/>
+          </a:p>
+        </p:txBody>
+      </p:sp>
+      <p:sp>
+        <p:nvSpPr>
+          <p:cNvPr id="11" name="Shape 8"/>
+          <p:cNvSpPr/>
+          <p:nvPr/>
+        </p:nvSpPr>
+        <p:spPr>
+          <a:xfrm>
+            <a:off x="8046720" y="4206240"/>
+            <a:ext cx="3611880" cy="1207008"/>
+          </a:xfrm>
+          <a:prstGeom prst="roundRect">
+            <a:avLst>
+              <a:gd name="adj" fmla="val 4545"/>
+            </a:avLst>
+          </a:prstGeom>
+          <a:solidFill>
+            <a:srgbClr val="F3E7E4"/>
+          </a:solidFill>
+          <a:ln w="12700">
+            <a:solidFill>
+              <a:srgbClr val="F3E7E4"/>
+            </a:solidFill>
+            <a:prstDash val="solid"/>
+          </a:ln>
+        </p:spPr>
+      </p:sp>
+      <p:sp>
+        <p:nvSpPr>
+          <p:cNvPr id="12" name="Text 9"/>
+          <p:cNvSpPr/>
+          <p:nvPr/>
+        </p:nvSpPr>
+        <p:spPr>
+          <a:xfrm>
+            <a:off x="8229600" y="4297680"/>
+            <a:ext cx="3291840" cy="365760"/>
+          </a:xfrm>
+          <a:prstGeom prst="rect">
+            <a:avLst/>
+          </a:prstGeom>
+          <a:noFill/>
+          <a:ln/>
+        </p:spPr>
+        <p:txBody>
+          <a:bodyPr wrap="square" lIns="0" tIns="0" rIns="0" bIns="0" rtlCol="0" anchor="ctr"/>
+          <a:lstStyle/>
+          <a:p>
+            <a:pPr indent="0" marL="0">
+              <a:buNone/>
+            </a:pPr>
+            <a:r>
+              <a:rPr lang="en-US" sz="1400" b="1" dirty="0">
+                <a:solidFill>
+                  <a:srgbClr val="0E2F3C"/>
+                </a:solidFill>
+                <a:latin typeface="PingFang SC" pitchFamily="34" charset="0"/>
+                <a:ea typeface="PingFang SC" pitchFamily="34" charset="-122"/>
+                <a:cs typeface="PingFang SC" pitchFamily="34" charset="-120"/>
+              </a:rPr>
+              <a:t>功效有限</a:t>
+            </a:r>
+            <a:endParaRPr lang="en-US" sz="1400" dirty="0"/>
+          </a:p>
+        </p:txBody>
+      </p:sp>
+      <p:sp>
+        <p:nvSpPr>
+          <p:cNvPr id="13" name="Text 10"/>
+          <p:cNvSpPr/>
+          <p:nvPr/>
+        </p:nvSpPr>
+        <p:spPr>
+          <a:xfrm>
+            <a:off x="8229600" y="4663440"/>
+            <a:ext cx="3291840" cy="713232"/>
+          </a:xfrm>
+          <a:prstGeom prst="rect">
+            <a:avLst/>
+          </a:prstGeom>
+          <a:noFill/>
+          <a:ln/>
+        </p:spPr>
+        <p:txBody>
+          <a:bodyPr wrap="square" lIns="0" tIns="0" rIns="0" bIns="0" rtlCol="0" anchor="ctr"/>
+          <a:lstStyle/>
+          <a:p>
+            <a:pPr indent="0" marL="0">
+              <a:buNone/>
+            </a:pPr>
+            <a:r>
+              <a:rPr lang="en-US" sz="1100" dirty="0">
+                <a:solidFill>
+                  <a:srgbClr val="1D2A33"/>
+                </a:solidFill>
+                <a:latin typeface="PingFang SC" pitchFamily="34" charset="0"/>
+                <a:ea typeface="PingFang SC" pitchFamily="34" charset="-122"/>
+                <a:cs typeface="PingFang SC" pitchFamily="34" charset="-120"/>
+              </a:rPr>
+              <a:t>覆盖度标准化的共同覆盖度仅 0.60,区间约 ±25%;只能排除大效应,且仅代表城郊站点</a:t>
+            </a:r>
+            <a:endParaRPr lang="en-US" sz="1100" dirty="0"/>
+          </a:p>
+        </p:txBody>
+      </p:sp>
+      <p:sp>
+        <p:nvSpPr>
+          <p:cNvPr id="14" name="Text 11"/>
+          <p:cNvSpPr/>
+          <p:nvPr/>
+        </p:nvSpPr>
+        <p:spPr>
+          <a:xfrm>
+            <a:off x="457200" y="5074920"/>
+            <a:ext cx="7315200" cy="822960"/>
+          </a:xfrm>
+          <a:prstGeom prst="rect">
+            <a:avLst/>
+          </a:prstGeom>
+          <a:noFill/>
+          <a:ln/>
+        </p:spPr>
+        <p:txBody>
+          <a:bodyPr wrap="square" lIns="0" tIns="0" rIns="0" bIns="0" rtlCol="0" anchor="ctr"/>
+          <a:lstStyle/>
+          <a:p>
+            <a:pPr indent="0" marL="0">
+              <a:buNone/>
+            </a:pPr>
+            <a:r>
+              <a:rPr lang="en-US" sz="1200" b="1" dirty="0">
+                <a:solidFill>
+                  <a:srgbClr val="1F6F78"/>
+                </a:solidFill>
+                <a:latin typeface="PingFang SC" pitchFamily="34" charset="0"/>
+                <a:ea typeface="PingFang SC" pitchFamily="34" charset="-122"/>
+                <a:cs typeface="PingFang SC" pitchFamily="34" charset="-120"/>
+              </a:rPr>
+              <a:t>清洗:同日同点多人清单合并(计数取最大);剔除所有计数为 1 的调查(观鸟中心占 40%);99% 截尾;保留单物种调查(按因变量剔除即样本选择)。</a:t>
+            </a:r>
+            <a:endParaRPr lang="en-US" sz="1200" dirty="0"/>
+          </a:p>
+        </p:txBody>
+      </p:sp>
+      <p:sp>
+        <p:nvSpPr>
+          <p:cNvPr id="15" name="Text 12"/>
+          <p:cNvSpPr/>
+          <p:nvPr/>
+        </p:nvSpPr>
+        <p:spPr>
+          <a:xfrm>
+            <a:off x="11277295" y="6400800"/>
+            <a:ext cx="457200" cy="274320"/>
+          </a:xfrm>
+          <a:prstGeom prst="rect">
+            <a:avLst/>
+          </a:prstGeom>
+          <a:noFill/>
+          <a:ln/>
+        </p:spPr>
+        <p:txBody>
+          <a:bodyPr wrap="square" lIns="0" tIns="0" rIns="0" bIns="0" rtlCol="0" anchor="ctr"/>
+          <a:lstStyle/>
+          <a:p>
+            <a:pPr algn="r" indent="0" marL="0">
+              <a:buNone/>
+            </a:pPr>
+            <a:r>
+              <a:rPr lang="en-US" sz="1000" dirty="0">
+                <a:solidFill>
+                  <a:srgbClr val="5E6B75"/>
+                </a:solidFill>
+                <a:latin typeface="Arial" pitchFamily="34" charset="0"/>
+                <a:ea typeface="Arial" pitchFamily="34" charset="-122"/>
+                <a:cs typeface="Arial" pitchFamily="34" charset="-120"/>
+              </a:rPr>
+              <a:t>22</a:t>
+            </a:r>
+            <a:endParaRPr lang="en-US" sz="1000" dirty="0"/>
+          </a:p>
+        </p:txBody>
+      </p:sp>
+    </p:spTree>
+  </p:cSld>
+  <p:clrMapOvr>
+    <a:masterClrMapping/>
+  </p:clrMapOvr>
+</p:sld>
+</file>
+
+<file path=ppt/slides/slide23.xml><?xml version="1.0" encoding="utf-8"?>
+<p:sld xmlns:a="http://schemas.openxmlformats.org/drawingml/2006/main" xmlns:r="http://schemas.openxmlformats.org/officeDocument/2006/relationships" xmlns:p="http://schemas.openxmlformats.org/presentationml/2006/main">
+  <p:cSld name="Slide 23">
+    <p:spTree>
+      <p:nvGrpSpPr>
+        <p:cNvPr id="1" name=""/>
+        <p:cNvGrpSpPr/>
+        <p:nvPr/>
+      </p:nvGrpSpPr>
+      <p:grpSpPr>
+        <a:xfrm>
+          <a:off x="0" y="0"/>
+          <a:ext cx="0" cy="0"/>
+          <a:chOff x="0" y="0"/>
+          <a:chExt cx="0" cy="0"/>
+        </a:xfrm>
+      </p:grpSpPr>
+      <p:sp>
+        <p:nvSpPr>
+          <p:cNvPr id="2" name="Text 0"/>
+          <p:cNvSpPr/>
+          <p:nvPr/>
+        </p:nvSpPr>
+        <p:spPr>
+          <a:xfrm>
+            <a:off x="548640" y="320040"/>
+            <a:ext cx="11094415" cy="685800"/>
+          </a:xfrm>
+          <a:prstGeom prst="rect">
+            <a:avLst/>
+          </a:prstGeom>
+          <a:noFill/>
+          <a:ln/>
+        </p:spPr>
+        <p:txBody>
+          <a:bodyPr wrap="square" lIns="0" tIns="0" rIns="0" bIns="0" rtlCol="0" anchor="ctr"/>
+          <a:lstStyle/>
+          <a:p>
+            <a:pPr indent="0" marL="0">
+              <a:buNone/>
+            </a:pPr>
+            <a:r>
+              <a:rPr lang="en-US" sz="3000" b="1" dirty="0">
+                <a:solidFill>
+                  <a:srgbClr val="0E2F3C"/>
+                </a:solidFill>
+                <a:latin typeface="PingFang SC" pitchFamily="34" charset="0"/>
+                <a:ea typeface="PingFang SC" pitchFamily="34" charset="-122"/>
+                <a:cs typeface="PingFang SC" pitchFamily="34" charset="-120"/>
+              </a:rPr>
               <a:t>主要风险与对策</a:t>
             </a:r>
             <a:endParaRPr lang="en-US" sz="3000" dirty="0"/>
@@ -16698,7 +17346,7 @@
       </p:sp>
       <p:graphicFrame>
         <p:nvGraphicFramePr>
-          <p:cNvPr id="23" name="Table 0"/>
+          <p:cNvPr id="24" name="Table 0"/>
           <p:cNvGraphicFramePr>
             <a:graphicFrameLocks noGrp="1"/>
           </p:cNvGraphicFramePr>
@@ -17821,7 +18469,7 @@
                 <a:ea typeface="Arial" pitchFamily="34" charset="-122"/>
                 <a:cs typeface="Arial" pitchFamily="34" charset="-120"/>
               </a:rPr>
-              <a:t>22</a:t>
+              <a:t>23</a:t>
             </a:r>
             <a:endParaRPr lang="en-US" sz="1000" dirty="0"/>
           </a:p>
@@ -17835,9 +18483,9 @@
 </p:sld>
 </file>
 
-<file path=ppt/slides/slide23.xml><?xml version="1.0" encoding="utf-8"?>
+<file path=ppt/slides/slide24.xml><?xml version="1.0" encoding="utf-8"?>
 <p:sld xmlns:a="http://schemas.openxmlformats.org/drawingml/2006/main" xmlns:r="http://schemas.openxmlformats.org/officeDocument/2006/relationships" xmlns:p="http://schemas.openxmlformats.org/presentationml/2006/main">
-  <p:cSld name="Slide 23">
+  <p:cSld name="Slide 24">
     <p:spTree>
       <p:nvGrpSpPr>
         <p:cNvPr id="1" name=""/>
@@ -18246,7 +18894,7 @@
                 <a:ea typeface="Arial" pitchFamily="34" charset="-122"/>
                 <a:cs typeface="Arial" pitchFamily="34" charset="-120"/>
               </a:rPr>
-              <a:t>23</a:t>
+              <a:t>24</a:t>
             </a:r>
             <a:endParaRPr lang="en-US" sz="1000" dirty="0"/>
           </a:p>
@@ -18260,9 +18908,9 @@
 </p:sld>
 </file>
 
-<file path=ppt/slides/slide24.xml><?xml version="1.0" encoding="utf-8"?>
+<file path=ppt/slides/slide25.xml><?xml version="1.0" encoding="utf-8"?>
 <p:sld xmlns:a="http://schemas.openxmlformats.org/drawingml/2006/main" xmlns:r="http://schemas.openxmlformats.org/officeDocument/2006/relationships" xmlns:p="http://schemas.openxmlformats.org/presentationml/2006/main">
-  <p:cSld name="Slide 24">
+  <p:cSld name="Slide 25">
     <p:bg>
       <p:bgPr>
         <a:solidFill>

</xml_diff>